<commit_message>
DP0: use general terms (proxy, Router, P/D auxiliary process) instead of Envoy/EPP/sidecar; add glossary and why proxy and Router are separate
Co-Authored-By: Claude Sonnet 5.5 <noreply@anthropic.com>
Claude-Session: https://claude.ai/code/session_014XKnsGjraFTY3Q8v5o1PT9
</commit_message>
<xml_diff>
--- a/doc-mk/DP0/DP0-slides-v2.pptx
+++ b/doc-mk/DP0/DP0-slides-v2.pptx
@@ -784,7 +784,7 @@
           </a:p>
           <a:p>
             <a:r>
-              <a:t>1안(왼쪽)은 llm-d를 그대로 쓰고 우리 로직만 얹습니다. Envoy가 요청을 받아 EPP(결정 프로세스)에 원격으로 물어보고(②, 원격 호출 1회), 선택된 서버의 decode pod 안 sidecar가 Prefill 서버를 호출해 P/D를 조율합니다. 노란색이 우리가 추가하는 부분(P1·P2는 설정, P3·P4는 확장 모듈)이고, 빨간 테두리는 기존 모듈을 고쳐야 하는 유일한 곳(P/D 경로의 노드 지시, P5)입니다.</a:t>
+              <a:t>1안(왼쪽)은 오픈소스(llm-d)를 그대로 쓰고 우리 로직만 얹습니다. 프록시가 요청을 받아 Router(결정 프로세스)에 원격으로 물어보고(②, 원격 호출 1회), 선택된 서버 옆의 P/D 보조 프로세스가 Prefill 서버를 호출해 P/D를 조율합니다. 노란색이 우리가 추가하는 부분(P1·P2는 설정, P3·P4는 확장 모듈)이고, 빨간 테두리는 기존 모듈을 고쳐야 하는 유일한 곳(P/D 경로의 노드 지시, P5)입니다.</a:t>
             </a:r>
           </a:p>
           <a:p>
@@ -895,7 +895,7 @@
           </a:p>
           <a:p>
             <a:r>
-              <a:t>오른쪽 결과는 별 합계가 9 대 9 동점입니다. 처리량은 교차(정상 부하·P/D 경로는 2안, 과부하는 1안), 지연은 2안, 변경 용이성은 3:3으로 성격만 다르고, 확장성은 1안입니다. QA 밖 비용도 구현 부담은 1안, 운영 환경 부담(Kubernetes·Envoy·자체 EPP 이미지)은 2안이 유리해 서로 반대입니다. 그래서 한쪽이 지배하지 않는 tradeoff입니다.</a:t>
+              <a:t>오른쪽 결과는 별 합계가 9 대 9 동점입니다. 처리량은 교차(정상 부하·P/D 경로는 2안, 과부하는 1안), 지연은 2안, 변경 용이성은 3:3으로 성격만 다르고, 확장성은 1안입니다. QA 밖 비용도 구현 부담은 1안, 운영 환경 부담(Kubernetes·프록시·자체 Router 이미지)은 2안이 유리해 서로 반대입니다. 그래서 한쪽이 지배하지 않는 tradeoff입니다.</a:t>
             </a:r>
           </a:p>
           <a:p>
@@ -13394,7 +13394,7 @@
                 <a:latin typeface="맑은 고딕"/>
                 <a:ea typeface="맑은 고딕"/>
               </a:rPr>
-              <a:t>(Handler)</a:t>
+              <a:t/>
             </a:r>
           </a:p>
         </p:txBody>
@@ -13798,7 +13798,7 @@
                 <a:latin typeface="맑은 고딕"/>
                 <a:ea typeface="맑은 고딕"/>
               </a:rPr>
-              <a:t>(Data Layer)</a:t>
+              <a:t/>
             </a:r>
           </a:p>
           <a:p>
@@ -22983,7 +22983,7 @@
                 <a:latin typeface="맑은 고딕"/>
                 <a:ea typeface="맑은 고딕"/>
               </a:rPr>
-              <a:t>«proxy» Envoy</a:t>
+              <a:t>«proxy» 프록시</a:t>
             </a:r>
           </a:p>
         </p:txBody>
@@ -23038,7 +23038,7 @@
                 <a:latin typeface="맑은 고딕"/>
                 <a:ea typeface="맑은 고딕"/>
               </a:rPr>
-              <a:t>ext-proc client</a:t>
+              <a:t>결정 호출 client</a:t>
             </a:r>
           </a:p>
         </p:txBody>
@@ -23231,7 +23231,7 @@
                 <a:latin typeface="맑은 고딕"/>
                 <a:ea typeface="맑은 고딕"/>
               </a:rPr>
-              <a:t>InferencePool</a:t>
+              <a:t>서버 풀</a:t>
             </a:r>
           </a:p>
         </p:txBody>
@@ -23369,7 +23369,7 @@
                 <a:latin typeface="맑은 고딕"/>
                 <a:ea typeface="맑은 고딕"/>
               </a:rPr>
-              <a:t>«pod» EPP  (llm-d Router, Go)</a:t>
+              <a:t>«process» Router  (llm-d 기준, Go)</a:t>
             </a:r>
           </a:p>
         </p:txBody>
@@ -23411,7 +23411,7 @@
                 <a:latin typeface="맑은 고딕"/>
                 <a:ea typeface="맑은 고딕"/>
               </a:rPr>
-              <a:t>Request Handler</a:t>
+              <a:t>요청 핸들러</a:t>
             </a:r>
           </a:p>
           <a:p>
@@ -23424,7 +23424,7 @@
                 <a:latin typeface="맑은 고딕"/>
                 <a:ea typeface="맑은 고딕"/>
               </a:rPr>
-              <a:t>Director</a:t>
+              <a:t>요청 제어</a:t>
             </a:r>
           </a:p>
         </p:txBody>
@@ -23530,7 +23530,7 @@
                 <a:latin typeface="맑은 고딕"/>
                 <a:ea typeface="맑은 고딕"/>
               </a:rPr>
-              <a:t>D Flow Control</a:t>
+              <a:t>D 흐름 제어</a:t>
             </a:r>
           </a:p>
           <a:p>
@@ -23836,7 +23836,7 @@
                 <a:latin typeface="맑은 고딕"/>
                 <a:ea typeface="맑은 고딕"/>
               </a:rPr>
-              <a:t>ProfileHandler</a:t>
+              <a:t>P/D 판단 모듈</a:t>
             </a:r>
           </a:p>
           <a:p>
@@ -23849,7 +23849,7 @@
                 <a:latin typeface="맑은 고딕"/>
                 <a:ea typeface="맑은 고딕"/>
               </a:rPr>
-              <a:t>★P4 P/D 판단 wrapper</a:t>
+              <a:t>★P4 비용 기반 P/D 판단</a:t>
             </a:r>
           </a:p>
           <a:p>
@@ -23862,7 +23862,7 @@
                 <a:latin typeface="맑은 고딕"/>
                 <a:ea typeface="맑은 고딕"/>
               </a:rPr>
-              <a:t>(disagg.Handler embed)</a:t>
+              <a:t>(기존 P/D 모듈을 감싸는 wrapper)</a:t>
             </a:r>
           </a:p>
         </p:txBody>
@@ -23904,7 +23904,7 @@
                 <a:latin typeface="맑은 고딕"/>
                 <a:ea typeface="맑은 고딕"/>
               </a:rPr>
-              <a:t>PreRequest 훅</a:t>
+              <a:t>요청 전처리 훅</a:t>
             </a:r>
           </a:p>
           <a:p>
@@ -24026,7 +24026,7 @@
                 <a:latin typeface="맑은 고딕"/>
                 <a:ea typeface="맑은 고딕"/>
               </a:rPr>
-              <a:t>C Data Layer</a:t>
+              <a:t>C 상태 계층</a:t>
             </a:r>
           </a:p>
         </p:txBody>
@@ -24431,7 +24431,7 @@
                 <a:latin typeface="맑은 고딕"/>
                 <a:ea typeface="맑은 고딕"/>
               </a:rPr>
-              <a:t>E pd-sidecar</a:t>
+              <a:t>E P/D 보조 프로세스</a:t>
             </a:r>
           </a:p>
         </p:txBody>
@@ -24486,7 +24486,7 @@
                 <a:latin typeface="맑은 고딕"/>
                 <a:ea typeface="맑은 고딕"/>
               </a:rPr>
-              <a:t>P/D 경로: sidecar 수정</a:t>
+              <a:t>P/D 경로: 보조 프로세스 수정</a:t>
             </a:r>
           </a:p>
           <a:p>
@@ -25282,7 +25282,7 @@
                 <a:latin typeface="맑은 고딕"/>
                 <a:ea typeface="맑은 고딕"/>
               </a:rPr>
-              <a:t>① HTTP ② 결정 요청(ext-proc gRPC: 원격 호출 1회 추가) ③ 선택된 서버 + 헤더를 sidecar로 전달(EPP를 거치지 않음) ④ Prefill 요청 + KV 전송 정보 ⑤ 서버 간 KV 전송(NIXL) ⑥ KV 이벤트·/metrics(두 pod 공통) ⑦ 서버 발견 ⑧ 상태 조회</a:t>
+              <a:t>① HTTP ② 결정 요청(프록시 → Router 원격 호출 1회 추가) ③ 선택된 서버 + 헤더를 P/D 보조 프로세스로 전달(Router를 거치지 않음) ④ Prefill 요청 + KV 전송 정보 ⑤ 서버 간 KV 전송(NIXL) ⑥ KV 이벤트·/metrics(두 pod 공통) ⑦ 서버 발견 ⑧ 상태 조회</a:t>
             </a:r>
           </a:p>
         </p:txBody>
@@ -28153,7 +28153,7 @@
                 <a:latin typeface="맑은 고딕"/>
                 <a:ea typeface="맑은 고딕"/>
               </a:rPr>
-              <a:t>별도 프로세스 (Envoy ext-proc, 원격 호출 1회)</a:t>
+              <a:t>별도 프로세스 (프록시 → Router 원격 호출 1회)</a:t>
             </a:r>
           </a:p>
         </p:txBody>
@@ -28321,7 +28321,7 @@
                 <a:latin typeface="맑은 고딕"/>
                 <a:ea typeface="맑은 고딕"/>
               </a:rPr>
-              <a:t>분산: decode pod의 pd-sidecar (Router는 데이터 경로 밖)</a:t>
+              <a:t>분산: decode 서버 옆 P/D 보조 프로세스 (Router는 데이터 경로 밖)</a:t>
             </a:r>
           </a:p>
         </p:txBody>
@@ -28489,7 +28489,7 @@
                 <a:latin typeface="맑은 고딕"/>
                 <a:ea typeface="맑은 고딕"/>
               </a:rPr>
-              <a:t>OSS 재사용 + 확장 (우리 소유 블록 3/6: B·C 확장, E patch)</a:t>
+              <a:t>OSS 재사용 + 확장 (우리 소유 블록 3/6: B·C 확장, E 수정)</a:t>
             </a:r>
           </a:p>
         </p:txBody>
@@ -29673,7 +29673,7 @@
                 <a:latin typeface="맑은 고딕"/>
                 <a:ea typeface="맑은 고딕"/>
               </a:rPr>
-              <a:t>별도 프로세스(ext-proc)</a:t>
+              <a:t>별도 프로세스(프록시 → Router)</a:t>
             </a:r>
           </a:p>
         </p:txBody>
@@ -29765,7 +29765,7 @@
                 <a:latin typeface="맑은 고딕"/>
                 <a:ea typeface="맑은 고딕"/>
               </a:rPr>
-              <a:t>원격 호출 1회 + sidecar 경유</a:t>
+              <a:t>원격 호출 1회 + 보조 프로세스 경유</a:t>
             </a:r>
           </a:p>
         </p:txBody>
@@ -30060,7 +30060,7 @@
                 <a:latin typeface="맑은 고딕"/>
                 <a:ea typeface="맑은 고딕"/>
               </a:rPr>
-              <a:t>분산: decode pod sidecar</a:t>
+              <a:t>분산: decode 옆 보조 프로세스</a:t>
             </a:r>
           </a:p>
         </p:txBody>
@@ -30152,7 +30152,7 @@
                 <a:latin typeface="맑은 고딕"/>
                 <a:ea typeface="맑은 고딕"/>
               </a:rPr>
-              <a:t>P/D 경로 노드 지시(P5)는 sidecar 수정</a:t>
+              <a:t>P/D 경로 노드 지시(P5)는 보조 프로세스 수정</a:t>
             </a:r>
           </a:p>
         </p:txBody>
@@ -30493,7 +30493,7 @@
                 <a:latin typeface="맑은 고딕"/>
                 <a:ea typeface="맑은 고딕"/>
               </a:rPr>
-              <a:t>S1·S5·S6(설정·업스트림 흡수·신기능)  ＋Q1 과부하 시 Flow Control 기본</a:t>
+              <a:t>S1·S5·S6(설정·업스트림 흡수·신기능)  ＋Q1 과부하 시 흐름 제어 기본</a:t>
             </a:r>
           </a:p>
         </p:txBody>
@@ -30539,7 +30539,7 @@
                 <a:latin typeface="맑은 고딕"/>
                 <a:ea typeface="맑은 고딕"/>
               </a:rPr>
-              <a:t>S3·S4: wrapper가 OSS 동작에 의존, 자체 EPP 이미지 운영</a:t>
+              <a:t>S3·S4: wrapper가 OSS 동작에 의존, 자체 Router 이미지 운영</a:t>
             </a:r>
           </a:p>
         </p:txBody>
@@ -31183,7 +31183,7 @@
                 <a:latin typeface="맑은 고딕"/>
                 <a:ea typeface="맑은 고딕"/>
               </a:rPr>
-              <a:t>교차: 정상 부하·P/D 경로는 2안(P5 직접 전달), 과부하는 1안(Flow Control 기본 제공). E4</a:t>
+              <a:t>교차: 정상 부하·P/D 경로는 2안(P5 직접 전달), 과부하는 1안(흐름 제어 기본 제공). E4</a:t>
             </a:r>
           </a:p>
         </p:txBody>
@@ -31351,7 +31351,7 @@
                 <a:latin typeface="맑은 고딕"/>
                 <a:ea typeface="맑은 고딕"/>
               </a:rPr>
-              <a:t>2안: 원격 호출 1회·sidecar 경유 제거. 크기 미측정이라 가장 약한 근거. E1</a:t>
+              <a:t>2안: 원격 호출 1회·보조 프로세스 경유 제거. 크기 미측정이라 가장 약한 근거. E1</a:t>
             </a:r>
           </a:p>
         </p:txBody>
@@ -31687,7 +31687,7 @@
                 <a:latin typeface="맑은 고딕"/>
                 <a:ea typeface="맑은 고딕"/>
               </a:rPr>
-              <a:t>1안: K8s 복제·InferencePool·Flow Control 검증됨. 2안: 레플리카·HA·sync 직접 구축, 2노드 실측 불가</a:t>
+              <a:t>1안: K8s 복제·서버 풀·흐름 제어 검증됨. 2안: 레플리카·HA·sync 직접 구축, 2노드 실측 불가</a:t>
             </a:r>
           </a:p>
         </p:txBody>
@@ -32079,7 +32079,7 @@
                 <a:latin typeface="맑은 고딕"/>
                 <a:ea typeface="맑은 고딕"/>
               </a:rPr>
-              <a:t>1안 불리 — K8s·Envoy·자체 EPP 이미지(C2)</a:t>
+              <a:t>1안 불리 — K8s·프록시·자체 Router 이미지(C2)</a:t>
             </a:r>
             <a:r>
               <a:rPr sz="800" b="0">
@@ -32099,7 +32099,7 @@
                 <a:latin typeface="맑은 고딕"/>
                 <a:ea typeface="맑은 고딕"/>
               </a:rPr>
-              <a:t>2안 유리 — K8s·Envoy 불필요</a:t>
+              <a:t>2안 유리 — K8s·프록시 불필요</a:t>
             </a:r>
           </a:p>
         </p:txBody>
@@ -32203,7 +32203,7 @@
                 <a:latin typeface="맑은 고딕"/>
                 <a:ea typeface="맑은 고딕"/>
               </a:rPr>
-              <a:t>· 2안으로 전환: E1에서 hop 증분이 TTFT 목표 대비 허용 불가 · P/D 경로 P5가 성능에 필수인데 sidecar patch 유지가 불가 · QA 우선순위를 Latency 우선으로 확정할 때.</a:t>
+              <a:t>· 2안으로 전환: E1에서 hop 증분이 TTFT 목표 대비 허용 불가 · P/D 경로 P5가 성능에 필수인데 보조 프로세스 수정 유지가 불가 · QA 우선순위를 Latency 우선으로 확정할 때.</a:t>
             </a:r>
           </a:p>
           <a:p>

</xml_diff>

<commit_message>
DP0: emphasize that only LLM-specific functions are needed, so proxy and decision logic need not be separate processes in candidate 2
Co-Authored-By: Claude Sonnet 5.5 <noreply@anthropic.com>
Claude-Session: https://claude.ai/code/session_014XKnsGjraFTY3Q8v5o1PT9
</commit_message>
<xml_diff>
--- a/doc-mk/DP0/DP0-slides-v2.pptx
+++ b/doc-mk/DP0/DP0-slides-v2.pptx
@@ -790,6 +790,11 @@
           <a:p>
             <a:r>
               <a:t>2안(오른쪽)은 전부 우리가 소유하는 계층형 구조입니다. 한 프로세스 안에 Ingress, Pipeline(Admission → PolicyEngine → P/D 조율), State Plane(상태 저장소, 이벤트 구독, 메트릭 수집, 서버 등록)을 나눴고, 정책은 PolicyEngine의 SPI(P1~P3 Scorer, P4 Planner)로 꽂고, 상태는 읽기 전용 StateView 인터페이스로만 읽습니다. 이전 안은 단일 프로세스·정적 설정의 최소 구성이어서 확장성이 일방적으로 약했는데, 이번에는 상태를 공유하지 않는 레플리카 여러 개를 L4 로드밸런서 뒤에 두고 etcd로 서버를 등록하는 구성으로 같은 노력 수준에서 비교합니다. 구현은 되어 있지 않은 설계안입니다.</a:t>
+            </a:r>
+          </a:p>
+          <a:p>
+            <a:r>
+              <a:t>후보 2가 한 프로세스인 이유: 우리에게 필요한 것은 요청 파싱, 서버 선택, P/D 조율, 토큰 스트림 중계 같은 LLM 전용 기능뿐이고 인증·다중 프로토콜 같은 범용 프록시 기능은 필요하지 않습니다. 그래서 프록시와 결정 로직을 나눌 이유가 없고, 합쳐서 원격 호출 1회를 없앱니다(범용 기능이 나중에 필요하면 앞단 로드밸런서에 맡깁니다).</a:t>
             </a:r>
           </a:p>
           <a:p>
@@ -28237,7 +28242,7 @@
                 <a:latin typeface="맑은 고딕"/>
                 <a:ea typeface="맑은 고딕"/>
               </a:rPr>
-              <a:t>프로세스 내부 호출 (원격 호출 없음)</a:t>
+              <a:t>프로세스 내부 호출 (원격 호출 없음) - 필요한 건 LLM 기능뿐이라 범용 프록시 분리가 불필요</a:t>
             </a:r>
           </a:p>
         </p:txBody>

</xml_diff>

<commit_message>
DP0: add cost/risk supporting indicators to the tradeoff, fix candidate 2 flow control scope, narrow Modifiability to S1-S4
- QA stays at four criteria (common QA doc untouched); cost and risk shown as
  supporting indicators outside the star total
- Candidate 2 flow control is implementable; its effort moves to cost
- S5/S6 (upstream tracking, new features) move from Modifiability to cost
- Revision history v1/v2/v3 and collapse conditions recorded
- Update tradeoff slide

Co-Authored-By: Claude Sonnet 5.5 <noreply@anthropic.com>
Claude-Session: https://claude.ai/code/session_014XKnsGjraFTY3Q8v5o1PT9
</commit_message>
<xml_diff>
--- a/doc-mk/DP0/DP0-slides-v2.pptx
+++ b/doc-mk/DP0/DP0-slides-v2.pptx
@@ -890,22 +890,22 @@
           </a:p>
           <a:p>
             <a:r>
-              <a:t>이전 평가는 1안이 4개 QA 중 3개에서 앞서 사실상 1안이 지배하는 구조였습니다. 원인은 2안을 단일 프로세스·정적 설정의 최소 구성으로 그려서 확장성과 흐름 제어가 일방적으로 약했던 것입니다. 그래서 2안을 레플리카·etcd를 포함한 같은 노력 수준으로 다시 설계했고, 변경 용이성은 시나리오 S1~S6 단위로 다시 셌습니다. 수치를 결론에 맞춘 것이 아니라 정의를 바로잡은 것이고, 이전 값과 사유는 설계 문서에 남겼습니다.</a:t>
-            </a:r>
-          </a:p>
-          <a:p>
-            <a:r>
-              <a:t>왼쪽은 설계 결정 세 개가 각각 어떤 QA를 얻고 잃는지입니다. D1 결정 위치: 프로세스 내부 호출은 지연에 유리하지만 결정 부하가 Router 확장에 묶입니다. D2 P/D 조율 위치: 중앙에 두면 전역 시야와 노드 지시(P5) 전달에 유리하지만 Router가 데이터 경로 안에 들어와 병목이 됩니다. D3 기능 소유: OSS 재사용은 신규 기능과 업스트림 흡수에 유리하고, 직접 소유는 우리 로직 변경(S2~S4)에 유리합니다.</a:t>
-            </a:r>
-          </a:p>
-          <a:p>
-            <a:r>
-              <a:t>오른쪽 결과는 별 합계가 9 대 9 동점입니다. 처리량은 교차(정상 부하·P/D 경로는 2안, 과부하는 1안), 지연은 2안, 변경 용이성은 3:3으로 성격만 다르고, 확장성은 1안입니다. QA 밖 비용도 구현 부담은 1안, 운영 환경 부담(Kubernetes·프록시·자체 Router 이미지)은 2안이 유리해 서로 반대입니다. 그래서 한쪽이 지배하지 않는 tradeoff입니다.</a:t>
-            </a:r>
-          </a:p>
-          <a:p>
-            <a:r>
-              <a:t>단, 이 평가는 전부 구조 논증에 기반한 가설이고 지연 차이의 크기는 측정하지 못했습니다. E1에서 hop 증분이 잡음 수준이면 2안의 지연 이점이 사라져 1안이 다시 지배합니다. 현재 기본 경로는 실제 실행으로 확인한 1안이고, 2안은 E1 결과와 QA 우선순위 확정에 따라 전환하는 헤지입니다. QA 우선순위(특히 지연 vs 확장성)는 아직 정해지지 않았으며 결정이 필요합니다.</a:t>
+              <a:t>이전 평가는 1안이 4개 QA 중 3개에서 앞서 사실상 1안이 지배하는 구조였습니다. 원인은 2안을 단일 프로세스·정적 설정·최소 흐름 제어의 최소 구성으로 그려서 불리하게 만든 것이었습니다. 그래서 2안을 레플리카·etcd·흐름 제어를 포함한 같은 노력 수준으로 다시 설계했고, 구현 부담이 늘어난 것은 QA가 아니라 비용 보조지표에 반영했습니다. 변경 용이성은 우리 로직을 바꾸는 비용(S1~S4)으로 좁히고, 업스트림 추종과 신기능 확보는 유지 부담 보조지표로 옮겼습니다. 별 경계와 QA 지표는 바꾸지 않았고, 이전 값과 사유는 설계 문서 7.4.1에 남겼습니다.</a:t>
+            </a:r>
+          </a:p>
+          <a:p>
+            <a:r>
+              <a:t>왼쪽은 설계 결정 세 개가 무엇을 얻고 잃는지입니다. D1 결정 위치: 프로세스 내부 호출은 지연에 유리하지만 결정 부하가 Router 확장에 묶입니다. D2 P/D 조율 위치: 중앙에 두면 전역 시야와 노드 지시(P5) 전달에 유리하지만 Router가 데이터 경로 안에 들어와 병목이 됩니다. D3 기능 소유: OSS 재사용은 구현·유지 부담이 적고 실행 확인된 경로가 있지만, 직접 소유는 우리 로직(S2~S4)을 한 코드베이스에서 통제할 수 있는 대신 전부 직접 구현해야 합니다.</a:t>
+            </a:r>
+          </a:p>
+          <a:p>
+            <a:r>
+              <a:t>오른쪽 QA는 2안이 10 대 9로 근소하게 앞섭니다. 처리량은 동등, 지연과 변경 용이성은 2안, 확장성은 1안입니다. 보조지표는 비용(구현·유지 부담)과 리스크(증거 수준, 미검증 가정)에서 1안이 앞서고, 운영 환경 부담과 업스트림 의존 리스크는 2안이 낫습니다. QA와 보조지표가 반대 방향이라 한쪽이 지배하지 않는 tradeoff입니다. 보조지표는 별 합계에 넣지 않습니다.</a:t>
+            </a:r>
+          </a:p>
+          <a:p>
+            <a:r>
+              <a:t>다만 모두 구조 논증에 기반한 가설이고 지연 차이의 크기는 측정하지 못했습니다. E1에서 hop 증분이 잡음 수준이면 2안의 QA 우위가 사라집니다. 현재 기본 경로는 실제 실행으로 확인한 1안이고, 2안은 E1 결과와 QA 우선순위(지연 우선 여부)에 따라 전환하는 헤지입니다.</a:t>
             </a:r>
           </a:p>
         </p:txBody>
@@ -25966,7 +25966,7 @@
                 <a:latin typeface="맑은 고딕"/>
                 <a:ea typeface="맑은 고딕"/>
               </a:rPr>
-              <a:t>Queue 정책</a:t>
+              <a:t>대기·우선순위</a:t>
             </a:r>
           </a:p>
           <a:p>
@@ -25979,7 +25979,7 @@
                 <a:latin typeface="맑은 고딕"/>
                 <a:ea typeface="맑은 고딕"/>
               </a:rPr>
-              <a:t>(최소: 임계값</a:t>
+              <a:t>·거절 정책</a:t>
             </a:r>
           </a:p>
           <a:p>
@@ -25992,7 +25992,7 @@
                 <a:latin typeface="맑은 고딕"/>
                 <a:ea typeface="맑은 고딕"/>
               </a:rPr>
-              <a:t>+ FCFS)</a:t>
+              <a:t>(직접 구현)</a:t>
             </a:r>
           </a:p>
         </p:txBody>
@@ -28755,7 +28755,7 @@
                   <a:schemeClr val="bg1"/>
                 </a:solidFill>
               </a:rPr>
-              <a:t>설계 결정(D1~D3)이 QA를 어떻게 맞바꾸는가</a:t>
+              <a:t>설계 결정(D1~D3)이 QA와 비용·리스크를 어떻게 맞바꾸는가</a:t>
             </a:r>
             <a:endParaRPr lang="ko-KR" altLang="en-US" sz="1400" b="1" dirty="0">
               <a:solidFill>
@@ -29423,7 +29423,7 @@
                 <a:latin typeface="맑은 고딕"/>
                 <a:ea typeface="맑은 고딕"/>
               </a:rPr>
-              <a:t>① 설계 결정마다 한 QA를 얻으면 다른 QA를 잃는다</a:t>
+              <a:t>① 설계 결정마다 한 쪽을 얻으면 다른 쪽을 잃는다</a:t>
             </a:r>
           </a:p>
         </p:txBody>
@@ -30277,7 +30277,7 @@
                 <a:latin typeface="맑은 고딕"/>
                 <a:ea typeface="맑은 고딕"/>
               </a:rPr>
-              <a:t>전역 시야, P5 직접 전달, prefill 결과 보고 decode 지정(설계 가능)</a:t>
+              <a:t>전역 시야, P5를 수정 없이 전달, 결정 정책 자유</a:t>
             </a:r>
           </a:p>
         </p:txBody>
@@ -30488,7 +30488,7 @@
                 <a:latin typeface="맑은 고딕"/>
                 <a:ea typeface="맑은 고딕"/>
               </a:rPr>
-              <a:t>＋ Q3 </a:t>
+              <a:t>＋ 비용·리스크 </a:t>
             </a:r>
             <a:r>
               <a:rPr sz="850" b="0">
@@ -30498,7 +30498,7 @@
                 <a:latin typeface="맑은 고딕"/>
                 <a:ea typeface="맑은 고딕"/>
               </a:rPr>
-              <a:t>S1·S5·S6(설정·업스트림 흡수·신기능)  ＋Q1 과부하 시 흐름 제어 기본</a:t>
+              <a:t>구현·유지 부담↓, 계약·신기능은 OSS가 흡수, 실행 확인 [A]</a:t>
             </a:r>
           </a:p>
         </p:txBody>
@@ -30544,7 +30544,7 @@
                 <a:latin typeface="맑은 고딕"/>
                 <a:ea typeface="맑은 고딕"/>
               </a:rPr>
-              <a:t>S3·S4: wrapper가 OSS 동작에 의존, 자체 Router 이미지 운영</a:t>
+              <a:t>S2~S4: wrapper가 OSS 동작에 의존, 보조 프로세스 수정, 자체 이미지</a:t>
             </a:r>
           </a:p>
         </p:txBody>
@@ -30664,7 +30664,7 @@
                 <a:latin typeface="맑은 고딕"/>
                 <a:ea typeface="맑은 고딕"/>
               </a:rPr>
-              <a:t>S2~S4(비용 함수·P/D 정책·노드 지시)를 한 코드베이스에서 통제</a:t>
+              <a:t>S2~S4: 비용 함수·P/D 정책·노드 지시를 한 코드베이스에서 통제</a:t>
             </a:r>
           </a:p>
         </p:txBody>
@@ -30700,7 +30700,7 @@
                 <a:latin typeface="맑은 고딕"/>
                 <a:ea typeface="맑은 고딕"/>
               </a:rPr>
-              <a:t>－ Q3·Q1 </a:t>
+              <a:t>－ 비용·리스크 </a:t>
             </a:r>
             <a:r>
               <a:rPr sz="850" b="0">
@@ -30710,7 +30710,7 @@
                 <a:latin typeface="맑은 고딕"/>
                 <a:ea typeface="맑은 고딕"/>
               </a:rPr>
-              <a:t>S5·S6 직접 추적·구현, 과부하 admission 직접 구현</a:t>
+              <a:t>6/6 직접 구현, 계약 추종·신기능·흐름 제어 전부 직접, 설계안뿐</a:t>
             </a:r>
           </a:p>
         </p:txBody>
@@ -30796,7 +30796,7 @@
                 <a:latin typeface="맑은 고딕"/>
                 <a:ea typeface="맑은 고딕"/>
               </a:rPr>
-              <a:t> 변경 용이성(S1 새 tier · S2 비용 함수 · S3 P/D 정책 · S4 노드 지시 · S5 vLLM/NIXL 변경 · S6 신규 기능)  </a:t>
+              <a:t> 변경 용이성(S1 새 tier · S2 비용 함수 · S3 P/D 정책 · S4 노드 지시)  </a:t>
             </a:r>
             <a:r>
               <a:rPr sz="750" b="1">
@@ -30852,7 +30852,7 @@
                 <a:latin typeface="맑은 고딕"/>
                 <a:ea typeface="맑은 고딕"/>
               </a:rPr>
-              <a:t>② QA 평가 (전부 가설 [C], 측정 전)</a:t>
+              <a:t>② QA 평가 (4개, 별 합계) + 보조지표 (합계에 넣지 않음)</a:t>
             </a:r>
           </a:p>
         </p:txBody>
@@ -31034,7 +31034,7 @@
         <p:spPr>
           <a:xfrm>
             <a:off x="6492240" y="1517904"/>
-            <a:ext cx="1005840" cy="621792"/>
+            <a:ext cx="1005840" cy="420624"/>
           </a:xfrm>
           <a:prstGeom prst="rect">
             <a:avLst/>
@@ -31076,7 +31076,7 @@
         <p:spPr>
           <a:xfrm>
             <a:off x="7498079" y="1517904"/>
-            <a:ext cx="987552" cy="621792"/>
+            <a:ext cx="987552" cy="420624"/>
           </a:xfrm>
           <a:prstGeom prst="rect">
             <a:avLst/>
@@ -31118,7 +31118,7 @@
         <p:spPr>
           <a:xfrm>
             <a:off x="8485632" y="1517904"/>
-            <a:ext cx="987552" cy="621792"/>
+            <a:ext cx="987552" cy="420624"/>
           </a:xfrm>
           <a:prstGeom prst="rect">
             <a:avLst/>
@@ -31160,7 +31160,7 @@
         <p:spPr>
           <a:xfrm>
             <a:off x="9473184" y="1517904"/>
-            <a:ext cx="2523744" cy="621792"/>
+            <a:ext cx="2523744" cy="420624"/>
           </a:xfrm>
           <a:prstGeom prst="rect">
             <a:avLst/>
@@ -31188,7 +31188,7 @@
                 <a:latin typeface="맑은 고딕"/>
                 <a:ea typeface="맑은 고딕"/>
               </a:rPr>
-              <a:t>교차: 정상 부하·P/D 경로는 2안(P5 직접 전달), 과부하는 1안(흐름 제어 기본 제공). E4</a:t>
+              <a:t>동등. 정책 P1~P5는 둘 다 표현 가능. 2안은 P/D 경로 P5를 수정 없이 전달하나 효과 미확인. E4</a:t>
             </a:r>
           </a:p>
         </p:txBody>
@@ -31201,8 +31201,8 @@
         </p:nvSpPr>
         <p:spPr>
           <a:xfrm>
-            <a:off x="6492240" y="2139696"/>
-            <a:ext cx="1005840" cy="621792"/>
+            <a:off x="6492240" y="1938528"/>
+            <a:ext cx="1005840" cy="420624"/>
           </a:xfrm>
           <a:prstGeom prst="rect">
             <a:avLst/>
@@ -31243,8 +31243,8 @@
         </p:nvSpPr>
         <p:spPr>
           <a:xfrm>
-            <a:off x="7498079" y="2139696"/>
-            <a:ext cx="987552" cy="621792"/>
+            <a:off x="7498079" y="1938528"/>
+            <a:ext cx="987552" cy="420624"/>
           </a:xfrm>
           <a:prstGeom prst="rect">
             <a:avLst/>
@@ -31285,8 +31285,8 @@
         </p:nvSpPr>
         <p:spPr>
           <a:xfrm>
-            <a:off x="8485632" y="2139696"/>
-            <a:ext cx="987552" cy="621792"/>
+            <a:off x="8485632" y="1938528"/>
+            <a:ext cx="987552" cy="420624"/>
           </a:xfrm>
           <a:prstGeom prst="rect">
             <a:avLst/>
@@ -31327,8 +31327,8 @@
         </p:nvSpPr>
         <p:spPr>
           <a:xfrm>
-            <a:off x="9473184" y="2139696"/>
-            <a:ext cx="2523744" cy="621792"/>
+            <a:off x="9473184" y="1938528"/>
+            <a:ext cx="2523744" cy="420624"/>
           </a:xfrm>
           <a:prstGeom prst="rect">
             <a:avLst/>
@@ -31369,8 +31369,8 @@
         </p:nvSpPr>
         <p:spPr>
           <a:xfrm>
-            <a:off x="6492240" y="2761488"/>
-            <a:ext cx="1005840" cy="621792"/>
+            <a:off x="6492240" y="2359152"/>
+            <a:ext cx="1005840" cy="420624"/>
           </a:xfrm>
           <a:prstGeom prst="rect">
             <a:avLst/>
@@ -31411,8 +31411,8 @@
         </p:nvSpPr>
         <p:spPr>
           <a:xfrm>
-            <a:off x="7498079" y="2761488"/>
-            <a:ext cx="987552" cy="621792"/>
+            <a:off x="7498079" y="2359152"/>
+            <a:ext cx="987552" cy="420624"/>
           </a:xfrm>
           <a:prstGeom prst="rect">
             <a:avLst/>
@@ -31453,8 +31453,50 @@
         </p:nvSpPr>
         <p:spPr>
           <a:xfrm>
-            <a:off x="8485632" y="2761488"/>
-            <a:ext cx="987552" cy="621792"/>
+            <a:off x="8485632" y="2359152"/>
+            <a:ext cx="987552" cy="420624"/>
+          </a:xfrm>
+          <a:prstGeom prst="rect">
+            <a:avLst/>
+          </a:prstGeom>
+          <a:solidFill>
+            <a:srgbClr val="FBE5D6"/>
+          </a:solidFill>
+          <a:ln w="6350">
+            <a:solidFill>
+              <a:srgbClr val="BFBFBF"/>
+            </a:solidFill>
+          </a:ln>
+          <a:effectLst/>
+        </p:spPr>
+        <p:txBody>
+          <a:bodyPr rtlCol="0" anchor="ctr" wrap="square" lIns="64008" tIns="27432" rIns="45720" bIns="27432"/>
+          <a:lstStyle/>
+          <a:p>
+            <a:pPr algn="ctr"/>
+            <a:r>
+              <a:rPr sz="1200" b="1">
+                <a:solidFill>
+                  <a:srgbClr val="C55A11"/>
+                </a:solidFill>
+                <a:latin typeface="맑은 고딕"/>
+                <a:ea typeface="맑은 고딕"/>
+              </a:rPr>
+              <a:t>●●●</a:t>
+            </a:r>
+          </a:p>
+        </p:txBody>
+      </p:sp>
+      <p:sp>
+        <p:nvSpPr>
+          <p:cNvPr id="150" name="Rectangle 149"/>
+          <p:cNvSpPr/>
+          <p:nvPr/>
+        </p:nvSpPr>
+        <p:spPr>
+          <a:xfrm>
+            <a:off x="9473184" y="2359152"/>
+            <a:ext cx="2523744" cy="420624"/>
           </a:xfrm>
           <a:prstGeom prst="rect">
             <a:avLst/>
@@ -31473,10 +31515,136 @@
           <a:bodyPr rtlCol="0" anchor="ctr" wrap="square" lIns="64008" tIns="27432" rIns="45720" bIns="27432"/>
           <a:lstStyle/>
           <a:p>
+            <a:pPr algn="l"/>
+            <a:r>
+              <a:rPr sz="750" b="0">
+                <a:solidFill>
+                  <a:srgbClr val="000000"/>
+                </a:solidFill>
+                <a:latin typeface="맑은 고딕"/>
+                <a:ea typeface="맑은 고딕"/>
+              </a:rPr>
+              <a:t>2안: S2~S4를 한 코드베이스에서 변경. 1안은 S1(설정만)만 유리, S3·S4는 OSS 제약</a:t>
+            </a:r>
+          </a:p>
+        </p:txBody>
+      </p:sp>
+      <p:sp>
+        <p:nvSpPr>
+          <p:cNvPr id="151" name="Rectangle 150"/>
+          <p:cNvSpPr/>
+          <p:nvPr/>
+        </p:nvSpPr>
+        <p:spPr>
+          <a:xfrm>
+            <a:off x="6492240" y="2779776"/>
+            <a:ext cx="1005840" cy="420624"/>
+          </a:xfrm>
+          <a:prstGeom prst="rect">
+            <a:avLst/>
+          </a:prstGeom>
+          <a:solidFill>
+            <a:srgbClr val="F2F2F2"/>
+          </a:solidFill>
+          <a:ln w="6350">
+            <a:solidFill>
+              <a:srgbClr val="BFBFBF"/>
+            </a:solidFill>
+          </a:ln>
+          <a:effectLst/>
+        </p:spPr>
+        <p:txBody>
+          <a:bodyPr rtlCol="0" anchor="ctr" wrap="square" lIns="64008" tIns="27432" rIns="45720" bIns="27432"/>
+          <a:lstStyle/>
+          <a:p>
+            <a:pPr algn="l"/>
+            <a:r>
+              <a:rPr sz="850" b="1">
+                <a:solidFill>
+                  <a:srgbClr val="000000"/>
+                </a:solidFill>
+                <a:latin typeface="맑은 고딕"/>
+                <a:ea typeface="맑은 고딕"/>
+              </a:rPr>
+              <a:t>Q4 확장성</a:t>
+            </a:r>
+          </a:p>
+        </p:txBody>
+      </p:sp>
+      <p:sp>
+        <p:nvSpPr>
+          <p:cNvPr id="152" name="Rectangle 151"/>
+          <p:cNvSpPr/>
+          <p:nvPr/>
+        </p:nvSpPr>
+        <p:spPr>
+          <a:xfrm>
+            <a:off x="7498079" y="2779776"/>
+            <a:ext cx="987552" cy="420624"/>
+          </a:xfrm>
+          <a:prstGeom prst="rect">
+            <a:avLst/>
+          </a:prstGeom>
+          <a:solidFill>
+            <a:srgbClr val="DAE3F3"/>
+          </a:solidFill>
+          <a:ln w="6350">
+            <a:solidFill>
+              <a:srgbClr val="BFBFBF"/>
+            </a:solidFill>
+          </a:ln>
+          <a:effectLst/>
+        </p:spPr>
+        <p:txBody>
+          <a:bodyPr rtlCol="0" anchor="ctr" wrap="square" lIns="64008" tIns="27432" rIns="45720" bIns="27432"/>
+          <a:lstStyle/>
+          <a:p>
             <a:pPr algn="ctr"/>
             <a:r>
               <a:rPr sz="1200" b="1">
                 <a:solidFill>
+                  <a:srgbClr val="2F5597"/>
+                </a:solidFill>
+                <a:latin typeface="맑은 고딕"/>
+                <a:ea typeface="맑은 고딕"/>
+              </a:rPr>
+              <a:t>●●●</a:t>
+            </a:r>
+          </a:p>
+        </p:txBody>
+      </p:sp>
+      <p:sp>
+        <p:nvSpPr>
+          <p:cNvPr id="153" name="Rectangle 152"/>
+          <p:cNvSpPr/>
+          <p:nvPr/>
+        </p:nvSpPr>
+        <p:spPr>
+          <a:xfrm>
+            <a:off x="8485632" y="2779776"/>
+            <a:ext cx="987552" cy="420624"/>
+          </a:xfrm>
+          <a:prstGeom prst="rect">
+            <a:avLst/>
+          </a:prstGeom>
+          <a:solidFill>
+            <a:srgbClr val="FFFFFF"/>
+          </a:solidFill>
+          <a:ln w="6350">
+            <a:solidFill>
+              <a:srgbClr val="BFBFBF"/>
+            </a:solidFill>
+          </a:ln>
+          <a:effectLst/>
+        </p:spPr>
+        <p:txBody>
+          <a:bodyPr rtlCol="0" anchor="ctr" wrap="square" lIns="64008" tIns="27432" rIns="45720" bIns="27432"/>
+          <a:lstStyle/>
+          <a:p>
+            <a:pPr algn="ctr"/>
+            <a:r>
+              <a:rPr sz="1200" b="1">
+                <a:solidFill>
                   <a:srgbClr val="C55A11"/>
                 </a:solidFill>
                 <a:latin typeface="맑은 고딕"/>
@@ -31489,14 +31657,14 @@
       </p:sp>
       <p:sp>
         <p:nvSpPr>
-          <p:cNvPr id="150" name="Rectangle 149"/>
-          <p:cNvSpPr/>
-          <p:nvPr/>
-        </p:nvSpPr>
-        <p:spPr>
-          <a:xfrm>
-            <a:off x="9473184" y="2761488"/>
-            <a:ext cx="2523744" cy="621792"/>
+          <p:cNvPr id="154" name="Rectangle 153"/>
+          <p:cNvSpPr/>
+          <p:nvPr/>
+        </p:nvSpPr>
+        <p:spPr>
+          <a:xfrm>
+            <a:off x="9473184" y="2779776"/>
+            <a:ext cx="2523744" cy="420624"/>
           </a:xfrm>
           <a:prstGeom prst="rect">
             <a:avLst/>
@@ -31524,21 +31692,21 @@
                 <a:latin typeface="맑은 고딕"/>
                 <a:ea typeface="맑은 고딕"/>
               </a:rPr>
-              <a:t>S1·S5·S6은 1안, S2·S3·S4는 2안 (3:3). 변경의 성격이 다름: 흡수 vs 통제</a:t>
-            </a:r>
-          </a:p>
-        </p:txBody>
-      </p:sp>
-      <p:sp>
-        <p:nvSpPr>
-          <p:cNvPr id="151" name="Rectangle 150"/>
-          <p:cNvSpPr/>
-          <p:nvPr/>
-        </p:nvSpPr>
-        <p:spPr>
-          <a:xfrm>
-            <a:off x="6492240" y="3383280"/>
-            <a:ext cx="1005840" cy="621792"/>
+              <a:t>1안: K8s 복제·서버 풀·흐름 제어 검증됨. 2안: 레플리카·HA 직접 구축, 2노드 실측 불가</a:t>
+            </a:r>
+          </a:p>
+        </p:txBody>
+      </p:sp>
+      <p:sp>
+        <p:nvSpPr>
+          <p:cNvPr id="155" name="Rectangle 154"/>
+          <p:cNvSpPr/>
+          <p:nvPr/>
+        </p:nvSpPr>
+        <p:spPr>
+          <a:xfrm>
+            <a:off x="6492240" y="3200400"/>
+            <a:ext cx="1005840" cy="256032"/>
           </a:xfrm>
           <a:prstGeom prst="rect">
             <a:avLst/>
@@ -31566,27 +31734,27 @@
                 <a:latin typeface="맑은 고딕"/>
                 <a:ea typeface="맑은 고딕"/>
               </a:rPr>
-              <a:t>Q4 확장성</a:t>
-            </a:r>
-          </a:p>
-        </p:txBody>
-      </p:sp>
-      <p:sp>
-        <p:nvSpPr>
-          <p:cNvPr id="152" name="Rectangle 151"/>
-          <p:cNvSpPr/>
-          <p:nvPr/>
-        </p:nvSpPr>
-        <p:spPr>
-          <a:xfrm>
-            <a:off x="7498079" y="3383280"/>
-            <a:ext cx="987552" cy="621792"/>
-          </a:xfrm>
-          <a:prstGeom prst="rect">
-            <a:avLst/>
-          </a:prstGeom>
-          <a:solidFill>
-            <a:srgbClr val="DAE3F3"/>
+              <a:t>별 합계</a:t>
+            </a:r>
+          </a:p>
+        </p:txBody>
+      </p:sp>
+      <p:sp>
+        <p:nvSpPr>
+          <p:cNvPr id="156" name="Rectangle 155"/>
+          <p:cNvSpPr/>
+          <p:nvPr/>
+        </p:nvSpPr>
+        <p:spPr>
+          <a:xfrm>
+            <a:off x="7498079" y="3200400"/>
+            <a:ext cx="987552" cy="256032"/>
+          </a:xfrm>
+          <a:prstGeom prst="rect">
+            <a:avLst/>
+          </a:prstGeom>
+          <a:solidFill>
+            <a:srgbClr val="FFFFFF"/>
           </a:solidFill>
           <a:ln w="6350">
             <a:solidFill>
@@ -31601,28 +31769,28 @@
           <a:p>
             <a:pPr algn="ctr"/>
             <a:r>
-              <a:rPr sz="1200" b="1">
+              <a:rPr sz="1000" b="1">
                 <a:solidFill>
                   <a:srgbClr val="2F5597"/>
                 </a:solidFill>
                 <a:latin typeface="맑은 고딕"/>
                 <a:ea typeface="맑은 고딕"/>
               </a:rPr>
-              <a:t>●●●</a:t>
-            </a:r>
-          </a:p>
-        </p:txBody>
-      </p:sp>
-      <p:sp>
-        <p:nvSpPr>
-          <p:cNvPr id="153" name="Rectangle 152"/>
-          <p:cNvSpPr/>
-          <p:nvPr/>
-        </p:nvSpPr>
-        <p:spPr>
-          <a:xfrm>
-            <a:off x="8485632" y="3383280"/>
-            <a:ext cx="987552" cy="621792"/>
+              <a:t>9 / 12</a:t>
+            </a:r>
+          </a:p>
+        </p:txBody>
+      </p:sp>
+      <p:sp>
+        <p:nvSpPr>
+          <p:cNvPr id="157" name="Rectangle 156"/>
+          <p:cNvSpPr/>
+          <p:nvPr/>
+        </p:nvSpPr>
+        <p:spPr>
+          <a:xfrm>
+            <a:off x="8485632" y="3200400"/>
+            <a:ext cx="987552" cy="256032"/>
           </a:xfrm>
           <a:prstGeom prst="rect">
             <a:avLst/>
@@ -31643,28 +31811,28 @@
           <a:p>
             <a:pPr algn="ctr"/>
             <a:r>
-              <a:rPr sz="1200" b="1">
+              <a:rPr sz="1000" b="1">
                 <a:solidFill>
                   <a:srgbClr val="C55A11"/>
                 </a:solidFill>
                 <a:latin typeface="맑은 고딕"/>
                 <a:ea typeface="맑은 고딕"/>
               </a:rPr>
-              <a:t>●●○</a:t>
-            </a:r>
-          </a:p>
-        </p:txBody>
-      </p:sp>
-      <p:sp>
-        <p:nvSpPr>
-          <p:cNvPr id="154" name="Rectangle 153"/>
-          <p:cNvSpPr/>
-          <p:nvPr/>
-        </p:nvSpPr>
-        <p:spPr>
-          <a:xfrm>
-            <a:off x="9473184" y="3383280"/>
-            <a:ext cx="2523744" cy="621792"/>
+              <a:t>10 / 12</a:t>
+            </a:r>
+          </a:p>
+        </p:txBody>
+      </p:sp>
+      <p:sp>
+        <p:nvSpPr>
+          <p:cNvPr id="158" name="Rectangle 157"/>
+          <p:cNvSpPr/>
+          <p:nvPr/>
+        </p:nvSpPr>
+        <p:spPr>
+          <a:xfrm>
+            <a:off x="9473184" y="3200400"/>
+            <a:ext cx="2523744" cy="256032"/>
           </a:xfrm>
           <a:prstGeom prst="rect">
             <a:avLst/>
@@ -31685,182 +31853,14 @@
           <a:p>
             <a:pPr algn="l"/>
             <a:r>
-              <a:rPr sz="750" b="0">
-                <a:solidFill>
-                  <a:srgbClr val="000000"/>
-                </a:solidFill>
-                <a:latin typeface="맑은 고딕"/>
-                <a:ea typeface="맑은 고딕"/>
-              </a:rPr>
-              <a:t>1안: K8s 복제·서버 풀·흐름 제어 검증됨. 2안: 레플리카·HA·sync 직접 구축, 2노드 실측 불가</a:t>
-            </a:r>
-          </a:p>
-        </p:txBody>
-      </p:sp>
-      <p:sp>
-        <p:nvSpPr>
-          <p:cNvPr id="155" name="Rectangle 154"/>
-          <p:cNvSpPr/>
-          <p:nvPr/>
-        </p:nvSpPr>
-        <p:spPr>
-          <a:xfrm>
-            <a:off x="6492240" y="4005072"/>
-            <a:ext cx="1005840" cy="310896"/>
-          </a:xfrm>
-          <a:prstGeom prst="rect">
-            <a:avLst/>
-          </a:prstGeom>
-          <a:solidFill>
-            <a:srgbClr val="F2F2F2"/>
-          </a:solidFill>
-          <a:ln w="6350">
-            <a:solidFill>
-              <a:srgbClr val="BFBFBF"/>
-            </a:solidFill>
-          </a:ln>
-          <a:effectLst/>
-        </p:spPr>
-        <p:txBody>
-          <a:bodyPr rtlCol="0" anchor="ctr" wrap="square" lIns="64008" tIns="27432" rIns="45720" bIns="27432"/>
-          <a:lstStyle/>
-          <a:p>
-            <a:pPr algn="l"/>
-            <a:r>
-              <a:rPr sz="850" b="1">
-                <a:solidFill>
-                  <a:srgbClr val="000000"/>
-                </a:solidFill>
-                <a:latin typeface="맑은 고딕"/>
-                <a:ea typeface="맑은 고딕"/>
-              </a:rPr>
-              <a:t>별 합계</a:t>
-            </a:r>
-          </a:p>
-        </p:txBody>
-      </p:sp>
-      <p:sp>
-        <p:nvSpPr>
-          <p:cNvPr id="156" name="Rectangle 155"/>
-          <p:cNvSpPr/>
-          <p:nvPr/>
-        </p:nvSpPr>
-        <p:spPr>
-          <a:xfrm>
-            <a:off x="7498079" y="4005072"/>
-            <a:ext cx="987552" cy="310896"/>
-          </a:xfrm>
-          <a:prstGeom prst="rect">
-            <a:avLst/>
-          </a:prstGeom>
-          <a:solidFill>
-            <a:srgbClr val="FFFFFF"/>
-          </a:solidFill>
-          <a:ln w="6350">
-            <a:solidFill>
-              <a:srgbClr val="BFBFBF"/>
-            </a:solidFill>
-          </a:ln>
-          <a:effectLst/>
-        </p:spPr>
-        <p:txBody>
-          <a:bodyPr rtlCol="0" anchor="ctr" wrap="square" lIns="64008" tIns="27432" rIns="45720" bIns="27432"/>
-          <a:lstStyle/>
-          <a:p>
-            <a:pPr algn="ctr"/>
-            <a:r>
-              <a:rPr sz="1000" b="1">
-                <a:solidFill>
-                  <a:srgbClr val="2F5597"/>
-                </a:solidFill>
-                <a:latin typeface="맑은 고딕"/>
-                <a:ea typeface="맑은 고딕"/>
-              </a:rPr>
-              <a:t>9 / 12</a:t>
-            </a:r>
-          </a:p>
-        </p:txBody>
-      </p:sp>
-      <p:sp>
-        <p:nvSpPr>
-          <p:cNvPr id="157" name="Rectangle 156"/>
-          <p:cNvSpPr/>
-          <p:nvPr/>
-        </p:nvSpPr>
-        <p:spPr>
-          <a:xfrm>
-            <a:off x="8485632" y="4005072"/>
-            <a:ext cx="987552" cy="310896"/>
-          </a:xfrm>
-          <a:prstGeom prst="rect">
-            <a:avLst/>
-          </a:prstGeom>
-          <a:solidFill>
-            <a:srgbClr val="FFFFFF"/>
-          </a:solidFill>
-          <a:ln w="6350">
-            <a:solidFill>
-              <a:srgbClr val="BFBFBF"/>
-            </a:solidFill>
-          </a:ln>
-          <a:effectLst/>
-        </p:spPr>
-        <p:txBody>
-          <a:bodyPr rtlCol="0" anchor="ctr" wrap="square" lIns="64008" tIns="27432" rIns="45720" bIns="27432"/>
-          <a:lstStyle/>
-          <a:p>
-            <a:pPr algn="ctr"/>
-            <a:r>
-              <a:rPr sz="1000" b="1">
+              <a:rPr sz="800" b="1">
                 <a:solidFill>
                   <a:srgbClr val="C55A11"/>
                 </a:solidFill>
                 <a:latin typeface="맑은 고딕"/>
                 <a:ea typeface="맑은 고딕"/>
               </a:rPr>
-              <a:t>9 / 12</a:t>
-            </a:r>
-          </a:p>
-        </p:txBody>
-      </p:sp>
-      <p:sp>
-        <p:nvSpPr>
-          <p:cNvPr id="158" name="Rectangle 157"/>
-          <p:cNvSpPr/>
-          <p:nvPr/>
-        </p:nvSpPr>
-        <p:spPr>
-          <a:xfrm>
-            <a:off x="9473184" y="4005072"/>
-            <a:ext cx="2523744" cy="310896"/>
-          </a:xfrm>
-          <a:prstGeom prst="rect">
-            <a:avLst/>
-          </a:prstGeom>
-          <a:solidFill>
-            <a:srgbClr val="FFFFFF"/>
-          </a:solidFill>
-          <a:ln w="6350">
-            <a:solidFill>
-              <a:srgbClr val="BFBFBF"/>
-            </a:solidFill>
-          </a:ln>
-          <a:effectLst/>
-        </p:spPr>
-        <p:txBody>
-          <a:bodyPr rtlCol="0" anchor="ctr" wrap="square" lIns="64008" tIns="27432" rIns="45720" bIns="27432"/>
-          <a:lstStyle/>
-          <a:p>
-            <a:pPr algn="l"/>
-            <a:r>
-              <a:rPr sz="750" b="1">
-                <a:solidFill>
-                  <a:srgbClr val="C00000"/>
-                </a:solidFill>
-                <a:latin typeface="맑은 고딕"/>
-                <a:ea typeface="맑은 고딕"/>
-              </a:rPr>
-              <a:t>동점 → QA만으로는 우열 없음 (QA 우선순위 미정)</a:t>
+              <a:t>QA는 2안이 근소 우위 (1점 차)</a:t>
             </a:r>
           </a:p>
         </p:txBody>
@@ -31873,7 +31873,7 @@
         </p:nvSpPr>
         <p:spPr>
           <a:xfrm>
-            <a:off x="6492240" y="4389120"/>
+            <a:off x="6492240" y="3483864"/>
             <a:ext cx="5504688" cy="182880"/>
           </a:xfrm>
           <a:prstGeom prst="rect">
@@ -31896,7 +31896,7 @@
                 <a:latin typeface="맑은 고딕"/>
                 <a:ea typeface="맑은 고딕"/>
               </a:rPr>
-              <a:t>QA 밖 비용 (프로젝트 제약)</a:t>
+              <a:t>보조지표: 비용 · 리스크 (별점 없음, 우위만 표시)</a:t>
             </a:r>
           </a:p>
         </p:txBody>
@@ -31909,8 +31909,8 @@
         </p:nvSpPr>
         <p:spPr>
           <a:xfrm>
-            <a:off x="6492240" y="4590288"/>
-            <a:ext cx="1005840" cy="329184"/>
+            <a:off x="6492240" y="3685032"/>
+            <a:ext cx="530352" cy="274320"/>
           </a:xfrm>
           <a:prstGeom prst="rect">
             <a:avLst/>
@@ -31929,6 +31929,48 @@
           <a:bodyPr rtlCol="0" anchor="ctr" wrap="square" lIns="64008" tIns="27432" rIns="45720" bIns="27432"/>
           <a:lstStyle/>
           <a:p>
+            <a:pPr algn="ctr"/>
+            <a:r>
+              <a:rPr sz="800" b="1">
+                <a:solidFill>
+                  <a:srgbClr val="000000"/>
+                </a:solidFill>
+                <a:latin typeface="맑은 고딕"/>
+                <a:ea typeface="맑은 고딕"/>
+              </a:rPr>
+              <a:t>비용</a:t>
+            </a:r>
+          </a:p>
+        </p:txBody>
+      </p:sp>
+      <p:sp>
+        <p:nvSpPr>
+          <p:cNvPr id="161" name="Rectangle 160"/>
+          <p:cNvSpPr/>
+          <p:nvPr/>
+        </p:nvSpPr>
+        <p:spPr>
+          <a:xfrm>
+            <a:off x="7022592" y="3685032"/>
+            <a:ext cx="777240" cy="274320"/>
+          </a:xfrm>
+          <a:prstGeom prst="rect">
+            <a:avLst/>
+          </a:prstGeom>
+          <a:solidFill>
+            <a:srgbClr val="F2F2F2"/>
+          </a:solidFill>
+          <a:ln w="6350">
+            <a:solidFill>
+              <a:srgbClr val="BFBFBF"/>
+            </a:solidFill>
+          </a:ln>
+          <a:effectLst/>
+        </p:spPr>
+        <p:txBody>
+          <a:bodyPr rtlCol="0" anchor="ctr" wrap="square" lIns="64008" tIns="27432" rIns="45720" bIns="27432"/>
+          <a:lstStyle/>
+          <a:p>
             <a:pPr algn="l"/>
             <a:r>
               <a:rPr sz="800" b="1">
@@ -31938,21 +31980,63 @@
                 <a:latin typeface="맑은 고딕"/>
                 <a:ea typeface="맑은 고딕"/>
               </a:rPr>
-              <a:t>구현·개발 부담</a:t>
-            </a:r>
-          </a:p>
-        </p:txBody>
-      </p:sp>
-      <p:sp>
-        <p:nvSpPr>
-          <p:cNvPr id="161" name="Rectangle 160"/>
-          <p:cNvSpPr/>
-          <p:nvPr/>
-        </p:nvSpPr>
-        <p:spPr>
-          <a:xfrm>
-            <a:off x="7498079" y="4590288"/>
-            <a:ext cx="4498848" cy="329184"/>
+              <a:t>구현 부담</a:t>
+            </a:r>
+          </a:p>
+        </p:txBody>
+      </p:sp>
+      <p:sp>
+        <p:nvSpPr>
+          <p:cNvPr id="162" name="Rectangle 161"/>
+          <p:cNvSpPr/>
+          <p:nvPr/>
+        </p:nvSpPr>
+        <p:spPr>
+          <a:xfrm>
+            <a:off x="7799831" y="3685032"/>
+            <a:ext cx="1755648" cy="274320"/>
+          </a:xfrm>
+          <a:prstGeom prst="rect">
+            <a:avLst/>
+          </a:prstGeom>
+          <a:solidFill>
+            <a:srgbClr val="DAE3F3"/>
+          </a:solidFill>
+          <a:ln w="6350">
+            <a:solidFill>
+              <a:srgbClr val="BFBFBF"/>
+            </a:solidFill>
+          </a:ln>
+          <a:effectLst/>
+        </p:spPr>
+        <p:txBody>
+          <a:bodyPr rtlCol="0" anchor="ctr" wrap="square" lIns="64008" tIns="27432" rIns="45720" bIns="27432"/>
+          <a:lstStyle/>
+          <a:p>
+            <a:pPr algn="l"/>
+            <a:r>
+              <a:rPr sz="750" b="1">
+                <a:solidFill>
+                  <a:srgbClr val="2F5597"/>
+                </a:solidFill>
+                <a:latin typeface="맑은 고딕"/>
+                <a:ea typeface="맑은 고딕"/>
+              </a:rPr>
+              <a:t>소유 블록 3/6 + Router 이미지</a:t>
+            </a:r>
+          </a:p>
+        </p:txBody>
+      </p:sp>
+      <p:sp>
+        <p:nvSpPr>
+          <p:cNvPr id="163" name="Rectangle 162"/>
+          <p:cNvSpPr/>
+          <p:nvPr/>
+        </p:nvSpPr>
+        <p:spPr>
+          <a:xfrm>
+            <a:off x="9555480" y="3685032"/>
+            <a:ext cx="1737360" cy="274320"/>
           </a:xfrm>
           <a:prstGeom prst="rect">
             <a:avLst/>
@@ -31973,48 +32057,270 @@
           <a:p>
             <a:pPr algn="l"/>
             <a:r>
+              <a:rPr sz="750" b="0">
+                <a:solidFill>
+                  <a:srgbClr val="C55A11"/>
+                </a:solidFill>
+                <a:latin typeface="맑은 고딕"/>
+                <a:ea typeface="맑은 고딕"/>
+              </a:rPr>
+              <a:t>6/6 + 레플리카·HA·흐름 제어</a:t>
+            </a:r>
+          </a:p>
+        </p:txBody>
+      </p:sp>
+      <p:sp>
+        <p:nvSpPr>
+          <p:cNvPr id="164" name="Rectangle 163"/>
+          <p:cNvSpPr/>
+          <p:nvPr/>
+        </p:nvSpPr>
+        <p:spPr>
+          <a:xfrm>
+            <a:off x="11292840" y="3685032"/>
+            <a:ext cx="704088" cy="274320"/>
+          </a:xfrm>
+          <a:prstGeom prst="rect">
+            <a:avLst/>
+          </a:prstGeom>
+          <a:solidFill>
+            <a:srgbClr val="DAE3F3"/>
+          </a:solidFill>
+          <a:ln w="6350">
+            <a:solidFill>
+              <a:srgbClr val="BFBFBF"/>
+            </a:solidFill>
+          </a:ln>
+          <a:effectLst/>
+        </p:spPr>
+        <p:txBody>
+          <a:bodyPr rtlCol="0" anchor="ctr" wrap="square" lIns="64008" tIns="27432" rIns="45720" bIns="27432"/>
+          <a:lstStyle/>
+          <a:p>
+            <a:pPr algn="ctr"/>
+            <a:r>
+              <a:rPr sz="750" b="1">
+                <a:solidFill>
+                  <a:srgbClr val="2F5597"/>
+                </a:solidFill>
+                <a:latin typeface="맑은 고딕"/>
+                <a:ea typeface="맑은 고딕"/>
+              </a:rPr>
+              <a:t>1안 유리</a:t>
+            </a:r>
+          </a:p>
+        </p:txBody>
+      </p:sp>
+      <p:sp>
+        <p:nvSpPr>
+          <p:cNvPr id="165" name="Rectangle 164"/>
+          <p:cNvSpPr/>
+          <p:nvPr/>
+        </p:nvSpPr>
+        <p:spPr>
+          <a:xfrm>
+            <a:off x="6492240" y="3959352"/>
+            <a:ext cx="530352" cy="274320"/>
+          </a:xfrm>
+          <a:prstGeom prst="rect">
+            <a:avLst/>
+          </a:prstGeom>
+          <a:solidFill>
+            <a:srgbClr val="F2F2F2"/>
+          </a:solidFill>
+          <a:ln w="6350">
+            <a:solidFill>
+              <a:srgbClr val="BFBFBF"/>
+            </a:solidFill>
+          </a:ln>
+          <a:effectLst/>
+        </p:spPr>
+        <p:txBody>
+          <a:bodyPr rtlCol="0" anchor="ctr"/>
+          <a:lstStyle/>
+          <a:p>
+            <a:pPr algn="ctr"/>
+          </a:p>
+        </p:txBody>
+      </p:sp>
+      <p:sp>
+        <p:nvSpPr>
+          <p:cNvPr id="166" name="Rectangle 165"/>
+          <p:cNvSpPr/>
+          <p:nvPr/>
+        </p:nvSpPr>
+        <p:spPr>
+          <a:xfrm>
+            <a:off x="7022592" y="3959352"/>
+            <a:ext cx="777240" cy="274320"/>
+          </a:xfrm>
+          <a:prstGeom prst="rect">
+            <a:avLst/>
+          </a:prstGeom>
+          <a:solidFill>
+            <a:srgbClr val="F2F2F2"/>
+          </a:solidFill>
+          <a:ln w="6350">
+            <a:solidFill>
+              <a:srgbClr val="BFBFBF"/>
+            </a:solidFill>
+          </a:ln>
+          <a:effectLst/>
+        </p:spPr>
+        <p:txBody>
+          <a:bodyPr rtlCol="0" anchor="ctr" wrap="square" lIns="64008" tIns="27432" rIns="45720" bIns="27432"/>
+          <a:lstStyle/>
+          <a:p>
+            <a:pPr algn="l"/>
+            <a:r>
               <a:rPr sz="800" b="1">
                 <a:solidFill>
+                  <a:srgbClr val="000000"/>
+                </a:solidFill>
+                <a:latin typeface="맑은 고딕"/>
+                <a:ea typeface="맑은 고딕"/>
+              </a:rPr>
+              <a:t>유지 부담</a:t>
+            </a:r>
+          </a:p>
+        </p:txBody>
+      </p:sp>
+      <p:sp>
+        <p:nvSpPr>
+          <p:cNvPr id="167" name="Rectangle 166"/>
+          <p:cNvSpPr/>
+          <p:nvPr/>
+        </p:nvSpPr>
+        <p:spPr>
+          <a:xfrm>
+            <a:off x="7799831" y="3959352"/>
+            <a:ext cx="1755648" cy="274320"/>
+          </a:xfrm>
+          <a:prstGeom prst="rect">
+            <a:avLst/>
+          </a:prstGeom>
+          <a:solidFill>
+            <a:srgbClr val="DAE3F3"/>
+          </a:solidFill>
+          <a:ln w="6350">
+            <a:solidFill>
+              <a:srgbClr val="BFBFBF"/>
+            </a:solidFill>
+          </a:ln>
+          <a:effectLst/>
+        </p:spPr>
+        <p:txBody>
+          <a:bodyPr rtlCol="0" anchor="ctr" wrap="square" lIns="64008" tIns="27432" rIns="45720" bIns="27432"/>
+          <a:lstStyle/>
+          <a:p>
+            <a:pPr algn="l"/>
+            <a:r>
+              <a:rPr sz="750" b="1">
+                <a:solidFill>
                   <a:srgbClr val="2F5597"/>
                 </a:solidFill>
                 <a:latin typeface="맑은 고딕"/>
                 <a:ea typeface="맑은 고딕"/>
               </a:rPr>
-              <a:t>1안 유리 — 우리 소유 블록 3/6</a:t>
-            </a:r>
-            <a:r>
-              <a:rPr sz="800" b="0">
-                <a:solidFill>
-                  <a:srgbClr val="7F7F7F"/>
-                </a:solidFill>
-                <a:latin typeface="맑은 고딕"/>
-                <a:ea typeface="맑은 고딕"/>
-              </a:rPr>
-              <a:t>   |   </a:t>
-            </a:r>
-            <a:r>
-              <a:rPr sz="800" b="0">
+              <a:t>계약·신기능은 OSS가 흡수, 우리 수정분만 재적용</a:t>
+            </a:r>
+          </a:p>
+        </p:txBody>
+      </p:sp>
+      <p:sp>
+        <p:nvSpPr>
+          <p:cNvPr id="168" name="Rectangle 167"/>
+          <p:cNvSpPr/>
+          <p:nvPr/>
+        </p:nvSpPr>
+        <p:spPr>
+          <a:xfrm>
+            <a:off x="9555480" y="3959352"/>
+            <a:ext cx="1737360" cy="274320"/>
+          </a:xfrm>
+          <a:prstGeom prst="rect">
+            <a:avLst/>
+          </a:prstGeom>
+          <a:solidFill>
+            <a:srgbClr val="FFFFFF"/>
+          </a:solidFill>
+          <a:ln w="6350">
+            <a:solidFill>
+              <a:srgbClr val="BFBFBF"/>
+            </a:solidFill>
+          </a:ln>
+          <a:effectLst/>
+        </p:spPr>
+        <p:txBody>
+          <a:bodyPr rtlCol="0" anchor="ctr" wrap="square" lIns="64008" tIns="27432" rIns="45720" bIns="27432"/>
+          <a:lstStyle/>
+          <a:p>
+            <a:pPr algn="l"/>
+            <a:r>
+              <a:rPr sz="750" b="0">
                 <a:solidFill>
                   <a:srgbClr val="C55A11"/>
                 </a:solidFill>
                 <a:latin typeface="맑은 고딕"/>
                 <a:ea typeface="맑은 고딕"/>
               </a:rPr>
-              <a:t>2안 불리 — 6/6 + 레플리카·HA</a:t>
-            </a:r>
-          </a:p>
-        </p:txBody>
-      </p:sp>
-      <p:sp>
-        <p:nvSpPr>
-          <p:cNvPr id="162" name="Rectangle 161"/>
-          <p:cNvSpPr/>
-          <p:nvPr/>
-        </p:nvSpPr>
-        <p:spPr>
-          <a:xfrm>
-            <a:off x="6492240" y="4919472"/>
-            <a:ext cx="1005840" cy="329184"/>
+              <a:t>계약 추종·신기능 전부 직접</a:t>
+            </a:r>
+          </a:p>
+        </p:txBody>
+      </p:sp>
+      <p:sp>
+        <p:nvSpPr>
+          <p:cNvPr id="169" name="Rectangle 168"/>
+          <p:cNvSpPr/>
+          <p:nvPr/>
+        </p:nvSpPr>
+        <p:spPr>
+          <a:xfrm>
+            <a:off x="11292840" y="3959352"/>
+            <a:ext cx="704088" cy="274320"/>
+          </a:xfrm>
+          <a:prstGeom prst="rect">
+            <a:avLst/>
+          </a:prstGeom>
+          <a:solidFill>
+            <a:srgbClr val="DAE3F3"/>
+          </a:solidFill>
+          <a:ln w="6350">
+            <a:solidFill>
+              <a:srgbClr val="BFBFBF"/>
+            </a:solidFill>
+          </a:ln>
+          <a:effectLst/>
+        </p:spPr>
+        <p:txBody>
+          <a:bodyPr rtlCol="0" anchor="ctr" wrap="square" lIns="64008" tIns="27432" rIns="45720" bIns="27432"/>
+          <a:lstStyle/>
+          <a:p>
+            <a:pPr algn="ctr"/>
+            <a:r>
+              <a:rPr sz="750" b="1">
+                <a:solidFill>
+                  <a:srgbClr val="2F5597"/>
+                </a:solidFill>
+                <a:latin typeface="맑은 고딕"/>
+                <a:ea typeface="맑은 고딕"/>
+              </a:rPr>
+              <a:t>1안 유리</a:t>
+            </a:r>
+          </a:p>
+        </p:txBody>
+      </p:sp>
+      <p:sp>
+        <p:nvSpPr>
+          <p:cNvPr id="170" name="Rectangle 169"/>
+          <p:cNvSpPr/>
+          <p:nvPr/>
+        </p:nvSpPr>
+        <p:spPr>
+          <a:xfrm>
+            <a:off x="6492240" y="4233672"/>
+            <a:ext cx="530352" cy="274320"/>
           </a:xfrm>
           <a:prstGeom prst="rect">
             <a:avLst/>
@@ -32030,6 +32336,38 @@
           <a:effectLst/>
         </p:spPr>
         <p:txBody>
+          <a:bodyPr rtlCol="0" anchor="ctr"/>
+          <a:lstStyle/>
+          <a:p>
+            <a:pPr algn="ctr"/>
+          </a:p>
+        </p:txBody>
+      </p:sp>
+      <p:sp>
+        <p:nvSpPr>
+          <p:cNvPr id="171" name="Rectangle 170"/>
+          <p:cNvSpPr/>
+          <p:nvPr/>
+        </p:nvSpPr>
+        <p:spPr>
+          <a:xfrm>
+            <a:off x="7022592" y="4233672"/>
+            <a:ext cx="777240" cy="274320"/>
+          </a:xfrm>
+          <a:prstGeom prst="rect">
+            <a:avLst/>
+          </a:prstGeom>
+          <a:solidFill>
+            <a:srgbClr val="F2F2F2"/>
+          </a:solidFill>
+          <a:ln w="6350">
+            <a:solidFill>
+              <a:srgbClr val="BFBFBF"/>
+            </a:solidFill>
+          </a:ln>
+          <a:effectLst/>
+        </p:spPr>
+        <p:txBody>
           <a:bodyPr rtlCol="0" anchor="ctr" wrap="square" lIns="64008" tIns="27432" rIns="45720" bIns="27432"/>
           <a:lstStyle/>
           <a:p>
@@ -32042,21 +32380,21 @@
                 <a:latin typeface="맑은 고딕"/>
                 <a:ea typeface="맑은 고딕"/>
               </a:rPr>
-              <a:t>운영 환경 부담</a:t>
-            </a:r>
-          </a:p>
-        </p:txBody>
-      </p:sp>
-      <p:sp>
-        <p:nvSpPr>
-          <p:cNvPr id="163" name="Rectangle 162"/>
-          <p:cNvSpPr/>
-          <p:nvPr/>
-        </p:nvSpPr>
-        <p:spPr>
-          <a:xfrm>
-            <a:off x="7498079" y="4919472"/>
-            <a:ext cx="4498848" cy="329184"/>
+              <a:t>운영 환경</a:t>
+            </a:r>
+          </a:p>
+        </p:txBody>
+      </p:sp>
+      <p:sp>
+        <p:nvSpPr>
+          <p:cNvPr id="172" name="Rectangle 171"/>
+          <p:cNvSpPr/>
+          <p:nvPr/>
+        </p:nvSpPr>
+        <p:spPr>
+          <a:xfrm>
+            <a:off x="7799831" y="4233672"/>
+            <a:ext cx="1755648" cy="274320"/>
           </a:xfrm>
           <a:prstGeom prst="rect">
             <a:avLst/>
@@ -32077,48 +32415,722 @@
           <a:p>
             <a:pPr algn="l"/>
             <a:r>
-              <a:rPr sz="800" b="0">
+              <a:rPr sz="750" b="0">
                 <a:solidFill>
                   <a:srgbClr val="2F5597"/>
                 </a:solidFill>
                 <a:latin typeface="맑은 고딕"/>
                 <a:ea typeface="맑은 고딕"/>
               </a:rPr>
-              <a:t>1안 불리 — K8s·프록시·자체 Router 이미지(C2)</a:t>
-            </a:r>
-            <a:r>
-              <a:rPr sz="800" b="0">
-                <a:solidFill>
-                  <a:srgbClr val="7F7F7F"/>
-                </a:solidFill>
-                <a:latin typeface="맑은 고딕"/>
-                <a:ea typeface="맑은 고딕"/>
-              </a:rPr>
-              <a:t>   |   </a:t>
-            </a:r>
+              <a:t>K8s·프록시·자체 이미지 (C2)</a:t>
+            </a:r>
+          </a:p>
+        </p:txBody>
+      </p:sp>
+      <p:sp>
+        <p:nvSpPr>
+          <p:cNvPr id="173" name="Rectangle 172"/>
+          <p:cNvSpPr/>
+          <p:nvPr/>
+        </p:nvSpPr>
+        <p:spPr>
+          <a:xfrm>
+            <a:off x="9555480" y="4233672"/>
+            <a:ext cx="1737360" cy="274320"/>
+          </a:xfrm>
+          <a:prstGeom prst="rect">
+            <a:avLst/>
+          </a:prstGeom>
+          <a:solidFill>
+            <a:srgbClr val="FBE5D6"/>
+          </a:solidFill>
+          <a:ln w="6350">
+            <a:solidFill>
+              <a:srgbClr val="BFBFBF"/>
+            </a:solidFill>
+          </a:ln>
+          <a:effectLst/>
+        </p:spPr>
+        <p:txBody>
+          <a:bodyPr rtlCol="0" anchor="ctr" wrap="square" lIns="64008" tIns="27432" rIns="45720" bIns="27432"/>
+          <a:lstStyle/>
+          <a:p>
+            <a:pPr algn="l"/>
+            <a:r>
+              <a:rPr sz="750" b="1">
+                <a:solidFill>
+                  <a:srgbClr val="C55A11"/>
+                </a:solidFill>
+                <a:latin typeface="맑은 고딕"/>
+                <a:ea typeface="맑은 고딕"/>
+              </a:rPr>
+              <a:t>K8s·프록시 불필요</a:t>
+            </a:r>
+          </a:p>
+        </p:txBody>
+      </p:sp>
+      <p:sp>
+        <p:nvSpPr>
+          <p:cNvPr id="174" name="Rectangle 173"/>
+          <p:cNvSpPr/>
+          <p:nvPr/>
+        </p:nvSpPr>
+        <p:spPr>
+          <a:xfrm>
+            <a:off x="11292840" y="4233672"/>
+            <a:ext cx="704088" cy="274320"/>
+          </a:xfrm>
+          <a:prstGeom prst="rect">
+            <a:avLst/>
+          </a:prstGeom>
+          <a:solidFill>
+            <a:srgbClr val="FBE5D6"/>
+          </a:solidFill>
+          <a:ln w="6350">
+            <a:solidFill>
+              <a:srgbClr val="BFBFBF"/>
+            </a:solidFill>
+          </a:ln>
+          <a:effectLst/>
+        </p:spPr>
+        <p:txBody>
+          <a:bodyPr rtlCol="0" anchor="ctr" wrap="square" lIns="64008" tIns="27432" rIns="45720" bIns="27432"/>
+          <a:lstStyle/>
+          <a:p>
+            <a:pPr algn="ctr"/>
+            <a:r>
+              <a:rPr sz="750" b="1">
+                <a:solidFill>
+                  <a:srgbClr val="C55A11"/>
+                </a:solidFill>
+                <a:latin typeface="맑은 고딕"/>
+                <a:ea typeface="맑은 고딕"/>
+              </a:rPr>
+              <a:t>2안 유리</a:t>
+            </a:r>
+          </a:p>
+        </p:txBody>
+      </p:sp>
+      <p:sp>
+        <p:nvSpPr>
+          <p:cNvPr id="175" name="Rectangle 174"/>
+          <p:cNvSpPr/>
+          <p:nvPr/>
+        </p:nvSpPr>
+        <p:spPr>
+          <a:xfrm>
+            <a:off x="6492240" y="4507992"/>
+            <a:ext cx="530352" cy="274320"/>
+          </a:xfrm>
+          <a:prstGeom prst="rect">
+            <a:avLst/>
+          </a:prstGeom>
+          <a:solidFill>
+            <a:srgbClr val="F2F2F2"/>
+          </a:solidFill>
+          <a:ln w="6350">
+            <a:solidFill>
+              <a:srgbClr val="BFBFBF"/>
+            </a:solidFill>
+          </a:ln>
+          <a:effectLst/>
+        </p:spPr>
+        <p:txBody>
+          <a:bodyPr rtlCol="0" anchor="ctr" wrap="square" lIns="64008" tIns="27432" rIns="45720" bIns="27432"/>
+          <a:lstStyle/>
+          <a:p>
+            <a:pPr algn="ctr"/>
             <a:r>
               <a:rPr sz="800" b="1">
                 <a:solidFill>
+                  <a:srgbClr val="000000"/>
+                </a:solidFill>
+                <a:latin typeface="맑은 고딕"/>
+                <a:ea typeface="맑은 고딕"/>
+              </a:rPr>
+              <a:t>리스크</a:t>
+            </a:r>
+          </a:p>
+        </p:txBody>
+      </p:sp>
+      <p:sp>
+        <p:nvSpPr>
+          <p:cNvPr id="176" name="Rectangle 175"/>
+          <p:cNvSpPr/>
+          <p:nvPr/>
+        </p:nvSpPr>
+        <p:spPr>
+          <a:xfrm>
+            <a:off x="7022592" y="4507992"/>
+            <a:ext cx="777240" cy="274320"/>
+          </a:xfrm>
+          <a:prstGeom prst="rect">
+            <a:avLst/>
+          </a:prstGeom>
+          <a:solidFill>
+            <a:srgbClr val="F2F2F2"/>
+          </a:solidFill>
+          <a:ln w="6350">
+            <a:solidFill>
+              <a:srgbClr val="BFBFBF"/>
+            </a:solidFill>
+          </a:ln>
+          <a:effectLst/>
+        </p:spPr>
+        <p:txBody>
+          <a:bodyPr rtlCol="0" anchor="ctr" wrap="square" lIns="64008" tIns="27432" rIns="45720" bIns="27432"/>
+          <a:lstStyle/>
+          <a:p>
+            <a:pPr algn="l"/>
+            <a:r>
+              <a:rPr sz="800" b="1">
+                <a:solidFill>
+                  <a:srgbClr val="000000"/>
+                </a:solidFill>
+                <a:latin typeface="맑은 고딕"/>
+                <a:ea typeface="맑은 고딕"/>
+              </a:rPr>
+              <a:t>증거 수준</a:t>
+            </a:r>
+          </a:p>
+        </p:txBody>
+      </p:sp>
+      <p:sp>
+        <p:nvSpPr>
+          <p:cNvPr id="177" name="Rectangle 176"/>
+          <p:cNvSpPr/>
+          <p:nvPr/>
+        </p:nvSpPr>
+        <p:spPr>
+          <a:xfrm>
+            <a:off x="7799831" y="4507992"/>
+            <a:ext cx="1755648" cy="274320"/>
+          </a:xfrm>
+          <a:prstGeom prst="rect">
+            <a:avLst/>
+          </a:prstGeom>
+          <a:solidFill>
+            <a:srgbClr val="DAE3F3"/>
+          </a:solidFill>
+          <a:ln w="6350">
+            <a:solidFill>
+              <a:srgbClr val="BFBFBF"/>
+            </a:solidFill>
+          </a:ln>
+          <a:effectLst/>
+        </p:spPr>
+        <p:txBody>
+          <a:bodyPr rtlCol="0" anchor="ctr" wrap="square" lIns="64008" tIns="27432" rIns="45720" bIns="27432"/>
+          <a:lstStyle/>
+          <a:p>
+            <a:pPr algn="l"/>
+            <a:r>
+              <a:rPr sz="750" b="1">
+                <a:solidFill>
+                  <a:srgbClr val="2F5597"/>
+                </a:solidFill>
+                <a:latin typeface="맑은 고딕"/>
+                <a:ea typeface="맑은 고딕"/>
+              </a:rPr>
+              <a:t>P1~P4 끝단 실행 [A]</a:t>
+            </a:r>
+          </a:p>
+        </p:txBody>
+      </p:sp>
+      <p:sp>
+        <p:nvSpPr>
+          <p:cNvPr id="178" name="Rectangle 177"/>
+          <p:cNvSpPr/>
+          <p:nvPr/>
+        </p:nvSpPr>
+        <p:spPr>
+          <a:xfrm>
+            <a:off x="9555480" y="4507992"/>
+            <a:ext cx="1737360" cy="274320"/>
+          </a:xfrm>
+          <a:prstGeom prst="rect">
+            <a:avLst/>
+          </a:prstGeom>
+          <a:solidFill>
+            <a:srgbClr val="FFFFFF"/>
+          </a:solidFill>
+          <a:ln w="6350">
+            <a:solidFill>
+              <a:srgbClr val="BFBFBF"/>
+            </a:solidFill>
+          </a:ln>
+          <a:effectLst/>
+        </p:spPr>
+        <p:txBody>
+          <a:bodyPr rtlCol="0" anchor="ctr" wrap="square" lIns="64008" tIns="27432" rIns="45720" bIns="27432"/>
+          <a:lstStyle/>
+          <a:p>
+            <a:pPr algn="l"/>
+            <a:r>
+              <a:rPr sz="750" b="0">
+                <a:solidFill>
                   <a:srgbClr val="C55A11"/>
                 </a:solidFill>
                 <a:latin typeface="맑은 고딕"/>
                 <a:ea typeface="맑은 고딕"/>
               </a:rPr>
-              <a:t>2안 유리 — K8s·프록시 불필요</a:t>
-            </a:r>
-          </a:p>
-        </p:txBody>
-      </p:sp>
-      <p:sp>
-        <p:nvSpPr>
-          <p:cNvPr id="164" name="Rectangle 163"/>
-          <p:cNvSpPr/>
-          <p:nvPr/>
-        </p:nvSpPr>
-        <p:spPr>
-          <a:xfrm>
-            <a:off x="246888" y="5468112"/>
-            <a:ext cx="11750040" cy="786384"/>
+              <a:t>설계안, 미구현 [C]</a:t>
+            </a:r>
+          </a:p>
+        </p:txBody>
+      </p:sp>
+      <p:sp>
+        <p:nvSpPr>
+          <p:cNvPr id="179" name="Rectangle 178"/>
+          <p:cNvSpPr/>
+          <p:nvPr/>
+        </p:nvSpPr>
+        <p:spPr>
+          <a:xfrm>
+            <a:off x="11292840" y="4507992"/>
+            <a:ext cx="704088" cy="274320"/>
+          </a:xfrm>
+          <a:prstGeom prst="rect">
+            <a:avLst/>
+          </a:prstGeom>
+          <a:solidFill>
+            <a:srgbClr val="DAE3F3"/>
+          </a:solidFill>
+          <a:ln w="6350">
+            <a:solidFill>
+              <a:srgbClr val="BFBFBF"/>
+            </a:solidFill>
+          </a:ln>
+          <a:effectLst/>
+        </p:spPr>
+        <p:txBody>
+          <a:bodyPr rtlCol="0" anchor="ctr" wrap="square" lIns="64008" tIns="27432" rIns="45720" bIns="27432"/>
+          <a:lstStyle/>
+          <a:p>
+            <a:pPr algn="ctr"/>
+            <a:r>
+              <a:rPr sz="750" b="1">
+                <a:solidFill>
+                  <a:srgbClr val="2F5597"/>
+                </a:solidFill>
+                <a:latin typeface="맑은 고딕"/>
+                <a:ea typeface="맑은 고딕"/>
+              </a:rPr>
+              <a:t>1안 유리</a:t>
+            </a:r>
+          </a:p>
+        </p:txBody>
+      </p:sp>
+      <p:sp>
+        <p:nvSpPr>
+          <p:cNvPr id="180" name="Rectangle 179"/>
+          <p:cNvSpPr/>
+          <p:nvPr/>
+        </p:nvSpPr>
+        <p:spPr>
+          <a:xfrm>
+            <a:off x="6492240" y="4782312"/>
+            <a:ext cx="530352" cy="274320"/>
+          </a:xfrm>
+          <a:prstGeom prst="rect">
+            <a:avLst/>
+          </a:prstGeom>
+          <a:solidFill>
+            <a:srgbClr val="F2F2F2"/>
+          </a:solidFill>
+          <a:ln w="6350">
+            <a:solidFill>
+              <a:srgbClr val="BFBFBF"/>
+            </a:solidFill>
+          </a:ln>
+          <a:effectLst/>
+        </p:spPr>
+        <p:txBody>
+          <a:bodyPr rtlCol="0" anchor="ctr"/>
+          <a:lstStyle/>
+          <a:p>
+            <a:pPr algn="ctr"/>
+          </a:p>
+        </p:txBody>
+      </p:sp>
+      <p:sp>
+        <p:nvSpPr>
+          <p:cNvPr id="181" name="Rectangle 180"/>
+          <p:cNvSpPr/>
+          <p:nvPr/>
+        </p:nvSpPr>
+        <p:spPr>
+          <a:xfrm>
+            <a:off x="7022592" y="4782312"/>
+            <a:ext cx="777240" cy="274320"/>
+          </a:xfrm>
+          <a:prstGeom prst="rect">
+            <a:avLst/>
+          </a:prstGeom>
+          <a:solidFill>
+            <a:srgbClr val="F2F2F2"/>
+          </a:solidFill>
+          <a:ln w="6350">
+            <a:solidFill>
+              <a:srgbClr val="BFBFBF"/>
+            </a:solidFill>
+          </a:ln>
+          <a:effectLst/>
+        </p:spPr>
+        <p:txBody>
+          <a:bodyPr rtlCol="0" anchor="ctr" wrap="square" lIns="64008" tIns="27432" rIns="45720" bIns="27432"/>
+          <a:lstStyle/>
+          <a:p>
+            <a:pPr algn="l"/>
+            <a:r>
+              <a:rPr sz="800" b="1">
+                <a:solidFill>
+                  <a:srgbClr val="000000"/>
+                </a:solidFill>
+                <a:latin typeface="맑은 고딕"/>
+                <a:ea typeface="맑은 고딕"/>
+              </a:rPr>
+              <a:t>업스트림 의존</a:t>
+            </a:r>
+          </a:p>
+        </p:txBody>
+      </p:sp>
+      <p:sp>
+        <p:nvSpPr>
+          <p:cNvPr id="182" name="Rectangle 181"/>
+          <p:cNvSpPr/>
+          <p:nvPr/>
+        </p:nvSpPr>
+        <p:spPr>
+          <a:xfrm>
+            <a:off x="7799831" y="4782312"/>
+            <a:ext cx="1755648" cy="274320"/>
+          </a:xfrm>
+          <a:prstGeom prst="rect">
+            <a:avLst/>
+          </a:prstGeom>
+          <a:solidFill>
+            <a:srgbClr val="FFFFFF"/>
+          </a:solidFill>
+          <a:ln w="6350">
+            <a:solidFill>
+              <a:srgbClr val="BFBFBF"/>
+            </a:solidFill>
+          </a:ln>
+          <a:effectLst/>
+        </p:spPr>
+        <p:txBody>
+          <a:bodyPr rtlCol="0" anchor="ctr" wrap="square" lIns="64008" tIns="27432" rIns="45720" bIns="27432"/>
+          <a:lstStyle/>
+          <a:p>
+            <a:pPr algn="l"/>
+            <a:r>
+              <a:rPr sz="750" b="0">
+                <a:solidFill>
+                  <a:srgbClr val="2F5597"/>
+                </a:solidFill>
+                <a:latin typeface="맑은 고딕"/>
+                <a:ea typeface="맑은 고딕"/>
+              </a:rPr>
+              <a:t>wrapper·수정이 OSS 동작에 의존</a:t>
+            </a:r>
+          </a:p>
+        </p:txBody>
+      </p:sp>
+      <p:sp>
+        <p:nvSpPr>
+          <p:cNvPr id="183" name="Rectangle 182"/>
+          <p:cNvSpPr/>
+          <p:nvPr/>
+        </p:nvSpPr>
+        <p:spPr>
+          <a:xfrm>
+            <a:off x="9555480" y="4782312"/>
+            <a:ext cx="1737360" cy="274320"/>
+          </a:xfrm>
+          <a:prstGeom prst="rect">
+            <a:avLst/>
+          </a:prstGeom>
+          <a:solidFill>
+            <a:srgbClr val="FBE5D6"/>
+          </a:solidFill>
+          <a:ln w="6350">
+            <a:solidFill>
+              <a:srgbClr val="BFBFBF"/>
+            </a:solidFill>
+          </a:ln>
+          <a:effectLst/>
+        </p:spPr>
+        <p:txBody>
+          <a:bodyPr rtlCol="0" anchor="ctr" wrap="square" lIns="64008" tIns="27432" rIns="45720" bIns="27432"/>
+          <a:lstStyle/>
+          <a:p>
+            <a:pPr algn="l"/>
+            <a:r>
+              <a:rPr sz="750" b="1">
+                <a:solidFill>
+                  <a:srgbClr val="C55A11"/>
+                </a:solidFill>
+                <a:latin typeface="맑은 고딕"/>
+                <a:ea typeface="맑은 고딕"/>
+              </a:rPr>
+              <a:t>OSS 의존 없음 (vLLM 계약만)</a:t>
+            </a:r>
+          </a:p>
+        </p:txBody>
+      </p:sp>
+      <p:sp>
+        <p:nvSpPr>
+          <p:cNvPr id="184" name="Rectangle 183"/>
+          <p:cNvSpPr/>
+          <p:nvPr/>
+        </p:nvSpPr>
+        <p:spPr>
+          <a:xfrm>
+            <a:off x="11292840" y="4782312"/>
+            <a:ext cx="704088" cy="274320"/>
+          </a:xfrm>
+          <a:prstGeom prst="rect">
+            <a:avLst/>
+          </a:prstGeom>
+          <a:solidFill>
+            <a:srgbClr val="FBE5D6"/>
+          </a:solidFill>
+          <a:ln w="6350">
+            <a:solidFill>
+              <a:srgbClr val="BFBFBF"/>
+            </a:solidFill>
+          </a:ln>
+          <a:effectLst/>
+        </p:spPr>
+        <p:txBody>
+          <a:bodyPr rtlCol="0" anchor="ctr" wrap="square" lIns="64008" tIns="27432" rIns="45720" bIns="27432"/>
+          <a:lstStyle/>
+          <a:p>
+            <a:pPr algn="ctr"/>
+            <a:r>
+              <a:rPr sz="750" b="1">
+                <a:solidFill>
+                  <a:srgbClr val="C55A11"/>
+                </a:solidFill>
+                <a:latin typeface="맑은 고딕"/>
+                <a:ea typeface="맑은 고딕"/>
+              </a:rPr>
+              <a:t>2안 유리</a:t>
+            </a:r>
+          </a:p>
+        </p:txBody>
+      </p:sp>
+      <p:sp>
+        <p:nvSpPr>
+          <p:cNvPr id="185" name="Rectangle 184"/>
+          <p:cNvSpPr/>
+          <p:nvPr/>
+        </p:nvSpPr>
+        <p:spPr>
+          <a:xfrm>
+            <a:off x="6492240" y="5056631"/>
+            <a:ext cx="530352" cy="274320"/>
+          </a:xfrm>
+          <a:prstGeom prst="rect">
+            <a:avLst/>
+          </a:prstGeom>
+          <a:solidFill>
+            <a:srgbClr val="F2F2F2"/>
+          </a:solidFill>
+          <a:ln w="6350">
+            <a:solidFill>
+              <a:srgbClr val="BFBFBF"/>
+            </a:solidFill>
+          </a:ln>
+          <a:effectLst/>
+        </p:spPr>
+        <p:txBody>
+          <a:bodyPr rtlCol="0" anchor="ctr"/>
+          <a:lstStyle/>
+          <a:p>
+            <a:pPr algn="ctr"/>
+          </a:p>
+        </p:txBody>
+      </p:sp>
+      <p:sp>
+        <p:nvSpPr>
+          <p:cNvPr id="186" name="Rectangle 185"/>
+          <p:cNvSpPr/>
+          <p:nvPr/>
+        </p:nvSpPr>
+        <p:spPr>
+          <a:xfrm>
+            <a:off x="7022592" y="5056631"/>
+            <a:ext cx="777240" cy="274320"/>
+          </a:xfrm>
+          <a:prstGeom prst="rect">
+            <a:avLst/>
+          </a:prstGeom>
+          <a:solidFill>
+            <a:srgbClr val="F2F2F2"/>
+          </a:solidFill>
+          <a:ln w="6350">
+            <a:solidFill>
+              <a:srgbClr val="BFBFBF"/>
+            </a:solidFill>
+          </a:ln>
+          <a:effectLst/>
+        </p:spPr>
+        <p:txBody>
+          <a:bodyPr rtlCol="0" anchor="ctr" wrap="square" lIns="64008" tIns="27432" rIns="45720" bIns="27432"/>
+          <a:lstStyle/>
+          <a:p>
+            <a:pPr algn="l"/>
+            <a:r>
+              <a:rPr sz="800" b="1">
+                <a:solidFill>
+                  <a:srgbClr val="000000"/>
+                </a:solidFill>
+                <a:latin typeface="맑은 고딕"/>
+                <a:ea typeface="맑은 고딕"/>
+              </a:rPr>
+              <a:t>미검증 가정</a:t>
+            </a:r>
+          </a:p>
+        </p:txBody>
+      </p:sp>
+      <p:sp>
+        <p:nvSpPr>
+          <p:cNvPr id="187" name="Rectangle 186"/>
+          <p:cNvSpPr/>
+          <p:nvPr/>
+        </p:nvSpPr>
+        <p:spPr>
+          <a:xfrm>
+            <a:off x="7799831" y="5056631"/>
+            <a:ext cx="1755648" cy="274320"/>
+          </a:xfrm>
+          <a:prstGeom prst="rect">
+            <a:avLst/>
+          </a:prstGeom>
+          <a:solidFill>
+            <a:srgbClr val="DAE3F3"/>
+          </a:solidFill>
+          <a:ln w="6350">
+            <a:solidFill>
+              <a:srgbClr val="BFBFBF"/>
+            </a:solidFill>
+          </a:ln>
+          <a:effectLst/>
+        </p:spPr>
+        <p:txBody>
+          <a:bodyPr rtlCol="0" anchor="ctr" wrap="square" lIns="64008" tIns="27432" rIns="45720" bIns="27432"/>
+          <a:lstStyle/>
+          <a:p>
+            <a:pPr algn="l"/>
+            <a:r>
+              <a:rPr sz="750" b="1">
+                <a:solidFill>
+                  <a:srgbClr val="2F5597"/>
+                </a:solidFill>
+                <a:latin typeface="맑은 고딕"/>
+                <a:ea typeface="맑은 고딕"/>
+              </a:rPr>
+              <a:t>지연 크기 미측정 (E1)</a:t>
+            </a:r>
+          </a:p>
+        </p:txBody>
+      </p:sp>
+      <p:sp>
+        <p:nvSpPr>
+          <p:cNvPr id="188" name="Rectangle 187"/>
+          <p:cNvSpPr/>
+          <p:nvPr/>
+        </p:nvSpPr>
+        <p:spPr>
+          <a:xfrm>
+            <a:off x="9555480" y="5056631"/>
+            <a:ext cx="1737360" cy="274320"/>
+          </a:xfrm>
+          <a:prstGeom prst="rect">
+            <a:avLst/>
+          </a:prstGeom>
+          <a:solidFill>
+            <a:srgbClr val="FFFFFF"/>
+          </a:solidFill>
+          <a:ln w="6350">
+            <a:solidFill>
+              <a:srgbClr val="BFBFBF"/>
+            </a:solidFill>
+          </a:ln>
+          <a:effectLst/>
+        </p:spPr>
+        <p:txBody>
+          <a:bodyPr rtlCol="0" anchor="ctr" wrap="square" lIns="64008" tIns="27432" rIns="45720" bIns="27432"/>
+          <a:lstStyle/>
+          <a:p>
+            <a:pPr algn="l"/>
+            <a:r>
+              <a:rPr sz="750" b="0">
+                <a:solidFill>
+                  <a:srgbClr val="C55A11"/>
+                </a:solidFill>
+                <a:latin typeface="맑은 고딕"/>
+                <a:ea typeface="맑은 고딕"/>
+              </a:rPr>
+              <a:t>지연 이점·구현량·신선도 미측정</a:t>
+            </a:r>
+          </a:p>
+        </p:txBody>
+      </p:sp>
+      <p:sp>
+        <p:nvSpPr>
+          <p:cNvPr id="189" name="Rectangle 188"/>
+          <p:cNvSpPr/>
+          <p:nvPr/>
+        </p:nvSpPr>
+        <p:spPr>
+          <a:xfrm>
+            <a:off x="11292840" y="5056631"/>
+            <a:ext cx="704088" cy="274320"/>
+          </a:xfrm>
+          <a:prstGeom prst="rect">
+            <a:avLst/>
+          </a:prstGeom>
+          <a:solidFill>
+            <a:srgbClr val="DAE3F3"/>
+          </a:solidFill>
+          <a:ln w="6350">
+            <a:solidFill>
+              <a:srgbClr val="BFBFBF"/>
+            </a:solidFill>
+          </a:ln>
+          <a:effectLst/>
+        </p:spPr>
+        <p:txBody>
+          <a:bodyPr rtlCol="0" anchor="ctr" wrap="square" lIns="64008" tIns="27432" rIns="45720" bIns="27432"/>
+          <a:lstStyle/>
+          <a:p>
+            <a:pPr algn="ctr"/>
+            <a:r>
+              <a:rPr sz="750" b="1">
+                <a:solidFill>
+                  <a:srgbClr val="2F5597"/>
+                </a:solidFill>
+                <a:latin typeface="맑은 고딕"/>
+                <a:ea typeface="맑은 고딕"/>
+              </a:rPr>
+              <a:t>1안 유리</a:t>
+            </a:r>
+          </a:p>
+        </p:txBody>
+      </p:sp>
+      <p:sp>
+        <p:nvSpPr>
+          <p:cNvPr id="190" name="Rectangle 189"/>
+          <p:cNvSpPr/>
+          <p:nvPr/>
+        </p:nvSpPr>
+        <p:spPr>
+          <a:xfrm>
+            <a:off x="246888" y="5440680"/>
+            <a:ext cx="11750040" cy="822960"/>
           </a:xfrm>
           <a:prstGeom prst="rect">
             <a:avLst/>
@@ -32143,14 +33155,14 @@
       </p:sp>
       <p:sp>
         <p:nvSpPr>
-          <p:cNvPr id="165" name="TextBox 164"/>
+          <p:cNvPr id="191" name="TextBox 190"/>
           <p:cNvSpPr txBox="1"/>
           <p:nvPr/>
         </p:nvSpPr>
         <p:spPr>
           <a:xfrm>
-            <a:off x="338328" y="5513832"/>
-            <a:ext cx="11567160" cy="841248"/>
+            <a:off x="338328" y="5477256"/>
+            <a:ext cx="11567160" cy="768096"/>
           </a:xfrm>
           <a:prstGeom prst="rect">
             <a:avLst/>
@@ -32182,7 +33194,7 @@
                 <a:latin typeface="맑은 고딕"/>
                 <a:ea typeface="맑은 고딕"/>
               </a:rPr>
-              <a:t>QA 합계는 동점이고 비용 항목도 서로 반대 방향이므로 tradeoff가 성립한다. 한쪽이 지배하지 않는다.</a:t>
+              <a:t>QA는 2안이 근소 우위(10 대 9)이고 보조지표(비용·리스크)는 1안이 우위다. 두 축이 반대 방향이므로 tradeoff가 성립한다.</a:t>
             </a:r>
           </a:p>
           <a:p>
@@ -32195,7 +33207,7 @@
                 <a:latin typeface="맑은 고딕"/>
                 <a:ea typeface="맑은 고딕"/>
               </a:rPr>
-              <a:t>· 기본 경로 = 1안(llm-d 확장): P1~P4를 실제 실행으로 확인한 [A] 경로가 있고, 2안은 설계안뿐이라 증거가 비대칭이다. 2안은 실험으로 확정되는 헤지로 둔다.</a:t>
+              <a:t>· 직접 개발(2안)은 지연·변경 용이성을 얻고 확장성·비용·증거를 잃는다. OSS 확장(1안)은 그 반대다.</a:t>
             </a:r>
           </a:p>
           <a:p>
@@ -32208,7 +33220,7 @@
                 <a:latin typeface="맑은 고딕"/>
                 <a:ea typeface="맑은 고딕"/>
               </a:rPr>
-              <a:t>· 2안으로 전환: E1에서 hop 증분이 TTFT 목표 대비 허용 불가 · P/D 경로 P5가 성능에 필수인데 보조 프로세스 수정 유지가 불가 · QA 우선순위를 Latency 우선으로 확정할 때.</a:t>
+              <a:t>· 기본 경로 = 1안: 증거(실행 확인)와 비용이 앞서고 QA 차이는 1점이며 2안의 지연 이점은 미측정이다. 2안은 E1 결과·QA 우선순위(지연 우선)에 따라 전환하는 헤지.</a:t>
             </a:r>
           </a:p>
           <a:p>
@@ -32221,14 +33233,14 @@
                 <a:latin typeface="맑은 고딕"/>
                 <a:ea typeface="맑은 고딕"/>
               </a:rPr>
-              <a:t>· 붕괴 조건: E1에서 hop 증분이 측정 잡음 수준이면 Q2가 동률이 되어 1안이 다시 지배한다. 2안의 레플리카 일관성 구현이 예상보다 크면 Q4가 ●○○로 내려간다.</a:t>
-            </a:r>
-          </a:p>
-        </p:txBody>
-      </p:sp>
-      <p:sp>
-        <p:nvSpPr>
-          <p:cNvPr id="166" name="TextBox 165"/>
+              <a:t>· 붕괴 조건: E1에서 hop 증분이 잡음 수준이면 Q2가 동률이 되어 QA 우위(9 대 9)가 사라진다. 레플리카 신선도 구현이 크면 2안 Q4가 ●○○로 내려간다.</a:t>
+            </a:r>
+          </a:p>
+        </p:txBody>
+      </p:sp>
+      <p:sp>
+        <p:nvSpPr>
+          <p:cNvPr id="192" name="TextBox 191"/>
           <p:cNvSpPr txBox="1"/>
           <p:nvPr/>
         </p:nvSpPr>
@@ -32257,7 +33269,7 @@
                 <a:latin typeface="맑은 고딕"/>
                 <a:ea typeface="맑은 고딕"/>
               </a:rPr>
-              <a:t>※ ●●●=우수 ●○○=취약, 모두 구조 논증 기반 가설 [C]. 확정 실험: E1(결정 경로 지연) · E3(상태 신선도) · E4(end-to-end Goodput). 이전 평가(1안 10 vs 2안 8)와의 차이·사유는 설계 문서 §7.4 개정 기록.</a:t>
+              <a:t>※ ●●●=우수 ●○○=취약, 구조 논증 기반 가설 [C]. 확정 실험: E1(결정 경로 지연) · E3(상태 신선도) · E4(end-to-end Goodput). 보조지표는 별 합계에 넣지 않는다. 이전 평가와의 차이·사유는 설계 문서 §7.4.1.</a:t>
             </a:r>
           </a:p>
         </p:txBody>

</xml_diff>

<commit_message>
DP0: simplify candidate 2 to a single Strategy pattern and one process box
Co-Authored-By: Claude Sonnet 5.5 <noreply@anthropic.com>
Claude-Session: https://claude.ai/code/session_014XKnsGjraFTY3Q8v5o1PT9
</commit_message>
<xml_diff>
--- a/doc-mk/DP0/DP0-slides-v2.pptx
+++ b/doc-mk/DP0/DP0-slides-v2.pptx
@@ -790,7 +790,7 @@
           </a:p>
           <a:p>
             <a:r>
-              <a:t>2안(오른쪽)은 전부 우리가 소유하는 계층형 구조입니다. 한 프로세스 안에 Ingress, Pipeline(Admission → PolicyEngine → P/D 조율), State Plane(상태 저장소, 이벤트 구독, 메트릭 수집, 서버 등록)을 나눴고, 정책은 디자인 패턴으로 갈아 끼웁니다. 요청 경로는 Chain of Responsibility(파이프라인), 점수·P/D 정책은 Strategy(P1~P3 Scorer, P4 Planner), 노드 지시는 Decorator(P5), 상태 갱신은 Observer, vLLM 계약은 Adapter로 격리하고, 상태는 읽기 전용 StateView(Facade)로만 읽습니다. 이전 안은 단일 프로세스·정적 설정의 최소 구성이어서 확장성이 일방적으로 약했는데, 이번에는 상태를 공유하지 않는 레플리카 여러 개를 L4 로드밸런서 뒤에 두고 etcd로 서버를 등록하는 구성으로 같은 노력 수준에서 비교합니다. 구현은 되어 있지 않은 설계안입니다.</a:t>
+              <a:t>2안(오른쪽)은 전부 우리가 소유하는 계층형 구조입니다. 한 프로세스 안에 Ingress, Pipeline(Admission → PolicyEngine → P/D 조율), State Plane(상태 저장소, 이벤트 구독, 메트릭 수집, 서버 등록)을 나눴고, 정책은 Strategy 패턴으로 갈아 끼웁니다. 점수·비용 함수·P/D 정책을 같은 인터페이스의 구현체로 두고 설정으로 교체하므로 Router 본체와 파이프라인은 그대로입니다. 이전 안은 단일 프로세스·정적 설정의 최소 구성이어서 확장성이 일방적으로 약했는데, 이번에는 상태를 공유하지 않는 레플리카 여러 개를 L4 로드밸런서 뒤에 두고 etcd로 서버를 등록하는 구성으로 같은 노력 수준에서 비교합니다. 구현은 되어 있지 않은 설계안입니다.</a:t>
             </a:r>
           </a:p>
           <a:p>
@@ -21943,7 +21943,7 @@
                   <a:schemeClr val="bg1"/>
                 </a:solidFill>
               </a:rPr>
-              <a:t>서버 간(클러스터) 요청을 조율하는 계층의 컴포넌트 뷰 (2안은 디자인 패턴 적용)</a:t>
+              <a:t>서버 간(클러스터) 요청을 조율하는 계층의 컴포넌트 뷰 (2안은 Strategy 패턴 적용)</a:t>
             </a:r>
             <a:endParaRPr lang="ko-KR" altLang="en-US" sz="1400" b="1" dirty="0">
               <a:solidFill>
@@ -22809,7 +22809,7 @@
                 <a:latin typeface="맑은 고딕"/>
                 <a:ea typeface="맑은 고딕"/>
               </a:rPr>
-              <a:t>(Own Router: 계층형 · 디자인 패턴 · 레플리카 확장)</a:t>
+              <a:t>(Own Router: 한 프로세스 · Strategy 패턴 · 레플리카 확장)</a:t>
             </a:r>
           </a:p>
         </p:txBody>
@@ -22845,7 +22845,7 @@
                 <a:latin typeface="맑은 고딕"/>
                 <a:ea typeface="맑은 고딕"/>
               </a:rPr>
-              <a:t>“결정·상태·P/D 조율을 한 프로세스에 모으고, 정책은 디자인 패턴으로 갈아 끼우는 구조”</a:t>
+              <a:t>“결정·상태·P/D 조율을 한 프로세스에 모으고, 정책은 Strategy 패턴으로 갈아 끼우는 구조”</a:t>
             </a:r>
           </a:p>
         </p:txBody>
@@ -25357,7 +25357,7 @@
         </p:nvSpPr>
         <p:spPr>
           <a:xfrm>
-            <a:off x="6583680" y="3776472"/>
+            <a:off x="6583680" y="3273552"/>
             <a:ext cx="566928" cy="384048"/>
           </a:xfrm>
           <a:prstGeom prst="rect">
@@ -25412,16 +25412,16 @@
         </p:nvSpPr>
         <p:spPr>
           <a:xfrm>
-            <a:off x="7351776" y="1645920"/>
-            <a:ext cx="3566160" cy="2834640"/>
-          </a:xfrm>
-          <a:prstGeom prst="rect">
-            <a:avLst/>
-          </a:prstGeom>
-          <a:solidFill>
-            <a:srgbClr val="FBE5D6"/>
-          </a:solidFill>
-          <a:ln w="9525">
+            <a:off x="7242048" y="1536192"/>
+            <a:ext cx="3566160" cy="2542032"/>
+          </a:xfrm>
+          <a:prstGeom prst="rect">
+            <a:avLst/>
+          </a:prstGeom>
+          <a:solidFill>
+            <a:srgbClr val="FFFFFF"/>
+          </a:solidFill>
+          <a:ln w="25400">
             <a:solidFill>
               <a:srgbClr val="C55A11"/>
             </a:solidFill>
@@ -25444,16 +25444,16 @@
         </p:nvSpPr>
         <p:spPr>
           <a:xfrm>
-            <a:off x="7296912" y="1591056"/>
-            <a:ext cx="3566160" cy="2834640"/>
-          </a:xfrm>
-          <a:prstGeom prst="rect">
-            <a:avLst/>
-          </a:prstGeom>
-          <a:solidFill>
-            <a:srgbClr val="FBE5D6"/>
-          </a:solidFill>
-          <a:ln w="9525">
+            <a:off x="7242048" y="1536192"/>
+            <a:ext cx="3566160" cy="182880"/>
+          </a:xfrm>
+          <a:prstGeom prst="rect">
+            <a:avLst/>
+          </a:prstGeom>
+          <a:solidFill>
+            <a:srgbClr val="C55A11"/>
+          </a:solidFill>
+          <a:ln w="12700">
             <a:solidFill>
               <a:srgbClr val="C55A11"/>
             </a:solidFill>
@@ -25461,10 +25461,20 @@
           <a:effectLst/>
         </p:spPr>
         <p:txBody>
-          <a:bodyPr rtlCol="0" anchor="ctr"/>
-          <a:lstStyle/>
-          <a:p>
-            <a:pPr algn="ctr"/>
+          <a:bodyPr rtlCol="0" anchor="ctr" wrap="square" lIns="45720" tIns="0" rIns="0" bIns="0"/>
+          <a:lstStyle/>
+          <a:p>
+            <a:pPr algn="l"/>
+            <a:r>
+              <a:rPr sz="750" b="1">
+                <a:solidFill>
+                  <a:srgbClr val="FFFFFF"/>
+                </a:solidFill>
+                <a:latin typeface="맑은 고딕"/>
+                <a:ea typeface="맑은 고딕"/>
+              </a:rPr>
+              <a:t>«process» Own Router  (한 프로세스)</a:t>
+            </a:r>
           </a:p>
         </p:txBody>
       </p:sp>
@@ -25476,8 +25486,8 @@
         </p:nvSpPr>
         <p:spPr>
           <a:xfrm>
-            <a:off x="7242048" y="1536192"/>
-            <a:ext cx="3566160" cy="2834640"/>
+            <a:off x="10104120" y="1563624"/>
+            <a:ext cx="658368" cy="128016"/>
           </a:xfrm>
           <a:prstGeom prst="rect">
             <a:avLst/>
@@ -25485,73 +25495,41 @@
           <a:solidFill>
             <a:srgbClr val="FFFFFF"/>
           </a:solidFill>
-          <a:ln w="19050">
-            <a:solidFill>
-              <a:srgbClr val="C55A11"/>
-            </a:solidFill>
-          </a:ln>
-          <a:effectLst/>
-        </p:spPr>
-        <p:txBody>
-          <a:bodyPr rtlCol="0" anchor="ctr"/>
-          <a:lstStyle/>
-          <a:p>
-            <a:pPr algn="ctr"/>
-          </a:p>
-        </p:txBody>
-      </p:sp>
-      <p:sp>
-        <p:nvSpPr>
-          <p:cNvPr id="176" name="Rectangle 175"/>
-          <p:cNvSpPr/>
-          <p:nvPr/>
-        </p:nvSpPr>
-        <p:spPr>
-          <a:xfrm>
-            <a:off x="7242048" y="1536192"/>
-            <a:ext cx="3566160" cy="164592"/>
-          </a:xfrm>
-          <a:prstGeom prst="rect">
-            <a:avLst/>
-          </a:prstGeom>
-          <a:solidFill>
-            <a:srgbClr val="C55A11"/>
-          </a:solidFill>
           <a:ln w="12700">
             <a:solidFill>
-              <a:srgbClr val="C55A11"/>
-            </a:solidFill>
-          </a:ln>
-          <a:effectLst/>
-        </p:spPr>
-        <p:txBody>
-          <a:bodyPr rtlCol="0" anchor="ctr" wrap="square" lIns="45720" tIns="0" rIns="0" bIns="0"/>
-          <a:lstStyle/>
-          <a:p>
-            <a:pPr algn="l"/>
-            <a:r>
-              <a:rPr sz="700" b="1">
-                <a:solidFill>
-                  <a:srgbClr val="FFFFFF"/>
-                </a:solidFill>
-                <a:latin typeface="맑은 고딕"/>
-                <a:ea typeface="맑은 고딕"/>
-              </a:rPr>
-              <a:t>«process» Own Router 레플리카 ×R (한 프로세스)</a:t>
+              <a:srgbClr val="FFFFFF"/>
+            </a:solidFill>
+          </a:ln>
+          <a:effectLst/>
+        </p:spPr>
+        <p:txBody>
+          <a:bodyPr rtlCol="0" anchor="ctr" wrap="square" lIns="0" tIns="0" rIns="0" bIns="0"/>
+          <a:lstStyle/>
+          <a:p>
+            <a:pPr algn="ctr"/>
+            <a:r>
+              <a:rPr sz="650" b="1">
+                <a:solidFill>
+                  <a:srgbClr val="C55A11"/>
+                </a:solidFill>
+                <a:latin typeface="맑은 고딕"/>
+                <a:ea typeface="맑은 고딕"/>
+              </a:rPr>
+              <a:t>×R 레플리카</a:t>
             </a:r>
           </a:p>
         </p:txBody>
       </p:sp>
       <p:cxnSp>
         <p:nvCxnSpPr>
-          <p:cNvPr id="177" name="Connector 176"/>
+          <p:cNvPr id="176" name="Connector 175"/>
           <p:cNvCxnSpPr/>
           <p:nvPr/>
         </p:nvCxnSpPr>
         <p:spPr>
           <a:xfrm flipV="1">
             <a:off x="7150608" y="1993392"/>
-            <a:ext cx="164592" cy="237744"/>
+            <a:ext cx="182880" cy="237744"/>
           </a:xfrm>
           <a:prstGeom prst="line">
             <a:avLst/>
@@ -25566,14 +25544,69 @@
       </p:cxnSp>
       <p:sp>
         <p:nvSpPr>
+          <p:cNvPr id="177" name="Rectangle 176"/>
+          <p:cNvSpPr/>
+          <p:nvPr/>
+        </p:nvSpPr>
+        <p:spPr>
+          <a:xfrm>
+            <a:off x="7333488" y="1810512"/>
+            <a:ext cx="713232" cy="384048"/>
+          </a:xfrm>
+          <a:prstGeom prst="rect">
+            <a:avLst/>
+          </a:prstGeom>
+          <a:solidFill>
+            <a:srgbClr val="FBE5D6"/>
+          </a:solidFill>
+          <a:ln w="19050">
+            <a:solidFill>
+              <a:srgbClr val="C55A11"/>
+            </a:solidFill>
+          </a:ln>
+          <a:effectLst/>
+        </p:spPr>
+        <p:txBody>
+          <a:bodyPr rtlCol="0" anchor="ctr" wrap="square" lIns="36576" tIns="18288" rIns="36576" bIns="18288"/>
+          <a:lstStyle/>
+          <a:p>
+            <a:pPr algn="ctr"/>
+            <a:r>
+              <a:rPr sz="750" b="1">
+                <a:solidFill>
+                  <a:srgbClr val="000000"/>
+                </a:solidFill>
+                <a:latin typeface="맑은 고딕"/>
+                <a:ea typeface="맑은 고딕"/>
+              </a:rPr>
+              <a:t>A Ingress</a:t>
+            </a:r>
+          </a:p>
+          <a:p>
+            <a:pPr algn="ctr"/>
+            <a:r>
+              <a:rPr sz="650" b="0">
+                <a:solidFill>
+                  <a:srgbClr val="000000"/>
+                </a:solidFill>
+                <a:latin typeface="맑은 고딕"/>
+                <a:ea typeface="맑은 고딕"/>
+              </a:rPr>
+              <a:t>요청 수신·중계</a:t>
+            </a:r>
+          </a:p>
+        </p:txBody>
+      </p:sp>
+      <p:sp>
+        <p:nvSpPr>
           <p:cNvPr id="178" name="Rectangle 177"/>
           <p:cNvSpPr/>
           <p:nvPr/>
         </p:nvSpPr>
         <p:spPr>
           <a:xfrm>
-            <a:off x="7333488" y="1755648"/>
-            <a:ext cx="3383280" cy="274320"/>
+            <a:off x="8138160" y="1810512"/>
+            <a:ext cx="658368" cy="384048"/>
           </a:xfrm>
           <a:prstGeom prst="rect">
             <a:avLst/>
@@ -25581,7 +25614,7 @@
           <a:solidFill>
             <a:srgbClr val="FBE5D6"/>
           </a:solidFill>
-          <a:ln w="12700">
+          <a:ln w="19050">
             <a:solidFill>
               <a:srgbClr val="C55A11"/>
             </a:solidFill>
@@ -25601,7 +25634,20 @@
                 <a:latin typeface="맑은 고딕"/>
                 <a:ea typeface="맑은 고딕"/>
               </a:rPr>
-              <a:t>A Ingress / API   요청 파싱 · 스트리밍 중계</a:t>
+              <a:t>D 흐름 제어</a:t>
+            </a:r>
+          </a:p>
+          <a:p>
+            <a:pPr algn="ctr"/>
+            <a:r>
+              <a:rPr sz="650" b="0">
+                <a:solidFill>
+                  <a:srgbClr val="000000"/>
+                </a:solidFill>
+                <a:latin typeface="맑은 고딕"/>
+                <a:ea typeface="맑은 고딕"/>
+              </a:rPr>
+              <a:t>admission</a:t>
             </a:r>
           </a:p>
         </p:txBody>
@@ -25614,36 +25660,49 @@
         </p:nvSpPr>
         <p:spPr>
           <a:xfrm>
-            <a:off x="7955279" y="2084832"/>
-            <a:ext cx="1691640" cy="137160"/>
-          </a:xfrm>
-          <a:prstGeom prst="rect">
-            <a:avLst/>
-          </a:prstGeom>
-          <a:solidFill>
-            <a:srgbClr val="EDE7F6"/>
-          </a:solidFill>
-          <a:ln w="9525">
-            <a:solidFill>
-              <a:srgbClr val="5E35B1"/>
-            </a:solidFill>
-          </a:ln>
-          <a:effectLst/>
-        </p:spPr>
-        <p:txBody>
-          <a:bodyPr rtlCol="0" anchor="ctr" wrap="square" lIns="18288" tIns="0" rIns="18288" bIns="0"/>
-          <a:lstStyle/>
-          <a:p>
-            <a:pPr algn="ctr"/>
-            <a:r>
-              <a:rPr sz="600" b="1">
-                <a:solidFill>
-                  <a:srgbClr val="5E35B1"/>
-                </a:solidFill>
-                <a:latin typeface="맑은 고딕"/>
-                <a:ea typeface="맑은 고딕"/>
-              </a:rPr>
-              <a:t>«Chain of Responsibility» Pipeline</a:t>
+            <a:off x="8887968" y="1810512"/>
+            <a:ext cx="841248" cy="384048"/>
+          </a:xfrm>
+          <a:prstGeom prst="rect">
+            <a:avLst/>
+          </a:prstGeom>
+          <a:solidFill>
+            <a:srgbClr val="FBE5D6"/>
+          </a:solidFill>
+          <a:ln w="19050">
+            <a:solidFill>
+              <a:srgbClr val="C55A11"/>
+            </a:solidFill>
+          </a:ln>
+          <a:effectLst/>
+        </p:spPr>
+        <p:txBody>
+          <a:bodyPr rtlCol="0" anchor="ctr" wrap="square" lIns="36576" tIns="18288" rIns="36576" bIns="18288"/>
+          <a:lstStyle/>
+          <a:p>
+            <a:pPr algn="ctr"/>
+            <a:r>
+              <a:rPr sz="750" b="1">
+                <a:solidFill>
+                  <a:srgbClr val="000000"/>
+                </a:solidFill>
+                <a:latin typeface="맑은 고딕"/>
+                <a:ea typeface="맑은 고딕"/>
+              </a:rPr>
+              <a:t>B Selector</a:t>
+            </a:r>
+          </a:p>
+          <a:p>
+            <a:pPr algn="ctr"/>
+            <a:r>
+              <a:rPr sz="650" b="0">
+                <a:solidFill>
+                  <a:srgbClr val="000000"/>
+                </a:solidFill>
+                <a:latin typeface="맑은 고딕"/>
+                <a:ea typeface="맑은 고딕"/>
+              </a:rPr>
+              <a:t>후보 서버 선택</a:t>
             </a:r>
           </a:p>
         </p:txBody>
@@ -25656,8 +25715,8 @@
         </p:nvSpPr>
         <p:spPr>
           <a:xfrm>
-            <a:off x="7333488" y="2240280"/>
-            <a:ext cx="868680" cy="237744"/>
+            <a:off x="9820656" y="1810512"/>
+            <a:ext cx="822960" cy="384048"/>
           </a:xfrm>
           <a:prstGeom prst="rect">
             <a:avLst/>
@@ -25685,95 +25744,68 @@
                 <a:latin typeface="맑은 고딕"/>
                 <a:ea typeface="맑은 고딕"/>
               </a:rPr>
-              <a:t>D Admission</a:t>
-            </a:r>
-          </a:p>
-        </p:txBody>
-      </p:sp>
-      <p:sp>
-        <p:nvSpPr>
-          <p:cNvPr id="181" name="Rectangle 180"/>
-          <p:cNvSpPr/>
-          <p:nvPr/>
-        </p:nvSpPr>
-        <p:spPr>
-          <a:xfrm>
-            <a:off x="8321040" y="2240280"/>
-            <a:ext cx="1051560" cy="237744"/>
-          </a:xfrm>
-          <a:prstGeom prst="rect">
-            <a:avLst/>
-          </a:prstGeom>
-          <a:solidFill>
-            <a:srgbClr val="FBE5D6"/>
-          </a:solidFill>
-          <a:ln w="19050">
+              <a:t>E P/D 조율</a:t>
+            </a:r>
+          </a:p>
+          <a:p>
+            <a:pPr algn="ctr"/>
+            <a:r>
+              <a:rPr sz="650" b="0">
+                <a:solidFill>
+                  <a:srgbClr val="000000"/>
+                </a:solidFill>
+                <a:latin typeface="맑은 고딕"/>
+                <a:ea typeface="맑은 고딕"/>
+              </a:rPr>
+              <a:t>P5 지시 송신</a:t>
+            </a:r>
+          </a:p>
+        </p:txBody>
+      </p:sp>
+      <p:cxnSp>
+        <p:nvCxnSpPr>
+          <p:cNvPr id="181" name="Connector 180"/>
+          <p:cNvCxnSpPr/>
+          <p:nvPr/>
+        </p:nvCxnSpPr>
+        <p:spPr>
+          <a:xfrm>
+            <a:off x="8046720" y="2002536"/>
+            <a:ext cx="91440" cy="0"/>
+          </a:xfrm>
+          <a:prstGeom prst="line">
+            <a:avLst/>
+          </a:prstGeom>
+          <a:ln w="15875">
             <a:solidFill>
               <a:srgbClr val="C55A11"/>
             </a:solidFill>
-          </a:ln>
-          <a:effectLst/>
-        </p:spPr>
-        <p:txBody>
-          <a:bodyPr rtlCol="0" anchor="ctr" wrap="square" lIns="36576" tIns="18288" rIns="36576" bIns="18288"/>
-          <a:lstStyle/>
-          <a:p>
-            <a:pPr algn="ctr"/>
-            <a:r>
-              <a:rPr sz="750" b="1">
-                <a:solidFill>
-                  <a:srgbClr val="000000"/>
-                </a:solidFill>
-                <a:latin typeface="맑은 고딕"/>
-                <a:ea typeface="맑은 고딕"/>
-              </a:rPr>
-              <a:t>B Selector</a:t>
-            </a:r>
-          </a:p>
-        </p:txBody>
-      </p:sp>
-      <p:sp>
-        <p:nvSpPr>
-          <p:cNvPr id="182" name="Rectangle 181"/>
-          <p:cNvSpPr/>
-          <p:nvPr/>
-        </p:nvSpPr>
-        <p:spPr>
-          <a:xfrm>
-            <a:off x="9491472" y="2240280"/>
-            <a:ext cx="1225296" cy="237744"/>
-          </a:xfrm>
-          <a:prstGeom prst="rect">
-            <a:avLst/>
-          </a:prstGeom>
-          <a:solidFill>
-            <a:srgbClr val="FBE5D6"/>
-          </a:solidFill>
-          <a:ln w="19050">
+            <a:tailEnd type="triangle"/>
+          </a:ln>
+        </p:spPr>
+      </p:cxnSp>
+      <p:cxnSp>
+        <p:nvCxnSpPr>
+          <p:cNvPr id="182" name="Connector 181"/>
+          <p:cNvCxnSpPr/>
+          <p:nvPr/>
+        </p:nvCxnSpPr>
+        <p:spPr>
+          <a:xfrm>
+            <a:off x="8796528" y="2002536"/>
+            <a:ext cx="91440" cy="0"/>
+          </a:xfrm>
+          <a:prstGeom prst="line">
+            <a:avLst/>
+          </a:prstGeom>
+          <a:ln w="15875">
             <a:solidFill>
               <a:srgbClr val="C55A11"/>
             </a:solidFill>
-          </a:ln>
-          <a:effectLst/>
-        </p:spPr>
-        <p:txBody>
-          <a:bodyPr rtlCol="0" anchor="ctr" wrap="square" lIns="36576" tIns="18288" rIns="36576" bIns="18288"/>
-          <a:lstStyle/>
-          <a:p>
-            <a:pPr algn="ctr"/>
-            <a:r>
-              <a:rPr sz="750" b="1">
-                <a:solidFill>
-                  <a:srgbClr val="000000"/>
-                </a:solidFill>
-                <a:latin typeface="맑은 고딕"/>
-                <a:ea typeface="맑은 고딕"/>
-              </a:rPr>
-              <a:t>E Dispatcher</a:t>
-            </a:r>
-          </a:p>
-        </p:txBody>
-      </p:sp>
+            <a:tailEnd type="triangle"/>
+          </a:ln>
+        </p:spPr>
+      </p:cxnSp>
       <p:cxnSp>
         <p:nvCxnSpPr>
           <p:cNvPr id="183" name="Connector 182"/>
@@ -25782,8 +25814,8 @@
         </p:nvCxnSpPr>
         <p:spPr>
           <a:xfrm>
-            <a:off x="8202168" y="2359152"/>
-            <a:ext cx="118872" cy="0"/>
+            <a:off x="9729216" y="2002536"/>
+            <a:ext cx="91440" cy="0"/>
           </a:xfrm>
           <a:prstGeom prst="line">
             <a:avLst/>
@@ -25796,38 +25828,484 @@
           </a:ln>
         </p:spPr>
       </p:cxnSp>
+      <p:sp>
+        <p:nvSpPr>
+          <p:cNvPr id="184" name="Oval 183"/>
+          <p:cNvSpPr/>
+          <p:nvPr/>
+        </p:nvSpPr>
+        <p:spPr>
+          <a:xfrm>
+            <a:off x="8014715" y="1714500"/>
+            <a:ext cx="155448" cy="155448"/>
+          </a:xfrm>
+          <a:prstGeom prst="ellipse">
+            <a:avLst/>
+          </a:prstGeom>
+          <a:solidFill>
+            <a:srgbClr val="C55A11"/>
+          </a:solidFill>
+          <a:ln w="9525">
+            <a:solidFill>
+              <a:srgbClr val="FFFFFF"/>
+            </a:solidFill>
+          </a:ln>
+          <a:effectLst/>
+        </p:spPr>
+        <p:txBody>
+          <a:bodyPr rtlCol="0" anchor="ctr" wrap="square" lIns="0" tIns="0" rIns="0" bIns="0"/>
+          <a:lstStyle/>
+          <a:p>
+            <a:pPr algn="ctr"/>
+            <a:r>
+              <a:rPr sz="650" b="1">
+                <a:solidFill>
+                  <a:srgbClr val="FFFFFF"/>
+                </a:solidFill>
+                <a:latin typeface="맑은 고딕"/>
+                <a:ea typeface="맑은 고딕"/>
+              </a:rPr>
+              <a:t>2</a:t>
+            </a:r>
+          </a:p>
+        </p:txBody>
+      </p:sp>
+      <p:sp>
+        <p:nvSpPr>
+          <p:cNvPr id="185" name="Rectangle 184"/>
+          <p:cNvSpPr/>
+          <p:nvPr/>
+        </p:nvSpPr>
+        <p:spPr>
+          <a:xfrm>
+            <a:off x="7333488" y="2432304"/>
+            <a:ext cx="3310128" cy="749808"/>
+          </a:xfrm>
+          <a:prstGeom prst="rect">
+            <a:avLst/>
+          </a:prstGeom>
+          <a:solidFill>
+            <a:srgbClr val="FFFFFF"/>
+          </a:solidFill>
+          <a:ln w="22225">
+            <a:solidFill>
+              <a:srgbClr val="5E35B1"/>
+            </a:solidFill>
+          </a:ln>
+          <a:effectLst/>
+        </p:spPr>
+        <p:txBody>
+          <a:bodyPr rtlCol="0" anchor="ctr"/>
+          <a:lstStyle/>
+          <a:p>
+            <a:pPr algn="ctr"/>
+          </a:p>
+        </p:txBody>
+      </p:sp>
+      <p:sp>
+        <p:nvSpPr>
+          <p:cNvPr id="186" name="Rectangle 185"/>
+          <p:cNvSpPr/>
+          <p:nvPr/>
+        </p:nvSpPr>
+        <p:spPr>
+          <a:xfrm>
+            <a:off x="7333488" y="2432304"/>
+            <a:ext cx="3310128" cy="173736"/>
+          </a:xfrm>
+          <a:prstGeom prst="rect">
+            <a:avLst/>
+          </a:prstGeom>
+          <a:solidFill>
+            <a:srgbClr val="5E35B1"/>
+          </a:solidFill>
+          <a:ln w="12700">
+            <a:solidFill>
+              <a:srgbClr val="5E35B1"/>
+            </a:solidFill>
+          </a:ln>
+          <a:effectLst/>
+        </p:spPr>
+        <p:txBody>
+          <a:bodyPr rtlCol="0" anchor="ctr" wrap="square" lIns="45720" tIns="0" rIns="0" bIns="0"/>
+          <a:lstStyle/>
+          <a:p>
+            <a:pPr algn="l"/>
+            <a:r>
+              <a:rPr sz="700" b="1">
+                <a:solidFill>
+                  <a:srgbClr val="FFFFFF"/>
+                </a:solidFill>
+                <a:latin typeface="맑은 고딕"/>
+                <a:ea typeface="맑은 고딕"/>
+              </a:rPr>
+              <a:t>«Strategy»  정책 인터페이스  (구현체를 설정으로 교체)</a:t>
+            </a:r>
+          </a:p>
+        </p:txBody>
+      </p:sp>
+      <p:sp>
+        <p:nvSpPr>
+          <p:cNvPr id="187" name="Rectangle 186"/>
+          <p:cNvSpPr/>
+          <p:nvPr/>
+        </p:nvSpPr>
+        <p:spPr>
+          <a:xfrm>
+            <a:off x="7388352" y="2660904"/>
+            <a:ext cx="768096" cy="457200"/>
+          </a:xfrm>
+          <a:prstGeom prst="rect">
+            <a:avLst/>
+          </a:prstGeom>
+          <a:solidFill>
+            <a:srgbClr val="FBE5D6"/>
+          </a:solidFill>
+          <a:ln w="15875">
+            <a:solidFill>
+              <a:srgbClr val="C55A11"/>
+            </a:solidFill>
+          </a:ln>
+          <a:effectLst/>
+        </p:spPr>
+        <p:txBody>
+          <a:bodyPr rtlCol="0" anchor="ctr" wrap="square" lIns="36576" tIns="18288" rIns="36576" bIns="18288"/>
+          <a:lstStyle/>
+          <a:p>
+            <a:pPr algn="ctr"/>
+            <a:r>
+              <a:rPr sz="800" b="1">
+                <a:solidFill>
+                  <a:srgbClr val="000000"/>
+                </a:solidFill>
+                <a:latin typeface="맑은 고딕"/>
+                <a:ea typeface="맑은 고딕"/>
+              </a:rPr>
+              <a:t>P1</a:t>
+            </a:r>
+          </a:p>
+          <a:p>
+            <a:pPr algn="ctr"/>
+            <a:r>
+              <a:rPr sz="650" b="0">
+                <a:solidFill>
+                  <a:srgbClr val="000000"/>
+                </a:solidFill>
+                <a:latin typeface="맑은 고딕"/>
+                <a:ea typeface="맑은 고딕"/>
+              </a:rPr>
+              <a:t>메모리 종류 가중치</a:t>
+            </a:r>
+          </a:p>
+        </p:txBody>
+      </p:sp>
+      <p:sp>
+        <p:nvSpPr>
+          <p:cNvPr id="188" name="Rectangle 187"/>
+          <p:cNvSpPr/>
+          <p:nvPr/>
+        </p:nvSpPr>
+        <p:spPr>
+          <a:xfrm>
+            <a:off x="8211312" y="2660904"/>
+            <a:ext cx="768096" cy="457200"/>
+          </a:xfrm>
+          <a:prstGeom prst="rect">
+            <a:avLst/>
+          </a:prstGeom>
+          <a:solidFill>
+            <a:srgbClr val="FBE5D6"/>
+          </a:solidFill>
+          <a:ln w="15875">
+            <a:solidFill>
+              <a:srgbClr val="C55A11"/>
+            </a:solidFill>
+          </a:ln>
+          <a:effectLst/>
+        </p:spPr>
+        <p:txBody>
+          <a:bodyPr rtlCol="0" anchor="ctr" wrap="square" lIns="36576" tIns="18288" rIns="36576" bIns="18288"/>
+          <a:lstStyle/>
+          <a:p>
+            <a:pPr algn="ctr"/>
+            <a:r>
+              <a:rPr sz="800" b="1">
+                <a:solidFill>
+                  <a:srgbClr val="000000"/>
+                </a:solidFill>
+                <a:latin typeface="맑은 고딕"/>
+                <a:ea typeface="맑은 고딕"/>
+              </a:rPr>
+              <a:t>P2</a:t>
+            </a:r>
+          </a:p>
+          <a:p>
+            <a:pPr algn="ctr"/>
+            <a:r>
+              <a:rPr sz="650" b="0">
+                <a:solidFill>
+                  <a:srgbClr val="000000"/>
+                </a:solidFill>
+                <a:latin typeface="맑은 고딕"/>
+                <a:ea typeface="맑은 고딕"/>
+              </a:rPr>
+              <a:t>실시간 상태</a:t>
+            </a:r>
+          </a:p>
+        </p:txBody>
+      </p:sp>
+      <p:sp>
+        <p:nvSpPr>
+          <p:cNvPr id="189" name="Rectangle 188"/>
+          <p:cNvSpPr/>
+          <p:nvPr/>
+        </p:nvSpPr>
+        <p:spPr>
+          <a:xfrm>
+            <a:off x="9034272" y="2660904"/>
+            <a:ext cx="768096" cy="457200"/>
+          </a:xfrm>
+          <a:prstGeom prst="rect">
+            <a:avLst/>
+          </a:prstGeom>
+          <a:solidFill>
+            <a:srgbClr val="FBE5D6"/>
+          </a:solidFill>
+          <a:ln w="15875">
+            <a:solidFill>
+              <a:srgbClr val="C55A11"/>
+            </a:solidFill>
+          </a:ln>
+          <a:effectLst/>
+        </p:spPr>
+        <p:txBody>
+          <a:bodyPr rtlCol="0" anchor="ctr" wrap="square" lIns="36576" tIns="18288" rIns="36576" bIns="18288"/>
+          <a:lstStyle/>
+          <a:p>
+            <a:pPr algn="ctr"/>
+            <a:r>
+              <a:rPr sz="800" b="1">
+                <a:solidFill>
+                  <a:srgbClr val="000000"/>
+                </a:solidFill>
+                <a:latin typeface="맑은 고딕"/>
+                <a:ea typeface="맑은 고딕"/>
+              </a:rPr>
+              <a:t>P3</a:t>
+            </a:r>
+          </a:p>
+          <a:p>
+            <a:pPr algn="ctr"/>
+            <a:r>
+              <a:rPr sz="650" b="0">
+                <a:solidFill>
+                  <a:srgbClr val="000000"/>
+                </a:solidFill>
+                <a:latin typeface="맑은 고딕"/>
+                <a:ea typeface="맑은 고딕"/>
+              </a:rPr>
+              <a:t>비용 기반 점수</a:t>
+            </a:r>
+          </a:p>
+        </p:txBody>
+      </p:sp>
+      <p:sp>
+        <p:nvSpPr>
+          <p:cNvPr id="190" name="Rectangle 189"/>
+          <p:cNvSpPr/>
+          <p:nvPr/>
+        </p:nvSpPr>
+        <p:spPr>
+          <a:xfrm>
+            <a:off x="9857232" y="2660904"/>
+            <a:ext cx="768096" cy="457200"/>
+          </a:xfrm>
+          <a:prstGeom prst="rect">
+            <a:avLst/>
+          </a:prstGeom>
+          <a:solidFill>
+            <a:srgbClr val="FBE5D6"/>
+          </a:solidFill>
+          <a:ln w="15875">
+            <a:solidFill>
+              <a:srgbClr val="C55A11"/>
+            </a:solidFill>
+          </a:ln>
+          <a:effectLst/>
+        </p:spPr>
+        <p:txBody>
+          <a:bodyPr rtlCol="0" anchor="ctr" wrap="square" lIns="36576" tIns="18288" rIns="36576" bIns="18288"/>
+          <a:lstStyle/>
+          <a:p>
+            <a:pPr algn="ctr"/>
+            <a:r>
+              <a:rPr sz="800" b="1">
+                <a:solidFill>
+                  <a:srgbClr val="000000"/>
+                </a:solidFill>
+                <a:latin typeface="맑은 고딕"/>
+                <a:ea typeface="맑은 고딕"/>
+              </a:rPr>
+              <a:t>P4</a:t>
+            </a:r>
+          </a:p>
+          <a:p>
+            <a:pPr algn="ctr"/>
+            <a:r>
+              <a:rPr sz="650" b="0">
+                <a:solidFill>
+                  <a:srgbClr val="000000"/>
+                </a:solidFill>
+                <a:latin typeface="맑은 고딕"/>
+                <a:ea typeface="맑은 고딕"/>
+              </a:rPr>
+              <a:t>비용 기반 P/D</a:t>
+            </a:r>
+          </a:p>
+        </p:txBody>
+      </p:sp>
       <p:cxnSp>
         <p:nvCxnSpPr>
-          <p:cNvPr id="184" name="Connector 183"/>
+          <p:cNvPr id="191" name="Connector 190"/>
           <p:cNvCxnSpPr/>
           <p:nvPr/>
         </p:nvCxnSpPr>
         <p:spPr>
           <a:xfrm>
-            <a:off x="9372600" y="2359152"/>
-            <a:ext cx="118872" cy="0"/>
+            <a:off x="9308592" y="2194560"/>
+            <a:ext cx="0" cy="237744"/>
           </a:xfrm>
           <a:prstGeom prst="line">
             <a:avLst/>
           </a:prstGeom>
-          <a:ln w="15875">
+          <a:ln w="19050">
+            <a:solidFill>
+              <a:srgbClr val="5E35B1"/>
+            </a:solidFill>
+            <a:tailEnd type="triangle"/>
+          </a:ln>
+        </p:spPr>
+      </p:cxnSp>
+      <p:sp>
+        <p:nvSpPr>
+          <p:cNvPr id="192" name="Rectangle 191"/>
+          <p:cNvSpPr/>
+          <p:nvPr/>
+        </p:nvSpPr>
+        <p:spPr>
+          <a:xfrm>
+            <a:off x="7333488" y="3346704"/>
+            <a:ext cx="1005840" cy="502920"/>
+          </a:xfrm>
+          <a:prstGeom prst="rect">
+            <a:avLst/>
+          </a:prstGeom>
+          <a:solidFill>
+            <a:srgbClr val="FBE5D6"/>
+          </a:solidFill>
+          <a:ln w="19050">
             <a:solidFill>
               <a:srgbClr val="C55A11"/>
             </a:solidFill>
-            <a:tailEnd type="triangle"/>
-          </a:ln>
-        </p:spPr>
-      </p:cxnSp>
+          </a:ln>
+          <a:effectLst/>
+        </p:spPr>
+        <p:txBody>
+          <a:bodyPr rtlCol="0" anchor="ctr" wrap="square" lIns="36576" tIns="18288" rIns="36576" bIns="18288"/>
+          <a:lstStyle/>
+          <a:p>
+            <a:pPr algn="ctr"/>
+            <a:r>
+              <a:rPr sz="750" b="1">
+                <a:solidFill>
+                  <a:srgbClr val="000000"/>
+                </a:solidFill>
+                <a:latin typeface="맑은 고딕"/>
+                <a:ea typeface="맑은 고딕"/>
+              </a:rPr>
+              <a:t>F 서버 발견</a:t>
+            </a:r>
+          </a:p>
+          <a:p>
+            <a:pPr algn="ctr"/>
+            <a:r>
+              <a:rPr sz="650" b="0">
+                <a:solidFill>
+                  <a:srgbClr val="000000"/>
+                </a:solidFill>
+                <a:latin typeface="맑은 고딕"/>
+                <a:ea typeface="맑은 고딕"/>
+              </a:rPr>
+              <a:t>etcd watch</a:t>
+            </a:r>
+          </a:p>
+        </p:txBody>
+      </p:sp>
+      <p:sp>
+        <p:nvSpPr>
+          <p:cNvPr id="193" name="Rectangle 192"/>
+          <p:cNvSpPr/>
+          <p:nvPr/>
+        </p:nvSpPr>
+        <p:spPr>
+          <a:xfrm>
+            <a:off x="8458200" y="3346704"/>
+            <a:ext cx="1463040" cy="502920"/>
+          </a:xfrm>
+          <a:prstGeom prst="rect">
+            <a:avLst/>
+          </a:prstGeom>
+          <a:solidFill>
+            <a:srgbClr val="FBE5D6"/>
+          </a:solidFill>
+          <a:ln w="19050">
+            <a:solidFill>
+              <a:srgbClr val="C55A11"/>
+            </a:solidFill>
+          </a:ln>
+          <a:effectLst/>
+        </p:spPr>
+        <p:txBody>
+          <a:bodyPr rtlCol="0" anchor="ctr" wrap="square" lIns="36576" tIns="18288" rIns="36576" bIns="18288"/>
+          <a:lstStyle/>
+          <a:p>
+            <a:pPr algn="ctr"/>
+            <a:r>
+              <a:rPr sz="750" b="1">
+                <a:solidFill>
+                  <a:srgbClr val="000000"/>
+                </a:solidFill>
+                <a:latin typeface="맑은 고딕"/>
+                <a:ea typeface="맑은 고딕"/>
+              </a:rPr>
+              <a:t>C 상태 저장소</a:t>
+            </a:r>
+          </a:p>
+          <a:p>
+            <a:pPr algn="ctr"/>
+            <a:r>
+              <a:rPr sz="650" b="0">
+                <a:solidFill>
+                  <a:srgbClr val="000000"/>
+                </a:solidFill>
+                <a:latin typeface="맑은 고딕"/>
+                <a:ea typeface="맑은 고딕"/>
+              </a:rPr>
+              <a:t>KV index · 메트릭</a:t>
+            </a:r>
+          </a:p>
+        </p:txBody>
+      </p:sp>
       <p:cxnSp>
         <p:nvCxnSpPr>
-          <p:cNvPr id="185" name="Connector 184"/>
+          <p:cNvPr id="194" name="Connector 193"/>
           <p:cNvCxnSpPr/>
           <p:nvPr/>
         </p:nvCxnSpPr>
         <p:spPr>
-          <a:xfrm>
-            <a:off x="7635240" y="2029968"/>
-            <a:ext cx="0" cy="210312"/>
+          <a:xfrm flipV="1">
+            <a:off x="9189720" y="3182112"/>
+            <a:ext cx="0" cy="164592"/>
           </a:xfrm>
           <a:prstGeom prst="line">
             <a:avLst/>
@@ -25842,13 +26320,13 @@
       </p:cxnSp>
       <p:sp>
         <p:nvSpPr>
-          <p:cNvPr id="186" name="Oval 185"/>
-          <p:cNvSpPr/>
-          <p:nvPr/>
-        </p:nvSpPr>
-        <p:spPr>
-          <a:xfrm>
-            <a:off x="7712963" y="2061972"/>
+          <p:cNvPr id="195" name="Oval 194"/>
+          <p:cNvSpPr/>
+          <p:nvPr/>
+        </p:nvSpPr>
+        <p:spPr>
+          <a:xfrm>
+            <a:off x="9249155" y="3186684"/>
             <a:ext cx="155448" cy="155448"/>
           </a:xfrm>
           <a:prstGeom prst="ellipse">
@@ -25877,417 +26355,72 @@
                 <a:latin typeface="맑은 고딕"/>
                 <a:ea typeface="맑은 고딕"/>
               </a:rPr>
-              <a:t>2</a:t>
-            </a:r>
-          </a:p>
-        </p:txBody>
-      </p:sp>
-      <p:sp>
-        <p:nvSpPr>
-          <p:cNvPr id="187" name="Rectangle 186"/>
-          <p:cNvSpPr/>
-          <p:nvPr/>
-        </p:nvSpPr>
-        <p:spPr>
-          <a:xfrm>
-            <a:off x="7333488" y="2523744"/>
-            <a:ext cx="914400" cy="137160"/>
-          </a:xfrm>
-          <a:prstGeom prst="rect">
-            <a:avLst/>
-          </a:prstGeom>
-          <a:solidFill>
-            <a:srgbClr val="EDE7F6"/>
-          </a:solidFill>
-          <a:ln w="9525">
-            <a:solidFill>
-              <a:srgbClr val="5E35B1"/>
-            </a:solidFill>
-          </a:ln>
-          <a:effectLst/>
-        </p:spPr>
-        <p:txBody>
-          <a:bodyPr rtlCol="0" anchor="ctr" wrap="square" lIns="18288" tIns="0" rIns="18288" bIns="0"/>
-          <a:lstStyle/>
-          <a:p>
-            <a:pPr algn="ctr"/>
-            <a:r>
-              <a:rPr sz="600" b="1">
-                <a:solidFill>
-                  <a:srgbClr val="5E35B1"/>
-                </a:solidFill>
-                <a:latin typeface="맑은 고딕"/>
-                <a:ea typeface="맑은 고딕"/>
-              </a:rPr>
-              <a:t>«Strategy» 점수 정책</a:t>
-            </a:r>
-          </a:p>
-        </p:txBody>
-      </p:sp>
-      <p:sp>
-        <p:nvSpPr>
-          <p:cNvPr id="188" name="Rectangle 187"/>
-          <p:cNvSpPr/>
-          <p:nvPr/>
-        </p:nvSpPr>
-        <p:spPr>
-          <a:xfrm>
-            <a:off x="7333488" y="2679192"/>
-            <a:ext cx="1783080" cy="713232"/>
-          </a:xfrm>
-          <a:prstGeom prst="rect">
-            <a:avLst/>
-          </a:prstGeom>
-          <a:solidFill>
-            <a:srgbClr val="FFFFFF"/>
-          </a:solidFill>
-          <a:ln w="15875">
-            <a:solidFill>
-              <a:srgbClr val="5E35B1"/>
-            </a:solidFill>
-          </a:ln>
-          <a:effectLst/>
-        </p:spPr>
-        <p:txBody>
-          <a:bodyPr rtlCol="0" anchor="ctr"/>
-          <a:lstStyle/>
-          <a:p>
-            <a:pPr algn="ctr"/>
-          </a:p>
-        </p:txBody>
-      </p:sp>
-      <p:sp>
-        <p:nvSpPr>
-          <p:cNvPr id="189" name="TextBox 188"/>
-          <p:cNvSpPr txBox="1"/>
-          <p:nvPr/>
-        </p:nvSpPr>
-        <p:spPr>
-          <a:xfrm>
-            <a:off x="7370064" y="2697480"/>
-            <a:ext cx="1737360" cy="118872"/>
-          </a:xfrm>
-          <a:prstGeom prst="rect">
-            <a:avLst/>
-          </a:prstGeom>
-          <a:noFill/>
-        </p:spPr>
-        <p:txBody>
-          <a:bodyPr wrap="square" anchor="t" lIns="0" tIns="0" rIns="0" bIns="0">
-            <a:spAutoFit/>
-          </a:bodyPr>
-          <a:lstStyle/>
-          <a:p>
-            <a:pPr algn="l"/>
-            <a:r>
-              <a:rPr sz="650" b="1">
-                <a:solidFill>
-                  <a:srgbClr val="5E35B1"/>
-                </a:solidFill>
-                <a:latin typeface="맑은 고딕"/>
-                <a:ea typeface="맑은 고딕"/>
-              </a:rPr>
-              <a:t>«interface» ScoreStrategy</a:t>
-            </a:r>
-          </a:p>
-        </p:txBody>
-      </p:sp>
-      <p:sp>
-        <p:nvSpPr>
-          <p:cNvPr id="190" name="Rectangle 189"/>
-          <p:cNvSpPr/>
-          <p:nvPr/>
-        </p:nvSpPr>
-        <p:spPr>
-          <a:xfrm>
-            <a:off x="7388352" y="2834640"/>
-            <a:ext cx="1673352" cy="146304"/>
-          </a:xfrm>
-          <a:prstGeom prst="rect">
-            <a:avLst/>
-          </a:prstGeom>
-          <a:solidFill>
-            <a:srgbClr val="FBE5D6"/>
-          </a:solidFill>
-          <a:ln w="12700">
-            <a:solidFill>
-              <a:srgbClr val="C55A11"/>
-            </a:solidFill>
-          </a:ln>
-          <a:effectLst/>
-        </p:spPr>
-        <p:txBody>
-          <a:bodyPr rtlCol="0" anchor="ctr" wrap="square" lIns="36576" tIns="18288" rIns="36576" bIns="18288"/>
-          <a:lstStyle/>
-          <a:p>
-            <a:pPr algn="ctr"/>
-            <a:r>
-              <a:rPr sz="700" b="0">
-                <a:solidFill>
-                  <a:srgbClr val="000000"/>
-                </a:solidFill>
-                <a:latin typeface="맑은 고딕"/>
-                <a:ea typeface="맑은 고딕"/>
-              </a:rPr>
-              <a:t>P1 TierWeightScorer</a:t>
-            </a:r>
-          </a:p>
-        </p:txBody>
-      </p:sp>
-      <p:sp>
-        <p:nvSpPr>
-          <p:cNvPr id="191" name="Rectangle 190"/>
-          <p:cNvSpPr/>
-          <p:nvPr/>
-        </p:nvSpPr>
-        <p:spPr>
-          <a:xfrm>
-            <a:off x="7388352" y="3008376"/>
-            <a:ext cx="1673352" cy="146304"/>
-          </a:xfrm>
-          <a:prstGeom prst="rect">
-            <a:avLst/>
-          </a:prstGeom>
-          <a:solidFill>
-            <a:srgbClr val="FBE5D6"/>
-          </a:solidFill>
-          <a:ln w="12700">
-            <a:solidFill>
-              <a:srgbClr val="C55A11"/>
-            </a:solidFill>
-          </a:ln>
-          <a:effectLst/>
-        </p:spPr>
-        <p:txBody>
-          <a:bodyPr rtlCol="0" anchor="ctr" wrap="square" lIns="36576" tIns="18288" rIns="36576" bIns="18288"/>
-          <a:lstStyle/>
-          <a:p>
-            <a:pPr algn="ctr"/>
-            <a:r>
-              <a:rPr sz="700" b="0">
-                <a:solidFill>
-                  <a:srgbClr val="000000"/>
-                </a:solidFill>
-                <a:latin typeface="맑은 고딕"/>
-                <a:ea typeface="맑은 고딕"/>
-              </a:rPr>
-              <a:t>P2 LiveStateScorer</a:t>
-            </a:r>
-          </a:p>
-        </p:txBody>
-      </p:sp>
-      <p:sp>
-        <p:nvSpPr>
-          <p:cNvPr id="192" name="Rectangle 191"/>
-          <p:cNvSpPr/>
-          <p:nvPr/>
-        </p:nvSpPr>
-        <p:spPr>
-          <a:xfrm>
-            <a:off x="7388352" y="3182112"/>
-            <a:ext cx="1673352" cy="146304"/>
-          </a:xfrm>
-          <a:prstGeom prst="rect">
-            <a:avLst/>
-          </a:prstGeom>
-          <a:solidFill>
-            <a:srgbClr val="FBE5D6"/>
-          </a:solidFill>
-          <a:ln w="12700">
-            <a:solidFill>
-              <a:srgbClr val="C55A11"/>
-            </a:solidFill>
-          </a:ln>
-          <a:effectLst/>
-        </p:spPr>
-        <p:txBody>
-          <a:bodyPr rtlCol="0" anchor="ctr" wrap="square" lIns="36576" tIns="18288" rIns="36576" bIns="18288"/>
-          <a:lstStyle/>
-          <a:p>
-            <a:pPr algn="ctr"/>
-            <a:r>
-              <a:rPr sz="700" b="0">
-                <a:solidFill>
-                  <a:srgbClr val="000000"/>
-                </a:solidFill>
-                <a:latin typeface="맑은 고딕"/>
-                <a:ea typeface="맑은 고딕"/>
-              </a:rPr>
-              <a:t>P3 CostBasedScorer</a:t>
+              <a:t>6</a:t>
             </a:r>
           </a:p>
         </p:txBody>
       </p:sp>
       <p:cxnSp>
         <p:nvCxnSpPr>
-          <p:cNvPr id="193" name="Connector 192"/>
+          <p:cNvPr id="196" name="Connector 195"/>
           <p:cNvCxnSpPr/>
           <p:nvPr/>
         </p:nvCxnSpPr>
         <p:spPr>
           <a:xfrm>
-            <a:off x="8823960" y="2478024"/>
-            <a:ext cx="0" cy="201168"/>
+            <a:off x="7150608" y="3456432"/>
+            <a:ext cx="182880" cy="0"/>
           </a:xfrm>
           <a:prstGeom prst="line">
             <a:avLst/>
           </a:prstGeom>
-          <a:ln w="15875">
-            <a:solidFill>
-              <a:srgbClr val="5E35B1"/>
-            </a:solidFill>
+          <a:ln w="12700">
+            <a:solidFill>
+              <a:srgbClr val="C55A11"/>
+            </a:solidFill>
+            <a:prstDash val="dash"/>
             <a:tailEnd type="triangle"/>
           </a:ln>
         </p:spPr>
       </p:cxnSp>
       <p:sp>
         <p:nvSpPr>
-          <p:cNvPr id="194" name="Rectangle 193"/>
-          <p:cNvSpPr/>
-          <p:nvPr/>
-        </p:nvSpPr>
-        <p:spPr>
-          <a:xfrm>
-            <a:off x="9217152" y="2523744"/>
-            <a:ext cx="1188720" cy="137160"/>
-          </a:xfrm>
-          <a:prstGeom prst="rect">
-            <a:avLst/>
-          </a:prstGeom>
-          <a:solidFill>
-            <a:srgbClr val="EDE7F6"/>
+          <p:cNvPr id="197" name="Oval 196"/>
+          <p:cNvSpPr/>
+          <p:nvPr/>
+        </p:nvSpPr>
+        <p:spPr>
+          <a:xfrm>
+            <a:off x="7164324" y="3241548"/>
+            <a:ext cx="155448" cy="155448"/>
+          </a:xfrm>
+          <a:prstGeom prst="ellipse">
+            <a:avLst/>
+          </a:prstGeom>
+          <a:solidFill>
+            <a:srgbClr val="C55A11"/>
           </a:solidFill>
           <a:ln w="9525">
             <a:solidFill>
-              <a:srgbClr val="5E35B1"/>
-            </a:solidFill>
-          </a:ln>
-          <a:effectLst/>
-        </p:spPr>
-        <p:txBody>
-          <a:bodyPr rtlCol="0" anchor="ctr" wrap="square" lIns="18288" tIns="0" rIns="18288" bIns="0"/>
-          <a:lstStyle/>
-          <a:p>
-            <a:pPr algn="ctr"/>
-            <a:r>
-              <a:rPr sz="600" b="1">
-                <a:solidFill>
-                  <a:srgbClr val="5E35B1"/>
-                </a:solidFill>
-                <a:latin typeface="맑은 고딕"/>
-                <a:ea typeface="맑은 고딕"/>
-              </a:rPr>
-              <a:t>«Strategy» P/D 정책</a:t>
-            </a:r>
-          </a:p>
-        </p:txBody>
-      </p:sp>
-      <p:sp>
-        <p:nvSpPr>
-          <p:cNvPr id="195" name="Rectangle 194"/>
-          <p:cNvSpPr/>
-          <p:nvPr/>
-        </p:nvSpPr>
-        <p:spPr>
-          <a:xfrm>
-            <a:off x="9217152" y="2679192"/>
-            <a:ext cx="1536192" cy="365760"/>
-          </a:xfrm>
-          <a:prstGeom prst="rect">
-            <a:avLst/>
-          </a:prstGeom>
-          <a:solidFill>
-            <a:srgbClr val="FFFFFF"/>
-          </a:solidFill>
-          <a:ln w="15875">
-            <a:solidFill>
-              <a:srgbClr val="5E35B1"/>
-            </a:solidFill>
-          </a:ln>
-          <a:effectLst/>
-        </p:spPr>
-        <p:txBody>
-          <a:bodyPr rtlCol="0" anchor="ctr"/>
-          <a:lstStyle/>
-          <a:p>
-            <a:pPr algn="ctr"/>
-          </a:p>
-        </p:txBody>
-      </p:sp>
-      <p:sp>
-        <p:nvSpPr>
-          <p:cNvPr id="196" name="TextBox 195"/>
-          <p:cNvSpPr txBox="1"/>
-          <p:nvPr/>
-        </p:nvSpPr>
-        <p:spPr>
-          <a:xfrm>
-            <a:off x="9253728" y="2697480"/>
-            <a:ext cx="1463040" cy="118872"/>
-          </a:xfrm>
-          <a:prstGeom prst="rect">
-            <a:avLst/>
-          </a:prstGeom>
-          <a:noFill/>
-        </p:spPr>
-        <p:txBody>
-          <a:bodyPr wrap="square" anchor="t" lIns="0" tIns="0" rIns="0" bIns="0">
-            <a:spAutoFit/>
-          </a:bodyPr>
-          <a:lstStyle/>
-          <a:p>
-            <a:pPr algn="l"/>
+              <a:srgbClr val="FFFFFF"/>
+            </a:solidFill>
+          </a:ln>
+          <a:effectLst/>
+        </p:spPr>
+        <p:txBody>
+          <a:bodyPr rtlCol="0" anchor="ctr" wrap="square" lIns="0" tIns="0" rIns="0" bIns="0"/>
+          <a:lstStyle/>
+          <a:p>
+            <a:pPr algn="ctr"/>
             <a:r>
               <a:rPr sz="650" b="1">
                 <a:solidFill>
-                  <a:srgbClr val="5E35B1"/>
-                </a:solidFill>
-                <a:latin typeface="맑은 고딕"/>
-                <a:ea typeface="맑은 고딕"/>
-              </a:rPr>
-              <a:t>«interface» PDPlanStrategy</a:t>
-            </a:r>
-          </a:p>
-        </p:txBody>
-      </p:sp>
-      <p:sp>
-        <p:nvSpPr>
-          <p:cNvPr id="197" name="Rectangle 196"/>
-          <p:cNvSpPr/>
-          <p:nvPr/>
-        </p:nvSpPr>
-        <p:spPr>
-          <a:xfrm>
-            <a:off x="9272016" y="2852928"/>
-            <a:ext cx="1426464" cy="146304"/>
-          </a:xfrm>
-          <a:prstGeom prst="rect">
-            <a:avLst/>
-          </a:prstGeom>
-          <a:solidFill>
-            <a:srgbClr val="FBE5D6"/>
-          </a:solidFill>
-          <a:ln w="12700">
-            <a:solidFill>
-              <a:srgbClr val="C55A11"/>
-            </a:solidFill>
-          </a:ln>
-          <a:effectLst/>
-        </p:spPr>
-        <p:txBody>
-          <a:bodyPr rtlCol="0" anchor="ctr" wrap="square" lIns="36576" tIns="18288" rIns="36576" bIns="18288"/>
-          <a:lstStyle/>
-          <a:p>
-            <a:pPr algn="ctr"/>
-            <a:r>
-              <a:rPr sz="700" b="0">
-                <a:solidFill>
-                  <a:srgbClr val="000000"/>
-                </a:solidFill>
-                <a:latin typeface="맑은 고딕"/>
-                <a:ea typeface="맑은 고딕"/>
-              </a:rPr>
-              <a:t>P4 CostPDPlanner</a:t>
+                  <a:srgbClr val="FFFFFF"/>
+                </a:solidFill>
+                <a:latin typeface="맑은 고딕"/>
+                <a:ea typeface="맑은 고딕"/>
+              </a:rPr>
+              <a:t>7</a:t>
             </a:r>
           </a:p>
         </p:txBody>
@@ -26300,59 +26433,50 @@
         </p:nvCxnSpPr>
         <p:spPr>
           <a:xfrm>
-            <a:off x="10104120" y="2478024"/>
-            <a:ext cx="0" cy="201168"/>
+            <a:off x="8339328" y="3593592"/>
+            <a:ext cx="118872" cy="0"/>
           </a:xfrm>
           <a:prstGeom prst="line">
             <a:avLst/>
           </a:prstGeom>
+          <a:ln w="12700">
+            <a:solidFill>
+              <a:srgbClr val="C55A11"/>
+            </a:solidFill>
+            <a:prstDash val="dash"/>
+            <a:tailEnd type="triangle"/>
+          </a:ln>
+        </p:spPr>
+      </p:cxnSp>
+      <p:sp>
+        <p:nvSpPr>
+          <p:cNvPr id="199" name="Rectangle 198"/>
+          <p:cNvSpPr/>
+          <p:nvPr/>
+        </p:nvSpPr>
+        <p:spPr>
+          <a:xfrm>
+            <a:off x="10954512" y="1536192"/>
+            <a:ext cx="914400" cy="1234440"/>
+          </a:xfrm>
+          <a:prstGeom prst="rect">
+            <a:avLst/>
+          </a:prstGeom>
+          <a:solidFill>
+            <a:srgbClr val="FFFFFF"/>
+          </a:solidFill>
           <a:ln w="15875">
             <a:solidFill>
-              <a:srgbClr val="5E35B1"/>
-            </a:solidFill>
-            <a:tailEnd type="triangle"/>
-          </a:ln>
-        </p:spPr>
-      </p:cxnSp>
-      <p:sp>
-        <p:nvSpPr>
-          <p:cNvPr id="199" name="Rectangle 198"/>
-          <p:cNvSpPr/>
-          <p:nvPr/>
-        </p:nvSpPr>
-        <p:spPr>
-          <a:xfrm>
-            <a:off x="9217152" y="3090672"/>
-            <a:ext cx="1371600" cy="137160"/>
-          </a:xfrm>
-          <a:prstGeom prst="rect">
-            <a:avLst/>
-          </a:prstGeom>
-          <a:solidFill>
-            <a:srgbClr val="EDE7F6"/>
-          </a:solidFill>
-          <a:ln w="9525">
-            <a:solidFill>
-              <a:srgbClr val="5E35B1"/>
-            </a:solidFill>
-          </a:ln>
-          <a:effectLst/>
-        </p:spPr>
-        <p:txBody>
-          <a:bodyPr rtlCol="0" anchor="ctr" wrap="square" lIns="18288" tIns="0" rIns="18288" bIns="0"/>
-          <a:lstStyle/>
-          <a:p>
-            <a:pPr algn="ctr"/>
-            <a:r>
-              <a:rPr sz="600" b="1">
-                <a:solidFill>
-                  <a:srgbClr val="5E35B1"/>
-                </a:solidFill>
-                <a:latin typeface="맑은 고딕"/>
-                <a:ea typeface="맑은 고딕"/>
-              </a:rPr>
-              <a:t>«Decorator» 지시 체인 (P5)</a:t>
-            </a:r>
+              <a:srgbClr val="7F7F7F"/>
+            </a:solidFill>
+          </a:ln>
+          <a:effectLst/>
+        </p:spPr>
+        <p:txBody>
+          <a:bodyPr rtlCol="0" anchor="ctr"/>
+          <a:lstStyle/>
+          <a:p>
+            <a:pPr algn="ctr"/>
           </a:p>
         </p:txBody>
       </p:sp>
@@ -26364,18 +26488,60 @@
         </p:nvSpPr>
         <p:spPr>
           <a:xfrm>
-            <a:off x="9217152" y="3236976"/>
-            <a:ext cx="1536192" cy="182880"/>
-          </a:xfrm>
-          <a:prstGeom prst="rect">
-            <a:avLst/>
-          </a:prstGeom>
-          <a:solidFill>
-            <a:srgbClr val="FBE5D6"/>
+            <a:off x="10954512" y="1536192"/>
+            <a:ext cx="914400" cy="173736"/>
+          </a:xfrm>
+          <a:prstGeom prst="rect">
+            <a:avLst/>
+          </a:prstGeom>
+          <a:solidFill>
+            <a:srgbClr val="7F7F7F"/>
           </a:solidFill>
           <a:ln w="12700">
             <a:solidFill>
-              <a:srgbClr val="C55A11"/>
+              <a:srgbClr val="7F7F7F"/>
+            </a:solidFill>
+          </a:ln>
+          <a:effectLst/>
+        </p:spPr>
+        <p:txBody>
+          <a:bodyPr rtlCol="0" anchor="ctr" wrap="square" lIns="45720" tIns="0" rIns="18288" bIns="0"/>
+          <a:lstStyle/>
+          <a:p>
+            <a:pPr algn="l"/>
+            <a:r>
+              <a:rPr sz="800" b="1">
+                <a:solidFill>
+                  <a:srgbClr val="FFFFFF"/>
+                </a:solidFill>
+                <a:latin typeface="맑은 고딕"/>
+                <a:ea typeface="맑은 고딕"/>
+              </a:rPr>
+              <a:t>«pod» vLLM</a:t>
+            </a:r>
+          </a:p>
+        </p:txBody>
+      </p:sp>
+      <p:sp>
+        <p:nvSpPr>
+          <p:cNvPr id="201" name="Rectangle 200"/>
+          <p:cNvSpPr/>
+          <p:nvPr/>
+        </p:nvSpPr>
+        <p:spPr>
+          <a:xfrm>
+            <a:off x="11009376" y="1764792"/>
+            <a:ext cx="804672" cy="941832"/>
+          </a:xfrm>
+          <a:prstGeom prst="rect">
+            <a:avLst/>
+          </a:prstGeom>
+          <a:solidFill>
+            <a:srgbClr val="F2F2F2"/>
+          </a:solidFill>
+          <a:ln w="12700">
+            <a:solidFill>
+              <a:srgbClr val="7F7F7F"/>
             </a:solidFill>
           </a:ln>
           <a:effectLst/>
@@ -26386,251 +26552,294 @@
           <a:p>
             <a:pPr algn="ctr"/>
             <a:r>
+              <a:rPr sz="800" b="1">
+                <a:solidFill>
+                  <a:srgbClr val="000000"/>
+                </a:solidFill>
+                <a:latin typeface="맑은 고딕"/>
+                <a:ea typeface="맑은 고딕"/>
+              </a:rPr>
+              <a:t>vLLM</a:t>
+            </a:r>
+          </a:p>
+          <a:p>
+            <a:pPr algn="ctr"/>
+            <a:r>
+              <a:rPr sz="750" b="0">
+                <a:solidFill>
+                  <a:srgbClr val="000000"/>
+                </a:solidFill>
+                <a:latin typeface="맑은 고딕"/>
+                <a:ea typeface="맑은 고딕"/>
+              </a:rPr>
+              <a:t>prefill</a:t>
+            </a:r>
+          </a:p>
+          <a:p>
+            <a:pPr algn="ctr"/>
+            <a:r>
               <a:rPr sz="650" b="0">
                 <a:solidFill>
+                  <a:srgbClr val="404040"/>
+                </a:solidFill>
+                <a:latin typeface="맑은 고딕"/>
+                <a:ea typeface="맑은 고딕"/>
+              </a:rPr>
+              <a:t>KV events</a:t>
+            </a:r>
+          </a:p>
+          <a:p>
+            <a:pPr algn="ctr"/>
+            <a:r>
+              <a:rPr sz="650" b="0">
+                <a:solidFill>
+                  <a:srgbClr val="404040"/>
+                </a:solidFill>
+                <a:latin typeface="맑은 고딕"/>
+                <a:ea typeface="맑은 고딕"/>
+              </a:rPr>
+              <a:t>/metrics</a:t>
+            </a:r>
+          </a:p>
+        </p:txBody>
+      </p:sp>
+      <p:sp>
+        <p:nvSpPr>
+          <p:cNvPr id="202" name="Rectangle 201"/>
+          <p:cNvSpPr/>
+          <p:nvPr/>
+        </p:nvSpPr>
+        <p:spPr>
+          <a:xfrm>
+            <a:off x="10954512" y="2999232"/>
+            <a:ext cx="914400" cy="1371600"/>
+          </a:xfrm>
+          <a:prstGeom prst="rect">
+            <a:avLst/>
+          </a:prstGeom>
+          <a:solidFill>
+            <a:srgbClr val="FFFFFF"/>
+          </a:solidFill>
+          <a:ln w="15875">
+            <a:solidFill>
+              <a:srgbClr val="7F7F7F"/>
+            </a:solidFill>
+          </a:ln>
+          <a:effectLst/>
+        </p:spPr>
+        <p:txBody>
+          <a:bodyPr rtlCol="0" anchor="ctr"/>
+          <a:lstStyle/>
+          <a:p>
+            <a:pPr algn="ctr"/>
+          </a:p>
+        </p:txBody>
+      </p:sp>
+      <p:sp>
+        <p:nvSpPr>
+          <p:cNvPr id="203" name="Rectangle 202"/>
+          <p:cNvSpPr/>
+          <p:nvPr/>
+        </p:nvSpPr>
+        <p:spPr>
+          <a:xfrm>
+            <a:off x="10954512" y="2999232"/>
+            <a:ext cx="914400" cy="173736"/>
+          </a:xfrm>
+          <a:prstGeom prst="rect">
+            <a:avLst/>
+          </a:prstGeom>
+          <a:solidFill>
+            <a:srgbClr val="7F7F7F"/>
+          </a:solidFill>
+          <a:ln w="12700">
+            <a:solidFill>
+              <a:srgbClr val="7F7F7F"/>
+            </a:solidFill>
+          </a:ln>
+          <a:effectLst/>
+        </p:spPr>
+        <p:txBody>
+          <a:bodyPr rtlCol="0" anchor="ctr" wrap="square" lIns="45720" tIns="0" rIns="18288" bIns="0"/>
+          <a:lstStyle/>
+          <a:p>
+            <a:pPr algn="l"/>
+            <a:r>
+              <a:rPr sz="800" b="1">
+                <a:solidFill>
+                  <a:srgbClr val="FFFFFF"/>
+                </a:solidFill>
+                <a:latin typeface="맑은 고딕"/>
+                <a:ea typeface="맑은 고딕"/>
+              </a:rPr>
+              <a:t>«pod» vLLM</a:t>
+            </a:r>
+          </a:p>
+        </p:txBody>
+      </p:sp>
+      <p:sp>
+        <p:nvSpPr>
+          <p:cNvPr id="204" name="Rectangle 203"/>
+          <p:cNvSpPr/>
+          <p:nvPr/>
+        </p:nvSpPr>
+        <p:spPr>
+          <a:xfrm>
+            <a:off x="11009376" y="3227832"/>
+            <a:ext cx="804672" cy="1078992"/>
+          </a:xfrm>
+          <a:prstGeom prst="rect">
+            <a:avLst/>
+          </a:prstGeom>
+          <a:solidFill>
+            <a:srgbClr val="F2F2F2"/>
+          </a:solidFill>
+          <a:ln w="12700">
+            <a:solidFill>
+              <a:srgbClr val="7F7F7F"/>
+            </a:solidFill>
+          </a:ln>
+          <a:effectLst/>
+        </p:spPr>
+        <p:txBody>
+          <a:bodyPr rtlCol="0" anchor="ctr" wrap="square" lIns="36576" tIns="18288" rIns="36576" bIns="18288"/>
+          <a:lstStyle/>
+          <a:p>
+            <a:pPr algn="ctr"/>
+            <a:r>
+              <a:rPr sz="800" b="1">
+                <a:solidFill>
                   <a:srgbClr val="000000"/>
                 </a:solidFill>
                 <a:latin typeface="맑은 고딕"/>
                 <a:ea typeface="맑은 고딕"/>
               </a:rPr>
-              <a:t>기본 ▸ +계층 ▸ +토큰 한도</a:t>
-            </a:r>
-          </a:p>
-        </p:txBody>
-      </p:sp>
-      <p:sp>
-        <p:nvSpPr>
-          <p:cNvPr id="201" name="Rectangle 200"/>
-          <p:cNvSpPr/>
-          <p:nvPr/>
-        </p:nvSpPr>
-        <p:spPr>
-          <a:xfrm>
-            <a:off x="7333488" y="3493008"/>
-            <a:ext cx="914400" cy="137160"/>
-          </a:xfrm>
-          <a:prstGeom prst="rect">
-            <a:avLst/>
-          </a:prstGeom>
-          <a:solidFill>
-            <a:srgbClr val="EDE7F6"/>
-          </a:solidFill>
-          <a:ln w="9525">
-            <a:solidFill>
-              <a:srgbClr val="5E35B1"/>
-            </a:solidFill>
-          </a:ln>
-          <a:effectLst/>
-        </p:spPr>
-        <p:txBody>
-          <a:bodyPr rtlCol="0" anchor="ctr" wrap="square" lIns="18288" tIns="0" rIns="18288" bIns="0"/>
-          <a:lstStyle/>
-          <a:p>
-            <a:pPr algn="ctr"/>
-            <a:r>
-              <a:rPr sz="600" b="1">
-                <a:solidFill>
-                  <a:srgbClr val="5E35B1"/>
-                </a:solidFill>
-                <a:latin typeface="맑은 고딕"/>
-                <a:ea typeface="맑은 고딕"/>
-              </a:rPr>
-              <a:t>«Observer» 상태 갱신</a:t>
-            </a:r>
-          </a:p>
-        </p:txBody>
-      </p:sp>
-      <p:sp>
-        <p:nvSpPr>
-          <p:cNvPr id="202" name="Rectangle 201"/>
-          <p:cNvSpPr/>
-          <p:nvPr/>
-        </p:nvSpPr>
-        <p:spPr>
-          <a:xfrm>
-            <a:off x="7333488" y="3657600"/>
-            <a:ext cx="777240" cy="457200"/>
-          </a:xfrm>
-          <a:prstGeom prst="rect">
-            <a:avLst/>
-          </a:prstGeom>
-          <a:solidFill>
-            <a:srgbClr val="FBE5D6"/>
-          </a:solidFill>
-          <a:ln w="19050">
-            <a:solidFill>
-              <a:srgbClr val="C55A11"/>
-            </a:solidFill>
-          </a:ln>
-          <a:effectLst/>
-        </p:spPr>
-        <p:txBody>
-          <a:bodyPr rtlCol="0" anchor="ctr" wrap="square" lIns="36576" tIns="18288" rIns="36576" bIns="18288"/>
-          <a:lstStyle/>
-          <a:p>
-            <a:pPr algn="ctr"/>
-            <a:r>
-              <a:rPr sz="700" b="1">
+              <a:t>vLLM</a:t>
+            </a:r>
+          </a:p>
+          <a:p>
+            <a:pPr algn="ctr"/>
+            <a:r>
+              <a:rPr sz="750" b="0">
                 <a:solidFill>
                   <a:srgbClr val="000000"/>
                 </a:solidFill>
                 <a:latin typeface="맑은 고딕"/>
                 <a:ea typeface="맑은 고딕"/>
               </a:rPr>
-              <a:t>Event</a:t>
-            </a:r>
-          </a:p>
-          <a:p>
-            <a:pPr algn="ctr"/>
-            <a:r>
-              <a:rPr sz="700" b="1">
-                <a:solidFill>
-                  <a:srgbClr val="000000"/>
-                </a:solidFill>
-                <a:latin typeface="맑은 고딕"/>
-                <a:ea typeface="맑은 고딕"/>
-              </a:rPr>
-              <a:t>Subscriber</a:t>
-            </a:r>
-          </a:p>
-          <a:p>
-            <a:pPr algn="ctr"/>
-            <a:r>
-              <a:rPr sz="600" b="0">
+              <a:t>decode</a:t>
+            </a:r>
+          </a:p>
+          <a:p>
+            <a:pPr algn="ctr"/>
+            <a:r>
+              <a:rPr sz="650" b="0">
                 <a:solidFill>
                   <a:srgbClr val="404040"/>
                 </a:solidFill>
                 <a:latin typeface="맑은 고딕"/>
                 <a:ea typeface="맑은 고딕"/>
               </a:rPr>
-              <a:t>(Subject)</a:t>
-            </a:r>
-          </a:p>
-        </p:txBody>
-      </p:sp>
-      <p:sp>
-        <p:nvSpPr>
-          <p:cNvPr id="203" name="Rectangle 202"/>
-          <p:cNvSpPr/>
-          <p:nvPr/>
-        </p:nvSpPr>
-        <p:spPr>
-          <a:xfrm>
-            <a:off x="8229600" y="3657600"/>
-            <a:ext cx="868680" cy="210312"/>
-          </a:xfrm>
-          <a:prstGeom prst="rect">
-            <a:avLst/>
-          </a:prstGeom>
-          <a:solidFill>
-            <a:srgbClr val="FBE5D6"/>
-          </a:solidFill>
-          <a:ln w="12700">
-            <a:solidFill>
-              <a:srgbClr val="C55A11"/>
-            </a:solidFill>
-          </a:ln>
-          <a:effectLst/>
-        </p:spPr>
-        <p:txBody>
-          <a:bodyPr rtlCol="0" anchor="ctr" wrap="square" lIns="36576" tIns="18288" rIns="36576" bIns="18288"/>
-          <a:lstStyle/>
-          <a:p>
-            <a:pPr algn="ctr"/>
-            <a:r>
-              <a:rPr sz="650" b="1">
-                <a:solidFill>
-                  <a:srgbClr val="000000"/>
-                </a:solidFill>
-                <a:latin typeface="맑은 고딕"/>
-                <a:ea typeface="맑은 고딕"/>
-              </a:rPr>
-              <a:t>KV Index 갱신</a:t>
+              <a:t>KV events</a:t>
+            </a:r>
+          </a:p>
+          <a:p>
+            <a:pPr algn="ctr"/>
+            <a:r>
+              <a:rPr sz="650" b="0">
+                <a:solidFill>
+                  <a:srgbClr val="404040"/>
+                </a:solidFill>
+                <a:latin typeface="맑은 고딕"/>
+                <a:ea typeface="맑은 고딕"/>
+              </a:rPr>
+              <a:t>/metrics</a:t>
             </a:r>
           </a:p>
         </p:txBody>
       </p:sp>
       <p:cxnSp>
         <p:nvCxnSpPr>
-          <p:cNvPr id="204" name="Connector 203"/>
+          <p:cNvPr id="205" name="Connector 204"/>
           <p:cNvCxnSpPr/>
           <p:nvPr/>
         </p:nvCxnSpPr>
         <p:spPr>
-          <a:xfrm flipV="1">
-            <a:off x="8110728" y="3758184"/>
-            <a:ext cx="118872" cy="64007"/>
+          <a:xfrm>
+            <a:off x="11411712" y="2770632"/>
+            <a:ext cx="0" cy="457200"/>
           </a:xfrm>
           <a:prstGeom prst="line">
             <a:avLst/>
           </a:prstGeom>
-          <a:ln w="12700">
-            <a:solidFill>
-              <a:srgbClr val="C55A11"/>
-            </a:solidFill>
+          <a:ln w="15875">
+            <a:solidFill>
+              <a:srgbClr val="404040"/>
+            </a:solidFill>
+            <a:headEnd type="triangle"/>
             <a:tailEnd type="triangle"/>
           </a:ln>
         </p:spPr>
       </p:cxnSp>
       <p:sp>
         <p:nvSpPr>
-          <p:cNvPr id="205" name="Rectangle 204"/>
-          <p:cNvSpPr/>
-          <p:nvPr/>
-        </p:nvSpPr>
-        <p:spPr>
-          <a:xfrm>
-            <a:off x="8229600" y="3904487"/>
-            <a:ext cx="868680" cy="210312"/>
-          </a:xfrm>
-          <a:prstGeom prst="rect">
-            <a:avLst/>
-          </a:prstGeom>
-          <a:solidFill>
-            <a:srgbClr val="FBE5D6"/>
-          </a:solidFill>
-          <a:ln w="12700">
-            <a:solidFill>
-              <a:srgbClr val="C55A11"/>
-            </a:solidFill>
-          </a:ln>
-          <a:effectLst/>
-        </p:spPr>
-        <p:txBody>
-          <a:bodyPr rtlCol="0" anchor="ctr" wrap="square" lIns="36576" tIns="18288" rIns="36576" bIns="18288"/>
+          <p:cNvPr id="206" name="Oval 205"/>
+          <p:cNvSpPr/>
+          <p:nvPr/>
+        </p:nvSpPr>
+        <p:spPr>
+          <a:xfrm>
+            <a:off x="11553443" y="2793492"/>
+            <a:ext cx="155448" cy="155448"/>
+          </a:xfrm>
+          <a:prstGeom prst="ellipse">
+            <a:avLst/>
+          </a:prstGeom>
+          <a:solidFill>
+            <a:srgbClr val="C55A11"/>
+          </a:solidFill>
+          <a:ln w="9525">
+            <a:solidFill>
+              <a:srgbClr val="FFFFFF"/>
+            </a:solidFill>
+          </a:ln>
+          <a:effectLst/>
+        </p:spPr>
+        <p:txBody>
+          <a:bodyPr rtlCol="0" anchor="ctr" wrap="square" lIns="0" tIns="0" rIns="0" bIns="0"/>
           <a:lstStyle/>
           <a:p>
             <a:pPr algn="ctr"/>
             <a:r>
               <a:rPr sz="650" b="1">
                 <a:solidFill>
-                  <a:srgbClr val="000000"/>
-                </a:solidFill>
-                <a:latin typeface="맑은 고딕"/>
-                <a:ea typeface="맑은 고딕"/>
-              </a:rPr>
-              <a:t>Metrics 스냅샷</a:t>
+                  <a:srgbClr val="FFFFFF"/>
+                </a:solidFill>
+                <a:latin typeface="맑은 고딕"/>
+                <a:ea typeface="맑은 고딕"/>
+              </a:rPr>
+              <a:t>4</a:t>
             </a:r>
           </a:p>
         </p:txBody>
       </p:sp>
       <p:cxnSp>
         <p:nvCxnSpPr>
-          <p:cNvPr id="206" name="Connector 205"/>
+          <p:cNvPr id="207" name="Connector 206"/>
           <p:cNvCxnSpPr/>
           <p:nvPr/>
         </p:nvCxnSpPr>
         <p:spPr>
           <a:xfrm>
-            <a:off x="8110728" y="3959352"/>
-            <a:ext cx="118872" cy="45720"/>
+            <a:off x="10643616" y="2002536"/>
+            <a:ext cx="365760" cy="173736"/>
           </a:xfrm>
           <a:prstGeom prst="line">
             <a:avLst/>
           </a:prstGeom>
-          <a:ln w="12700">
-            <a:solidFill>
-              <a:srgbClr val="C55A11"/>
+          <a:ln w="15875">
+            <a:solidFill>
+              <a:srgbClr val="404040"/>
             </a:solidFill>
             <a:tailEnd type="triangle"/>
           </a:ln>
@@ -26638,81 +26847,46 @@
       </p:cxnSp>
       <p:sp>
         <p:nvSpPr>
-          <p:cNvPr id="207" name="Rectangle 206"/>
-          <p:cNvSpPr/>
-          <p:nvPr/>
-        </p:nvSpPr>
-        <p:spPr>
-          <a:xfrm>
-            <a:off x="9217152" y="3657600"/>
-            <a:ext cx="731520" cy="457200"/>
-          </a:xfrm>
-          <a:prstGeom prst="rect">
-            <a:avLst/>
-          </a:prstGeom>
-          <a:solidFill>
-            <a:srgbClr val="FBE5D6"/>
-          </a:solidFill>
-          <a:ln w="19050">
-            <a:solidFill>
-              <a:srgbClr val="C55A11"/>
-            </a:solidFill>
-          </a:ln>
-          <a:effectLst/>
-        </p:spPr>
-        <p:txBody>
-          <a:bodyPr rtlCol="0" anchor="ctr" wrap="square" lIns="36576" tIns="18288" rIns="36576" bIns="18288"/>
-          <a:lstStyle/>
-          <a:p>
-            <a:pPr algn="ctr"/>
-            <a:r>
-              <a:rPr sz="700" b="1">
-                <a:solidFill>
-                  <a:srgbClr val="000000"/>
-                </a:solidFill>
-                <a:latin typeface="맑은 고딕"/>
-                <a:ea typeface="맑은 고딕"/>
-              </a:rPr>
-              <a:t>StateView</a:t>
-            </a:r>
-          </a:p>
-          <a:p>
-            <a:pPr algn="ctr"/>
-            <a:r>
-              <a:rPr sz="600" b="0">
-                <a:solidFill>
-                  <a:srgbClr val="404040"/>
-                </a:solidFill>
-                <a:latin typeface="맑은 고딕"/>
-                <a:ea typeface="맑은 고딕"/>
-              </a:rPr>
-              <a:t>읽기 전용 Facade</a:t>
-            </a:r>
-          </a:p>
-        </p:txBody>
-      </p:sp>
-      <p:cxnSp>
-        <p:nvCxnSpPr>
-          <p:cNvPr id="208" name="Connector 207"/>
-          <p:cNvCxnSpPr/>
-          <p:nvPr/>
-        </p:nvCxnSpPr>
-        <p:spPr>
-          <a:xfrm>
-            <a:off x="9098280" y="3877056"/>
-            <a:ext cx="118872" cy="0"/>
-          </a:xfrm>
-          <a:prstGeom prst="line">
-            <a:avLst/>
-          </a:prstGeom>
-          <a:ln w="12700">
-            <a:solidFill>
-              <a:srgbClr val="C55A11"/>
-            </a:solidFill>
-            <a:tailEnd type="triangle"/>
-          </a:ln>
-        </p:spPr>
-      </p:cxnSp>
+          <p:cNvPr id="208" name="Oval 207"/>
+          <p:cNvSpPr/>
+          <p:nvPr/>
+        </p:nvSpPr>
+        <p:spPr>
+          <a:xfrm>
+            <a:off x="10730484" y="1851660"/>
+            <a:ext cx="155448" cy="155448"/>
+          </a:xfrm>
+          <a:prstGeom prst="ellipse">
+            <a:avLst/>
+          </a:prstGeom>
+          <a:solidFill>
+            <a:srgbClr val="C55A11"/>
+          </a:solidFill>
+          <a:ln w="9525">
+            <a:solidFill>
+              <a:srgbClr val="FFFFFF"/>
+            </a:solidFill>
+          </a:ln>
+          <a:effectLst/>
+        </p:spPr>
+        <p:txBody>
+          <a:bodyPr rtlCol="0" anchor="ctr" wrap="square" lIns="0" tIns="0" rIns="0" bIns="0"/>
+          <a:lstStyle/>
+          <a:p>
+            <a:pPr algn="ctr"/>
+            <a:r>
+              <a:rPr sz="650" b="1">
+                <a:solidFill>
+                  <a:srgbClr val="FFFFFF"/>
+                </a:solidFill>
+                <a:latin typeface="맑은 고딕"/>
+                <a:ea typeface="맑은 고딕"/>
+              </a:rPr>
+              <a:t>3</a:t>
+            </a:r>
+          </a:p>
+        </p:txBody>
+      </p:sp>
       <p:cxnSp>
         <p:nvCxnSpPr>
           <p:cNvPr id="209" name="Connector 208"/>
@@ -26720,157 +26894,16 @@
           <p:nvPr/>
         </p:nvCxnSpPr>
         <p:spPr>
-          <a:xfrm flipH="1" flipV="1">
-            <a:off x="8961120" y="3392424"/>
-            <a:ext cx="548640" cy="265176"/>
+          <a:xfrm flipH="1">
+            <a:off x="9189720" y="3959352"/>
+            <a:ext cx="1819656" cy="0"/>
           </a:xfrm>
           <a:prstGeom prst="line">
             <a:avLst/>
           </a:prstGeom>
-          <a:ln w="15875">
-            <a:solidFill>
-              <a:srgbClr val="C55A11"/>
-            </a:solidFill>
-            <a:tailEnd type="triangle"/>
-          </a:ln>
-        </p:spPr>
-      </p:cxnSp>
-      <p:sp>
-        <p:nvSpPr>
-          <p:cNvPr id="210" name="Oval 209"/>
-          <p:cNvSpPr/>
-          <p:nvPr/>
-        </p:nvSpPr>
-        <p:spPr>
-          <a:xfrm>
-            <a:off x="9203436" y="3451860"/>
-            <a:ext cx="155448" cy="155448"/>
-          </a:xfrm>
-          <a:prstGeom prst="ellipse">
-            <a:avLst/>
-          </a:prstGeom>
-          <a:solidFill>
-            <a:srgbClr val="C55A11"/>
-          </a:solidFill>
-          <a:ln w="9525">
-            <a:solidFill>
-              <a:srgbClr val="FFFFFF"/>
-            </a:solidFill>
-          </a:ln>
-          <a:effectLst/>
-        </p:spPr>
-        <p:txBody>
-          <a:bodyPr rtlCol="0" anchor="ctr" wrap="square" lIns="0" tIns="0" rIns="0" bIns="0"/>
-          <a:lstStyle/>
-          <a:p>
-            <a:pPr algn="ctr"/>
-            <a:r>
-              <a:rPr sz="650" b="1">
-                <a:solidFill>
-                  <a:srgbClr val="FFFFFF"/>
-                </a:solidFill>
-                <a:latin typeface="맑은 고딕"/>
-                <a:ea typeface="맑은 고딕"/>
-              </a:rPr>
-              <a:t>6</a:t>
-            </a:r>
-          </a:p>
-        </p:txBody>
-      </p:sp>
-      <p:cxnSp>
-        <p:nvCxnSpPr>
-          <p:cNvPr id="211" name="Connector 210"/>
-          <p:cNvCxnSpPr/>
-          <p:nvPr/>
-        </p:nvCxnSpPr>
-        <p:spPr>
-          <a:xfrm flipV="1">
-            <a:off x="9784080" y="3419856"/>
-            <a:ext cx="0" cy="237744"/>
-          </a:xfrm>
-          <a:prstGeom prst="line">
-            <a:avLst/>
-          </a:prstGeom>
-          <a:ln w="15875">
-            <a:solidFill>
-              <a:srgbClr val="C55A11"/>
-            </a:solidFill>
-            <a:tailEnd type="triangle"/>
-          </a:ln>
-        </p:spPr>
-      </p:cxnSp>
-      <p:sp>
-        <p:nvSpPr>
-          <p:cNvPr id="212" name="Rectangle 211"/>
-          <p:cNvSpPr/>
-          <p:nvPr/>
-        </p:nvSpPr>
-        <p:spPr>
-          <a:xfrm>
-            <a:off x="10021824" y="3657600"/>
-            <a:ext cx="694944" cy="457200"/>
-          </a:xfrm>
-          <a:prstGeom prst="rect">
-            <a:avLst/>
-          </a:prstGeom>
-          <a:solidFill>
-            <a:srgbClr val="FBE5D6"/>
-          </a:solidFill>
-          <a:ln w="19050">
-            <a:solidFill>
-              <a:srgbClr val="C55A11"/>
-            </a:solidFill>
-          </a:ln>
-          <a:effectLst/>
-        </p:spPr>
-        <p:txBody>
-          <a:bodyPr rtlCol="0" anchor="ctr" wrap="square" lIns="36576" tIns="18288" rIns="36576" bIns="18288"/>
-          <a:lstStyle/>
-          <a:p>
-            <a:pPr algn="ctr"/>
-            <a:r>
-              <a:rPr sz="700" b="1">
-                <a:solidFill>
-                  <a:srgbClr val="000000"/>
-                </a:solidFill>
-                <a:latin typeface="맑은 고딕"/>
-                <a:ea typeface="맑은 고딕"/>
-              </a:rPr>
-              <a:t>F Registry</a:t>
-            </a:r>
-          </a:p>
-          <a:p>
-            <a:pPr algn="ctr"/>
-            <a:r>
-              <a:rPr sz="600" b="0">
-                <a:solidFill>
-                  <a:srgbClr val="404040"/>
-                </a:solidFill>
-                <a:latin typeface="맑은 고딕"/>
-                <a:ea typeface="맑은 고딕"/>
-              </a:rPr>
-              <a:t>etcd watch</a:t>
-            </a:r>
-          </a:p>
-        </p:txBody>
-      </p:sp>
-      <p:cxnSp>
-        <p:nvCxnSpPr>
-          <p:cNvPr id="213" name="Connector 212"/>
-          <p:cNvCxnSpPr/>
-          <p:nvPr/>
-        </p:nvCxnSpPr>
-        <p:spPr>
-          <a:xfrm>
-            <a:off x="7150608" y="4165091"/>
-            <a:ext cx="2999232" cy="0"/>
-          </a:xfrm>
-          <a:prstGeom prst="line">
-            <a:avLst/>
-          </a:prstGeom>
           <a:ln w="12700">
             <a:solidFill>
-              <a:srgbClr val="C55A11"/>
+              <a:srgbClr val="404040"/>
             </a:solidFill>
             <a:prstDash val="dash"/>
           </a:ln>
@@ -26878,606 +26911,19 @@
       </p:cxnSp>
       <p:cxnSp>
         <p:nvCxnSpPr>
-          <p:cNvPr id="214" name="Connector 213"/>
+          <p:cNvPr id="210" name="Connector 209"/>
           <p:cNvCxnSpPr/>
           <p:nvPr/>
         </p:nvCxnSpPr>
         <p:spPr>
           <a:xfrm flipV="1">
-            <a:off x="10149840" y="4114800"/>
-            <a:ext cx="0" cy="50291"/>
+            <a:off x="9189720" y="3849624"/>
+            <a:ext cx="0" cy="109728"/>
           </a:xfrm>
           <a:prstGeom prst="line">
             <a:avLst/>
           </a:prstGeom>
           <a:ln w="12700">
-            <a:solidFill>
-              <a:srgbClr val="C55A11"/>
-            </a:solidFill>
-            <a:tailEnd type="triangle"/>
-          </a:ln>
-        </p:spPr>
-      </p:cxnSp>
-      <p:sp>
-        <p:nvSpPr>
-          <p:cNvPr id="215" name="Oval 214"/>
-          <p:cNvSpPr/>
-          <p:nvPr/>
-        </p:nvSpPr>
-        <p:spPr>
-          <a:xfrm>
-            <a:off x="7109460" y="3927348"/>
-            <a:ext cx="155448" cy="155448"/>
-          </a:xfrm>
-          <a:prstGeom prst="ellipse">
-            <a:avLst/>
-          </a:prstGeom>
-          <a:solidFill>
-            <a:srgbClr val="C55A11"/>
-          </a:solidFill>
-          <a:ln w="9525">
-            <a:solidFill>
-              <a:srgbClr val="FFFFFF"/>
-            </a:solidFill>
-          </a:ln>
-          <a:effectLst/>
-        </p:spPr>
-        <p:txBody>
-          <a:bodyPr rtlCol="0" anchor="ctr" wrap="square" lIns="0" tIns="0" rIns="0" bIns="0"/>
-          <a:lstStyle/>
-          <a:p>
-            <a:pPr algn="ctr"/>
-            <a:r>
-              <a:rPr sz="650" b="1">
-                <a:solidFill>
-                  <a:srgbClr val="FFFFFF"/>
-                </a:solidFill>
-                <a:latin typeface="맑은 고딕"/>
-                <a:ea typeface="맑은 고딕"/>
-              </a:rPr>
-              <a:t>7</a:t>
-            </a:r>
-          </a:p>
-        </p:txBody>
-      </p:sp>
-      <p:sp>
-        <p:nvSpPr>
-          <p:cNvPr id="216" name="Rectangle 215"/>
-          <p:cNvSpPr/>
-          <p:nvPr/>
-        </p:nvSpPr>
-        <p:spPr>
-          <a:xfrm>
-            <a:off x="7333488" y="4215384"/>
-            <a:ext cx="822960" cy="137160"/>
-          </a:xfrm>
-          <a:prstGeom prst="rect">
-            <a:avLst/>
-          </a:prstGeom>
-          <a:solidFill>
-            <a:srgbClr val="EDE7F6"/>
-          </a:solidFill>
-          <a:ln w="9525">
-            <a:solidFill>
-              <a:srgbClr val="5E35B1"/>
-            </a:solidFill>
-          </a:ln>
-          <a:effectLst/>
-        </p:spPr>
-        <p:txBody>
-          <a:bodyPr rtlCol="0" anchor="ctr" wrap="square" lIns="18288" tIns="0" rIns="18288" bIns="0"/>
-          <a:lstStyle/>
-          <a:p>
-            <a:pPr algn="ctr"/>
-            <a:r>
-              <a:rPr sz="600" b="1">
-                <a:solidFill>
-                  <a:srgbClr val="5E35B1"/>
-                </a:solidFill>
-                <a:latin typeface="맑은 고딕"/>
-                <a:ea typeface="맑은 고딕"/>
-              </a:rPr>
-              <a:t>«Adapter»</a:t>
-            </a:r>
-          </a:p>
-        </p:txBody>
-      </p:sp>
-      <p:sp>
-        <p:nvSpPr>
-          <p:cNvPr id="217" name="Rectangle 216"/>
-          <p:cNvSpPr/>
-          <p:nvPr/>
-        </p:nvSpPr>
-        <p:spPr>
-          <a:xfrm>
-            <a:off x="8193024" y="4215384"/>
-            <a:ext cx="2523744" cy="137160"/>
-          </a:xfrm>
-          <a:prstGeom prst="rect">
-            <a:avLst/>
-          </a:prstGeom>
-          <a:solidFill>
-            <a:srgbClr val="FFFFFF"/>
-          </a:solidFill>
-          <a:ln w="9525">
-            <a:solidFill>
-              <a:srgbClr val="5E35B1"/>
-            </a:solidFill>
-          </a:ln>
-          <a:effectLst/>
-        </p:spPr>
-        <p:txBody>
-          <a:bodyPr rtlCol="0" anchor="ctr" wrap="square" lIns="18288" tIns="0" rIns="18288" bIns="0"/>
-          <a:lstStyle/>
-          <a:p>
-            <a:pPr algn="ctr"/>
-            <a:r>
-              <a:rPr sz="600" b="1">
-                <a:solidFill>
-                  <a:srgbClr val="5E35B1"/>
-                </a:solidFill>
-                <a:latin typeface="맑은 고딕"/>
-                <a:ea typeface="맑은 고딕"/>
-              </a:rPr>
-              <a:t>vLLM 계약 어댑터: KV 이벤트 · /metrics · kv_transfer_params</a:t>
-            </a:r>
-          </a:p>
-        </p:txBody>
-      </p:sp>
-      <p:sp>
-        <p:nvSpPr>
-          <p:cNvPr id="218" name="Rectangle 217"/>
-          <p:cNvSpPr/>
-          <p:nvPr/>
-        </p:nvSpPr>
-        <p:spPr>
-          <a:xfrm>
-            <a:off x="10954512" y="1536192"/>
-            <a:ext cx="914400" cy="1234440"/>
-          </a:xfrm>
-          <a:prstGeom prst="rect">
-            <a:avLst/>
-          </a:prstGeom>
-          <a:solidFill>
-            <a:srgbClr val="FFFFFF"/>
-          </a:solidFill>
-          <a:ln w="15875">
-            <a:solidFill>
-              <a:srgbClr val="7F7F7F"/>
-            </a:solidFill>
-          </a:ln>
-          <a:effectLst/>
-        </p:spPr>
-        <p:txBody>
-          <a:bodyPr rtlCol="0" anchor="ctr"/>
-          <a:lstStyle/>
-          <a:p>
-            <a:pPr algn="ctr"/>
-          </a:p>
-        </p:txBody>
-      </p:sp>
-      <p:sp>
-        <p:nvSpPr>
-          <p:cNvPr id="219" name="Rectangle 218"/>
-          <p:cNvSpPr/>
-          <p:nvPr/>
-        </p:nvSpPr>
-        <p:spPr>
-          <a:xfrm>
-            <a:off x="10954512" y="1536192"/>
-            <a:ext cx="914400" cy="173736"/>
-          </a:xfrm>
-          <a:prstGeom prst="rect">
-            <a:avLst/>
-          </a:prstGeom>
-          <a:solidFill>
-            <a:srgbClr val="7F7F7F"/>
-          </a:solidFill>
-          <a:ln w="12700">
-            <a:solidFill>
-              <a:srgbClr val="7F7F7F"/>
-            </a:solidFill>
-          </a:ln>
-          <a:effectLst/>
-        </p:spPr>
-        <p:txBody>
-          <a:bodyPr rtlCol="0" anchor="ctr" wrap="square" lIns="45720" tIns="0" rIns="18288" bIns="0"/>
-          <a:lstStyle/>
-          <a:p>
-            <a:pPr algn="l"/>
-            <a:r>
-              <a:rPr sz="800" b="1">
-                <a:solidFill>
-                  <a:srgbClr val="FFFFFF"/>
-                </a:solidFill>
-                <a:latin typeface="맑은 고딕"/>
-                <a:ea typeface="맑은 고딕"/>
-              </a:rPr>
-              <a:t>«pod» vLLM</a:t>
-            </a:r>
-          </a:p>
-        </p:txBody>
-      </p:sp>
-      <p:sp>
-        <p:nvSpPr>
-          <p:cNvPr id="220" name="Rectangle 219"/>
-          <p:cNvSpPr/>
-          <p:nvPr/>
-        </p:nvSpPr>
-        <p:spPr>
-          <a:xfrm>
-            <a:off x="11009376" y="1764792"/>
-            <a:ext cx="804672" cy="941832"/>
-          </a:xfrm>
-          <a:prstGeom prst="rect">
-            <a:avLst/>
-          </a:prstGeom>
-          <a:solidFill>
-            <a:srgbClr val="F2F2F2"/>
-          </a:solidFill>
-          <a:ln w="12700">
-            <a:solidFill>
-              <a:srgbClr val="7F7F7F"/>
-            </a:solidFill>
-          </a:ln>
-          <a:effectLst/>
-        </p:spPr>
-        <p:txBody>
-          <a:bodyPr rtlCol="0" anchor="ctr" wrap="square" lIns="36576" tIns="18288" rIns="36576" bIns="18288"/>
-          <a:lstStyle/>
-          <a:p>
-            <a:pPr algn="ctr"/>
-            <a:r>
-              <a:rPr sz="800" b="1">
-                <a:solidFill>
-                  <a:srgbClr val="000000"/>
-                </a:solidFill>
-                <a:latin typeface="맑은 고딕"/>
-                <a:ea typeface="맑은 고딕"/>
-              </a:rPr>
-              <a:t>vLLM</a:t>
-            </a:r>
-          </a:p>
-          <a:p>
-            <a:pPr algn="ctr"/>
-            <a:r>
-              <a:rPr sz="750" b="0">
-                <a:solidFill>
-                  <a:srgbClr val="000000"/>
-                </a:solidFill>
-                <a:latin typeface="맑은 고딕"/>
-                <a:ea typeface="맑은 고딕"/>
-              </a:rPr>
-              <a:t>prefill</a:t>
-            </a:r>
-          </a:p>
-          <a:p>
-            <a:pPr algn="ctr"/>
-            <a:r>
-              <a:rPr sz="650" b="0">
-                <a:solidFill>
-                  <a:srgbClr val="404040"/>
-                </a:solidFill>
-                <a:latin typeface="맑은 고딕"/>
-                <a:ea typeface="맑은 고딕"/>
-              </a:rPr>
-              <a:t>KV events</a:t>
-            </a:r>
-          </a:p>
-          <a:p>
-            <a:pPr algn="ctr"/>
-            <a:r>
-              <a:rPr sz="650" b="0">
-                <a:solidFill>
-                  <a:srgbClr val="404040"/>
-                </a:solidFill>
-                <a:latin typeface="맑은 고딕"/>
-                <a:ea typeface="맑은 고딕"/>
-              </a:rPr>
-              <a:t>/metrics</a:t>
-            </a:r>
-          </a:p>
-        </p:txBody>
-      </p:sp>
-      <p:sp>
-        <p:nvSpPr>
-          <p:cNvPr id="221" name="Rectangle 220"/>
-          <p:cNvSpPr/>
-          <p:nvPr/>
-        </p:nvSpPr>
-        <p:spPr>
-          <a:xfrm>
-            <a:off x="10954512" y="2999232"/>
-            <a:ext cx="914400" cy="1371600"/>
-          </a:xfrm>
-          <a:prstGeom prst="rect">
-            <a:avLst/>
-          </a:prstGeom>
-          <a:solidFill>
-            <a:srgbClr val="FFFFFF"/>
-          </a:solidFill>
-          <a:ln w="15875">
-            <a:solidFill>
-              <a:srgbClr val="7F7F7F"/>
-            </a:solidFill>
-          </a:ln>
-          <a:effectLst/>
-        </p:spPr>
-        <p:txBody>
-          <a:bodyPr rtlCol="0" anchor="ctr"/>
-          <a:lstStyle/>
-          <a:p>
-            <a:pPr algn="ctr"/>
-          </a:p>
-        </p:txBody>
-      </p:sp>
-      <p:sp>
-        <p:nvSpPr>
-          <p:cNvPr id="222" name="Rectangle 221"/>
-          <p:cNvSpPr/>
-          <p:nvPr/>
-        </p:nvSpPr>
-        <p:spPr>
-          <a:xfrm>
-            <a:off x="10954512" y="2999232"/>
-            <a:ext cx="914400" cy="173736"/>
-          </a:xfrm>
-          <a:prstGeom prst="rect">
-            <a:avLst/>
-          </a:prstGeom>
-          <a:solidFill>
-            <a:srgbClr val="7F7F7F"/>
-          </a:solidFill>
-          <a:ln w="12700">
-            <a:solidFill>
-              <a:srgbClr val="7F7F7F"/>
-            </a:solidFill>
-          </a:ln>
-          <a:effectLst/>
-        </p:spPr>
-        <p:txBody>
-          <a:bodyPr rtlCol="0" anchor="ctr" wrap="square" lIns="45720" tIns="0" rIns="18288" bIns="0"/>
-          <a:lstStyle/>
-          <a:p>
-            <a:pPr algn="l"/>
-            <a:r>
-              <a:rPr sz="800" b="1">
-                <a:solidFill>
-                  <a:srgbClr val="FFFFFF"/>
-                </a:solidFill>
-                <a:latin typeface="맑은 고딕"/>
-                <a:ea typeface="맑은 고딕"/>
-              </a:rPr>
-              <a:t>«pod» vLLM</a:t>
-            </a:r>
-          </a:p>
-        </p:txBody>
-      </p:sp>
-      <p:sp>
-        <p:nvSpPr>
-          <p:cNvPr id="223" name="Rectangle 222"/>
-          <p:cNvSpPr/>
-          <p:nvPr/>
-        </p:nvSpPr>
-        <p:spPr>
-          <a:xfrm>
-            <a:off x="11009376" y="3227832"/>
-            <a:ext cx="804672" cy="1078992"/>
-          </a:xfrm>
-          <a:prstGeom prst="rect">
-            <a:avLst/>
-          </a:prstGeom>
-          <a:solidFill>
-            <a:srgbClr val="F2F2F2"/>
-          </a:solidFill>
-          <a:ln w="12700">
-            <a:solidFill>
-              <a:srgbClr val="7F7F7F"/>
-            </a:solidFill>
-          </a:ln>
-          <a:effectLst/>
-        </p:spPr>
-        <p:txBody>
-          <a:bodyPr rtlCol="0" anchor="ctr" wrap="square" lIns="36576" tIns="18288" rIns="36576" bIns="18288"/>
-          <a:lstStyle/>
-          <a:p>
-            <a:pPr algn="ctr"/>
-            <a:r>
-              <a:rPr sz="800" b="1">
-                <a:solidFill>
-                  <a:srgbClr val="000000"/>
-                </a:solidFill>
-                <a:latin typeface="맑은 고딕"/>
-                <a:ea typeface="맑은 고딕"/>
-              </a:rPr>
-              <a:t>vLLM</a:t>
-            </a:r>
-          </a:p>
-          <a:p>
-            <a:pPr algn="ctr"/>
-            <a:r>
-              <a:rPr sz="750" b="0">
-                <a:solidFill>
-                  <a:srgbClr val="000000"/>
-                </a:solidFill>
-                <a:latin typeface="맑은 고딕"/>
-                <a:ea typeface="맑은 고딕"/>
-              </a:rPr>
-              <a:t>decode</a:t>
-            </a:r>
-          </a:p>
-          <a:p>
-            <a:pPr algn="ctr"/>
-            <a:r>
-              <a:rPr sz="650" b="0">
-                <a:solidFill>
-                  <a:srgbClr val="404040"/>
-                </a:solidFill>
-                <a:latin typeface="맑은 고딕"/>
-                <a:ea typeface="맑은 고딕"/>
-              </a:rPr>
-              <a:t>KV events</a:t>
-            </a:r>
-          </a:p>
-          <a:p>
-            <a:pPr algn="ctr"/>
-            <a:r>
-              <a:rPr sz="650" b="0">
-                <a:solidFill>
-                  <a:srgbClr val="404040"/>
-                </a:solidFill>
-                <a:latin typeface="맑은 고딕"/>
-                <a:ea typeface="맑은 고딕"/>
-              </a:rPr>
-              <a:t>/metrics</a:t>
-            </a:r>
-          </a:p>
-        </p:txBody>
-      </p:sp>
-      <p:cxnSp>
-        <p:nvCxnSpPr>
-          <p:cNvPr id="224" name="Connector 223"/>
-          <p:cNvCxnSpPr/>
-          <p:nvPr/>
-        </p:nvCxnSpPr>
-        <p:spPr>
-          <a:xfrm>
-            <a:off x="11411712" y="2770632"/>
-            <a:ext cx="0" cy="457200"/>
-          </a:xfrm>
-          <a:prstGeom prst="line">
-            <a:avLst/>
-          </a:prstGeom>
-          <a:ln w="15875">
-            <a:solidFill>
-              <a:srgbClr val="404040"/>
-            </a:solidFill>
-            <a:headEnd type="triangle"/>
-            <a:tailEnd type="triangle"/>
-          </a:ln>
-        </p:spPr>
-      </p:cxnSp>
-      <p:sp>
-        <p:nvSpPr>
-          <p:cNvPr id="225" name="Oval 224"/>
-          <p:cNvSpPr/>
-          <p:nvPr/>
-        </p:nvSpPr>
-        <p:spPr>
-          <a:xfrm>
-            <a:off x="11553443" y="2793492"/>
-            <a:ext cx="155448" cy="155448"/>
-          </a:xfrm>
-          <a:prstGeom prst="ellipse">
-            <a:avLst/>
-          </a:prstGeom>
-          <a:solidFill>
-            <a:srgbClr val="C55A11"/>
-          </a:solidFill>
-          <a:ln w="9525">
-            <a:solidFill>
-              <a:srgbClr val="FFFFFF"/>
-            </a:solidFill>
-          </a:ln>
-          <a:effectLst/>
-        </p:spPr>
-        <p:txBody>
-          <a:bodyPr rtlCol="0" anchor="ctr" wrap="square" lIns="0" tIns="0" rIns="0" bIns="0"/>
-          <a:lstStyle/>
-          <a:p>
-            <a:pPr algn="ctr"/>
-            <a:r>
-              <a:rPr sz="650" b="1">
-                <a:solidFill>
-                  <a:srgbClr val="FFFFFF"/>
-                </a:solidFill>
-                <a:latin typeface="맑은 고딕"/>
-                <a:ea typeface="맑은 고딕"/>
-              </a:rPr>
-              <a:t>4</a:t>
-            </a:r>
-          </a:p>
-        </p:txBody>
-      </p:sp>
-      <p:cxnSp>
-        <p:nvCxnSpPr>
-          <p:cNvPr id="226" name="Connector 225"/>
-          <p:cNvCxnSpPr/>
-          <p:nvPr/>
-        </p:nvCxnSpPr>
-        <p:spPr>
-          <a:xfrm flipV="1">
-            <a:off x="10716767" y="2194560"/>
-            <a:ext cx="292609" cy="164592"/>
-          </a:xfrm>
-          <a:prstGeom prst="line">
-            <a:avLst/>
-          </a:prstGeom>
-          <a:ln w="15875">
-            <a:solidFill>
-              <a:srgbClr val="404040"/>
-            </a:solidFill>
-            <a:tailEnd type="triangle"/>
-          </a:ln>
-        </p:spPr>
-      </p:cxnSp>
-      <p:sp>
-        <p:nvSpPr>
-          <p:cNvPr id="227" name="Oval 226"/>
-          <p:cNvSpPr/>
-          <p:nvPr/>
-        </p:nvSpPr>
-        <p:spPr>
-          <a:xfrm>
-            <a:off x="10785347" y="2025396"/>
-            <a:ext cx="155448" cy="155448"/>
-          </a:xfrm>
-          <a:prstGeom prst="ellipse">
-            <a:avLst/>
-          </a:prstGeom>
-          <a:solidFill>
-            <a:srgbClr val="C55A11"/>
-          </a:solidFill>
-          <a:ln w="9525">
-            <a:solidFill>
-              <a:srgbClr val="FFFFFF"/>
-            </a:solidFill>
-          </a:ln>
-          <a:effectLst/>
-        </p:spPr>
-        <p:txBody>
-          <a:bodyPr rtlCol="0" anchor="ctr" wrap="square" lIns="0" tIns="0" rIns="0" bIns="0"/>
-          <a:lstStyle/>
-          <a:p>
-            <a:pPr algn="ctr"/>
-            <a:r>
-              <a:rPr sz="650" b="1">
-                <a:solidFill>
-                  <a:srgbClr val="FFFFFF"/>
-                </a:solidFill>
-                <a:latin typeface="맑은 고딕"/>
-                <a:ea typeface="맑은 고딕"/>
-              </a:rPr>
-              <a:t>3</a:t>
-            </a:r>
-          </a:p>
-        </p:txBody>
-      </p:sp>
-      <p:cxnSp>
-        <p:nvCxnSpPr>
-          <p:cNvPr id="228" name="Connector 227"/>
-          <p:cNvCxnSpPr/>
-          <p:nvPr/>
-        </p:nvCxnSpPr>
-        <p:spPr>
-          <a:xfrm flipH="1">
-            <a:off x="10716767" y="3822191"/>
-            <a:ext cx="292609" cy="0"/>
-          </a:xfrm>
-          <a:prstGeom prst="line">
-            <a:avLst/>
-          </a:prstGeom>
-          <a:ln w="15875">
             <a:solidFill>
               <a:srgbClr val="404040"/>
             </a:solidFill>
@@ -27488,13 +26934,13 @@
       </p:cxnSp>
       <p:sp>
         <p:nvSpPr>
-          <p:cNvPr id="229" name="Oval 228"/>
-          <p:cNvSpPr/>
-          <p:nvPr/>
-        </p:nvSpPr>
-        <p:spPr>
-          <a:xfrm>
-            <a:off x="10785347" y="3598163"/>
+          <p:cNvPr id="211" name="Oval 210"/>
+          <p:cNvSpPr/>
+          <p:nvPr/>
+        </p:nvSpPr>
+        <p:spPr>
+          <a:xfrm>
+            <a:off x="10730484" y="3744468"/>
             <a:ext cx="155448" cy="155448"/>
           </a:xfrm>
           <a:prstGeom prst="ellipse">
@@ -27530,7 +26976,7 @@
       </p:sp>
       <p:sp>
         <p:nvSpPr>
-          <p:cNvPr id="230" name="Rectangle 229"/>
+          <p:cNvPr id="212" name="Rectangle 211"/>
           <p:cNvSpPr/>
           <p:nvPr/>
         </p:nvSpPr>
@@ -27572,7 +27018,7 @@
       </p:sp>
       <p:sp>
         <p:nvSpPr>
-          <p:cNvPr id="231" name="Rectangle 230"/>
+          <p:cNvPr id="213" name="Rectangle 212"/>
           <p:cNvSpPr/>
           <p:nvPr/>
         </p:nvSpPr>
@@ -27614,7 +27060,7 @@
       </p:sp>
       <p:sp>
         <p:nvSpPr>
-          <p:cNvPr id="232" name="Rectangle 231"/>
+          <p:cNvPr id="214" name="Rectangle 213"/>
           <p:cNvSpPr/>
           <p:nvPr/>
         </p:nvSpPr>
@@ -27657,7 +27103,7 @@
       </p:sp>
       <p:sp>
         <p:nvSpPr>
-          <p:cNvPr id="233" name="Rectangle 232"/>
+          <p:cNvPr id="215" name="Rectangle 214"/>
           <p:cNvSpPr/>
           <p:nvPr/>
         </p:nvSpPr>
@@ -27699,7 +27145,7 @@
       </p:sp>
       <p:sp>
         <p:nvSpPr>
-          <p:cNvPr id="234" name="Rectangle 233"/>
+          <p:cNvPr id="216" name="Rectangle 215"/>
           <p:cNvSpPr/>
           <p:nvPr/>
         </p:nvSpPr>
@@ -27741,7 +27187,7 @@
       </p:sp>
       <p:sp>
         <p:nvSpPr>
-          <p:cNvPr id="235" name="Rectangle 234"/>
+          <p:cNvPr id="217" name="Rectangle 216"/>
           <p:cNvSpPr/>
           <p:nvPr/>
         </p:nvSpPr>
@@ -27776,14 +27222,14 @@
                 <a:latin typeface="맑은 고딕"/>
                 <a:ea typeface="맑은 고딕"/>
               </a:rPr>
-              <a:t>디자인 패턴 (Chain·Strategy·Decorator·Observer·Adapter)</a:t>
-            </a:r>
-          </a:p>
-        </p:txBody>
-      </p:sp>
-      <p:sp>
-        <p:nvSpPr>
-          <p:cNvPr id="236" name="Rectangle 235"/>
+              <a:t>디자인 패턴: Strategy (정책 구현체를 갈아 끼움)</a:t>
+            </a:r>
+          </a:p>
+        </p:txBody>
+      </p:sp>
+      <p:sp>
+        <p:nvSpPr>
+          <p:cNvPr id="218" name="Rectangle 217"/>
           <p:cNvSpPr/>
           <p:nvPr/>
         </p:nvSpPr>
@@ -27825,7 +27271,7 @@
       </p:sp>
       <p:sp>
         <p:nvSpPr>
-          <p:cNvPr id="237" name="TextBox 236"/>
+          <p:cNvPr id="219" name="TextBox 218"/>
           <p:cNvSpPr txBox="1"/>
           <p:nvPr/>
         </p:nvSpPr>
@@ -27861,7 +27307,7 @@
       </p:sp>
       <p:sp>
         <p:nvSpPr>
-          <p:cNvPr id="238" name="Rectangle 237"/>
+          <p:cNvPr id="220" name="Rectangle 219"/>
           <p:cNvSpPr/>
           <p:nvPr/>
         </p:nvSpPr>
@@ -27903,7 +27349,7 @@
       </p:sp>
       <p:sp>
         <p:nvSpPr>
-          <p:cNvPr id="239" name="Rectangle 238"/>
+          <p:cNvPr id="221" name="Rectangle 220"/>
           <p:cNvSpPr/>
           <p:nvPr/>
         </p:nvSpPr>
@@ -27971,7 +27417,7 @@
       </p:sp>
       <p:sp>
         <p:nvSpPr>
-          <p:cNvPr id="240" name="Rectangle 239"/>
+          <p:cNvPr id="222" name="Rectangle 221"/>
           <p:cNvSpPr/>
           <p:nvPr/>
         </p:nvSpPr>
@@ -28019,7 +27465,7 @@
                 <a:latin typeface="맑은 고딕"/>
                 <a:ea typeface="맑은 고딕"/>
               </a:rPr>
-              <a:t>▪ Strategy·Decorator로 정책·지시를 갈아 끼움: 비용 함수·P/D 정책·노드 지시를 한 코드베이스에서 변경</a:t>
+              <a:t>▪ Strategy 패턴: 점수·비용 함수·P/D 정책을 구현체 교체로 변경, 파이프라인은 불변</a:t>
             </a:r>
           </a:p>
           <a:p>
@@ -28032,14 +27478,14 @@
                 <a:latin typeface="맑은 고딕"/>
                 <a:ea typeface="맑은 고딕"/>
               </a:rPr>
-              <a:t>▪ Adapter로 vLLM 계약 변경을 격리, K8s·프록시 불필요</a:t>
-            </a:r>
-          </a:p>
-        </p:txBody>
-      </p:sp>
-      <p:sp>
-        <p:nvSpPr>
-          <p:cNvPr id="241" name="Rectangle 240"/>
+              <a:t>▪ K8s·프록시 불필요, OSS 업스트림 의존 없음</a:t>
+            </a:r>
+          </a:p>
+        </p:txBody>
+      </p:sp>
+      <p:sp>
+        <p:nvSpPr>
+          <p:cNvPr id="223" name="Rectangle 222"/>
           <p:cNvSpPr/>
           <p:nvPr/>
         </p:nvSpPr>
@@ -28081,7 +27527,7 @@
       </p:sp>
       <p:sp>
         <p:nvSpPr>
-          <p:cNvPr id="242" name="Rectangle 241"/>
+          <p:cNvPr id="224" name="Rectangle 223"/>
           <p:cNvSpPr/>
           <p:nvPr/>
         </p:nvSpPr>
@@ -28149,7 +27595,7 @@
       </p:sp>
       <p:sp>
         <p:nvSpPr>
-          <p:cNvPr id="243" name="Rectangle 242"/>
+          <p:cNvPr id="225" name="Rectangle 224"/>
           <p:cNvSpPr/>
           <p:nvPr/>
         </p:nvSpPr>
@@ -28197,7 +27643,7 @@
                 <a:latin typeface="맑은 고딕"/>
                 <a:ea typeface="맑은 고딕"/>
               </a:rPr>
-              <a:t>▪ vLLM·NIXL 계약 추종·신기능은 우리 몫 (Adapter는 격리일 뿐 대신해 주지 않음)</a:t>
+              <a:t>▪ vLLM·NIXL 계약 추종·신기능 구현은 전부 우리 몫</a:t>
             </a:r>
           </a:p>
           <a:p>
@@ -28217,7 +27663,7 @@
       </p:sp>
       <p:sp>
         <p:nvSpPr>
-          <p:cNvPr id="244" name="TextBox 243"/>
+          <p:cNvPr id="226" name="TextBox 225"/>
           <p:cNvSpPr txBox="1"/>
           <p:nvPr/>
         </p:nvSpPr>
@@ -28253,7 +27699,7 @@
       </p:sp>
       <p:sp>
         <p:nvSpPr>
-          <p:cNvPr id="245" name="TextBox 244"/>
+          <p:cNvPr id="227" name="TextBox 226"/>
           <p:cNvSpPr txBox="1"/>
           <p:nvPr/>
         </p:nvSpPr>
@@ -28282,7 +27728,7 @@
                 <a:latin typeface="맑은 고딕"/>
                 <a:ea typeface="맑은 고딕"/>
               </a:rPr>
-              <a:t>※ ★P5 = 지시의 '송신'(오케스트레이션 범위). 수신·실행은 vLLM(엔진) 공통 선결(C5 접점 계약). P/D 보조 프로세스는 엔진이 아니라 오케스트레이션 소프트웨어다. 디자인 패턴: Chain of Responsibility(파이프라인), Strategy(정책 교체), Decorator(지시 조립), Observer(상태 갱신), Adapter(엔진 계약 격리)</a:t>
+              <a:t>※ ★P5 = 지시의 '송신'(오케스트레이션 범위). 수신·실행은 vLLM(엔진) 공통 선결(C5 접점 계약). P/D 보조 프로세스는 엔진이 아니라 오케스트레이션 소프트웨어다. 디자인 패턴: Strategy = 정책(P1~P4)을 같은 인터페이스의 구현체로 두고 설정으로 교체. 박스는 프로세스가 아니라 한 프로세스 안의 모듈이고, 프로세스 경계는 굵은 바깥 박스.</a:t>
             </a:r>
           </a:p>
         </p:txBody>

</xml_diff>

<commit_message>
DP0: draw Strategy pattern in UML form (Context uses interface, concrete strategies implement it)
Co-Authored-By: Claude Sonnet 5.5 <noreply@anthropic.com>
Claude-Session: https://claude.ai/code/session_014XKnsGjraFTY3Q8v5o1PT9
</commit_message>
<xml_diff>
--- a/doc-mk/DP0/DP0-slides-v2.pptx
+++ b/doc-mk/DP0/DP0-slides-v2.pptx
@@ -25357,7 +25357,7 @@
         </p:nvSpPr>
         <p:spPr>
           <a:xfrm>
-            <a:off x="6583680" y="3273552"/>
+            <a:off x="6583680" y="3410712"/>
             <a:ext cx="566928" cy="384048"/>
           </a:xfrm>
           <a:prstGeom prst="rect">
@@ -25413,7 +25413,7 @@
         <p:spPr>
           <a:xfrm>
             <a:off x="7242048" y="1536192"/>
-            <a:ext cx="3566160" cy="2542032"/>
+            <a:ext cx="3566160" cy="2852928"/>
           </a:xfrm>
           <a:prstGeom prst="rect">
             <a:avLst/>
@@ -25878,16 +25878,129 @@
         </p:nvSpPr>
         <p:spPr>
           <a:xfrm>
-            <a:off x="7333488" y="2432304"/>
-            <a:ext cx="3310128" cy="749808"/>
-          </a:xfrm>
-          <a:prstGeom prst="rect">
+            <a:off x="8366760" y="2450592"/>
+            <a:ext cx="1828800" cy="384048"/>
+          </a:xfrm>
+          <a:prstGeom prst="rect">
+            <a:avLst/>
+          </a:prstGeom>
+          <a:solidFill>
+            <a:srgbClr val="EDE7F6"/>
+          </a:solidFill>
+          <a:ln w="22225">
+            <a:solidFill>
+              <a:srgbClr val="5E35B1"/>
+            </a:solidFill>
+          </a:ln>
+          <a:effectLst/>
+        </p:spPr>
+        <p:txBody>
+          <a:bodyPr rtlCol="0" anchor="ctr" wrap="square" lIns="36576" tIns="18288" rIns="36576" bIns="18288"/>
+          <a:lstStyle/>
+          <a:p>
+            <a:pPr algn="ctr"/>
+            <a:r>
+              <a:rPr sz="750" b="1">
+                <a:solidFill>
+                  <a:srgbClr val="5E35B1"/>
+                </a:solidFill>
+                <a:latin typeface="맑은 고딕"/>
+                <a:ea typeface="맑은 고딕"/>
+              </a:rPr>
+              <a:t>«interface» ScoreStrategy</a:t>
+            </a:r>
+          </a:p>
+          <a:p>
+            <a:pPr algn="ctr"/>
+            <a:r>
+              <a:rPr sz="700" b="0">
+                <a:solidFill>
+                  <a:srgbClr val="000000"/>
+                </a:solidFill>
+                <a:latin typeface="맑은 고딕"/>
+                <a:ea typeface="맑은 고딕"/>
+              </a:rPr>
+              <a:t>score(요청, 상태)</a:t>
+            </a:r>
+          </a:p>
+        </p:txBody>
+      </p:sp>
+      <p:cxnSp>
+        <p:nvCxnSpPr>
+          <p:cNvPr id="186" name="Connector 185"/>
+          <p:cNvCxnSpPr/>
+          <p:nvPr/>
+        </p:nvCxnSpPr>
+        <p:spPr>
+          <a:xfrm>
+            <a:off x="9308592" y="2194560"/>
+            <a:ext cx="0" cy="256032"/>
+          </a:xfrm>
+          <a:prstGeom prst="line">
+            <a:avLst/>
+          </a:prstGeom>
+          <a:ln w="19050">
+            <a:solidFill>
+              <a:srgbClr val="5E35B1"/>
+            </a:solidFill>
+            <a:tailEnd type="triangle"/>
+          </a:ln>
+        </p:spPr>
+      </p:cxnSp>
+      <p:sp>
+        <p:nvSpPr>
+          <p:cNvPr id="187" name="TextBox 186"/>
+          <p:cNvSpPr txBox="1"/>
+          <p:nvPr/>
+        </p:nvSpPr>
+        <p:spPr>
+          <a:xfrm>
+            <a:off x="9363456" y="2249424"/>
+            <a:ext cx="822960" cy="128016"/>
+          </a:xfrm>
+          <a:prstGeom prst="rect">
+            <a:avLst/>
+          </a:prstGeom>
+          <a:noFill/>
+        </p:spPr>
+        <p:txBody>
+          <a:bodyPr wrap="square" anchor="t" lIns="0" tIns="0" rIns="0" bIns="0">
+            <a:spAutoFit/>
+          </a:bodyPr>
+          <a:lstStyle/>
+          <a:p>
+            <a:pPr algn="l"/>
+            <a:r>
+              <a:rPr sz="650" b="1">
+                <a:solidFill>
+                  <a:srgbClr val="5E35B1"/>
+                </a:solidFill>
+                <a:latin typeface="맑은 고딕"/>
+                <a:ea typeface="맑은 고딕"/>
+              </a:rPr>
+              <a:t>uses</a:t>
+            </a:r>
+          </a:p>
+        </p:txBody>
+      </p:sp>
+      <p:sp>
+        <p:nvSpPr>
+          <p:cNvPr id="188" name="Isosceles Triangle 187"/>
+          <p:cNvSpPr/>
+          <p:nvPr/>
+        </p:nvSpPr>
+        <p:spPr>
+          <a:xfrm>
+            <a:off x="9235440" y="2834640"/>
+            <a:ext cx="146304" cy="128016"/>
+          </a:xfrm>
+          <a:prstGeom prst="triangle">
             <a:avLst/>
           </a:prstGeom>
           <a:solidFill>
             <a:srgbClr val="FFFFFF"/>
           </a:solidFill>
-          <a:ln w="22225">
+          <a:ln w="15875">
             <a:solidFill>
               <a:srgbClr val="5E35B1"/>
             </a:solidFill>
@@ -25904,266 +26017,62 @@
       </p:sp>
       <p:sp>
         <p:nvSpPr>
-          <p:cNvPr id="186" name="Rectangle 185"/>
-          <p:cNvSpPr/>
-          <p:nvPr/>
-        </p:nvSpPr>
-        <p:spPr>
-          <a:xfrm>
-            <a:off x="7333488" y="2432304"/>
-            <a:ext cx="3310128" cy="173736"/>
-          </a:xfrm>
-          <a:prstGeom prst="rect">
-            <a:avLst/>
-          </a:prstGeom>
-          <a:solidFill>
-            <a:srgbClr val="5E35B1"/>
-          </a:solidFill>
+          <p:cNvPr id="189" name="TextBox 188"/>
+          <p:cNvSpPr txBox="1"/>
+          <p:nvPr/>
+        </p:nvSpPr>
+        <p:spPr>
+          <a:xfrm>
+            <a:off x="9509760" y="2843784"/>
+            <a:ext cx="1097280" cy="128016"/>
+          </a:xfrm>
+          <a:prstGeom prst="rect">
+            <a:avLst/>
+          </a:prstGeom>
+          <a:noFill/>
+        </p:spPr>
+        <p:txBody>
+          <a:bodyPr wrap="square" anchor="t" lIns="0" tIns="0" rIns="0" bIns="0">
+            <a:spAutoFit/>
+          </a:bodyPr>
+          <a:lstStyle/>
+          <a:p>
+            <a:pPr algn="l"/>
+            <a:r>
+              <a:rPr sz="650" b="1">
+                <a:solidFill>
+                  <a:srgbClr val="5E35B1"/>
+                </a:solidFill>
+                <a:latin typeface="맑은 고딕"/>
+                <a:ea typeface="맑은 고딕"/>
+              </a:rPr>
+              <a:t>implements (구현)</a:t>
+            </a:r>
+          </a:p>
+        </p:txBody>
+      </p:sp>
+      <p:cxnSp>
+        <p:nvCxnSpPr>
+          <p:cNvPr id="190" name="Connector 189"/>
+          <p:cNvCxnSpPr/>
+          <p:nvPr/>
+        </p:nvCxnSpPr>
+        <p:spPr>
+          <a:xfrm>
+            <a:off x="8343900" y="3054096"/>
+            <a:ext cx="1956816" cy="0"/>
+          </a:xfrm>
+          <a:prstGeom prst="line">
+            <a:avLst/>
+          </a:prstGeom>
           <a:ln w="12700">
             <a:solidFill>
               <a:srgbClr val="5E35B1"/>
             </a:solidFill>
-          </a:ln>
-          <a:effectLst/>
-        </p:spPr>
-        <p:txBody>
-          <a:bodyPr rtlCol="0" anchor="ctr" wrap="square" lIns="45720" tIns="0" rIns="0" bIns="0"/>
-          <a:lstStyle/>
-          <a:p>
-            <a:pPr algn="l"/>
-            <a:r>
-              <a:rPr sz="700" b="1">
-                <a:solidFill>
-                  <a:srgbClr val="FFFFFF"/>
-                </a:solidFill>
-                <a:latin typeface="맑은 고딕"/>
-                <a:ea typeface="맑은 고딕"/>
-              </a:rPr>
-              <a:t>«Strategy»  정책 인터페이스  (구현체를 설정으로 교체)</a:t>
-            </a:r>
-          </a:p>
-        </p:txBody>
-      </p:sp>
-      <p:sp>
-        <p:nvSpPr>
-          <p:cNvPr id="187" name="Rectangle 186"/>
-          <p:cNvSpPr/>
-          <p:nvPr/>
-        </p:nvSpPr>
-        <p:spPr>
-          <a:xfrm>
-            <a:off x="7388352" y="2660904"/>
-            <a:ext cx="768096" cy="457200"/>
-          </a:xfrm>
-          <a:prstGeom prst="rect">
-            <a:avLst/>
-          </a:prstGeom>
-          <a:solidFill>
-            <a:srgbClr val="FBE5D6"/>
-          </a:solidFill>
-          <a:ln w="15875">
-            <a:solidFill>
-              <a:srgbClr val="C55A11"/>
-            </a:solidFill>
-          </a:ln>
-          <a:effectLst/>
-        </p:spPr>
-        <p:txBody>
-          <a:bodyPr rtlCol="0" anchor="ctr" wrap="square" lIns="36576" tIns="18288" rIns="36576" bIns="18288"/>
-          <a:lstStyle/>
-          <a:p>
-            <a:pPr algn="ctr"/>
-            <a:r>
-              <a:rPr sz="800" b="1">
-                <a:solidFill>
-                  <a:srgbClr val="000000"/>
-                </a:solidFill>
-                <a:latin typeface="맑은 고딕"/>
-                <a:ea typeface="맑은 고딕"/>
-              </a:rPr>
-              <a:t>P1</a:t>
-            </a:r>
-          </a:p>
-          <a:p>
-            <a:pPr algn="ctr"/>
-            <a:r>
-              <a:rPr sz="650" b="0">
-                <a:solidFill>
-                  <a:srgbClr val="000000"/>
-                </a:solidFill>
-                <a:latin typeface="맑은 고딕"/>
-                <a:ea typeface="맑은 고딕"/>
-              </a:rPr>
-              <a:t>메모리 종류 가중치</a:t>
-            </a:r>
-          </a:p>
-        </p:txBody>
-      </p:sp>
-      <p:sp>
-        <p:nvSpPr>
-          <p:cNvPr id="188" name="Rectangle 187"/>
-          <p:cNvSpPr/>
-          <p:nvPr/>
-        </p:nvSpPr>
-        <p:spPr>
-          <a:xfrm>
-            <a:off x="8211312" y="2660904"/>
-            <a:ext cx="768096" cy="457200"/>
-          </a:xfrm>
-          <a:prstGeom prst="rect">
-            <a:avLst/>
-          </a:prstGeom>
-          <a:solidFill>
-            <a:srgbClr val="FBE5D6"/>
-          </a:solidFill>
-          <a:ln w="15875">
-            <a:solidFill>
-              <a:srgbClr val="C55A11"/>
-            </a:solidFill>
-          </a:ln>
-          <a:effectLst/>
-        </p:spPr>
-        <p:txBody>
-          <a:bodyPr rtlCol="0" anchor="ctr" wrap="square" lIns="36576" tIns="18288" rIns="36576" bIns="18288"/>
-          <a:lstStyle/>
-          <a:p>
-            <a:pPr algn="ctr"/>
-            <a:r>
-              <a:rPr sz="800" b="1">
-                <a:solidFill>
-                  <a:srgbClr val="000000"/>
-                </a:solidFill>
-                <a:latin typeface="맑은 고딕"/>
-                <a:ea typeface="맑은 고딕"/>
-              </a:rPr>
-              <a:t>P2</a:t>
-            </a:r>
-          </a:p>
-          <a:p>
-            <a:pPr algn="ctr"/>
-            <a:r>
-              <a:rPr sz="650" b="0">
-                <a:solidFill>
-                  <a:srgbClr val="000000"/>
-                </a:solidFill>
-                <a:latin typeface="맑은 고딕"/>
-                <a:ea typeface="맑은 고딕"/>
-              </a:rPr>
-              <a:t>실시간 상태</a:t>
-            </a:r>
-          </a:p>
-        </p:txBody>
-      </p:sp>
-      <p:sp>
-        <p:nvSpPr>
-          <p:cNvPr id="189" name="Rectangle 188"/>
-          <p:cNvSpPr/>
-          <p:nvPr/>
-        </p:nvSpPr>
-        <p:spPr>
-          <a:xfrm>
-            <a:off x="9034272" y="2660904"/>
-            <a:ext cx="768096" cy="457200"/>
-          </a:xfrm>
-          <a:prstGeom prst="rect">
-            <a:avLst/>
-          </a:prstGeom>
-          <a:solidFill>
-            <a:srgbClr val="FBE5D6"/>
-          </a:solidFill>
-          <a:ln w="15875">
-            <a:solidFill>
-              <a:srgbClr val="C55A11"/>
-            </a:solidFill>
-          </a:ln>
-          <a:effectLst/>
-        </p:spPr>
-        <p:txBody>
-          <a:bodyPr rtlCol="0" anchor="ctr" wrap="square" lIns="36576" tIns="18288" rIns="36576" bIns="18288"/>
-          <a:lstStyle/>
-          <a:p>
-            <a:pPr algn="ctr"/>
-            <a:r>
-              <a:rPr sz="800" b="1">
-                <a:solidFill>
-                  <a:srgbClr val="000000"/>
-                </a:solidFill>
-                <a:latin typeface="맑은 고딕"/>
-                <a:ea typeface="맑은 고딕"/>
-              </a:rPr>
-              <a:t>P3</a:t>
-            </a:r>
-          </a:p>
-          <a:p>
-            <a:pPr algn="ctr"/>
-            <a:r>
-              <a:rPr sz="650" b="0">
-                <a:solidFill>
-                  <a:srgbClr val="000000"/>
-                </a:solidFill>
-                <a:latin typeface="맑은 고딕"/>
-                <a:ea typeface="맑은 고딕"/>
-              </a:rPr>
-              <a:t>비용 기반 점수</a:t>
-            </a:r>
-          </a:p>
-        </p:txBody>
-      </p:sp>
-      <p:sp>
-        <p:nvSpPr>
-          <p:cNvPr id="190" name="Rectangle 189"/>
-          <p:cNvSpPr/>
-          <p:nvPr/>
-        </p:nvSpPr>
-        <p:spPr>
-          <a:xfrm>
-            <a:off x="9857232" y="2660904"/>
-            <a:ext cx="768096" cy="457200"/>
-          </a:xfrm>
-          <a:prstGeom prst="rect">
-            <a:avLst/>
-          </a:prstGeom>
-          <a:solidFill>
-            <a:srgbClr val="FBE5D6"/>
-          </a:solidFill>
-          <a:ln w="15875">
-            <a:solidFill>
-              <a:srgbClr val="C55A11"/>
-            </a:solidFill>
-          </a:ln>
-          <a:effectLst/>
-        </p:spPr>
-        <p:txBody>
-          <a:bodyPr rtlCol="0" anchor="ctr" wrap="square" lIns="36576" tIns="18288" rIns="36576" bIns="18288"/>
-          <a:lstStyle/>
-          <a:p>
-            <a:pPr algn="ctr"/>
-            <a:r>
-              <a:rPr sz="800" b="1">
-                <a:solidFill>
-                  <a:srgbClr val="000000"/>
-                </a:solidFill>
-                <a:latin typeface="맑은 고딕"/>
-                <a:ea typeface="맑은 고딕"/>
-              </a:rPr>
-              <a:t>P4</a:t>
-            </a:r>
-          </a:p>
-          <a:p>
-            <a:pPr algn="ctr"/>
-            <a:r>
-              <a:rPr sz="650" b="0">
-                <a:solidFill>
-                  <a:srgbClr val="000000"/>
-                </a:solidFill>
-                <a:latin typeface="맑은 고딕"/>
-                <a:ea typeface="맑은 고딕"/>
-              </a:rPr>
-              <a:t>비용 기반 P/D</a:t>
-            </a:r>
-          </a:p>
-        </p:txBody>
-      </p:sp>
+            <a:prstDash val="dash"/>
+          </a:ln>
+        </p:spPr>
+      </p:cxnSp>
       <p:cxnSp>
         <p:nvCxnSpPr>
           <p:cNvPr id="191" name="Connector 190"/>
@@ -26171,40 +26080,63 @@
           <p:nvPr/>
         </p:nvCxnSpPr>
         <p:spPr>
-          <a:xfrm>
-            <a:off x="9308592" y="2194560"/>
-            <a:ext cx="0" cy="237744"/>
+          <a:xfrm flipV="1">
+            <a:off x="9308592" y="2962656"/>
+            <a:ext cx="0" cy="91440"/>
           </a:xfrm>
           <a:prstGeom prst="line">
             <a:avLst/>
           </a:prstGeom>
+          <a:ln w="12700">
+            <a:solidFill>
+              <a:srgbClr val="5E35B1"/>
+            </a:solidFill>
+            <a:prstDash val="dash"/>
+            <a:tailEnd type="triangle"/>
+          </a:ln>
+        </p:spPr>
+      </p:cxnSp>
+      <p:cxnSp>
+        <p:nvCxnSpPr>
+          <p:cNvPr id="192" name="Connector 191"/>
+          <p:cNvCxnSpPr/>
+          <p:nvPr/>
+        </p:nvCxnSpPr>
+        <p:spPr>
+          <a:xfrm flipV="1">
+            <a:off x="8343900" y="3054096"/>
+            <a:ext cx="0" cy="109728"/>
+          </a:xfrm>
+          <a:prstGeom prst="line">
+            <a:avLst/>
+          </a:prstGeom>
+          <a:ln w="12700">
+            <a:solidFill>
+              <a:srgbClr val="5E35B1"/>
+            </a:solidFill>
+            <a:prstDash val="dash"/>
+          </a:ln>
+        </p:spPr>
+      </p:cxnSp>
+      <p:sp>
+        <p:nvSpPr>
+          <p:cNvPr id="193" name="Rectangle 192"/>
+          <p:cNvSpPr/>
+          <p:nvPr/>
+        </p:nvSpPr>
+        <p:spPr>
+          <a:xfrm>
+            <a:off x="7909560" y="3163824"/>
+            <a:ext cx="868680" cy="384048"/>
+          </a:xfrm>
+          <a:prstGeom prst="rect">
+            <a:avLst/>
+          </a:prstGeom>
+          <a:solidFill>
+            <a:srgbClr val="FBE5D6"/>
+          </a:solidFill>
           <a:ln w="19050">
             <a:solidFill>
-              <a:srgbClr val="5E35B1"/>
-            </a:solidFill>
-            <a:tailEnd type="triangle"/>
-          </a:ln>
-        </p:spPr>
-      </p:cxnSp>
-      <p:sp>
-        <p:nvSpPr>
-          <p:cNvPr id="192" name="Rectangle 191"/>
-          <p:cNvSpPr/>
-          <p:nvPr/>
-        </p:nvSpPr>
-        <p:spPr>
-          <a:xfrm>
-            <a:off x="7333488" y="3346704"/>
-            <a:ext cx="1005840" cy="502920"/>
-          </a:xfrm>
-          <a:prstGeom prst="rect">
-            <a:avLst/>
-          </a:prstGeom>
-          <a:solidFill>
-            <a:srgbClr val="FBE5D6"/>
-          </a:solidFill>
-          <a:ln w="19050">
-            <a:solidFill>
               <a:srgbClr val="C55A11"/>
             </a:solidFill>
           </a:ln>
@@ -26216,14 +26148,14 @@
           <a:p>
             <a:pPr algn="ctr"/>
             <a:r>
-              <a:rPr sz="750" b="1">
+              <a:rPr sz="700" b="1">
                 <a:solidFill>
                   <a:srgbClr val="000000"/>
                 </a:solidFill>
                 <a:latin typeface="맑은 고딕"/>
                 <a:ea typeface="맑은 고딕"/>
               </a:rPr>
-              <a:t>F 서버 발견</a:t>
+              <a:t>P1 TierWeight</a:t>
             </a:r>
           </a:p>
           <a:p>
@@ -26236,62 +26168,7 @@
                 <a:latin typeface="맑은 고딕"/>
                 <a:ea typeface="맑은 고딕"/>
               </a:rPr>
-              <a:t>etcd watch</a:t>
-            </a:r>
-          </a:p>
-        </p:txBody>
-      </p:sp>
-      <p:sp>
-        <p:nvSpPr>
-          <p:cNvPr id="193" name="Rectangle 192"/>
-          <p:cNvSpPr/>
-          <p:nvPr/>
-        </p:nvSpPr>
-        <p:spPr>
-          <a:xfrm>
-            <a:off x="8458200" y="3346704"/>
-            <a:ext cx="1463040" cy="502920"/>
-          </a:xfrm>
-          <a:prstGeom prst="rect">
-            <a:avLst/>
-          </a:prstGeom>
-          <a:solidFill>
-            <a:srgbClr val="FBE5D6"/>
-          </a:solidFill>
-          <a:ln w="19050">
-            <a:solidFill>
-              <a:srgbClr val="C55A11"/>
-            </a:solidFill>
-          </a:ln>
-          <a:effectLst/>
-        </p:spPr>
-        <p:txBody>
-          <a:bodyPr rtlCol="0" anchor="ctr" wrap="square" lIns="36576" tIns="18288" rIns="36576" bIns="18288"/>
-          <a:lstStyle/>
-          <a:p>
-            <a:pPr algn="ctr"/>
-            <a:r>
-              <a:rPr sz="750" b="1">
-                <a:solidFill>
-                  <a:srgbClr val="000000"/>
-                </a:solidFill>
-                <a:latin typeface="맑은 고딕"/>
-                <a:ea typeface="맑은 고딕"/>
-              </a:rPr>
-              <a:t>C 상태 저장소</a:t>
-            </a:r>
-          </a:p>
-          <a:p>
-            <a:pPr algn="ctr"/>
-            <a:r>
-              <a:rPr sz="650" b="0">
-                <a:solidFill>
-                  <a:srgbClr val="000000"/>
-                </a:solidFill>
-                <a:latin typeface="맑은 고딕"/>
-                <a:ea typeface="맑은 고딕"/>
-              </a:rPr>
-              <a:t>KV index · 메트릭</a:t>
+              <a:t>메모리 종류 가중치</a:t>
             </a:r>
           </a:p>
         </p:txBody>
@@ -26304,58 +26181,71 @@
         </p:nvCxnSpPr>
         <p:spPr>
           <a:xfrm flipV="1">
-            <a:off x="9189720" y="3182112"/>
-            <a:ext cx="0" cy="164592"/>
+            <a:off x="9322308" y="3054096"/>
+            <a:ext cx="0" cy="109728"/>
           </a:xfrm>
           <a:prstGeom prst="line">
             <a:avLst/>
           </a:prstGeom>
-          <a:ln w="15875">
+          <a:ln w="12700">
+            <a:solidFill>
+              <a:srgbClr val="5E35B1"/>
+            </a:solidFill>
+            <a:prstDash val="dash"/>
+          </a:ln>
+        </p:spPr>
+      </p:cxnSp>
+      <p:sp>
+        <p:nvSpPr>
+          <p:cNvPr id="195" name="Rectangle 194"/>
+          <p:cNvSpPr/>
+          <p:nvPr/>
+        </p:nvSpPr>
+        <p:spPr>
+          <a:xfrm>
+            <a:off x="8887968" y="3163824"/>
+            <a:ext cx="868680" cy="384048"/>
+          </a:xfrm>
+          <a:prstGeom prst="rect">
+            <a:avLst/>
+          </a:prstGeom>
+          <a:solidFill>
+            <a:srgbClr val="FBE5D6"/>
+          </a:solidFill>
+          <a:ln w="19050">
             <a:solidFill>
               <a:srgbClr val="C55A11"/>
             </a:solidFill>
-            <a:tailEnd type="triangle"/>
-          </a:ln>
-        </p:spPr>
-      </p:cxnSp>
-      <p:sp>
-        <p:nvSpPr>
-          <p:cNvPr id="195" name="Oval 194"/>
-          <p:cNvSpPr/>
-          <p:nvPr/>
-        </p:nvSpPr>
-        <p:spPr>
-          <a:xfrm>
-            <a:off x="9249155" y="3186684"/>
-            <a:ext cx="155448" cy="155448"/>
-          </a:xfrm>
-          <a:prstGeom prst="ellipse">
-            <a:avLst/>
-          </a:prstGeom>
-          <a:solidFill>
-            <a:srgbClr val="C55A11"/>
-          </a:solidFill>
-          <a:ln w="9525">
-            <a:solidFill>
-              <a:srgbClr val="FFFFFF"/>
-            </a:solidFill>
-          </a:ln>
-          <a:effectLst/>
-        </p:spPr>
-        <p:txBody>
-          <a:bodyPr rtlCol="0" anchor="ctr" wrap="square" lIns="0" tIns="0" rIns="0" bIns="0"/>
-          <a:lstStyle/>
-          <a:p>
-            <a:pPr algn="ctr"/>
-            <a:r>
-              <a:rPr sz="650" b="1">
-                <a:solidFill>
-                  <a:srgbClr val="FFFFFF"/>
-                </a:solidFill>
-                <a:latin typeface="맑은 고딕"/>
-                <a:ea typeface="맑은 고딕"/>
-              </a:rPr>
-              <a:t>6</a:t>
+          </a:ln>
+          <a:effectLst/>
+        </p:spPr>
+        <p:txBody>
+          <a:bodyPr rtlCol="0" anchor="ctr" wrap="square" lIns="36576" tIns="18288" rIns="36576" bIns="18288"/>
+          <a:lstStyle/>
+          <a:p>
+            <a:pPr algn="ctr"/>
+            <a:r>
+              <a:rPr sz="700" b="1">
+                <a:solidFill>
+                  <a:srgbClr val="000000"/>
+                </a:solidFill>
+                <a:latin typeface="맑은 고딕"/>
+                <a:ea typeface="맑은 고딕"/>
+              </a:rPr>
+              <a:t>P2 LiveState</a:t>
+            </a:r>
+          </a:p>
+          <a:p>
+            <a:pPr algn="ctr"/>
+            <a:r>
+              <a:rPr sz="650" b="0">
+                <a:solidFill>
+                  <a:srgbClr val="000000"/>
+                </a:solidFill>
+                <a:latin typeface="맑은 고딕"/>
+                <a:ea typeface="맑은 고딕"/>
+              </a:rPr>
+              <a:t>실시간 상태 반영</a:t>
             </a:r>
           </a:p>
         </p:txBody>
@@ -26367,9 +26257,296 @@
           <p:nvPr/>
         </p:nvCxnSpPr>
         <p:spPr>
-          <a:xfrm>
-            <a:off x="7150608" y="3456432"/>
-            <a:ext cx="182880" cy="0"/>
+          <a:xfrm flipV="1">
+            <a:off x="10300716" y="3054096"/>
+            <a:ext cx="0" cy="109728"/>
+          </a:xfrm>
+          <a:prstGeom prst="line">
+            <a:avLst/>
+          </a:prstGeom>
+          <a:ln w="12700">
+            <a:solidFill>
+              <a:srgbClr val="5E35B1"/>
+            </a:solidFill>
+            <a:prstDash val="dash"/>
+          </a:ln>
+        </p:spPr>
+      </p:cxnSp>
+      <p:sp>
+        <p:nvSpPr>
+          <p:cNvPr id="197" name="Rectangle 196"/>
+          <p:cNvSpPr/>
+          <p:nvPr/>
+        </p:nvSpPr>
+        <p:spPr>
+          <a:xfrm>
+            <a:off x="9866376" y="3163824"/>
+            <a:ext cx="868680" cy="384048"/>
+          </a:xfrm>
+          <a:prstGeom prst="rect">
+            <a:avLst/>
+          </a:prstGeom>
+          <a:solidFill>
+            <a:srgbClr val="FBE5D6"/>
+          </a:solidFill>
+          <a:ln w="19050">
+            <a:solidFill>
+              <a:srgbClr val="C55A11"/>
+            </a:solidFill>
+          </a:ln>
+          <a:effectLst/>
+        </p:spPr>
+        <p:txBody>
+          <a:bodyPr rtlCol="0" anchor="ctr" wrap="square" lIns="36576" tIns="18288" rIns="36576" bIns="18288"/>
+          <a:lstStyle/>
+          <a:p>
+            <a:pPr algn="ctr"/>
+            <a:r>
+              <a:rPr sz="700" b="1">
+                <a:solidFill>
+                  <a:srgbClr val="000000"/>
+                </a:solidFill>
+                <a:latin typeface="맑은 고딕"/>
+                <a:ea typeface="맑은 고딕"/>
+              </a:rPr>
+              <a:t>P3 CostBased</a:t>
+            </a:r>
+          </a:p>
+          <a:p>
+            <a:pPr algn="ctr"/>
+            <a:r>
+              <a:rPr sz="650" b="0">
+                <a:solidFill>
+                  <a:srgbClr val="000000"/>
+                </a:solidFill>
+                <a:latin typeface="맑은 고딕"/>
+                <a:ea typeface="맑은 고딕"/>
+              </a:rPr>
+              <a:t>비용 기반 점수</a:t>
+            </a:r>
+          </a:p>
+        </p:txBody>
+      </p:sp>
+      <p:sp>
+        <p:nvSpPr>
+          <p:cNvPr id="198" name="TextBox 197"/>
+          <p:cNvSpPr txBox="1"/>
+          <p:nvPr/>
+        </p:nvSpPr>
+        <p:spPr>
+          <a:xfrm>
+            <a:off x="7406640" y="3584448"/>
+            <a:ext cx="2651760" cy="128016"/>
+          </a:xfrm>
+          <a:prstGeom prst="rect">
+            <a:avLst/>
+          </a:prstGeom>
+          <a:noFill/>
+        </p:spPr>
+        <p:txBody>
+          <a:bodyPr wrap="square" anchor="t" lIns="0" tIns="0" rIns="0" bIns="0">
+            <a:spAutoFit/>
+          </a:bodyPr>
+          <a:lstStyle/>
+          <a:p>
+            <a:pPr algn="l"/>
+            <a:r>
+              <a:rPr sz="650" b="1">
+                <a:solidFill>
+                  <a:srgbClr val="5E35B1"/>
+                </a:solidFill>
+                <a:latin typeface="맑은 고딕"/>
+                <a:ea typeface="맑은 고딕"/>
+              </a:rPr>
+              <a:t>«Strategy» 구현체만 교체 · P4(P/D 판단)도 같은 방식</a:t>
+            </a:r>
+          </a:p>
+        </p:txBody>
+      </p:sp>
+      <p:sp>
+        <p:nvSpPr>
+          <p:cNvPr id="199" name="Rectangle 198"/>
+          <p:cNvSpPr/>
+          <p:nvPr/>
+        </p:nvSpPr>
+        <p:spPr>
+          <a:xfrm>
+            <a:off x="7333488" y="3776472"/>
+            <a:ext cx="1280160" cy="457200"/>
+          </a:xfrm>
+          <a:prstGeom prst="rect">
+            <a:avLst/>
+          </a:prstGeom>
+          <a:solidFill>
+            <a:srgbClr val="FBE5D6"/>
+          </a:solidFill>
+          <a:ln w="19050">
+            <a:solidFill>
+              <a:srgbClr val="C55A11"/>
+            </a:solidFill>
+          </a:ln>
+          <a:effectLst/>
+        </p:spPr>
+        <p:txBody>
+          <a:bodyPr rtlCol="0" anchor="ctr" wrap="square" lIns="36576" tIns="18288" rIns="36576" bIns="18288"/>
+          <a:lstStyle/>
+          <a:p>
+            <a:pPr algn="ctr"/>
+            <a:r>
+              <a:rPr sz="750" b="1">
+                <a:solidFill>
+                  <a:srgbClr val="000000"/>
+                </a:solidFill>
+                <a:latin typeface="맑은 고딕"/>
+                <a:ea typeface="맑은 고딕"/>
+              </a:rPr>
+              <a:t>F 서버 발견</a:t>
+            </a:r>
+          </a:p>
+          <a:p>
+            <a:pPr algn="ctr"/>
+            <a:r>
+              <a:rPr sz="650" b="0">
+                <a:solidFill>
+                  <a:srgbClr val="000000"/>
+                </a:solidFill>
+                <a:latin typeface="맑은 고딕"/>
+                <a:ea typeface="맑은 고딕"/>
+              </a:rPr>
+              <a:t>etcd watch</a:t>
+            </a:r>
+          </a:p>
+        </p:txBody>
+      </p:sp>
+      <p:sp>
+        <p:nvSpPr>
+          <p:cNvPr id="200" name="Rectangle 199"/>
+          <p:cNvSpPr/>
+          <p:nvPr/>
+        </p:nvSpPr>
+        <p:spPr>
+          <a:xfrm>
+            <a:off x="8778240" y="3776472"/>
+            <a:ext cx="1737360" cy="457200"/>
+          </a:xfrm>
+          <a:prstGeom prst="rect">
+            <a:avLst/>
+          </a:prstGeom>
+          <a:solidFill>
+            <a:srgbClr val="FBE5D6"/>
+          </a:solidFill>
+          <a:ln w="19050">
+            <a:solidFill>
+              <a:srgbClr val="C55A11"/>
+            </a:solidFill>
+          </a:ln>
+          <a:effectLst/>
+        </p:spPr>
+        <p:txBody>
+          <a:bodyPr rtlCol="0" anchor="ctr" wrap="square" lIns="36576" tIns="18288" rIns="36576" bIns="18288"/>
+          <a:lstStyle/>
+          <a:p>
+            <a:pPr algn="ctr"/>
+            <a:r>
+              <a:rPr sz="750" b="1">
+                <a:solidFill>
+                  <a:srgbClr val="000000"/>
+                </a:solidFill>
+                <a:latin typeface="맑은 고딕"/>
+                <a:ea typeface="맑은 고딕"/>
+              </a:rPr>
+              <a:t>C 상태 저장소</a:t>
+            </a:r>
+          </a:p>
+          <a:p>
+            <a:pPr algn="ctr"/>
+            <a:r>
+              <a:rPr sz="650" b="0">
+                <a:solidFill>
+                  <a:srgbClr val="000000"/>
+                </a:solidFill>
+                <a:latin typeface="맑은 고딕"/>
+                <a:ea typeface="맑은 고딕"/>
+              </a:rPr>
+              <a:t>KV index · 메트릭 (정책이 조회)</a:t>
+            </a:r>
+          </a:p>
+        </p:txBody>
+      </p:sp>
+      <p:cxnSp>
+        <p:nvCxnSpPr>
+          <p:cNvPr id="201" name="Connector 200"/>
+          <p:cNvCxnSpPr/>
+          <p:nvPr/>
+        </p:nvCxnSpPr>
+        <p:spPr>
+          <a:xfrm flipV="1">
+            <a:off x="10287000" y="3547872"/>
+            <a:ext cx="0" cy="228600"/>
+          </a:xfrm>
+          <a:prstGeom prst="line">
+            <a:avLst/>
+          </a:prstGeom>
+          <a:ln w="15875">
+            <a:solidFill>
+              <a:srgbClr val="C55A11"/>
+            </a:solidFill>
+            <a:tailEnd type="triangle"/>
+          </a:ln>
+        </p:spPr>
+      </p:cxnSp>
+      <p:sp>
+        <p:nvSpPr>
+          <p:cNvPr id="202" name="Oval 201"/>
+          <p:cNvSpPr/>
+          <p:nvPr/>
+        </p:nvSpPr>
+        <p:spPr>
+          <a:xfrm>
+            <a:off x="10392155" y="3598163"/>
+            <a:ext cx="155448" cy="155448"/>
+          </a:xfrm>
+          <a:prstGeom prst="ellipse">
+            <a:avLst/>
+          </a:prstGeom>
+          <a:solidFill>
+            <a:srgbClr val="C55A11"/>
+          </a:solidFill>
+          <a:ln w="9525">
+            <a:solidFill>
+              <a:srgbClr val="FFFFFF"/>
+            </a:solidFill>
+          </a:ln>
+          <a:effectLst/>
+        </p:spPr>
+        <p:txBody>
+          <a:bodyPr rtlCol="0" anchor="ctr" wrap="square" lIns="0" tIns="0" rIns="0" bIns="0"/>
+          <a:lstStyle/>
+          <a:p>
+            <a:pPr algn="ctr"/>
+            <a:r>
+              <a:rPr sz="650" b="1">
+                <a:solidFill>
+                  <a:srgbClr val="FFFFFF"/>
+                </a:solidFill>
+                <a:latin typeface="맑은 고딕"/>
+                <a:ea typeface="맑은 고딕"/>
+              </a:rPr>
+              <a:t>6</a:t>
+            </a:r>
+          </a:p>
+        </p:txBody>
+      </p:sp>
+      <p:cxnSp>
+        <p:nvCxnSpPr>
+          <p:cNvPr id="203" name="Connector 202"/>
+          <p:cNvCxnSpPr/>
+          <p:nvPr/>
+        </p:nvCxnSpPr>
+        <p:spPr>
+          <a:xfrm>
+            <a:off x="7150608" y="3547872"/>
+            <a:ext cx="182880" cy="320040"/>
           </a:xfrm>
           <a:prstGeom prst="line">
             <a:avLst/>
@@ -26385,13 +26562,13 @@
       </p:cxnSp>
       <p:sp>
         <p:nvSpPr>
-          <p:cNvPr id="197" name="Oval 196"/>
-          <p:cNvSpPr/>
-          <p:nvPr/>
-        </p:nvSpPr>
-        <p:spPr>
-          <a:xfrm>
-            <a:off x="7164324" y="3241548"/>
+          <p:cNvPr id="204" name="Oval 203"/>
+          <p:cNvSpPr/>
+          <p:nvPr/>
+        </p:nvSpPr>
+        <p:spPr>
+          <a:xfrm>
+            <a:off x="7164324" y="3616452"/>
             <a:ext cx="155448" cy="155448"/>
           </a:xfrm>
           <a:prstGeom prst="ellipse">
@@ -26421,339 +26598,6 @@
                 <a:ea typeface="맑은 고딕"/>
               </a:rPr>
               <a:t>7</a:t>
-            </a:r>
-          </a:p>
-        </p:txBody>
-      </p:sp>
-      <p:cxnSp>
-        <p:nvCxnSpPr>
-          <p:cNvPr id="198" name="Connector 197"/>
-          <p:cNvCxnSpPr/>
-          <p:nvPr/>
-        </p:nvCxnSpPr>
-        <p:spPr>
-          <a:xfrm>
-            <a:off x="8339328" y="3593592"/>
-            <a:ext cx="118872" cy="0"/>
-          </a:xfrm>
-          <a:prstGeom prst="line">
-            <a:avLst/>
-          </a:prstGeom>
-          <a:ln w="12700">
-            <a:solidFill>
-              <a:srgbClr val="C55A11"/>
-            </a:solidFill>
-            <a:prstDash val="dash"/>
-            <a:tailEnd type="triangle"/>
-          </a:ln>
-        </p:spPr>
-      </p:cxnSp>
-      <p:sp>
-        <p:nvSpPr>
-          <p:cNvPr id="199" name="Rectangle 198"/>
-          <p:cNvSpPr/>
-          <p:nvPr/>
-        </p:nvSpPr>
-        <p:spPr>
-          <a:xfrm>
-            <a:off x="10954512" y="1536192"/>
-            <a:ext cx="914400" cy="1234440"/>
-          </a:xfrm>
-          <a:prstGeom prst="rect">
-            <a:avLst/>
-          </a:prstGeom>
-          <a:solidFill>
-            <a:srgbClr val="FFFFFF"/>
-          </a:solidFill>
-          <a:ln w="15875">
-            <a:solidFill>
-              <a:srgbClr val="7F7F7F"/>
-            </a:solidFill>
-          </a:ln>
-          <a:effectLst/>
-        </p:spPr>
-        <p:txBody>
-          <a:bodyPr rtlCol="0" anchor="ctr"/>
-          <a:lstStyle/>
-          <a:p>
-            <a:pPr algn="ctr"/>
-          </a:p>
-        </p:txBody>
-      </p:sp>
-      <p:sp>
-        <p:nvSpPr>
-          <p:cNvPr id="200" name="Rectangle 199"/>
-          <p:cNvSpPr/>
-          <p:nvPr/>
-        </p:nvSpPr>
-        <p:spPr>
-          <a:xfrm>
-            <a:off x="10954512" y="1536192"/>
-            <a:ext cx="914400" cy="173736"/>
-          </a:xfrm>
-          <a:prstGeom prst="rect">
-            <a:avLst/>
-          </a:prstGeom>
-          <a:solidFill>
-            <a:srgbClr val="7F7F7F"/>
-          </a:solidFill>
-          <a:ln w="12700">
-            <a:solidFill>
-              <a:srgbClr val="7F7F7F"/>
-            </a:solidFill>
-          </a:ln>
-          <a:effectLst/>
-        </p:spPr>
-        <p:txBody>
-          <a:bodyPr rtlCol="0" anchor="ctr" wrap="square" lIns="45720" tIns="0" rIns="18288" bIns="0"/>
-          <a:lstStyle/>
-          <a:p>
-            <a:pPr algn="l"/>
-            <a:r>
-              <a:rPr sz="800" b="1">
-                <a:solidFill>
-                  <a:srgbClr val="FFFFFF"/>
-                </a:solidFill>
-                <a:latin typeface="맑은 고딕"/>
-                <a:ea typeface="맑은 고딕"/>
-              </a:rPr>
-              <a:t>«pod» vLLM</a:t>
-            </a:r>
-          </a:p>
-        </p:txBody>
-      </p:sp>
-      <p:sp>
-        <p:nvSpPr>
-          <p:cNvPr id="201" name="Rectangle 200"/>
-          <p:cNvSpPr/>
-          <p:nvPr/>
-        </p:nvSpPr>
-        <p:spPr>
-          <a:xfrm>
-            <a:off x="11009376" y="1764792"/>
-            <a:ext cx="804672" cy="941832"/>
-          </a:xfrm>
-          <a:prstGeom prst="rect">
-            <a:avLst/>
-          </a:prstGeom>
-          <a:solidFill>
-            <a:srgbClr val="F2F2F2"/>
-          </a:solidFill>
-          <a:ln w="12700">
-            <a:solidFill>
-              <a:srgbClr val="7F7F7F"/>
-            </a:solidFill>
-          </a:ln>
-          <a:effectLst/>
-        </p:spPr>
-        <p:txBody>
-          <a:bodyPr rtlCol="0" anchor="ctr" wrap="square" lIns="36576" tIns="18288" rIns="36576" bIns="18288"/>
-          <a:lstStyle/>
-          <a:p>
-            <a:pPr algn="ctr"/>
-            <a:r>
-              <a:rPr sz="800" b="1">
-                <a:solidFill>
-                  <a:srgbClr val="000000"/>
-                </a:solidFill>
-                <a:latin typeface="맑은 고딕"/>
-                <a:ea typeface="맑은 고딕"/>
-              </a:rPr>
-              <a:t>vLLM</a:t>
-            </a:r>
-          </a:p>
-          <a:p>
-            <a:pPr algn="ctr"/>
-            <a:r>
-              <a:rPr sz="750" b="0">
-                <a:solidFill>
-                  <a:srgbClr val="000000"/>
-                </a:solidFill>
-                <a:latin typeface="맑은 고딕"/>
-                <a:ea typeface="맑은 고딕"/>
-              </a:rPr>
-              <a:t>prefill</a:t>
-            </a:r>
-          </a:p>
-          <a:p>
-            <a:pPr algn="ctr"/>
-            <a:r>
-              <a:rPr sz="650" b="0">
-                <a:solidFill>
-                  <a:srgbClr val="404040"/>
-                </a:solidFill>
-                <a:latin typeface="맑은 고딕"/>
-                <a:ea typeface="맑은 고딕"/>
-              </a:rPr>
-              <a:t>KV events</a:t>
-            </a:r>
-          </a:p>
-          <a:p>
-            <a:pPr algn="ctr"/>
-            <a:r>
-              <a:rPr sz="650" b="0">
-                <a:solidFill>
-                  <a:srgbClr val="404040"/>
-                </a:solidFill>
-                <a:latin typeface="맑은 고딕"/>
-                <a:ea typeface="맑은 고딕"/>
-              </a:rPr>
-              <a:t>/metrics</a:t>
-            </a:r>
-          </a:p>
-        </p:txBody>
-      </p:sp>
-      <p:sp>
-        <p:nvSpPr>
-          <p:cNvPr id="202" name="Rectangle 201"/>
-          <p:cNvSpPr/>
-          <p:nvPr/>
-        </p:nvSpPr>
-        <p:spPr>
-          <a:xfrm>
-            <a:off x="10954512" y="2999232"/>
-            <a:ext cx="914400" cy="1371600"/>
-          </a:xfrm>
-          <a:prstGeom prst="rect">
-            <a:avLst/>
-          </a:prstGeom>
-          <a:solidFill>
-            <a:srgbClr val="FFFFFF"/>
-          </a:solidFill>
-          <a:ln w="15875">
-            <a:solidFill>
-              <a:srgbClr val="7F7F7F"/>
-            </a:solidFill>
-          </a:ln>
-          <a:effectLst/>
-        </p:spPr>
-        <p:txBody>
-          <a:bodyPr rtlCol="0" anchor="ctr"/>
-          <a:lstStyle/>
-          <a:p>
-            <a:pPr algn="ctr"/>
-          </a:p>
-        </p:txBody>
-      </p:sp>
-      <p:sp>
-        <p:nvSpPr>
-          <p:cNvPr id="203" name="Rectangle 202"/>
-          <p:cNvSpPr/>
-          <p:nvPr/>
-        </p:nvSpPr>
-        <p:spPr>
-          <a:xfrm>
-            <a:off x="10954512" y="2999232"/>
-            <a:ext cx="914400" cy="173736"/>
-          </a:xfrm>
-          <a:prstGeom prst="rect">
-            <a:avLst/>
-          </a:prstGeom>
-          <a:solidFill>
-            <a:srgbClr val="7F7F7F"/>
-          </a:solidFill>
-          <a:ln w="12700">
-            <a:solidFill>
-              <a:srgbClr val="7F7F7F"/>
-            </a:solidFill>
-          </a:ln>
-          <a:effectLst/>
-        </p:spPr>
-        <p:txBody>
-          <a:bodyPr rtlCol="0" anchor="ctr" wrap="square" lIns="45720" tIns="0" rIns="18288" bIns="0"/>
-          <a:lstStyle/>
-          <a:p>
-            <a:pPr algn="l"/>
-            <a:r>
-              <a:rPr sz="800" b="1">
-                <a:solidFill>
-                  <a:srgbClr val="FFFFFF"/>
-                </a:solidFill>
-                <a:latin typeface="맑은 고딕"/>
-                <a:ea typeface="맑은 고딕"/>
-              </a:rPr>
-              <a:t>«pod» vLLM</a:t>
-            </a:r>
-          </a:p>
-        </p:txBody>
-      </p:sp>
-      <p:sp>
-        <p:nvSpPr>
-          <p:cNvPr id="204" name="Rectangle 203"/>
-          <p:cNvSpPr/>
-          <p:nvPr/>
-        </p:nvSpPr>
-        <p:spPr>
-          <a:xfrm>
-            <a:off x="11009376" y="3227832"/>
-            <a:ext cx="804672" cy="1078992"/>
-          </a:xfrm>
-          <a:prstGeom prst="rect">
-            <a:avLst/>
-          </a:prstGeom>
-          <a:solidFill>
-            <a:srgbClr val="F2F2F2"/>
-          </a:solidFill>
-          <a:ln w="12700">
-            <a:solidFill>
-              <a:srgbClr val="7F7F7F"/>
-            </a:solidFill>
-          </a:ln>
-          <a:effectLst/>
-        </p:spPr>
-        <p:txBody>
-          <a:bodyPr rtlCol="0" anchor="ctr" wrap="square" lIns="36576" tIns="18288" rIns="36576" bIns="18288"/>
-          <a:lstStyle/>
-          <a:p>
-            <a:pPr algn="ctr"/>
-            <a:r>
-              <a:rPr sz="800" b="1">
-                <a:solidFill>
-                  <a:srgbClr val="000000"/>
-                </a:solidFill>
-                <a:latin typeface="맑은 고딕"/>
-                <a:ea typeface="맑은 고딕"/>
-              </a:rPr>
-              <a:t>vLLM</a:t>
-            </a:r>
-          </a:p>
-          <a:p>
-            <a:pPr algn="ctr"/>
-            <a:r>
-              <a:rPr sz="750" b="0">
-                <a:solidFill>
-                  <a:srgbClr val="000000"/>
-                </a:solidFill>
-                <a:latin typeface="맑은 고딕"/>
-                <a:ea typeface="맑은 고딕"/>
-              </a:rPr>
-              <a:t>decode</a:t>
-            </a:r>
-          </a:p>
-          <a:p>
-            <a:pPr algn="ctr"/>
-            <a:r>
-              <a:rPr sz="650" b="0">
-                <a:solidFill>
-                  <a:srgbClr val="404040"/>
-                </a:solidFill>
-                <a:latin typeface="맑은 고딕"/>
-                <a:ea typeface="맑은 고딕"/>
-              </a:rPr>
-              <a:t>KV events</a:t>
-            </a:r>
-          </a:p>
-          <a:p>
-            <a:pPr algn="ctr"/>
-            <a:r>
-              <a:rPr sz="650" b="0">
-                <a:solidFill>
-                  <a:srgbClr val="404040"/>
-                </a:solidFill>
-                <a:latin typeface="맑은 고딕"/>
-                <a:ea typeface="맑은 고딕"/>
-              </a:rPr>
-              <a:t>/metrics</a:t>
             </a:r>
           </a:p>
         </p:txBody>
@@ -26766,6 +26610,339 @@
         </p:nvCxnSpPr>
         <p:spPr>
           <a:xfrm>
+            <a:off x="8613648" y="4005072"/>
+            <a:ext cx="164592" cy="0"/>
+          </a:xfrm>
+          <a:prstGeom prst="line">
+            <a:avLst/>
+          </a:prstGeom>
+          <a:ln w="12700">
+            <a:solidFill>
+              <a:srgbClr val="C55A11"/>
+            </a:solidFill>
+            <a:prstDash val="dash"/>
+            <a:tailEnd type="triangle"/>
+          </a:ln>
+        </p:spPr>
+      </p:cxnSp>
+      <p:sp>
+        <p:nvSpPr>
+          <p:cNvPr id="206" name="Rectangle 205"/>
+          <p:cNvSpPr/>
+          <p:nvPr/>
+        </p:nvSpPr>
+        <p:spPr>
+          <a:xfrm>
+            <a:off x="10954512" y="1536192"/>
+            <a:ext cx="914400" cy="1234440"/>
+          </a:xfrm>
+          <a:prstGeom prst="rect">
+            <a:avLst/>
+          </a:prstGeom>
+          <a:solidFill>
+            <a:srgbClr val="FFFFFF"/>
+          </a:solidFill>
+          <a:ln w="15875">
+            <a:solidFill>
+              <a:srgbClr val="7F7F7F"/>
+            </a:solidFill>
+          </a:ln>
+          <a:effectLst/>
+        </p:spPr>
+        <p:txBody>
+          <a:bodyPr rtlCol="0" anchor="ctr"/>
+          <a:lstStyle/>
+          <a:p>
+            <a:pPr algn="ctr"/>
+          </a:p>
+        </p:txBody>
+      </p:sp>
+      <p:sp>
+        <p:nvSpPr>
+          <p:cNvPr id="207" name="Rectangle 206"/>
+          <p:cNvSpPr/>
+          <p:nvPr/>
+        </p:nvSpPr>
+        <p:spPr>
+          <a:xfrm>
+            <a:off x="10954512" y="1536192"/>
+            <a:ext cx="914400" cy="173736"/>
+          </a:xfrm>
+          <a:prstGeom prst="rect">
+            <a:avLst/>
+          </a:prstGeom>
+          <a:solidFill>
+            <a:srgbClr val="7F7F7F"/>
+          </a:solidFill>
+          <a:ln w="12700">
+            <a:solidFill>
+              <a:srgbClr val="7F7F7F"/>
+            </a:solidFill>
+          </a:ln>
+          <a:effectLst/>
+        </p:spPr>
+        <p:txBody>
+          <a:bodyPr rtlCol="0" anchor="ctr" wrap="square" lIns="45720" tIns="0" rIns="18288" bIns="0"/>
+          <a:lstStyle/>
+          <a:p>
+            <a:pPr algn="l"/>
+            <a:r>
+              <a:rPr sz="800" b="1">
+                <a:solidFill>
+                  <a:srgbClr val="FFFFFF"/>
+                </a:solidFill>
+                <a:latin typeface="맑은 고딕"/>
+                <a:ea typeface="맑은 고딕"/>
+              </a:rPr>
+              <a:t>«pod» vLLM</a:t>
+            </a:r>
+          </a:p>
+        </p:txBody>
+      </p:sp>
+      <p:sp>
+        <p:nvSpPr>
+          <p:cNvPr id="208" name="Rectangle 207"/>
+          <p:cNvSpPr/>
+          <p:nvPr/>
+        </p:nvSpPr>
+        <p:spPr>
+          <a:xfrm>
+            <a:off x="11009376" y="1764792"/>
+            <a:ext cx="804672" cy="941832"/>
+          </a:xfrm>
+          <a:prstGeom prst="rect">
+            <a:avLst/>
+          </a:prstGeom>
+          <a:solidFill>
+            <a:srgbClr val="F2F2F2"/>
+          </a:solidFill>
+          <a:ln w="12700">
+            <a:solidFill>
+              <a:srgbClr val="7F7F7F"/>
+            </a:solidFill>
+          </a:ln>
+          <a:effectLst/>
+        </p:spPr>
+        <p:txBody>
+          <a:bodyPr rtlCol="0" anchor="ctr" wrap="square" lIns="36576" tIns="18288" rIns="36576" bIns="18288"/>
+          <a:lstStyle/>
+          <a:p>
+            <a:pPr algn="ctr"/>
+            <a:r>
+              <a:rPr sz="800" b="1">
+                <a:solidFill>
+                  <a:srgbClr val="000000"/>
+                </a:solidFill>
+                <a:latin typeface="맑은 고딕"/>
+                <a:ea typeface="맑은 고딕"/>
+              </a:rPr>
+              <a:t>vLLM</a:t>
+            </a:r>
+          </a:p>
+          <a:p>
+            <a:pPr algn="ctr"/>
+            <a:r>
+              <a:rPr sz="750" b="0">
+                <a:solidFill>
+                  <a:srgbClr val="000000"/>
+                </a:solidFill>
+                <a:latin typeface="맑은 고딕"/>
+                <a:ea typeface="맑은 고딕"/>
+              </a:rPr>
+              <a:t>prefill</a:t>
+            </a:r>
+          </a:p>
+          <a:p>
+            <a:pPr algn="ctr"/>
+            <a:r>
+              <a:rPr sz="650" b="0">
+                <a:solidFill>
+                  <a:srgbClr val="404040"/>
+                </a:solidFill>
+                <a:latin typeface="맑은 고딕"/>
+                <a:ea typeface="맑은 고딕"/>
+              </a:rPr>
+              <a:t>KV events</a:t>
+            </a:r>
+          </a:p>
+          <a:p>
+            <a:pPr algn="ctr"/>
+            <a:r>
+              <a:rPr sz="650" b="0">
+                <a:solidFill>
+                  <a:srgbClr val="404040"/>
+                </a:solidFill>
+                <a:latin typeface="맑은 고딕"/>
+                <a:ea typeface="맑은 고딕"/>
+              </a:rPr>
+              <a:t>/metrics</a:t>
+            </a:r>
+          </a:p>
+        </p:txBody>
+      </p:sp>
+      <p:sp>
+        <p:nvSpPr>
+          <p:cNvPr id="209" name="Rectangle 208"/>
+          <p:cNvSpPr/>
+          <p:nvPr/>
+        </p:nvSpPr>
+        <p:spPr>
+          <a:xfrm>
+            <a:off x="10954512" y="2999232"/>
+            <a:ext cx="914400" cy="1371600"/>
+          </a:xfrm>
+          <a:prstGeom prst="rect">
+            <a:avLst/>
+          </a:prstGeom>
+          <a:solidFill>
+            <a:srgbClr val="FFFFFF"/>
+          </a:solidFill>
+          <a:ln w="15875">
+            <a:solidFill>
+              <a:srgbClr val="7F7F7F"/>
+            </a:solidFill>
+          </a:ln>
+          <a:effectLst/>
+        </p:spPr>
+        <p:txBody>
+          <a:bodyPr rtlCol="0" anchor="ctr"/>
+          <a:lstStyle/>
+          <a:p>
+            <a:pPr algn="ctr"/>
+          </a:p>
+        </p:txBody>
+      </p:sp>
+      <p:sp>
+        <p:nvSpPr>
+          <p:cNvPr id="210" name="Rectangle 209"/>
+          <p:cNvSpPr/>
+          <p:nvPr/>
+        </p:nvSpPr>
+        <p:spPr>
+          <a:xfrm>
+            <a:off x="10954512" y="2999232"/>
+            <a:ext cx="914400" cy="173736"/>
+          </a:xfrm>
+          <a:prstGeom prst="rect">
+            <a:avLst/>
+          </a:prstGeom>
+          <a:solidFill>
+            <a:srgbClr val="7F7F7F"/>
+          </a:solidFill>
+          <a:ln w="12700">
+            <a:solidFill>
+              <a:srgbClr val="7F7F7F"/>
+            </a:solidFill>
+          </a:ln>
+          <a:effectLst/>
+        </p:spPr>
+        <p:txBody>
+          <a:bodyPr rtlCol="0" anchor="ctr" wrap="square" lIns="45720" tIns="0" rIns="18288" bIns="0"/>
+          <a:lstStyle/>
+          <a:p>
+            <a:pPr algn="l"/>
+            <a:r>
+              <a:rPr sz="800" b="1">
+                <a:solidFill>
+                  <a:srgbClr val="FFFFFF"/>
+                </a:solidFill>
+                <a:latin typeface="맑은 고딕"/>
+                <a:ea typeface="맑은 고딕"/>
+              </a:rPr>
+              <a:t>«pod» vLLM</a:t>
+            </a:r>
+          </a:p>
+        </p:txBody>
+      </p:sp>
+      <p:sp>
+        <p:nvSpPr>
+          <p:cNvPr id="211" name="Rectangle 210"/>
+          <p:cNvSpPr/>
+          <p:nvPr/>
+        </p:nvSpPr>
+        <p:spPr>
+          <a:xfrm>
+            <a:off x="11009376" y="3227832"/>
+            <a:ext cx="804672" cy="1078992"/>
+          </a:xfrm>
+          <a:prstGeom prst="rect">
+            <a:avLst/>
+          </a:prstGeom>
+          <a:solidFill>
+            <a:srgbClr val="F2F2F2"/>
+          </a:solidFill>
+          <a:ln w="12700">
+            <a:solidFill>
+              <a:srgbClr val="7F7F7F"/>
+            </a:solidFill>
+          </a:ln>
+          <a:effectLst/>
+        </p:spPr>
+        <p:txBody>
+          <a:bodyPr rtlCol="0" anchor="ctr" wrap="square" lIns="36576" tIns="18288" rIns="36576" bIns="18288"/>
+          <a:lstStyle/>
+          <a:p>
+            <a:pPr algn="ctr"/>
+            <a:r>
+              <a:rPr sz="800" b="1">
+                <a:solidFill>
+                  <a:srgbClr val="000000"/>
+                </a:solidFill>
+                <a:latin typeface="맑은 고딕"/>
+                <a:ea typeface="맑은 고딕"/>
+              </a:rPr>
+              <a:t>vLLM</a:t>
+            </a:r>
+          </a:p>
+          <a:p>
+            <a:pPr algn="ctr"/>
+            <a:r>
+              <a:rPr sz="750" b="0">
+                <a:solidFill>
+                  <a:srgbClr val="000000"/>
+                </a:solidFill>
+                <a:latin typeface="맑은 고딕"/>
+                <a:ea typeface="맑은 고딕"/>
+              </a:rPr>
+              <a:t>decode</a:t>
+            </a:r>
+          </a:p>
+          <a:p>
+            <a:pPr algn="ctr"/>
+            <a:r>
+              <a:rPr sz="650" b="0">
+                <a:solidFill>
+                  <a:srgbClr val="404040"/>
+                </a:solidFill>
+                <a:latin typeface="맑은 고딕"/>
+                <a:ea typeface="맑은 고딕"/>
+              </a:rPr>
+              <a:t>KV events</a:t>
+            </a:r>
+          </a:p>
+          <a:p>
+            <a:pPr algn="ctr"/>
+            <a:r>
+              <a:rPr sz="650" b="0">
+                <a:solidFill>
+                  <a:srgbClr val="404040"/>
+                </a:solidFill>
+                <a:latin typeface="맑은 고딕"/>
+                <a:ea typeface="맑은 고딕"/>
+              </a:rPr>
+              <a:t>/metrics</a:t>
+            </a:r>
+          </a:p>
+        </p:txBody>
+      </p:sp>
+      <p:cxnSp>
+        <p:nvCxnSpPr>
+          <p:cNvPr id="212" name="Connector 211"/>
+          <p:cNvCxnSpPr/>
+          <p:nvPr/>
+        </p:nvCxnSpPr>
+        <p:spPr>
+          <a:xfrm>
             <a:off x="11411712" y="2770632"/>
             <a:ext cx="0" cy="457200"/>
           </a:xfrm>
@@ -26783,7 +26960,7 @@
       </p:cxnSp>
       <p:sp>
         <p:nvSpPr>
-          <p:cNvPr id="206" name="Oval 205"/>
+          <p:cNvPr id="213" name="Oval 212"/>
           <p:cNvSpPr/>
           <p:nvPr/>
         </p:nvSpPr>
@@ -26825,7 +27002,7 @@
       </p:sp>
       <p:cxnSp>
         <p:nvCxnSpPr>
-          <p:cNvPr id="207" name="Connector 206"/>
+          <p:cNvPr id="214" name="Connector 213"/>
           <p:cNvCxnSpPr/>
           <p:nvPr/>
         </p:nvCxnSpPr>
@@ -26847,7 +27024,7 @@
       </p:cxnSp>
       <p:sp>
         <p:nvSpPr>
-          <p:cNvPr id="208" name="Oval 207"/>
+          <p:cNvPr id="215" name="Oval 214"/>
           <p:cNvSpPr/>
           <p:nvPr/>
         </p:nvSpPr>
@@ -26889,14 +27066,14 @@
       </p:sp>
       <p:cxnSp>
         <p:nvCxnSpPr>
-          <p:cNvPr id="209" name="Connector 208"/>
+          <p:cNvPr id="216" name="Connector 215"/>
           <p:cNvCxnSpPr/>
           <p:nvPr/>
         </p:nvCxnSpPr>
         <p:spPr>
           <a:xfrm flipH="1">
-            <a:off x="9189720" y="3959352"/>
-            <a:ext cx="1819656" cy="0"/>
+            <a:off x="9646920" y="4315968"/>
+            <a:ext cx="1362456" cy="0"/>
           </a:xfrm>
           <a:prstGeom prst="line">
             <a:avLst/>
@@ -26911,14 +27088,14 @@
       </p:cxnSp>
       <p:cxnSp>
         <p:nvCxnSpPr>
-          <p:cNvPr id="210" name="Connector 209"/>
+          <p:cNvPr id="217" name="Connector 216"/>
           <p:cNvCxnSpPr/>
           <p:nvPr/>
         </p:nvCxnSpPr>
         <p:spPr>
           <a:xfrm flipV="1">
-            <a:off x="9189720" y="3849624"/>
-            <a:ext cx="0" cy="109728"/>
+            <a:off x="9646920" y="4233672"/>
+            <a:ext cx="0" cy="82296"/>
           </a:xfrm>
           <a:prstGeom prst="line">
             <a:avLst/>
@@ -26934,13 +27111,13 @@
       </p:cxnSp>
       <p:sp>
         <p:nvSpPr>
-          <p:cNvPr id="211" name="Oval 210"/>
-          <p:cNvSpPr/>
-          <p:nvPr/>
-        </p:nvSpPr>
-        <p:spPr>
-          <a:xfrm>
-            <a:off x="10730484" y="3744468"/>
+          <p:cNvPr id="218" name="Oval 217"/>
+          <p:cNvSpPr/>
+          <p:nvPr/>
+        </p:nvSpPr>
+        <p:spPr>
+          <a:xfrm>
+            <a:off x="10730484" y="4110228"/>
             <a:ext cx="155448" cy="155448"/>
           </a:xfrm>
           <a:prstGeom prst="ellipse">
@@ -26976,7 +27153,7 @@
       </p:sp>
       <p:sp>
         <p:nvSpPr>
-          <p:cNvPr id="212" name="Rectangle 211"/>
+          <p:cNvPr id="219" name="Rectangle 218"/>
           <p:cNvSpPr/>
           <p:nvPr/>
         </p:nvSpPr>
@@ -27018,7 +27195,7 @@
       </p:sp>
       <p:sp>
         <p:nvSpPr>
-          <p:cNvPr id="213" name="Rectangle 212"/>
+          <p:cNvPr id="220" name="Rectangle 219"/>
           <p:cNvSpPr/>
           <p:nvPr/>
         </p:nvSpPr>
@@ -27060,7 +27237,7 @@
       </p:sp>
       <p:sp>
         <p:nvSpPr>
-          <p:cNvPr id="214" name="Rectangle 213"/>
+          <p:cNvPr id="221" name="Rectangle 220"/>
           <p:cNvSpPr/>
           <p:nvPr/>
         </p:nvSpPr>
@@ -27103,7 +27280,7 @@
       </p:sp>
       <p:sp>
         <p:nvSpPr>
-          <p:cNvPr id="215" name="Rectangle 214"/>
+          <p:cNvPr id="222" name="Rectangle 221"/>
           <p:cNvSpPr/>
           <p:nvPr/>
         </p:nvSpPr>
@@ -27145,7 +27322,7 @@
       </p:sp>
       <p:sp>
         <p:nvSpPr>
-          <p:cNvPr id="216" name="Rectangle 215"/>
+          <p:cNvPr id="223" name="Rectangle 222"/>
           <p:cNvSpPr/>
           <p:nvPr/>
         </p:nvSpPr>
@@ -27187,7 +27364,7 @@
       </p:sp>
       <p:sp>
         <p:nvSpPr>
-          <p:cNvPr id="217" name="Rectangle 216"/>
+          <p:cNvPr id="224" name="Rectangle 223"/>
           <p:cNvSpPr/>
           <p:nvPr/>
         </p:nvSpPr>
@@ -27222,14 +27399,14 @@
                 <a:latin typeface="맑은 고딕"/>
                 <a:ea typeface="맑은 고딕"/>
               </a:rPr>
-              <a:t>디자인 패턴: Strategy (정책 구현체를 갈아 끼움)</a:t>
-            </a:r>
-          </a:p>
-        </p:txBody>
-      </p:sp>
-      <p:sp>
-        <p:nvSpPr>
-          <p:cNvPr id="218" name="Rectangle 217"/>
+              <a:t>디자인 패턴: Strategy (uses ▸ interface ◂ △ implements)</a:t>
+            </a:r>
+          </a:p>
+        </p:txBody>
+      </p:sp>
+      <p:sp>
+        <p:nvSpPr>
+          <p:cNvPr id="225" name="Rectangle 224"/>
           <p:cNvSpPr/>
           <p:nvPr/>
         </p:nvSpPr>
@@ -27271,7 +27448,7 @@
       </p:sp>
       <p:sp>
         <p:nvSpPr>
-          <p:cNvPr id="219" name="TextBox 218"/>
+          <p:cNvPr id="226" name="TextBox 225"/>
           <p:cNvSpPr txBox="1"/>
           <p:nvPr/>
         </p:nvSpPr>
@@ -27307,7 +27484,7 @@
       </p:sp>
       <p:sp>
         <p:nvSpPr>
-          <p:cNvPr id="220" name="Rectangle 219"/>
+          <p:cNvPr id="227" name="Rectangle 226"/>
           <p:cNvSpPr/>
           <p:nvPr/>
         </p:nvSpPr>
@@ -27349,7 +27526,7 @@
       </p:sp>
       <p:sp>
         <p:nvSpPr>
-          <p:cNvPr id="221" name="Rectangle 220"/>
+          <p:cNvPr id="228" name="Rectangle 227"/>
           <p:cNvSpPr/>
           <p:nvPr/>
         </p:nvSpPr>
@@ -27417,7 +27594,7 @@
       </p:sp>
       <p:sp>
         <p:nvSpPr>
-          <p:cNvPr id="222" name="Rectangle 221"/>
+          <p:cNvPr id="229" name="Rectangle 228"/>
           <p:cNvSpPr/>
           <p:nvPr/>
         </p:nvSpPr>
@@ -27485,7 +27662,7 @@
       </p:sp>
       <p:sp>
         <p:nvSpPr>
-          <p:cNvPr id="223" name="Rectangle 222"/>
+          <p:cNvPr id="230" name="Rectangle 229"/>
           <p:cNvSpPr/>
           <p:nvPr/>
         </p:nvSpPr>
@@ -27527,7 +27704,7 @@
       </p:sp>
       <p:sp>
         <p:nvSpPr>
-          <p:cNvPr id="224" name="Rectangle 223"/>
+          <p:cNvPr id="231" name="Rectangle 230"/>
           <p:cNvSpPr/>
           <p:nvPr/>
         </p:nvSpPr>
@@ -27595,7 +27772,7 @@
       </p:sp>
       <p:sp>
         <p:nvSpPr>
-          <p:cNvPr id="225" name="Rectangle 224"/>
+          <p:cNvPr id="232" name="Rectangle 231"/>
           <p:cNvSpPr/>
           <p:nvPr/>
         </p:nvSpPr>
@@ -27663,7 +27840,7 @@
       </p:sp>
       <p:sp>
         <p:nvSpPr>
-          <p:cNvPr id="226" name="TextBox 225"/>
+          <p:cNvPr id="233" name="TextBox 232"/>
           <p:cNvSpPr txBox="1"/>
           <p:nvPr/>
         </p:nvSpPr>
@@ -27699,7 +27876,7 @@
       </p:sp>
       <p:sp>
         <p:nvSpPr>
-          <p:cNvPr id="227" name="TextBox 226"/>
+          <p:cNvPr id="234" name="TextBox 233"/>
           <p:cNvSpPr txBox="1"/>
           <p:nvPr/>
         </p:nvSpPr>
@@ -27728,7 +27905,7 @@
                 <a:latin typeface="맑은 고딕"/>
                 <a:ea typeface="맑은 고딕"/>
               </a:rPr>
-              <a:t>※ ★P5 = 지시의 '송신'(오케스트레이션 범위). 수신·실행은 vLLM(엔진) 공통 선결(C5 접점 계약). P/D 보조 프로세스는 엔진이 아니라 오케스트레이션 소프트웨어다. 디자인 패턴: Strategy = 정책(P1~P4)을 같은 인터페이스의 구현체로 두고 설정으로 교체. 박스는 프로세스가 아니라 한 프로세스 안의 모듈이고, 프로세스 경계는 굵은 바깥 박스.</a:t>
+              <a:t>※ ★P5 = 지시의 '송신'(오케스트레이션 범위). 수신·실행은 vLLM(엔진) 공통 선결(C5 접점 계약). P/D 보조 프로세스는 엔진이 아니라 오케스트레이션 소프트웨어다. 디자인 패턴: Strategy = Selector(Context)가 인터페이스를 참조(uses)하고 정책 구현체(P1~P3, P/D 판단 P4)가 이를 구현(implements, △)해 설정으로 교체. 박스는 프로세스가 아니라 한 프로세스 안의 모듈이고, 프로세스 경계는 굵은 바깥 박스.</a:t>
             </a:r>
           </a:p>
         </p:txBody>

</xml_diff>

<commit_message>
DP0: restore the multi-pattern structure slide and docs, show a single replica
Co-Authored-By: Claude Sonnet 5.5 <noreply@anthropic.com>
Claude-Session: https://claude.ai/code/session_014XKnsGjraFTY3Q8v5o1PT9
</commit_message>
<xml_diff>
--- a/doc-mk/DP0/DP0-slides-v2.pptx
+++ b/doc-mk/DP0/DP0-slides-v2.pptx
@@ -790,7 +790,7 @@
           </a:p>
           <a:p>
             <a:r>
-              <a:t>2안(오른쪽)은 전부 우리가 소유하는 계층형 구조입니다. 한 프로세스 안에 Ingress, Pipeline(Admission → PolicyEngine → P/D 조율), State Plane(상태 저장소, 이벤트 구독, 메트릭 수집, 서버 등록)을 나눴고, 정책은 Strategy 패턴으로 갈아 끼웁니다. 점수·비용 함수·P/D 정책을 같은 인터페이스의 구현체로 두고 설정으로 교체하므로 Router 본체와 파이프라인은 그대로입니다. 이전 안은 단일 프로세스·정적 설정의 최소 구성이어서 확장성이 일방적으로 약했는데, 이번에는 상태를 공유하지 않는 레플리카 여러 개를 L4 로드밸런서 뒤에 두고 etcd로 서버를 등록하는 구성으로 같은 노력 수준에서 비교합니다. 구현은 되어 있지 않은 설계안입니다.</a:t>
+              <a:t>2안(오른쪽)은 전부 우리가 소유하는 계층형 구조입니다. 한 프로세스 안에 Ingress, Pipeline(Admission → PolicyEngine → P/D 조율), State Plane(상태 저장소, 이벤트 구독, 메트릭 수집, 서버 등록)을 나눴고, 정책은 디자인 패턴으로 갈아 끼웁니다. 요청 경로는 Chain of Responsibility(파이프라인), 점수·P/D 정책은 Strategy(P1~P3 Scorer, P4 Planner), 노드 지시는 Decorator(P5), 상태 갱신은 Observer, vLLM 계약은 Adapter로 격리하고, 상태는 읽기 전용 StateView(Facade)로만 읽습니다. 이전 안은 단일 프로세스·정적 설정의 최소 구성이어서 확장성이 일방적으로 약했는데, 이번에는 상태를 공유하지 않는 레플리카 여러 개를 L4 로드밸런서 뒤에 두고 etcd로 서버를 등록하는 구성으로 같은 노력 수준에서 비교합니다. 구현은 되어 있지 않은 설계안입니다.</a:t>
             </a:r>
           </a:p>
           <a:p>
@@ -21943,7 +21943,7 @@
                   <a:schemeClr val="bg1"/>
                 </a:solidFill>
               </a:rPr>
-              <a:t>서버 간(클러스터) 요청을 조율하는 계층의 컴포넌트 뷰 (2안은 Strategy 패턴 적용)</a:t>
+              <a:t>서버 간(클러스터) 요청을 조율하는 계층의 컴포넌트 뷰 (2안은 디자인 패턴 적용)</a:t>
             </a:r>
             <a:endParaRPr lang="ko-KR" altLang="en-US" sz="1400" b="1" dirty="0">
               <a:solidFill>
@@ -22809,7 +22809,7 @@
                 <a:latin typeface="맑은 고딕"/>
                 <a:ea typeface="맑은 고딕"/>
               </a:rPr>
-              <a:t>(Own Router: 한 프로세스 · Strategy 패턴 · 레플리카 확장)</a:t>
+              <a:t>(Own Router: 계층형 · 디자인 패턴 · 레플리카 확장)</a:t>
             </a:r>
           </a:p>
         </p:txBody>
@@ -22845,7 +22845,7 @@
                 <a:latin typeface="맑은 고딕"/>
                 <a:ea typeface="맑은 고딕"/>
               </a:rPr>
-              <a:t>“결정·상태·P/D 조율을 한 프로세스에 모으고, 정책은 Strategy 패턴으로 갈아 끼우는 구조”</a:t>
+              <a:t>“결정·상태·P/D 조율을 한 프로세스에 모으고, 정책은 디자인 패턴으로 갈아 끼우는 구조”</a:t>
             </a:r>
           </a:p>
         </p:txBody>
@@ -25357,7 +25357,7 @@
         </p:nvSpPr>
         <p:spPr>
           <a:xfrm>
-            <a:off x="6583680" y="3410712"/>
+            <a:off x="6583680" y="3776472"/>
             <a:ext cx="566928" cy="384048"/>
           </a:xfrm>
           <a:prstGeom prst="rect">
@@ -25413,7 +25413,7 @@
         <p:spPr>
           <a:xfrm>
             <a:off x="7242048" y="1536192"/>
-            <a:ext cx="3566160" cy="2852928"/>
+            <a:ext cx="3566160" cy="2834640"/>
           </a:xfrm>
           <a:prstGeom prst="rect">
             <a:avLst/>
@@ -25421,7 +25421,7 @@
           <a:solidFill>
             <a:srgbClr val="FFFFFF"/>
           </a:solidFill>
-          <a:ln w="25400">
+          <a:ln w="19050">
             <a:solidFill>
               <a:srgbClr val="C55A11"/>
             </a:solidFill>
@@ -25445,7 +25445,7 @@
         <p:spPr>
           <a:xfrm>
             <a:off x="7242048" y="1536192"/>
-            <a:ext cx="3566160" cy="182880"/>
+            <a:ext cx="3566160" cy="164592"/>
           </a:xfrm>
           <a:prstGeom prst="rect">
             <a:avLst/>
@@ -25466,70 +25466,28 @@
           <a:p>
             <a:pPr algn="l"/>
             <a:r>
-              <a:rPr sz="750" b="1">
+              <a:rPr sz="700" b="1">
                 <a:solidFill>
                   <a:srgbClr val="FFFFFF"/>
                 </a:solidFill>
                 <a:latin typeface="맑은 고딕"/>
                 <a:ea typeface="맑은 고딕"/>
               </a:rPr>
-              <a:t>«process» Own Router  (한 프로세스)</a:t>
-            </a:r>
-          </a:p>
-        </p:txBody>
-      </p:sp>
-      <p:sp>
-        <p:nvSpPr>
-          <p:cNvPr id="175" name="Rectangle 174"/>
-          <p:cNvSpPr/>
-          <p:nvPr/>
-        </p:nvSpPr>
-        <p:spPr>
-          <a:xfrm>
-            <a:off x="10104120" y="1563624"/>
-            <a:ext cx="658368" cy="128016"/>
-          </a:xfrm>
-          <a:prstGeom prst="rect">
-            <a:avLst/>
-          </a:prstGeom>
-          <a:solidFill>
-            <a:srgbClr val="FFFFFF"/>
-          </a:solidFill>
-          <a:ln w="12700">
-            <a:solidFill>
-              <a:srgbClr val="FFFFFF"/>
-            </a:solidFill>
-          </a:ln>
-          <a:effectLst/>
-        </p:spPr>
-        <p:txBody>
-          <a:bodyPr rtlCol="0" anchor="ctr" wrap="square" lIns="0" tIns="0" rIns="0" bIns="0"/>
-          <a:lstStyle/>
-          <a:p>
-            <a:pPr algn="ctr"/>
-            <a:r>
-              <a:rPr sz="650" b="1">
-                <a:solidFill>
-                  <a:srgbClr val="C55A11"/>
-                </a:solidFill>
-                <a:latin typeface="맑은 고딕"/>
-                <a:ea typeface="맑은 고딕"/>
-              </a:rPr>
-              <a:t>×R 레플리카</a:t>
+              <a:t>«process» Own Router 레플리카 1개 (한 프로세스)</a:t>
             </a:r>
           </a:p>
         </p:txBody>
       </p:sp>
       <p:cxnSp>
         <p:nvCxnSpPr>
-          <p:cNvPr id="176" name="Connector 175"/>
+          <p:cNvPr id="175" name="Connector 174"/>
           <p:cNvCxnSpPr/>
           <p:nvPr/>
         </p:nvCxnSpPr>
         <p:spPr>
           <a:xfrm flipV="1">
             <a:off x="7150608" y="1993392"/>
-            <a:ext cx="182880" cy="237744"/>
+            <a:ext cx="164592" cy="237744"/>
           </a:xfrm>
           <a:prstGeom prst="line">
             <a:avLst/>
@@ -25544,14 +25502,98 @@
       </p:cxnSp>
       <p:sp>
         <p:nvSpPr>
+          <p:cNvPr id="176" name="Rectangle 175"/>
+          <p:cNvSpPr/>
+          <p:nvPr/>
+        </p:nvSpPr>
+        <p:spPr>
+          <a:xfrm>
+            <a:off x="7333488" y="1755648"/>
+            <a:ext cx="3383280" cy="274320"/>
+          </a:xfrm>
+          <a:prstGeom prst="rect">
+            <a:avLst/>
+          </a:prstGeom>
+          <a:solidFill>
+            <a:srgbClr val="FBE5D6"/>
+          </a:solidFill>
+          <a:ln w="12700">
+            <a:solidFill>
+              <a:srgbClr val="C55A11"/>
+            </a:solidFill>
+          </a:ln>
+          <a:effectLst/>
+        </p:spPr>
+        <p:txBody>
+          <a:bodyPr rtlCol="0" anchor="ctr" wrap="square" lIns="36576" tIns="18288" rIns="36576" bIns="18288"/>
+          <a:lstStyle/>
+          <a:p>
+            <a:pPr algn="ctr"/>
+            <a:r>
+              <a:rPr sz="750" b="1">
+                <a:solidFill>
+                  <a:srgbClr val="000000"/>
+                </a:solidFill>
+                <a:latin typeface="맑은 고딕"/>
+                <a:ea typeface="맑은 고딕"/>
+              </a:rPr>
+              <a:t>A Ingress / API   요청 파싱 · 스트리밍 중계</a:t>
+            </a:r>
+          </a:p>
+        </p:txBody>
+      </p:sp>
+      <p:sp>
+        <p:nvSpPr>
           <p:cNvPr id="177" name="Rectangle 176"/>
           <p:cNvSpPr/>
           <p:nvPr/>
         </p:nvSpPr>
         <p:spPr>
           <a:xfrm>
-            <a:off x="7333488" y="1810512"/>
-            <a:ext cx="713232" cy="384048"/>
+            <a:off x="7955279" y="2084832"/>
+            <a:ext cx="1691640" cy="137160"/>
+          </a:xfrm>
+          <a:prstGeom prst="rect">
+            <a:avLst/>
+          </a:prstGeom>
+          <a:solidFill>
+            <a:srgbClr val="EDE7F6"/>
+          </a:solidFill>
+          <a:ln w="9525">
+            <a:solidFill>
+              <a:srgbClr val="5E35B1"/>
+            </a:solidFill>
+          </a:ln>
+          <a:effectLst/>
+        </p:spPr>
+        <p:txBody>
+          <a:bodyPr rtlCol="0" anchor="ctr" wrap="square" lIns="18288" tIns="0" rIns="18288" bIns="0"/>
+          <a:lstStyle/>
+          <a:p>
+            <a:pPr algn="ctr"/>
+            <a:r>
+              <a:rPr sz="600" b="1">
+                <a:solidFill>
+                  <a:srgbClr val="5E35B1"/>
+                </a:solidFill>
+                <a:latin typeface="맑은 고딕"/>
+                <a:ea typeface="맑은 고딕"/>
+              </a:rPr>
+              <a:t>«Chain of Responsibility» Pipeline</a:t>
+            </a:r>
+          </a:p>
+        </p:txBody>
+      </p:sp>
+      <p:sp>
+        <p:nvSpPr>
+          <p:cNvPr id="178" name="Rectangle 177"/>
+          <p:cNvSpPr/>
+          <p:nvPr/>
+        </p:nvSpPr>
+        <p:spPr>
+          <a:xfrm>
+            <a:off x="7333488" y="2240280"/>
+            <a:ext cx="868680" cy="237744"/>
           </a:xfrm>
           <a:prstGeom prst="rect">
             <a:avLst/>
@@ -25579,34 +25621,63 @@
                 <a:latin typeface="맑은 고딕"/>
                 <a:ea typeface="맑은 고딕"/>
               </a:rPr>
-              <a:t>A Ingress</a:t>
-            </a:r>
-          </a:p>
-          <a:p>
-            <a:pPr algn="ctr"/>
-            <a:r>
-              <a:rPr sz="650" b="0">
+              <a:t>D Admission</a:t>
+            </a:r>
+          </a:p>
+        </p:txBody>
+      </p:sp>
+      <p:sp>
+        <p:nvSpPr>
+          <p:cNvPr id="179" name="Rectangle 178"/>
+          <p:cNvSpPr/>
+          <p:nvPr/>
+        </p:nvSpPr>
+        <p:spPr>
+          <a:xfrm>
+            <a:off x="8321040" y="2240280"/>
+            <a:ext cx="1051560" cy="237744"/>
+          </a:xfrm>
+          <a:prstGeom prst="rect">
+            <a:avLst/>
+          </a:prstGeom>
+          <a:solidFill>
+            <a:srgbClr val="FBE5D6"/>
+          </a:solidFill>
+          <a:ln w="19050">
+            <a:solidFill>
+              <a:srgbClr val="C55A11"/>
+            </a:solidFill>
+          </a:ln>
+          <a:effectLst/>
+        </p:spPr>
+        <p:txBody>
+          <a:bodyPr rtlCol="0" anchor="ctr" wrap="square" lIns="36576" tIns="18288" rIns="36576" bIns="18288"/>
+          <a:lstStyle/>
+          <a:p>
+            <a:pPr algn="ctr"/>
+            <a:r>
+              <a:rPr sz="750" b="1">
                 <a:solidFill>
                   <a:srgbClr val="000000"/>
                 </a:solidFill>
                 <a:latin typeface="맑은 고딕"/>
                 <a:ea typeface="맑은 고딕"/>
               </a:rPr>
-              <a:t>요청 수신·중계</a:t>
-            </a:r>
-          </a:p>
-        </p:txBody>
-      </p:sp>
-      <p:sp>
-        <p:nvSpPr>
-          <p:cNvPr id="178" name="Rectangle 177"/>
-          <p:cNvSpPr/>
-          <p:nvPr/>
-        </p:nvSpPr>
-        <p:spPr>
-          <a:xfrm>
-            <a:off x="8138160" y="1810512"/>
-            <a:ext cx="658368" cy="384048"/>
+              <a:t>B Selector</a:t>
+            </a:r>
+          </a:p>
+        </p:txBody>
+      </p:sp>
+      <p:sp>
+        <p:nvSpPr>
+          <p:cNvPr id="180" name="Rectangle 179"/>
+          <p:cNvSpPr/>
+          <p:nvPr/>
+        </p:nvSpPr>
+        <p:spPr>
+          <a:xfrm>
+            <a:off x="9491472" y="2240280"/>
+            <a:ext cx="1225296" cy="237744"/>
           </a:xfrm>
           <a:prstGeom prst="rect">
             <a:avLst/>
@@ -25634,130 +25705,7 @@
                 <a:latin typeface="맑은 고딕"/>
                 <a:ea typeface="맑은 고딕"/>
               </a:rPr>
-              <a:t>D 흐름 제어</a:t>
-            </a:r>
-          </a:p>
-          <a:p>
-            <a:pPr algn="ctr"/>
-            <a:r>
-              <a:rPr sz="650" b="0">
-                <a:solidFill>
-                  <a:srgbClr val="000000"/>
-                </a:solidFill>
-                <a:latin typeface="맑은 고딕"/>
-                <a:ea typeface="맑은 고딕"/>
-              </a:rPr>
-              <a:t>admission</a:t>
-            </a:r>
-          </a:p>
-        </p:txBody>
-      </p:sp>
-      <p:sp>
-        <p:nvSpPr>
-          <p:cNvPr id="179" name="Rectangle 178"/>
-          <p:cNvSpPr/>
-          <p:nvPr/>
-        </p:nvSpPr>
-        <p:spPr>
-          <a:xfrm>
-            <a:off x="8887968" y="1810512"/>
-            <a:ext cx="841248" cy="384048"/>
-          </a:xfrm>
-          <a:prstGeom prst="rect">
-            <a:avLst/>
-          </a:prstGeom>
-          <a:solidFill>
-            <a:srgbClr val="FBE5D6"/>
-          </a:solidFill>
-          <a:ln w="19050">
-            <a:solidFill>
-              <a:srgbClr val="C55A11"/>
-            </a:solidFill>
-          </a:ln>
-          <a:effectLst/>
-        </p:spPr>
-        <p:txBody>
-          <a:bodyPr rtlCol="0" anchor="ctr" wrap="square" lIns="36576" tIns="18288" rIns="36576" bIns="18288"/>
-          <a:lstStyle/>
-          <a:p>
-            <a:pPr algn="ctr"/>
-            <a:r>
-              <a:rPr sz="750" b="1">
-                <a:solidFill>
-                  <a:srgbClr val="000000"/>
-                </a:solidFill>
-                <a:latin typeface="맑은 고딕"/>
-                <a:ea typeface="맑은 고딕"/>
-              </a:rPr>
-              <a:t>B Selector</a:t>
-            </a:r>
-          </a:p>
-          <a:p>
-            <a:pPr algn="ctr"/>
-            <a:r>
-              <a:rPr sz="650" b="0">
-                <a:solidFill>
-                  <a:srgbClr val="000000"/>
-                </a:solidFill>
-                <a:latin typeface="맑은 고딕"/>
-                <a:ea typeface="맑은 고딕"/>
-              </a:rPr>
-              <a:t>후보 서버 선택</a:t>
-            </a:r>
-          </a:p>
-        </p:txBody>
-      </p:sp>
-      <p:sp>
-        <p:nvSpPr>
-          <p:cNvPr id="180" name="Rectangle 179"/>
-          <p:cNvSpPr/>
-          <p:nvPr/>
-        </p:nvSpPr>
-        <p:spPr>
-          <a:xfrm>
-            <a:off x="9820656" y="1810512"/>
-            <a:ext cx="822960" cy="384048"/>
-          </a:xfrm>
-          <a:prstGeom prst="rect">
-            <a:avLst/>
-          </a:prstGeom>
-          <a:solidFill>
-            <a:srgbClr val="FBE5D6"/>
-          </a:solidFill>
-          <a:ln w="19050">
-            <a:solidFill>
-              <a:srgbClr val="C55A11"/>
-            </a:solidFill>
-          </a:ln>
-          <a:effectLst/>
-        </p:spPr>
-        <p:txBody>
-          <a:bodyPr rtlCol="0" anchor="ctr" wrap="square" lIns="36576" tIns="18288" rIns="36576" bIns="18288"/>
-          <a:lstStyle/>
-          <a:p>
-            <a:pPr algn="ctr"/>
-            <a:r>
-              <a:rPr sz="750" b="1">
-                <a:solidFill>
-                  <a:srgbClr val="000000"/>
-                </a:solidFill>
-                <a:latin typeface="맑은 고딕"/>
-                <a:ea typeface="맑은 고딕"/>
-              </a:rPr>
-              <a:t>E P/D 조율</a:t>
-            </a:r>
-          </a:p>
-          <a:p>
-            <a:pPr algn="ctr"/>
-            <a:r>
-              <a:rPr sz="650" b="0">
-                <a:solidFill>
-                  <a:srgbClr val="000000"/>
-                </a:solidFill>
-                <a:latin typeface="맑은 고딕"/>
-                <a:ea typeface="맑은 고딕"/>
-              </a:rPr>
-              <a:t>P5 지시 송신</a:t>
+              <a:t>E Dispatcher</a:t>
             </a:r>
           </a:p>
         </p:txBody>
@@ -25770,8 +25718,8 @@
         </p:nvCxnSpPr>
         <p:spPr>
           <a:xfrm>
-            <a:off x="8046720" y="2002536"/>
-            <a:ext cx="91440" cy="0"/>
+            <a:off x="8202168" y="2359152"/>
+            <a:ext cx="118872" cy="0"/>
           </a:xfrm>
           <a:prstGeom prst="line">
             <a:avLst/>
@@ -25792,8 +25740,8 @@
         </p:nvCxnSpPr>
         <p:spPr>
           <a:xfrm>
-            <a:off x="8796528" y="2002536"/>
-            <a:ext cx="91440" cy="0"/>
+            <a:off x="9372600" y="2359152"/>
+            <a:ext cx="118872" cy="0"/>
           </a:xfrm>
           <a:prstGeom prst="line">
             <a:avLst/>
@@ -25814,8 +25762,8 @@
         </p:nvCxnSpPr>
         <p:spPr>
           <a:xfrm>
-            <a:off x="9729216" y="2002536"/>
-            <a:ext cx="91440" cy="0"/>
+            <a:off x="7635240" y="2029968"/>
+            <a:ext cx="0" cy="210312"/>
           </a:xfrm>
           <a:prstGeom prst="line">
             <a:avLst/>
@@ -25836,7 +25784,7 @@
         </p:nvSpPr>
         <p:spPr>
           <a:xfrm>
-            <a:off x="8014715" y="1714500"/>
+            <a:off x="7712963" y="2061972"/>
             <a:ext cx="155448" cy="155448"/>
           </a:xfrm>
           <a:prstGeom prst="ellipse">
@@ -25878,8 +25826,8 @@
         </p:nvSpPr>
         <p:spPr>
           <a:xfrm>
-            <a:off x="8366760" y="2450592"/>
-            <a:ext cx="1828800" cy="384048"/>
+            <a:off x="7333488" y="2523744"/>
+            <a:ext cx="914400" cy="137160"/>
           </a:xfrm>
           <a:prstGeom prst="rect">
             <a:avLst/>
@@ -25887,7 +25835,7 @@
           <a:solidFill>
             <a:srgbClr val="EDE7F6"/>
           </a:solidFill>
-          <a:ln w="22225">
+          <a:ln w="9525">
             <a:solidFill>
               <a:srgbClr val="5E35B1"/>
             </a:solidFill>
@@ -25895,58 +25843,55 @@
           <a:effectLst/>
         </p:spPr>
         <p:txBody>
-          <a:bodyPr rtlCol="0" anchor="ctr" wrap="square" lIns="36576" tIns="18288" rIns="36576" bIns="18288"/>
-          <a:lstStyle/>
-          <a:p>
-            <a:pPr algn="ctr"/>
-            <a:r>
-              <a:rPr sz="750" b="1">
+          <a:bodyPr rtlCol="0" anchor="ctr" wrap="square" lIns="18288" tIns="0" rIns="18288" bIns="0"/>
+          <a:lstStyle/>
+          <a:p>
+            <a:pPr algn="ctr"/>
+            <a:r>
+              <a:rPr sz="600" b="1">
                 <a:solidFill>
                   <a:srgbClr val="5E35B1"/>
                 </a:solidFill>
                 <a:latin typeface="맑은 고딕"/>
                 <a:ea typeface="맑은 고딕"/>
               </a:rPr>
-              <a:t>«interface» ScoreStrategy</a:t>
-            </a:r>
-          </a:p>
-          <a:p>
-            <a:pPr algn="ctr"/>
-            <a:r>
-              <a:rPr sz="700" b="0">
-                <a:solidFill>
-                  <a:srgbClr val="000000"/>
-                </a:solidFill>
-                <a:latin typeface="맑은 고딕"/>
-                <a:ea typeface="맑은 고딕"/>
-              </a:rPr>
-              <a:t>score(요청, 상태)</a:t>
-            </a:r>
-          </a:p>
-        </p:txBody>
-      </p:sp>
-      <p:cxnSp>
-        <p:nvCxnSpPr>
-          <p:cNvPr id="186" name="Connector 185"/>
-          <p:cNvCxnSpPr/>
-          <p:nvPr/>
-        </p:nvCxnSpPr>
-        <p:spPr>
-          <a:xfrm>
-            <a:off x="9308592" y="2194560"/>
-            <a:ext cx="0" cy="256032"/>
-          </a:xfrm>
-          <a:prstGeom prst="line">
-            <a:avLst/>
-          </a:prstGeom>
-          <a:ln w="19050">
+              <a:t>«Strategy» 점수 정책</a:t>
+            </a:r>
+          </a:p>
+        </p:txBody>
+      </p:sp>
+      <p:sp>
+        <p:nvSpPr>
+          <p:cNvPr id="186" name="Rectangle 185"/>
+          <p:cNvSpPr/>
+          <p:nvPr/>
+        </p:nvSpPr>
+        <p:spPr>
+          <a:xfrm>
+            <a:off x="7333488" y="2679192"/>
+            <a:ext cx="1783080" cy="713232"/>
+          </a:xfrm>
+          <a:prstGeom prst="rect">
+            <a:avLst/>
+          </a:prstGeom>
+          <a:solidFill>
+            <a:srgbClr val="FFFFFF"/>
+          </a:solidFill>
+          <a:ln w="15875">
             <a:solidFill>
               <a:srgbClr val="5E35B1"/>
             </a:solidFill>
-            <a:tailEnd type="triangle"/>
-          </a:ln>
-        </p:spPr>
-      </p:cxnSp>
+          </a:ln>
+          <a:effectLst/>
+        </p:spPr>
+        <p:txBody>
+          <a:bodyPr rtlCol="0" anchor="ctr"/>
+          <a:lstStyle/>
+          <a:p>
+            <a:pPr algn="ctr"/>
+          </a:p>
+        </p:txBody>
+      </p:sp>
       <p:sp>
         <p:nvSpPr>
           <p:cNvPr id="187" name="TextBox 186"/>
@@ -25955,8 +25900,8 @@
         </p:nvSpPr>
         <p:spPr>
           <a:xfrm>
-            <a:off x="9363456" y="2249424"/>
-            <a:ext cx="822960" cy="128016"/>
+            <a:off x="7370064" y="2697480"/>
+            <a:ext cx="1737360" cy="118872"/>
           </a:xfrm>
           <a:prstGeom prst="rect">
             <a:avLst/>
@@ -25978,101 +25923,137 @@
                 <a:latin typeface="맑은 고딕"/>
                 <a:ea typeface="맑은 고딕"/>
               </a:rPr>
-              <a:t>uses</a:t>
-            </a:r>
-          </a:p>
-        </p:txBody>
-      </p:sp>
-      <p:sp>
-        <p:nvSpPr>
-          <p:cNvPr id="188" name="Isosceles Triangle 187"/>
-          <p:cNvSpPr/>
-          <p:nvPr/>
-        </p:nvSpPr>
-        <p:spPr>
-          <a:xfrm>
-            <a:off x="9235440" y="2834640"/>
-            <a:ext cx="146304" cy="128016"/>
-          </a:xfrm>
-          <a:prstGeom prst="triangle">
-            <a:avLst/>
-          </a:prstGeom>
-          <a:solidFill>
-            <a:srgbClr val="FFFFFF"/>
-          </a:solidFill>
-          <a:ln w="15875">
-            <a:solidFill>
-              <a:srgbClr val="5E35B1"/>
-            </a:solidFill>
-          </a:ln>
-          <a:effectLst/>
-        </p:spPr>
-        <p:txBody>
-          <a:bodyPr rtlCol="0" anchor="ctr"/>
-          <a:lstStyle/>
-          <a:p>
-            <a:pPr algn="ctr"/>
-          </a:p>
-        </p:txBody>
-      </p:sp>
-      <p:sp>
-        <p:nvSpPr>
-          <p:cNvPr id="189" name="TextBox 188"/>
-          <p:cNvSpPr txBox="1"/>
-          <p:nvPr/>
-        </p:nvSpPr>
-        <p:spPr>
-          <a:xfrm>
-            <a:off x="9509760" y="2843784"/>
-            <a:ext cx="1097280" cy="128016"/>
-          </a:xfrm>
-          <a:prstGeom prst="rect">
-            <a:avLst/>
-          </a:prstGeom>
-          <a:noFill/>
-        </p:spPr>
-        <p:txBody>
-          <a:bodyPr wrap="square" anchor="t" lIns="0" tIns="0" rIns="0" bIns="0">
-            <a:spAutoFit/>
-          </a:bodyPr>
-          <a:lstStyle/>
-          <a:p>
-            <a:pPr algn="l"/>
-            <a:r>
-              <a:rPr sz="650" b="1">
-                <a:solidFill>
-                  <a:srgbClr val="5E35B1"/>
-                </a:solidFill>
-                <a:latin typeface="맑은 고딕"/>
-                <a:ea typeface="맑은 고딕"/>
-              </a:rPr>
-              <a:t>implements (구현)</a:t>
-            </a:r>
-          </a:p>
-        </p:txBody>
-      </p:sp>
-      <p:cxnSp>
-        <p:nvCxnSpPr>
-          <p:cNvPr id="190" name="Connector 189"/>
-          <p:cNvCxnSpPr/>
-          <p:nvPr/>
-        </p:nvCxnSpPr>
-        <p:spPr>
-          <a:xfrm>
-            <a:off x="8343900" y="3054096"/>
-            <a:ext cx="1956816" cy="0"/>
-          </a:xfrm>
-          <a:prstGeom prst="line">
-            <a:avLst/>
-          </a:prstGeom>
+              <a:t>«interface» ScoreStrategy</a:t>
+            </a:r>
+          </a:p>
+        </p:txBody>
+      </p:sp>
+      <p:sp>
+        <p:nvSpPr>
+          <p:cNvPr id="188" name="Rectangle 187"/>
+          <p:cNvSpPr/>
+          <p:nvPr/>
+        </p:nvSpPr>
+        <p:spPr>
+          <a:xfrm>
+            <a:off x="7388352" y="2834640"/>
+            <a:ext cx="1673352" cy="146304"/>
+          </a:xfrm>
+          <a:prstGeom prst="rect">
+            <a:avLst/>
+          </a:prstGeom>
+          <a:solidFill>
+            <a:srgbClr val="FBE5D6"/>
+          </a:solidFill>
           <a:ln w="12700">
             <a:solidFill>
-              <a:srgbClr val="5E35B1"/>
-            </a:solidFill>
-            <a:prstDash val="dash"/>
-          </a:ln>
-        </p:spPr>
-      </p:cxnSp>
+              <a:srgbClr val="C55A11"/>
+            </a:solidFill>
+          </a:ln>
+          <a:effectLst/>
+        </p:spPr>
+        <p:txBody>
+          <a:bodyPr rtlCol="0" anchor="ctr" wrap="square" lIns="36576" tIns="18288" rIns="36576" bIns="18288"/>
+          <a:lstStyle/>
+          <a:p>
+            <a:pPr algn="ctr"/>
+            <a:r>
+              <a:rPr sz="700" b="0">
+                <a:solidFill>
+                  <a:srgbClr val="000000"/>
+                </a:solidFill>
+                <a:latin typeface="맑은 고딕"/>
+                <a:ea typeface="맑은 고딕"/>
+              </a:rPr>
+              <a:t>P1 TierWeightScorer</a:t>
+            </a:r>
+          </a:p>
+        </p:txBody>
+      </p:sp>
+      <p:sp>
+        <p:nvSpPr>
+          <p:cNvPr id="189" name="Rectangle 188"/>
+          <p:cNvSpPr/>
+          <p:nvPr/>
+        </p:nvSpPr>
+        <p:spPr>
+          <a:xfrm>
+            <a:off x="7388352" y="3008376"/>
+            <a:ext cx="1673352" cy="146304"/>
+          </a:xfrm>
+          <a:prstGeom prst="rect">
+            <a:avLst/>
+          </a:prstGeom>
+          <a:solidFill>
+            <a:srgbClr val="FBE5D6"/>
+          </a:solidFill>
+          <a:ln w="12700">
+            <a:solidFill>
+              <a:srgbClr val="C55A11"/>
+            </a:solidFill>
+          </a:ln>
+          <a:effectLst/>
+        </p:spPr>
+        <p:txBody>
+          <a:bodyPr rtlCol="0" anchor="ctr" wrap="square" lIns="36576" tIns="18288" rIns="36576" bIns="18288"/>
+          <a:lstStyle/>
+          <a:p>
+            <a:pPr algn="ctr"/>
+            <a:r>
+              <a:rPr sz="700" b="0">
+                <a:solidFill>
+                  <a:srgbClr val="000000"/>
+                </a:solidFill>
+                <a:latin typeface="맑은 고딕"/>
+                <a:ea typeface="맑은 고딕"/>
+              </a:rPr>
+              <a:t>P2 LiveStateScorer</a:t>
+            </a:r>
+          </a:p>
+        </p:txBody>
+      </p:sp>
+      <p:sp>
+        <p:nvSpPr>
+          <p:cNvPr id="190" name="Rectangle 189"/>
+          <p:cNvSpPr/>
+          <p:nvPr/>
+        </p:nvSpPr>
+        <p:spPr>
+          <a:xfrm>
+            <a:off x="7388352" y="3182112"/>
+            <a:ext cx="1673352" cy="146304"/>
+          </a:xfrm>
+          <a:prstGeom prst="rect">
+            <a:avLst/>
+          </a:prstGeom>
+          <a:solidFill>
+            <a:srgbClr val="FBE5D6"/>
+          </a:solidFill>
+          <a:ln w="12700">
+            <a:solidFill>
+              <a:srgbClr val="C55A11"/>
+            </a:solidFill>
+          </a:ln>
+          <a:effectLst/>
+        </p:spPr>
+        <p:txBody>
+          <a:bodyPr rtlCol="0" anchor="ctr" wrap="square" lIns="36576" tIns="18288" rIns="36576" bIns="18288"/>
+          <a:lstStyle/>
+          <a:p>
+            <a:pPr algn="ctr"/>
+            <a:r>
+              <a:rPr sz="700" b="0">
+                <a:solidFill>
+                  <a:srgbClr val="000000"/>
+                </a:solidFill>
+                <a:latin typeface="맑은 고딕"/>
+                <a:ea typeface="맑은 고딕"/>
+              </a:rPr>
+              <a:t>P3 CostBasedScorer</a:t>
+            </a:r>
+          </a:p>
+        </p:txBody>
+      </p:sp>
       <p:cxnSp>
         <p:nvCxnSpPr>
           <p:cNvPr id="191" name="Connector 190"/>
@@ -26080,63 +26061,150 @@
           <p:nvPr/>
         </p:nvCxnSpPr>
         <p:spPr>
-          <a:xfrm flipV="1">
-            <a:off x="9308592" y="2962656"/>
-            <a:ext cx="0" cy="91440"/>
+          <a:xfrm>
+            <a:off x="8823960" y="2478024"/>
+            <a:ext cx="0" cy="201168"/>
           </a:xfrm>
           <a:prstGeom prst="line">
             <a:avLst/>
           </a:prstGeom>
+          <a:ln w="15875">
+            <a:solidFill>
+              <a:srgbClr val="5E35B1"/>
+            </a:solidFill>
+            <a:tailEnd type="triangle"/>
+          </a:ln>
+        </p:spPr>
+      </p:cxnSp>
+      <p:sp>
+        <p:nvSpPr>
+          <p:cNvPr id="192" name="Rectangle 191"/>
+          <p:cNvSpPr/>
+          <p:nvPr/>
+        </p:nvSpPr>
+        <p:spPr>
+          <a:xfrm>
+            <a:off x="9217152" y="2523744"/>
+            <a:ext cx="1188720" cy="137160"/>
+          </a:xfrm>
+          <a:prstGeom prst="rect">
+            <a:avLst/>
+          </a:prstGeom>
+          <a:solidFill>
+            <a:srgbClr val="EDE7F6"/>
+          </a:solidFill>
+          <a:ln w="9525">
+            <a:solidFill>
+              <a:srgbClr val="5E35B1"/>
+            </a:solidFill>
+          </a:ln>
+          <a:effectLst/>
+        </p:spPr>
+        <p:txBody>
+          <a:bodyPr rtlCol="0" anchor="ctr" wrap="square" lIns="18288" tIns="0" rIns="18288" bIns="0"/>
+          <a:lstStyle/>
+          <a:p>
+            <a:pPr algn="ctr"/>
+            <a:r>
+              <a:rPr sz="600" b="1">
+                <a:solidFill>
+                  <a:srgbClr val="5E35B1"/>
+                </a:solidFill>
+                <a:latin typeface="맑은 고딕"/>
+                <a:ea typeface="맑은 고딕"/>
+              </a:rPr>
+              <a:t>«Strategy» P/D 정책</a:t>
+            </a:r>
+          </a:p>
+        </p:txBody>
+      </p:sp>
+      <p:sp>
+        <p:nvSpPr>
+          <p:cNvPr id="193" name="Rectangle 192"/>
+          <p:cNvSpPr/>
+          <p:nvPr/>
+        </p:nvSpPr>
+        <p:spPr>
+          <a:xfrm>
+            <a:off x="9217152" y="2679192"/>
+            <a:ext cx="1536192" cy="365760"/>
+          </a:xfrm>
+          <a:prstGeom prst="rect">
+            <a:avLst/>
+          </a:prstGeom>
+          <a:solidFill>
+            <a:srgbClr val="FFFFFF"/>
+          </a:solidFill>
+          <a:ln w="15875">
+            <a:solidFill>
+              <a:srgbClr val="5E35B1"/>
+            </a:solidFill>
+          </a:ln>
+          <a:effectLst/>
+        </p:spPr>
+        <p:txBody>
+          <a:bodyPr rtlCol="0" anchor="ctr"/>
+          <a:lstStyle/>
+          <a:p>
+            <a:pPr algn="ctr"/>
+          </a:p>
+        </p:txBody>
+      </p:sp>
+      <p:sp>
+        <p:nvSpPr>
+          <p:cNvPr id="194" name="TextBox 193"/>
+          <p:cNvSpPr txBox="1"/>
+          <p:nvPr/>
+        </p:nvSpPr>
+        <p:spPr>
+          <a:xfrm>
+            <a:off x="9253728" y="2697480"/>
+            <a:ext cx="1463040" cy="118872"/>
+          </a:xfrm>
+          <a:prstGeom prst="rect">
+            <a:avLst/>
+          </a:prstGeom>
+          <a:noFill/>
+        </p:spPr>
+        <p:txBody>
+          <a:bodyPr wrap="square" anchor="t" lIns="0" tIns="0" rIns="0" bIns="0">
+            <a:spAutoFit/>
+          </a:bodyPr>
+          <a:lstStyle/>
+          <a:p>
+            <a:pPr algn="l"/>
+            <a:r>
+              <a:rPr sz="650" b="1">
+                <a:solidFill>
+                  <a:srgbClr val="5E35B1"/>
+                </a:solidFill>
+                <a:latin typeface="맑은 고딕"/>
+                <a:ea typeface="맑은 고딕"/>
+              </a:rPr>
+              <a:t>«interface» PDPlanStrategy</a:t>
+            </a:r>
+          </a:p>
+        </p:txBody>
+      </p:sp>
+      <p:sp>
+        <p:nvSpPr>
+          <p:cNvPr id="195" name="Rectangle 194"/>
+          <p:cNvSpPr/>
+          <p:nvPr/>
+        </p:nvSpPr>
+        <p:spPr>
+          <a:xfrm>
+            <a:off x="9272016" y="2852928"/>
+            <a:ext cx="1426464" cy="146304"/>
+          </a:xfrm>
+          <a:prstGeom prst="rect">
+            <a:avLst/>
+          </a:prstGeom>
+          <a:solidFill>
+            <a:srgbClr val="FBE5D6"/>
+          </a:solidFill>
           <a:ln w="12700">
             <a:solidFill>
-              <a:srgbClr val="5E35B1"/>
-            </a:solidFill>
-            <a:prstDash val="dash"/>
-            <a:tailEnd type="triangle"/>
-          </a:ln>
-        </p:spPr>
-      </p:cxnSp>
-      <p:cxnSp>
-        <p:nvCxnSpPr>
-          <p:cNvPr id="192" name="Connector 191"/>
-          <p:cNvCxnSpPr/>
-          <p:nvPr/>
-        </p:nvCxnSpPr>
-        <p:spPr>
-          <a:xfrm flipV="1">
-            <a:off x="8343900" y="3054096"/>
-            <a:ext cx="0" cy="109728"/>
-          </a:xfrm>
-          <a:prstGeom prst="line">
-            <a:avLst/>
-          </a:prstGeom>
-          <a:ln w="12700">
-            <a:solidFill>
-              <a:srgbClr val="5E35B1"/>
-            </a:solidFill>
-            <a:prstDash val="dash"/>
-          </a:ln>
-        </p:spPr>
-      </p:cxnSp>
-      <p:sp>
-        <p:nvSpPr>
-          <p:cNvPr id="193" name="Rectangle 192"/>
-          <p:cNvSpPr/>
-          <p:nvPr/>
-        </p:nvSpPr>
-        <p:spPr>
-          <a:xfrm>
-            <a:off x="7909560" y="3163824"/>
-            <a:ext cx="868680" cy="384048"/>
-          </a:xfrm>
-          <a:prstGeom prst="rect">
-            <a:avLst/>
-          </a:prstGeom>
-          <a:solidFill>
-            <a:srgbClr val="FBE5D6"/>
-          </a:solidFill>
-          <a:ln w="19050">
-            <a:solidFill>
               <a:srgbClr val="C55A11"/>
             </a:solidFill>
           </a:ln>
@@ -26148,104 +26216,14 @@
           <a:p>
             <a:pPr algn="ctr"/>
             <a:r>
-              <a:rPr sz="700" b="1">
+              <a:rPr sz="700" b="0">
                 <a:solidFill>
                   <a:srgbClr val="000000"/>
                 </a:solidFill>
                 <a:latin typeface="맑은 고딕"/>
                 <a:ea typeface="맑은 고딕"/>
               </a:rPr>
-              <a:t>P1 TierWeight</a:t>
-            </a:r>
-          </a:p>
-          <a:p>
-            <a:pPr algn="ctr"/>
-            <a:r>
-              <a:rPr sz="650" b="0">
-                <a:solidFill>
-                  <a:srgbClr val="000000"/>
-                </a:solidFill>
-                <a:latin typeface="맑은 고딕"/>
-                <a:ea typeface="맑은 고딕"/>
-              </a:rPr>
-              <a:t>메모리 종류 가중치</a:t>
-            </a:r>
-          </a:p>
-        </p:txBody>
-      </p:sp>
-      <p:cxnSp>
-        <p:nvCxnSpPr>
-          <p:cNvPr id="194" name="Connector 193"/>
-          <p:cNvCxnSpPr/>
-          <p:nvPr/>
-        </p:nvCxnSpPr>
-        <p:spPr>
-          <a:xfrm flipV="1">
-            <a:off x="9322308" y="3054096"/>
-            <a:ext cx="0" cy="109728"/>
-          </a:xfrm>
-          <a:prstGeom prst="line">
-            <a:avLst/>
-          </a:prstGeom>
-          <a:ln w="12700">
-            <a:solidFill>
-              <a:srgbClr val="5E35B1"/>
-            </a:solidFill>
-            <a:prstDash val="dash"/>
-          </a:ln>
-        </p:spPr>
-      </p:cxnSp>
-      <p:sp>
-        <p:nvSpPr>
-          <p:cNvPr id="195" name="Rectangle 194"/>
-          <p:cNvSpPr/>
-          <p:nvPr/>
-        </p:nvSpPr>
-        <p:spPr>
-          <a:xfrm>
-            <a:off x="8887968" y="3163824"/>
-            <a:ext cx="868680" cy="384048"/>
-          </a:xfrm>
-          <a:prstGeom prst="rect">
-            <a:avLst/>
-          </a:prstGeom>
-          <a:solidFill>
-            <a:srgbClr val="FBE5D6"/>
-          </a:solidFill>
-          <a:ln w="19050">
-            <a:solidFill>
-              <a:srgbClr val="C55A11"/>
-            </a:solidFill>
-          </a:ln>
-          <a:effectLst/>
-        </p:spPr>
-        <p:txBody>
-          <a:bodyPr rtlCol="0" anchor="ctr" wrap="square" lIns="36576" tIns="18288" rIns="36576" bIns="18288"/>
-          <a:lstStyle/>
-          <a:p>
-            <a:pPr algn="ctr"/>
-            <a:r>
-              <a:rPr sz="700" b="1">
-                <a:solidFill>
-                  <a:srgbClr val="000000"/>
-                </a:solidFill>
-                <a:latin typeface="맑은 고딕"/>
-                <a:ea typeface="맑은 고딕"/>
-              </a:rPr>
-              <a:t>P2 LiveState</a:t>
-            </a:r>
-          </a:p>
-          <a:p>
-            <a:pPr algn="ctr"/>
-            <a:r>
-              <a:rPr sz="650" b="0">
-                <a:solidFill>
-                  <a:srgbClr val="000000"/>
-                </a:solidFill>
-                <a:latin typeface="맑은 고딕"/>
-                <a:ea typeface="맑은 고딕"/>
-              </a:rPr>
-              <a:t>실시간 상태 반영</a:t>
+              <a:t>P4 CostPDPlanner</a:t>
             </a:r>
           </a:p>
         </p:txBody>
@@ -26257,31 +26235,157 @@
           <p:nvPr/>
         </p:nvCxnSpPr>
         <p:spPr>
-          <a:xfrm flipV="1">
-            <a:off x="10300716" y="3054096"/>
-            <a:ext cx="0" cy="109728"/>
+          <a:xfrm>
+            <a:off x="10104120" y="2478024"/>
+            <a:ext cx="0" cy="201168"/>
           </a:xfrm>
           <a:prstGeom prst="line">
             <a:avLst/>
           </a:prstGeom>
+          <a:ln w="15875">
+            <a:solidFill>
+              <a:srgbClr val="5E35B1"/>
+            </a:solidFill>
+            <a:tailEnd type="triangle"/>
+          </a:ln>
+        </p:spPr>
+      </p:cxnSp>
+      <p:sp>
+        <p:nvSpPr>
+          <p:cNvPr id="197" name="Rectangle 196"/>
+          <p:cNvSpPr/>
+          <p:nvPr/>
+        </p:nvSpPr>
+        <p:spPr>
+          <a:xfrm>
+            <a:off x="9217152" y="3090672"/>
+            <a:ext cx="1371600" cy="137160"/>
+          </a:xfrm>
+          <a:prstGeom prst="rect">
+            <a:avLst/>
+          </a:prstGeom>
+          <a:solidFill>
+            <a:srgbClr val="EDE7F6"/>
+          </a:solidFill>
+          <a:ln w="9525">
+            <a:solidFill>
+              <a:srgbClr val="5E35B1"/>
+            </a:solidFill>
+          </a:ln>
+          <a:effectLst/>
+        </p:spPr>
+        <p:txBody>
+          <a:bodyPr rtlCol="0" anchor="ctr" wrap="square" lIns="18288" tIns="0" rIns="18288" bIns="0"/>
+          <a:lstStyle/>
+          <a:p>
+            <a:pPr algn="ctr"/>
+            <a:r>
+              <a:rPr sz="600" b="1">
+                <a:solidFill>
+                  <a:srgbClr val="5E35B1"/>
+                </a:solidFill>
+                <a:latin typeface="맑은 고딕"/>
+                <a:ea typeface="맑은 고딕"/>
+              </a:rPr>
+              <a:t>«Decorator» 지시 체인 (P5)</a:t>
+            </a:r>
+          </a:p>
+        </p:txBody>
+      </p:sp>
+      <p:sp>
+        <p:nvSpPr>
+          <p:cNvPr id="198" name="Rectangle 197"/>
+          <p:cNvSpPr/>
+          <p:nvPr/>
+        </p:nvSpPr>
+        <p:spPr>
+          <a:xfrm>
+            <a:off x="9217152" y="3236976"/>
+            <a:ext cx="1536192" cy="182880"/>
+          </a:xfrm>
+          <a:prstGeom prst="rect">
+            <a:avLst/>
+          </a:prstGeom>
+          <a:solidFill>
+            <a:srgbClr val="FBE5D6"/>
+          </a:solidFill>
           <a:ln w="12700">
             <a:solidFill>
+              <a:srgbClr val="C55A11"/>
+            </a:solidFill>
+          </a:ln>
+          <a:effectLst/>
+        </p:spPr>
+        <p:txBody>
+          <a:bodyPr rtlCol="0" anchor="ctr" wrap="square" lIns="36576" tIns="18288" rIns="36576" bIns="18288"/>
+          <a:lstStyle/>
+          <a:p>
+            <a:pPr algn="ctr"/>
+            <a:r>
+              <a:rPr sz="650" b="0">
+                <a:solidFill>
+                  <a:srgbClr val="000000"/>
+                </a:solidFill>
+                <a:latin typeface="맑은 고딕"/>
+                <a:ea typeface="맑은 고딕"/>
+              </a:rPr>
+              <a:t>기본 ▸ +계층 ▸ +토큰 한도</a:t>
+            </a:r>
+          </a:p>
+        </p:txBody>
+      </p:sp>
+      <p:sp>
+        <p:nvSpPr>
+          <p:cNvPr id="199" name="Rectangle 198"/>
+          <p:cNvSpPr/>
+          <p:nvPr/>
+        </p:nvSpPr>
+        <p:spPr>
+          <a:xfrm>
+            <a:off x="7333488" y="3493008"/>
+            <a:ext cx="914400" cy="137160"/>
+          </a:xfrm>
+          <a:prstGeom prst="rect">
+            <a:avLst/>
+          </a:prstGeom>
+          <a:solidFill>
+            <a:srgbClr val="EDE7F6"/>
+          </a:solidFill>
+          <a:ln w="9525">
+            <a:solidFill>
               <a:srgbClr val="5E35B1"/>
             </a:solidFill>
-            <a:prstDash val="dash"/>
-          </a:ln>
-        </p:spPr>
-      </p:cxnSp>
-      <p:sp>
-        <p:nvSpPr>
-          <p:cNvPr id="197" name="Rectangle 196"/>
-          <p:cNvSpPr/>
-          <p:nvPr/>
-        </p:nvSpPr>
-        <p:spPr>
-          <a:xfrm>
-            <a:off x="9866376" y="3163824"/>
-            <a:ext cx="868680" cy="384048"/>
+          </a:ln>
+          <a:effectLst/>
+        </p:spPr>
+        <p:txBody>
+          <a:bodyPr rtlCol="0" anchor="ctr" wrap="square" lIns="18288" tIns="0" rIns="18288" bIns="0"/>
+          <a:lstStyle/>
+          <a:p>
+            <a:pPr algn="ctr"/>
+            <a:r>
+              <a:rPr sz="600" b="1">
+                <a:solidFill>
+                  <a:srgbClr val="5E35B1"/>
+                </a:solidFill>
+                <a:latin typeface="맑은 고딕"/>
+                <a:ea typeface="맑은 고딕"/>
+              </a:rPr>
+              <a:t>«Observer» 상태 갱신</a:t>
+            </a:r>
+          </a:p>
+        </p:txBody>
+      </p:sp>
+      <p:sp>
+        <p:nvSpPr>
+          <p:cNvPr id="200" name="Rectangle 199"/>
+          <p:cNvSpPr/>
+          <p:nvPr/>
+        </p:nvSpPr>
+        <p:spPr>
+          <a:xfrm>
+            <a:off x="7333488" y="3657600"/>
+            <a:ext cx="777240" cy="457200"/>
           </a:xfrm>
           <a:prstGeom prst="rect">
             <a:avLst/>
@@ -26309,185 +26413,94 @@
                 <a:latin typeface="맑은 고딕"/>
                 <a:ea typeface="맑은 고딕"/>
               </a:rPr>
-              <a:t>P3 CostBased</a:t>
-            </a:r>
-          </a:p>
-          <a:p>
-            <a:pPr algn="ctr"/>
-            <a:r>
-              <a:rPr sz="650" b="0">
+              <a:t>Event</a:t>
+            </a:r>
+          </a:p>
+          <a:p>
+            <a:pPr algn="ctr"/>
+            <a:r>
+              <a:rPr sz="700" b="1">
                 <a:solidFill>
                   <a:srgbClr val="000000"/>
                 </a:solidFill>
                 <a:latin typeface="맑은 고딕"/>
                 <a:ea typeface="맑은 고딕"/>
               </a:rPr>
-              <a:t>비용 기반 점수</a:t>
-            </a:r>
-          </a:p>
-        </p:txBody>
-      </p:sp>
-      <p:sp>
-        <p:nvSpPr>
-          <p:cNvPr id="198" name="TextBox 197"/>
-          <p:cNvSpPr txBox="1"/>
-          <p:nvPr/>
-        </p:nvSpPr>
-        <p:spPr>
-          <a:xfrm>
-            <a:off x="7406640" y="3584448"/>
-            <a:ext cx="2651760" cy="128016"/>
-          </a:xfrm>
-          <a:prstGeom prst="rect">
-            <a:avLst/>
-          </a:prstGeom>
-          <a:noFill/>
-        </p:spPr>
-        <p:txBody>
-          <a:bodyPr wrap="square" anchor="t" lIns="0" tIns="0" rIns="0" bIns="0">
-            <a:spAutoFit/>
-          </a:bodyPr>
-          <a:lstStyle/>
-          <a:p>
-            <a:pPr algn="l"/>
+              <a:t>Subscriber</a:t>
+            </a:r>
+          </a:p>
+          <a:p>
+            <a:pPr algn="ctr"/>
+            <a:r>
+              <a:rPr sz="600" b="0">
+                <a:solidFill>
+                  <a:srgbClr val="404040"/>
+                </a:solidFill>
+                <a:latin typeface="맑은 고딕"/>
+                <a:ea typeface="맑은 고딕"/>
+              </a:rPr>
+              <a:t>(Subject)</a:t>
+            </a:r>
+          </a:p>
+        </p:txBody>
+      </p:sp>
+      <p:sp>
+        <p:nvSpPr>
+          <p:cNvPr id="201" name="Rectangle 200"/>
+          <p:cNvSpPr/>
+          <p:nvPr/>
+        </p:nvSpPr>
+        <p:spPr>
+          <a:xfrm>
+            <a:off x="8229600" y="3657600"/>
+            <a:ext cx="868680" cy="210312"/>
+          </a:xfrm>
+          <a:prstGeom prst="rect">
+            <a:avLst/>
+          </a:prstGeom>
+          <a:solidFill>
+            <a:srgbClr val="FBE5D6"/>
+          </a:solidFill>
+          <a:ln w="12700">
+            <a:solidFill>
+              <a:srgbClr val="C55A11"/>
+            </a:solidFill>
+          </a:ln>
+          <a:effectLst/>
+        </p:spPr>
+        <p:txBody>
+          <a:bodyPr rtlCol="0" anchor="ctr" wrap="square" lIns="36576" tIns="18288" rIns="36576" bIns="18288"/>
+          <a:lstStyle/>
+          <a:p>
+            <a:pPr algn="ctr"/>
             <a:r>
               <a:rPr sz="650" b="1">
                 <a:solidFill>
-                  <a:srgbClr val="5E35B1"/>
-                </a:solidFill>
-                <a:latin typeface="맑은 고딕"/>
-                <a:ea typeface="맑은 고딕"/>
-              </a:rPr>
-              <a:t>«Strategy» 구현체만 교체 · P4(P/D 판단)도 같은 방식</a:t>
-            </a:r>
-          </a:p>
-        </p:txBody>
-      </p:sp>
-      <p:sp>
-        <p:nvSpPr>
-          <p:cNvPr id="199" name="Rectangle 198"/>
-          <p:cNvSpPr/>
-          <p:nvPr/>
-        </p:nvSpPr>
-        <p:spPr>
-          <a:xfrm>
-            <a:off x="7333488" y="3776472"/>
-            <a:ext cx="1280160" cy="457200"/>
-          </a:xfrm>
-          <a:prstGeom prst="rect">
-            <a:avLst/>
-          </a:prstGeom>
-          <a:solidFill>
-            <a:srgbClr val="FBE5D6"/>
-          </a:solidFill>
-          <a:ln w="19050">
-            <a:solidFill>
-              <a:srgbClr val="C55A11"/>
-            </a:solidFill>
-          </a:ln>
-          <a:effectLst/>
-        </p:spPr>
-        <p:txBody>
-          <a:bodyPr rtlCol="0" anchor="ctr" wrap="square" lIns="36576" tIns="18288" rIns="36576" bIns="18288"/>
-          <a:lstStyle/>
-          <a:p>
-            <a:pPr algn="ctr"/>
-            <a:r>
-              <a:rPr sz="750" b="1">
-                <a:solidFill>
                   <a:srgbClr val="000000"/>
                 </a:solidFill>
                 <a:latin typeface="맑은 고딕"/>
                 <a:ea typeface="맑은 고딕"/>
               </a:rPr>
-              <a:t>F 서버 발견</a:t>
-            </a:r>
-          </a:p>
-          <a:p>
-            <a:pPr algn="ctr"/>
-            <a:r>
-              <a:rPr sz="650" b="0">
-                <a:solidFill>
-                  <a:srgbClr val="000000"/>
-                </a:solidFill>
-                <a:latin typeface="맑은 고딕"/>
-                <a:ea typeface="맑은 고딕"/>
-              </a:rPr>
-              <a:t>etcd watch</a:t>
-            </a:r>
-          </a:p>
-        </p:txBody>
-      </p:sp>
-      <p:sp>
-        <p:nvSpPr>
-          <p:cNvPr id="200" name="Rectangle 199"/>
-          <p:cNvSpPr/>
-          <p:nvPr/>
-        </p:nvSpPr>
-        <p:spPr>
-          <a:xfrm>
-            <a:off x="8778240" y="3776472"/>
-            <a:ext cx="1737360" cy="457200"/>
-          </a:xfrm>
-          <a:prstGeom prst="rect">
-            <a:avLst/>
-          </a:prstGeom>
-          <a:solidFill>
-            <a:srgbClr val="FBE5D6"/>
-          </a:solidFill>
-          <a:ln w="19050">
-            <a:solidFill>
-              <a:srgbClr val="C55A11"/>
-            </a:solidFill>
-          </a:ln>
-          <a:effectLst/>
-        </p:spPr>
-        <p:txBody>
-          <a:bodyPr rtlCol="0" anchor="ctr" wrap="square" lIns="36576" tIns="18288" rIns="36576" bIns="18288"/>
-          <a:lstStyle/>
-          <a:p>
-            <a:pPr algn="ctr"/>
-            <a:r>
-              <a:rPr sz="750" b="1">
-                <a:solidFill>
-                  <a:srgbClr val="000000"/>
-                </a:solidFill>
-                <a:latin typeface="맑은 고딕"/>
-                <a:ea typeface="맑은 고딕"/>
-              </a:rPr>
-              <a:t>C 상태 저장소</a:t>
-            </a:r>
-          </a:p>
-          <a:p>
-            <a:pPr algn="ctr"/>
-            <a:r>
-              <a:rPr sz="650" b="0">
-                <a:solidFill>
-                  <a:srgbClr val="000000"/>
-                </a:solidFill>
-                <a:latin typeface="맑은 고딕"/>
-                <a:ea typeface="맑은 고딕"/>
-              </a:rPr>
-              <a:t>KV index · 메트릭 (정책이 조회)</a:t>
+              <a:t>KV Index 갱신</a:t>
             </a:r>
           </a:p>
         </p:txBody>
       </p:sp>
       <p:cxnSp>
         <p:nvCxnSpPr>
-          <p:cNvPr id="201" name="Connector 200"/>
+          <p:cNvPr id="202" name="Connector 201"/>
           <p:cNvCxnSpPr/>
           <p:nvPr/>
         </p:nvCxnSpPr>
         <p:spPr>
           <a:xfrm flipV="1">
-            <a:off x="10287000" y="3547872"/>
-            <a:ext cx="0" cy="228600"/>
+            <a:off x="8110728" y="3758184"/>
+            <a:ext cx="118872" cy="64007"/>
           </a:xfrm>
           <a:prstGeom prst="line">
             <a:avLst/>
           </a:prstGeom>
-          <a:ln w="15875">
+          <a:ln w="12700">
             <a:solidFill>
               <a:srgbClr val="C55A11"/>
             </a:solidFill>
@@ -26497,56 +26510,56 @@
       </p:cxnSp>
       <p:sp>
         <p:nvSpPr>
-          <p:cNvPr id="202" name="Oval 201"/>
-          <p:cNvSpPr/>
-          <p:nvPr/>
-        </p:nvSpPr>
-        <p:spPr>
-          <a:xfrm>
-            <a:off x="10392155" y="3598163"/>
-            <a:ext cx="155448" cy="155448"/>
-          </a:xfrm>
-          <a:prstGeom prst="ellipse">
-            <a:avLst/>
-          </a:prstGeom>
-          <a:solidFill>
-            <a:srgbClr val="C55A11"/>
-          </a:solidFill>
-          <a:ln w="9525">
-            <a:solidFill>
-              <a:srgbClr val="FFFFFF"/>
-            </a:solidFill>
-          </a:ln>
-          <a:effectLst/>
-        </p:spPr>
-        <p:txBody>
-          <a:bodyPr rtlCol="0" anchor="ctr" wrap="square" lIns="0" tIns="0" rIns="0" bIns="0"/>
+          <p:cNvPr id="203" name="Rectangle 202"/>
+          <p:cNvSpPr/>
+          <p:nvPr/>
+        </p:nvSpPr>
+        <p:spPr>
+          <a:xfrm>
+            <a:off x="8229600" y="3904487"/>
+            <a:ext cx="868680" cy="210312"/>
+          </a:xfrm>
+          <a:prstGeom prst="rect">
+            <a:avLst/>
+          </a:prstGeom>
+          <a:solidFill>
+            <a:srgbClr val="FBE5D6"/>
+          </a:solidFill>
+          <a:ln w="12700">
+            <a:solidFill>
+              <a:srgbClr val="C55A11"/>
+            </a:solidFill>
+          </a:ln>
+          <a:effectLst/>
+        </p:spPr>
+        <p:txBody>
+          <a:bodyPr rtlCol="0" anchor="ctr" wrap="square" lIns="36576" tIns="18288" rIns="36576" bIns="18288"/>
           <a:lstStyle/>
           <a:p>
             <a:pPr algn="ctr"/>
             <a:r>
               <a:rPr sz="650" b="1">
                 <a:solidFill>
-                  <a:srgbClr val="FFFFFF"/>
-                </a:solidFill>
-                <a:latin typeface="맑은 고딕"/>
-                <a:ea typeface="맑은 고딕"/>
-              </a:rPr>
-              <a:t>6</a:t>
+                  <a:srgbClr val="000000"/>
+                </a:solidFill>
+                <a:latin typeface="맑은 고딕"/>
+                <a:ea typeface="맑은 고딕"/>
+              </a:rPr>
+              <a:t>Metrics 스냅샷</a:t>
             </a:r>
           </a:p>
         </p:txBody>
       </p:sp>
       <p:cxnSp>
         <p:nvCxnSpPr>
-          <p:cNvPr id="203" name="Connector 202"/>
+          <p:cNvPr id="204" name="Connector 203"/>
           <p:cNvCxnSpPr/>
           <p:nvPr/>
         </p:nvCxnSpPr>
         <p:spPr>
           <a:xfrm>
-            <a:off x="7150608" y="3547872"/>
-            <a:ext cx="182880" cy="320040"/>
+            <a:off x="8110728" y="3959352"/>
+            <a:ext cx="118872" cy="45720"/>
           </a:xfrm>
           <a:prstGeom prst="line">
             <a:avLst/>
@@ -26555,63 +26568,75 @@
             <a:solidFill>
               <a:srgbClr val="C55A11"/>
             </a:solidFill>
-            <a:prstDash val="dash"/>
             <a:tailEnd type="triangle"/>
           </a:ln>
         </p:spPr>
       </p:cxnSp>
       <p:sp>
         <p:nvSpPr>
-          <p:cNvPr id="204" name="Oval 203"/>
-          <p:cNvSpPr/>
-          <p:nvPr/>
-        </p:nvSpPr>
-        <p:spPr>
-          <a:xfrm>
-            <a:off x="7164324" y="3616452"/>
-            <a:ext cx="155448" cy="155448"/>
-          </a:xfrm>
-          <a:prstGeom prst="ellipse">
-            <a:avLst/>
-          </a:prstGeom>
-          <a:solidFill>
-            <a:srgbClr val="C55A11"/>
-          </a:solidFill>
-          <a:ln w="9525">
-            <a:solidFill>
-              <a:srgbClr val="FFFFFF"/>
-            </a:solidFill>
-          </a:ln>
-          <a:effectLst/>
-        </p:spPr>
-        <p:txBody>
-          <a:bodyPr rtlCol="0" anchor="ctr" wrap="square" lIns="0" tIns="0" rIns="0" bIns="0"/>
-          <a:lstStyle/>
-          <a:p>
-            <a:pPr algn="ctr"/>
-            <a:r>
-              <a:rPr sz="650" b="1">
-                <a:solidFill>
-                  <a:srgbClr val="FFFFFF"/>
-                </a:solidFill>
-                <a:latin typeface="맑은 고딕"/>
-                <a:ea typeface="맑은 고딕"/>
-              </a:rPr>
-              <a:t>7</a:t>
+          <p:cNvPr id="205" name="Rectangle 204"/>
+          <p:cNvSpPr/>
+          <p:nvPr/>
+        </p:nvSpPr>
+        <p:spPr>
+          <a:xfrm>
+            <a:off x="9217152" y="3657600"/>
+            <a:ext cx="731520" cy="457200"/>
+          </a:xfrm>
+          <a:prstGeom prst="rect">
+            <a:avLst/>
+          </a:prstGeom>
+          <a:solidFill>
+            <a:srgbClr val="FBE5D6"/>
+          </a:solidFill>
+          <a:ln w="19050">
+            <a:solidFill>
+              <a:srgbClr val="C55A11"/>
+            </a:solidFill>
+          </a:ln>
+          <a:effectLst/>
+        </p:spPr>
+        <p:txBody>
+          <a:bodyPr rtlCol="0" anchor="ctr" wrap="square" lIns="36576" tIns="18288" rIns="36576" bIns="18288"/>
+          <a:lstStyle/>
+          <a:p>
+            <a:pPr algn="ctr"/>
+            <a:r>
+              <a:rPr sz="700" b="1">
+                <a:solidFill>
+                  <a:srgbClr val="000000"/>
+                </a:solidFill>
+                <a:latin typeface="맑은 고딕"/>
+                <a:ea typeface="맑은 고딕"/>
+              </a:rPr>
+              <a:t>StateView</a:t>
+            </a:r>
+          </a:p>
+          <a:p>
+            <a:pPr algn="ctr"/>
+            <a:r>
+              <a:rPr sz="600" b="0">
+                <a:solidFill>
+                  <a:srgbClr val="404040"/>
+                </a:solidFill>
+                <a:latin typeface="맑은 고딕"/>
+                <a:ea typeface="맑은 고딕"/>
+              </a:rPr>
+              <a:t>읽기 전용 Facade</a:t>
             </a:r>
           </a:p>
         </p:txBody>
       </p:sp>
       <p:cxnSp>
         <p:nvCxnSpPr>
-          <p:cNvPr id="205" name="Connector 204"/>
+          <p:cNvPr id="206" name="Connector 205"/>
           <p:cNvCxnSpPr/>
           <p:nvPr/>
         </p:nvCxnSpPr>
         <p:spPr>
           <a:xfrm>
-            <a:off x="8613648" y="4005072"/>
-            <a:ext cx="164592" cy="0"/>
+            <a:off x="9098280" y="3877056"/>
+            <a:ext cx="118872" cy="0"/>
           </a:xfrm>
           <a:prstGeom prst="line">
             <a:avLst/>
@@ -26620,321 +26645,173 @@
             <a:solidFill>
               <a:srgbClr val="C55A11"/>
             </a:solidFill>
+            <a:tailEnd type="triangle"/>
+          </a:ln>
+        </p:spPr>
+      </p:cxnSp>
+      <p:cxnSp>
+        <p:nvCxnSpPr>
+          <p:cNvPr id="207" name="Connector 206"/>
+          <p:cNvCxnSpPr/>
+          <p:nvPr/>
+        </p:nvCxnSpPr>
+        <p:spPr>
+          <a:xfrm flipH="1" flipV="1">
+            <a:off x="8961120" y="3392424"/>
+            <a:ext cx="548640" cy="265176"/>
+          </a:xfrm>
+          <a:prstGeom prst="line">
+            <a:avLst/>
+          </a:prstGeom>
+          <a:ln w="15875">
+            <a:solidFill>
+              <a:srgbClr val="C55A11"/>
+            </a:solidFill>
+            <a:tailEnd type="triangle"/>
+          </a:ln>
+        </p:spPr>
+      </p:cxnSp>
+      <p:sp>
+        <p:nvSpPr>
+          <p:cNvPr id="208" name="Oval 207"/>
+          <p:cNvSpPr/>
+          <p:nvPr/>
+        </p:nvSpPr>
+        <p:spPr>
+          <a:xfrm>
+            <a:off x="9203436" y="3451860"/>
+            <a:ext cx="155448" cy="155448"/>
+          </a:xfrm>
+          <a:prstGeom prst="ellipse">
+            <a:avLst/>
+          </a:prstGeom>
+          <a:solidFill>
+            <a:srgbClr val="C55A11"/>
+          </a:solidFill>
+          <a:ln w="9525">
+            <a:solidFill>
+              <a:srgbClr val="FFFFFF"/>
+            </a:solidFill>
+          </a:ln>
+          <a:effectLst/>
+        </p:spPr>
+        <p:txBody>
+          <a:bodyPr rtlCol="0" anchor="ctr" wrap="square" lIns="0" tIns="0" rIns="0" bIns="0"/>
+          <a:lstStyle/>
+          <a:p>
+            <a:pPr algn="ctr"/>
+            <a:r>
+              <a:rPr sz="650" b="1">
+                <a:solidFill>
+                  <a:srgbClr val="FFFFFF"/>
+                </a:solidFill>
+                <a:latin typeface="맑은 고딕"/>
+                <a:ea typeface="맑은 고딕"/>
+              </a:rPr>
+              <a:t>6</a:t>
+            </a:r>
+          </a:p>
+        </p:txBody>
+      </p:sp>
+      <p:cxnSp>
+        <p:nvCxnSpPr>
+          <p:cNvPr id="209" name="Connector 208"/>
+          <p:cNvCxnSpPr/>
+          <p:nvPr/>
+        </p:nvCxnSpPr>
+        <p:spPr>
+          <a:xfrm flipV="1">
+            <a:off x="9784080" y="3419856"/>
+            <a:ext cx="0" cy="237744"/>
+          </a:xfrm>
+          <a:prstGeom prst="line">
+            <a:avLst/>
+          </a:prstGeom>
+          <a:ln w="15875">
+            <a:solidFill>
+              <a:srgbClr val="C55A11"/>
+            </a:solidFill>
+            <a:tailEnd type="triangle"/>
+          </a:ln>
+        </p:spPr>
+      </p:cxnSp>
+      <p:sp>
+        <p:nvSpPr>
+          <p:cNvPr id="210" name="Rectangle 209"/>
+          <p:cNvSpPr/>
+          <p:nvPr/>
+        </p:nvSpPr>
+        <p:spPr>
+          <a:xfrm>
+            <a:off x="10021824" y="3657600"/>
+            <a:ext cx="694944" cy="457200"/>
+          </a:xfrm>
+          <a:prstGeom prst="rect">
+            <a:avLst/>
+          </a:prstGeom>
+          <a:solidFill>
+            <a:srgbClr val="FBE5D6"/>
+          </a:solidFill>
+          <a:ln w="19050">
+            <a:solidFill>
+              <a:srgbClr val="C55A11"/>
+            </a:solidFill>
+          </a:ln>
+          <a:effectLst/>
+        </p:spPr>
+        <p:txBody>
+          <a:bodyPr rtlCol="0" anchor="ctr" wrap="square" lIns="36576" tIns="18288" rIns="36576" bIns="18288"/>
+          <a:lstStyle/>
+          <a:p>
+            <a:pPr algn="ctr"/>
+            <a:r>
+              <a:rPr sz="700" b="1">
+                <a:solidFill>
+                  <a:srgbClr val="000000"/>
+                </a:solidFill>
+                <a:latin typeface="맑은 고딕"/>
+                <a:ea typeface="맑은 고딕"/>
+              </a:rPr>
+              <a:t>F Registry</a:t>
+            </a:r>
+          </a:p>
+          <a:p>
+            <a:pPr algn="ctr"/>
+            <a:r>
+              <a:rPr sz="600" b="0">
+                <a:solidFill>
+                  <a:srgbClr val="404040"/>
+                </a:solidFill>
+                <a:latin typeface="맑은 고딕"/>
+                <a:ea typeface="맑은 고딕"/>
+              </a:rPr>
+              <a:t>etcd watch</a:t>
+            </a:r>
+          </a:p>
+        </p:txBody>
+      </p:sp>
+      <p:cxnSp>
+        <p:nvCxnSpPr>
+          <p:cNvPr id="211" name="Connector 210"/>
+          <p:cNvCxnSpPr/>
+          <p:nvPr/>
+        </p:nvCxnSpPr>
+        <p:spPr>
+          <a:xfrm>
+            <a:off x="7150608" y="4165091"/>
+            <a:ext cx="2999232" cy="0"/>
+          </a:xfrm>
+          <a:prstGeom prst="line">
+            <a:avLst/>
+          </a:prstGeom>
+          <a:ln w="12700">
+            <a:solidFill>
+              <a:srgbClr val="C55A11"/>
+            </a:solidFill>
             <a:prstDash val="dash"/>
-            <a:tailEnd type="triangle"/>
           </a:ln>
         </p:spPr>
       </p:cxnSp>
-      <p:sp>
-        <p:nvSpPr>
-          <p:cNvPr id="206" name="Rectangle 205"/>
-          <p:cNvSpPr/>
-          <p:nvPr/>
-        </p:nvSpPr>
-        <p:spPr>
-          <a:xfrm>
-            <a:off x="10954512" y="1536192"/>
-            <a:ext cx="914400" cy="1234440"/>
-          </a:xfrm>
-          <a:prstGeom prst="rect">
-            <a:avLst/>
-          </a:prstGeom>
-          <a:solidFill>
-            <a:srgbClr val="FFFFFF"/>
-          </a:solidFill>
-          <a:ln w="15875">
-            <a:solidFill>
-              <a:srgbClr val="7F7F7F"/>
-            </a:solidFill>
-          </a:ln>
-          <a:effectLst/>
-        </p:spPr>
-        <p:txBody>
-          <a:bodyPr rtlCol="0" anchor="ctr"/>
-          <a:lstStyle/>
-          <a:p>
-            <a:pPr algn="ctr"/>
-          </a:p>
-        </p:txBody>
-      </p:sp>
-      <p:sp>
-        <p:nvSpPr>
-          <p:cNvPr id="207" name="Rectangle 206"/>
-          <p:cNvSpPr/>
-          <p:nvPr/>
-        </p:nvSpPr>
-        <p:spPr>
-          <a:xfrm>
-            <a:off x="10954512" y="1536192"/>
-            <a:ext cx="914400" cy="173736"/>
-          </a:xfrm>
-          <a:prstGeom prst="rect">
-            <a:avLst/>
-          </a:prstGeom>
-          <a:solidFill>
-            <a:srgbClr val="7F7F7F"/>
-          </a:solidFill>
-          <a:ln w="12700">
-            <a:solidFill>
-              <a:srgbClr val="7F7F7F"/>
-            </a:solidFill>
-          </a:ln>
-          <a:effectLst/>
-        </p:spPr>
-        <p:txBody>
-          <a:bodyPr rtlCol="0" anchor="ctr" wrap="square" lIns="45720" tIns="0" rIns="18288" bIns="0"/>
-          <a:lstStyle/>
-          <a:p>
-            <a:pPr algn="l"/>
-            <a:r>
-              <a:rPr sz="800" b="1">
-                <a:solidFill>
-                  <a:srgbClr val="FFFFFF"/>
-                </a:solidFill>
-                <a:latin typeface="맑은 고딕"/>
-                <a:ea typeface="맑은 고딕"/>
-              </a:rPr>
-              <a:t>«pod» vLLM</a:t>
-            </a:r>
-          </a:p>
-        </p:txBody>
-      </p:sp>
-      <p:sp>
-        <p:nvSpPr>
-          <p:cNvPr id="208" name="Rectangle 207"/>
-          <p:cNvSpPr/>
-          <p:nvPr/>
-        </p:nvSpPr>
-        <p:spPr>
-          <a:xfrm>
-            <a:off x="11009376" y="1764792"/>
-            <a:ext cx="804672" cy="941832"/>
-          </a:xfrm>
-          <a:prstGeom prst="rect">
-            <a:avLst/>
-          </a:prstGeom>
-          <a:solidFill>
-            <a:srgbClr val="F2F2F2"/>
-          </a:solidFill>
-          <a:ln w="12700">
-            <a:solidFill>
-              <a:srgbClr val="7F7F7F"/>
-            </a:solidFill>
-          </a:ln>
-          <a:effectLst/>
-        </p:spPr>
-        <p:txBody>
-          <a:bodyPr rtlCol="0" anchor="ctr" wrap="square" lIns="36576" tIns="18288" rIns="36576" bIns="18288"/>
-          <a:lstStyle/>
-          <a:p>
-            <a:pPr algn="ctr"/>
-            <a:r>
-              <a:rPr sz="800" b="1">
-                <a:solidFill>
-                  <a:srgbClr val="000000"/>
-                </a:solidFill>
-                <a:latin typeface="맑은 고딕"/>
-                <a:ea typeface="맑은 고딕"/>
-              </a:rPr>
-              <a:t>vLLM</a:t>
-            </a:r>
-          </a:p>
-          <a:p>
-            <a:pPr algn="ctr"/>
-            <a:r>
-              <a:rPr sz="750" b="0">
-                <a:solidFill>
-                  <a:srgbClr val="000000"/>
-                </a:solidFill>
-                <a:latin typeface="맑은 고딕"/>
-                <a:ea typeface="맑은 고딕"/>
-              </a:rPr>
-              <a:t>prefill</a:t>
-            </a:r>
-          </a:p>
-          <a:p>
-            <a:pPr algn="ctr"/>
-            <a:r>
-              <a:rPr sz="650" b="0">
-                <a:solidFill>
-                  <a:srgbClr val="404040"/>
-                </a:solidFill>
-                <a:latin typeface="맑은 고딕"/>
-                <a:ea typeface="맑은 고딕"/>
-              </a:rPr>
-              <a:t>KV events</a:t>
-            </a:r>
-          </a:p>
-          <a:p>
-            <a:pPr algn="ctr"/>
-            <a:r>
-              <a:rPr sz="650" b="0">
-                <a:solidFill>
-                  <a:srgbClr val="404040"/>
-                </a:solidFill>
-                <a:latin typeface="맑은 고딕"/>
-                <a:ea typeface="맑은 고딕"/>
-              </a:rPr>
-              <a:t>/metrics</a:t>
-            </a:r>
-          </a:p>
-        </p:txBody>
-      </p:sp>
-      <p:sp>
-        <p:nvSpPr>
-          <p:cNvPr id="209" name="Rectangle 208"/>
-          <p:cNvSpPr/>
-          <p:nvPr/>
-        </p:nvSpPr>
-        <p:spPr>
-          <a:xfrm>
-            <a:off x="10954512" y="2999232"/>
-            <a:ext cx="914400" cy="1371600"/>
-          </a:xfrm>
-          <a:prstGeom prst="rect">
-            <a:avLst/>
-          </a:prstGeom>
-          <a:solidFill>
-            <a:srgbClr val="FFFFFF"/>
-          </a:solidFill>
-          <a:ln w="15875">
-            <a:solidFill>
-              <a:srgbClr val="7F7F7F"/>
-            </a:solidFill>
-          </a:ln>
-          <a:effectLst/>
-        </p:spPr>
-        <p:txBody>
-          <a:bodyPr rtlCol="0" anchor="ctr"/>
-          <a:lstStyle/>
-          <a:p>
-            <a:pPr algn="ctr"/>
-          </a:p>
-        </p:txBody>
-      </p:sp>
-      <p:sp>
-        <p:nvSpPr>
-          <p:cNvPr id="210" name="Rectangle 209"/>
-          <p:cNvSpPr/>
-          <p:nvPr/>
-        </p:nvSpPr>
-        <p:spPr>
-          <a:xfrm>
-            <a:off x="10954512" y="2999232"/>
-            <a:ext cx="914400" cy="173736"/>
-          </a:xfrm>
-          <a:prstGeom prst="rect">
-            <a:avLst/>
-          </a:prstGeom>
-          <a:solidFill>
-            <a:srgbClr val="7F7F7F"/>
-          </a:solidFill>
-          <a:ln w="12700">
-            <a:solidFill>
-              <a:srgbClr val="7F7F7F"/>
-            </a:solidFill>
-          </a:ln>
-          <a:effectLst/>
-        </p:spPr>
-        <p:txBody>
-          <a:bodyPr rtlCol="0" anchor="ctr" wrap="square" lIns="45720" tIns="0" rIns="18288" bIns="0"/>
-          <a:lstStyle/>
-          <a:p>
-            <a:pPr algn="l"/>
-            <a:r>
-              <a:rPr sz="800" b="1">
-                <a:solidFill>
-                  <a:srgbClr val="FFFFFF"/>
-                </a:solidFill>
-                <a:latin typeface="맑은 고딕"/>
-                <a:ea typeface="맑은 고딕"/>
-              </a:rPr>
-              <a:t>«pod» vLLM</a:t>
-            </a:r>
-          </a:p>
-        </p:txBody>
-      </p:sp>
-      <p:sp>
-        <p:nvSpPr>
-          <p:cNvPr id="211" name="Rectangle 210"/>
-          <p:cNvSpPr/>
-          <p:nvPr/>
-        </p:nvSpPr>
-        <p:spPr>
-          <a:xfrm>
-            <a:off x="11009376" y="3227832"/>
-            <a:ext cx="804672" cy="1078992"/>
-          </a:xfrm>
-          <a:prstGeom prst="rect">
-            <a:avLst/>
-          </a:prstGeom>
-          <a:solidFill>
-            <a:srgbClr val="F2F2F2"/>
-          </a:solidFill>
-          <a:ln w="12700">
-            <a:solidFill>
-              <a:srgbClr val="7F7F7F"/>
-            </a:solidFill>
-          </a:ln>
-          <a:effectLst/>
-        </p:spPr>
-        <p:txBody>
-          <a:bodyPr rtlCol="0" anchor="ctr" wrap="square" lIns="36576" tIns="18288" rIns="36576" bIns="18288"/>
-          <a:lstStyle/>
-          <a:p>
-            <a:pPr algn="ctr"/>
-            <a:r>
-              <a:rPr sz="800" b="1">
-                <a:solidFill>
-                  <a:srgbClr val="000000"/>
-                </a:solidFill>
-                <a:latin typeface="맑은 고딕"/>
-                <a:ea typeface="맑은 고딕"/>
-              </a:rPr>
-              <a:t>vLLM</a:t>
-            </a:r>
-          </a:p>
-          <a:p>
-            <a:pPr algn="ctr"/>
-            <a:r>
-              <a:rPr sz="750" b="0">
-                <a:solidFill>
-                  <a:srgbClr val="000000"/>
-                </a:solidFill>
-                <a:latin typeface="맑은 고딕"/>
-                <a:ea typeface="맑은 고딕"/>
-              </a:rPr>
-              <a:t>decode</a:t>
-            </a:r>
-          </a:p>
-          <a:p>
-            <a:pPr algn="ctr"/>
-            <a:r>
-              <a:rPr sz="650" b="0">
-                <a:solidFill>
-                  <a:srgbClr val="404040"/>
-                </a:solidFill>
-                <a:latin typeface="맑은 고딕"/>
-                <a:ea typeface="맑은 고딕"/>
-              </a:rPr>
-              <a:t>KV events</a:t>
-            </a:r>
-          </a:p>
-          <a:p>
-            <a:pPr algn="ctr"/>
-            <a:r>
-              <a:rPr sz="650" b="0">
-                <a:solidFill>
-                  <a:srgbClr val="404040"/>
-                </a:solidFill>
-                <a:latin typeface="맑은 고딕"/>
-                <a:ea typeface="맑은 고딕"/>
-              </a:rPr>
-              <a:t>/metrics</a:t>
-            </a:r>
-          </a:p>
-        </p:txBody>
-      </p:sp>
       <p:cxnSp>
         <p:nvCxnSpPr>
           <p:cNvPr id="212" name="Connector 211"/>
@@ -26942,6 +26819,464 @@
           <p:nvPr/>
         </p:nvCxnSpPr>
         <p:spPr>
+          <a:xfrm flipV="1">
+            <a:off x="10149840" y="4114800"/>
+            <a:ext cx="0" cy="50291"/>
+          </a:xfrm>
+          <a:prstGeom prst="line">
+            <a:avLst/>
+          </a:prstGeom>
+          <a:ln w="12700">
+            <a:solidFill>
+              <a:srgbClr val="C55A11"/>
+            </a:solidFill>
+            <a:tailEnd type="triangle"/>
+          </a:ln>
+        </p:spPr>
+      </p:cxnSp>
+      <p:sp>
+        <p:nvSpPr>
+          <p:cNvPr id="213" name="Oval 212"/>
+          <p:cNvSpPr/>
+          <p:nvPr/>
+        </p:nvSpPr>
+        <p:spPr>
+          <a:xfrm>
+            <a:off x="7109460" y="3927348"/>
+            <a:ext cx="155448" cy="155448"/>
+          </a:xfrm>
+          <a:prstGeom prst="ellipse">
+            <a:avLst/>
+          </a:prstGeom>
+          <a:solidFill>
+            <a:srgbClr val="C55A11"/>
+          </a:solidFill>
+          <a:ln w="9525">
+            <a:solidFill>
+              <a:srgbClr val="FFFFFF"/>
+            </a:solidFill>
+          </a:ln>
+          <a:effectLst/>
+        </p:spPr>
+        <p:txBody>
+          <a:bodyPr rtlCol="0" anchor="ctr" wrap="square" lIns="0" tIns="0" rIns="0" bIns="0"/>
+          <a:lstStyle/>
+          <a:p>
+            <a:pPr algn="ctr"/>
+            <a:r>
+              <a:rPr sz="650" b="1">
+                <a:solidFill>
+                  <a:srgbClr val="FFFFFF"/>
+                </a:solidFill>
+                <a:latin typeface="맑은 고딕"/>
+                <a:ea typeface="맑은 고딕"/>
+              </a:rPr>
+              <a:t>7</a:t>
+            </a:r>
+          </a:p>
+        </p:txBody>
+      </p:sp>
+      <p:sp>
+        <p:nvSpPr>
+          <p:cNvPr id="214" name="Rectangle 213"/>
+          <p:cNvSpPr/>
+          <p:nvPr/>
+        </p:nvSpPr>
+        <p:spPr>
+          <a:xfrm>
+            <a:off x="7333488" y="4215384"/>
+            <a:ext cx="822960" cy="137160"/>
+          </a:xfrm>
+          <a:prstGeom prst="rect">
+            <a:avLst/>
+          </a:prstGeom>
+          <a:solidFill>
+            <a:srgbClr val="EDE7F6"/>
+          </a:solidFill>
+          <a:ln w="9525">
+            <a:solidFill>
+              <a:srgbClr val="5E35B1"/>
+            </a:solidFill>
+          </a:ln>
+          <a:effectLst/>
+        </p:spPr>
+        <p:txBody>
+          <a:bodyPr rtlCol="0" anchor="ctr" wrap="square" lIns="18288" tIns="0" rIns="18288" bIns="0"/>
+          <a:lstStyle/>
+          <a:p>
+            <a:pPr algn="ctr"/>
+            <a:r>
+              <a:rPr sz="600" b="1">
+                <a:solidFill>
+                  <a:srgbClr val="5E35B1"/>
+                </a:solidFill>
+                <a:latin typeface="맑은 고딕"/>
+                <a:ea typeface="맑은 고딕"/>
+              </a:rPr>
+              <a:t>«Adapter»</a:t>
+            </a:r>
+          </a:p>
+        </p:txBody>
+      </p:sp>
+      <p:sp>
+        <p:nvSpPr>
+          <p:cNvPr id="215" name="Rectangle 214"/>
+          <p:cNvSpPr/>
+          <p:nvPr/>
+        </p:nvSpPr>
+        <p:spPr>
+          <a:xfrm>
+            <a:off x="8193024" y="4215384"/>
+            <a:ext cx="2523744" cy="137160"/>
+          </a:xfrm>
+          <a:prstGeom prst="rect">
+            <a:avLst/>
+          </a:prstGeom>
+          <a:solidFill>
+            <a:srgbClr val="FFFFFF"/>
+          </a:solidFill>
+          <a:ln w="9525">
+            <a:solidFill>
+              <a:srgbClr val="5E35B1"/>
+            </a:solidFill>
+          </a:ln>
+          <a:effectLst/>
+        </p:spPr>
+        <p:txBody>
+          <a:bodyPr rtlCol="0" anchor="ctr" wrap="square" lIns="18288" tIns="0" rIns="18288" bIns="0"/>
+          <a:lstStyle/>
+          <a:p>
+            <a:pPr algn="ctr"/>
+            <a:r>
+              <a:rPr sz="600" b="1">
+                <a:solidFill>
+                  <a:srgbClr val="5E35B1"/>
+                </a:solidFill>
+                <a:latin typeface="맑은 고딕"/>
+                <a:ea typeface="맑은 고딕"/>
+              </a:rPr>
+              <a:t>vLLM 계약 어댑터: KV 이벤트 · /metrics · kv_transfer_params</a:t>
+            </a:r>
+          </a:p>
+        </p:txBody>
+      </p:sp>
+      <p:sp>
+        <p:nvSpPr>
+          <p:cNvPr id="216" name="Rectangle 215"/>
+          <p:cNvSpPr/>
+          <p:nvPr/>
+        </p:nvSpPr>
+        <p:spPr>
+          <a:xfrm>
+            <a:off x="10954512" y="1536192"/>
+            <a:ext cx="914400" cy="1234440"/>
+          </a:xfrm>
+          <a:prstGeom prst="rect">
+            <a:avLst/>
+          </a:prstGeom>
+          <a:solidFill>
+            <a:srgbClr val="FFFFFF"/>
+          </a:solidFill>
+          <a:ln w="15875">
+            <a:solidFill>
+              <a:srgbClr val="7F7F7F"/>
+            </a:solidFill>
+          </a:ln>
+          <a:effectLst/>
+        </p:spPr>
+        <p:txBody>
+          <a:bodyPr rtlCol="0" anchor="ctr"/>
+          <a:lstStyle/>
+          <a:p>
+            <a:pPr algn="ctr"/>
+          </a:p>
+        </p:txBody>
+      </p:sp>
+      <p:sp>
+        <p:nvSpPr>
+          <p:cNvPr id="217" name="Rectangle 216"/>
+          <p:cNvSpPr/>
+          <p:nvPr/>
+        </p:nvSpPr>
+        <p:spPr>
+          <a:xfrm>
+            <a:off x="10954512" y="1536192"/>
+            <a:ext cx="914400" cy="173736"/>
+          </a:xfrm>
+          <a:prstGeom prst="rect">
+            <a:avLst/>
+          </a:prstGeom>
+          <a:solidFill>
+            <a:srgbClr val="7F7F7F"/>
+          </a:solidFill>
+          <a:ln w="12700">
+            <a:solidFill>
+              <a:srgbClr val="7F7F7F"/>
+            </a:solidFill>
+          </a:ln>
+          <a:effectLst/>
+        </p:spPr>
+        <p:txBody>
+          <a:bodyPr rtlCol="0" anchor="ctr" wrap="square" lIns="45720" tIns="0" rIns="18288" bIns="0"/>
+          <a:lstStyle/>
+          <a:p>
+            <a:pPr algn="l"/>
+            <a:r>
+              <a:rPr sz="800" b="1">
+                <a:solidFill>
+                  <a:srgbClr val="FFFFFF"/>
+                </a:solidFill>
+                <a:latin typeface="맑은 고딕"/>
+                <a:ea typeface="맑은 고딕"/>
+              </a:rPr>
+              <a:t>«pod» vLLM</a:t>
+            </a:r>
+          </a:p>
+        </p:txBody>
+      </p:sp>
+      <p:sp>
+        <p:nvSpPr>
+          <p:cNvPr id="218" name="Rectangle 217"/>
+          <p:cNvSpPr/>
+          <p:nvPr/>
+        </p:nvSpPr>
+        <p:spPr>
+          <a:xfrm>
+            <a:off x="11009376" y="1764792"/>
+            <a:ext cx="804672" cy="941832"/>
+          </a:xfrm>
+          <a:prstGeom prst="rect">
+            <a:avLst/>
+          </a:prstGeom>
+          <a:solidFill>
+            <a:srgbClr val="F2F2F2"/>
+          </a:solidFill>
+          <a:ln w="12700">
+            <a:solidFill>
+              <a:srgbClr val="7F7F7F"/>
+            </a:solidFill>
+          </a:ln>
+          <a:effectLst/>
+        </p:spPr>
+        <p:txBody>
+          <a:bodyPr rtlCol="0" anchor="ctr" wrap="square" lIns="36576" tIns="18288" rIns="36576" bIns="18288"/>
+          <a:lstStyle/>
+          <a:p>
+            <a:pPr algn="ctr"/>
+            <a:r>
+              <a:rPr sz="800" b="1">
+                <a:solidFill>
+                  <a:srgbClr val="000000"/>
+                </a:solidFill>
+                <a:latin typeface="맑은 고딕"/>
+                <a:ea typeface="맑은 고딕"/>
+              </a:rPr>
+              <a:t>vLLM</a:t>
+            </a:r>
+          </a:p>
+          <a:p>
+            <a:pPr algn="ctr"/>
+            <a:r>
+              <a:rPr sz="750" b="0">
+                <a:solidFill>
+                  <a:srgbClr val="000000"/>
+                </a:solidFill>
+                <a:latin typeface="맑은 고딕"/>
+                <a:ea typeface="맑은 고딕"/>
+              </a:rPr>
+              <a:t>prefill</a:t>
+            </a:r>
+          </a:p>
+          <a:p>
+            <a:pPr algn="ctr"/>
+            <a:r>
+              <a:rPr sz="650" b="0">
+                <a:solidFill>
+                  <a:srgbClr val="404040"/>
+                </a:solidFill>
+                <a:latin typeface="맑은 고딕"/>
+                <a:ea typeface="맑은 고딕"/>
+              </a:rPr>
+              <a:t>KV events</a:t>
+            </a:r>
+          </a:p>
+          <a:p>
+            <a:pPr algn="ctr"/>
+            <a:r>
+              <a:rPr sz="650" b="0">
+                <a:solidFill>
+                  <a:srgbClr val="404040"/>
+                </a:solidFill>
+                <a:latin typeface="맑은 고딕"/>
+                <a:ea typeface="맑은 고딕"/>
+              </a:rPr>
+              <a:t>/metrics</a:t>
+            </a:r>
+          </a:p>
+        </p:txBody>
+      </p:sp>
+      <p:sp>
+        <p:nvSpPr>
+          <p:cNvPr id="219" name="Rectangle 218"/>
+          <p:cNvSpPr/>
+          <p:nvPr/>
+        </p:nvSpPr>
+        <p:spPr>
+          <a:xfrm>
+            <a:off x="10954512" y="2999232"/>
+            <a:ext cx="914400" cy="1371600"/>
+          </a:xfrm>
+          <a:prstGeom prst="rect">
+            <a:avLst/>
+          </a:prstGeom>
+          <a:solidFill>
+            <a:srgbClr val="FFFFFF"/>
+          </a:solidFill>
+          <a:ln w="15875">
+            <a:solidFill>
+              <a:srgbClr val="7F7F7F"/>
+            </a:solidFill>
+          </a:ln>
+          <a:effectLst/>
+        </p:spPr>
+        <p:txBody>
+          <a:bodyPr rtlCol="0" anchor="ctr"/>
+          <a:lstStyle/>
+          <a:p>
+            <a:pPr algn="ctr"/>
+          </a:p>
+        </p:txBody>
+      </p:sp>
+      <p:sp>
+        <p:nvSpPr>
+          <p:cNvPr id="220" name="Rectangle 219"/>
+          <p:cNvSpPr/>
+          <p:nvPr/>
+        </p:nvSpPr>
+        <p:spPr>
+          <a:xfrm>
+            <a:off x="10954512" y="2999232"/>
+            <a:ext cx="914400" cy="173736"/>
+          </a:xfrm>
+          <a:prstGeom prst="rect">
+            <a:avLst/>
+          </a:prstGeom>
+          <a:solidFill>
+            <a:srgbClr val="7F7F7F"/>
+          </a:solidFill>
+          <a:ln w="12700">
+            <a:solidFill>
+              <a:srgbClr val="7F7F7F"/>
+            </a:solidFill>
+          </a:ln>
+          <a:effectLst/>
+        </p:spPr>
+        <p:txBody>
+          <a:bodyPr rtlCol="0" anchor="ctr" wrap="square" lIns="45720" tIns="0" rIns="18288" bIns="0"/>
+          <a:lstStyle/>
+          <a:p>
+            <a:pPr algn="l"/>
+            <a:r>
+              <a:rPr sz="800" b="1">
+                <a:solidFill>
+                  <a:srgbClr val="FFFFFF"/>
+                </a:solidFill>
+                <a:latin typeface="맑은 고딕"/>
+                <a:ea typeface="맑은 고딕"/>
+              </a:rPr>
+              <a:t>«pod» vLLM</a:t>
+            </a:r>
+          </a:p>
+        </p:txBody>
+      </p:sp>
+      <p:sp>
+        <p:nvSpPr>
+          <p:cNvPr id="221" name="Rectangle 220"/>
+          <p:cNvSpPr/>
+          <p:nvPr/>
+        </p:nvSpPr>
+        <p:spPr>
+          <a:xfrm>
+            <a:off x="11009376" y="3227832"/>
+            <a:ext cx="804672" cy="1078992"/>
+          </a:xfrm>
+          <a:prstGeom prst="rect">
+            <a:avLst/>
+          </a:prstGeom>
+          <a:solidFill>
+            <a:srgbClr val="F2F2F2"/>
+          </a:solidFill>
+          <a:ln w="12700">
+            <a:solidFill>
+              <a:srgbClr val="7F7F7F"/>
+            </a:solidFill>
+          </a:ln>
+          <a:effectLst/>
+        </p:spPr>
+        <p:txBody>
+          <a:bodyPr rtlCol="0" anchor="ctr" wrap="square" lIns="36576" tIns="18288" rIns="36576" bIns="18288"/>
+          <a:lstStyle/>
+          <a:p>
+            <a:pPr algn="ctr"/>
+            <a:r>
+              <a:rPr sz="800" b="1">
+                <a:solidFill>
+                  <a:srgbClr val="000000"/>
+                </a:solidFill>
+                <a:latin typeface="맑은 고딕"/>
+                <a:ea typeface="맑은 고딕"/>
+              </a:rPr>
+              <a:t>vLLM</a:t>
+            </a:r>
+          </a:p>
+          <a:p>
+            <a:pPr algn="ctr"/>
+            <a:r>
+              <a:rPr sz="750" b="0">
+                <a:solidFill>
+                  <a:srgbClr val="000000"/>
+                </a:solidFill>
+                <a:latin typeface="맑은 고딕"/>
+                <a:ea typeface="맑은 고딕"/>
+              </a:rPr>
+              <a:t>decode</a:t>
+            </a:r>
+          </a:p>
+          <a:p>
+            <a:pPr algn="ctr"/>
+            <a:r>
+              <a:rPr sz="650" b="0">
+                <a:solidFill>
+                  <a:srgbClr val="404040"/>
+                </a:solidFill>
+                <a:latin typeface="맑은 고딕"/>
+                <a:ea typeface="맑은 고딕"/>
+              </a:rPr>
+              <a:t>KV events</a:t>
+            </a:r>
+          </a:p>
+          <a:p>
+            <a:pPr algn="ctr"/>
+            <a:r>
+              <a:rPr sz="650" b="0">
+                <a:solidFill>
+                  <a:srgbClr val="404040"/>
+                </a:solidFill>
+                <a:latin typeface="맑은 고딕"/>
+                <a:ea typeface="맑은 고딕"/>
+              </a:rPr>
+              <a:t>/metrics</a:t>
+            </a:r>
+          </a:p>
+        </p:txBody>
+      </p:sp>
+      <p:cxnSp>
+        <p:nvCxnSpPr>
+          <p:cNvPr id="222" name="Connector 221"/>
+          <p:cNvCxnSpPr/>
+          <p:nvPr/>
+        </p:nvCxnSpPr>
+        <p:spPr>
           <a:xfrm>
             <a:off x="11411712" y="2770632"/>
             <a:ext cx="0" cy="457200"/>
@@ -26960,7 +27295,7 @@
       </p:cxnSp>
       <p:sp>
         <p:nvSpPr>
-          <p:cNvPr id="213" name="Oval 212"/>
+          <p:cNvPr id="223" name="Oval 222"/>
           <p:cNvSpPr/>
           <p:nvPr/>
         </p:nvSpPr>
@@ -27002,14 +27337,14 @@
       </p:sp>
       <p:cxnSp>
         <p:nvCxnSpPr>
-          <p:cNvPr id="214" name="Connector 213"/>
+          <p:cNvPr id="224" name="Connector 223"/>
           <p:cNvCxnSpPr/>
           <p:nvPr/>
         </p:nvCxnSpPr>
         <p:spPr>
-          <a:xfrm>
-            <a:off x="10643616" y="2002536"/>
-            <a:ext cx="365760" cy="173736"/>
+          <a:xfrm flipV="1">
+            <a:off x="10716767" y="2194560"/>
+            <a:ext cx="292609" cy="164592"/>
           </a:xfrm>
           <a:prstGeom prst="line">
             <a:avLst/>
@@ -27024,13 +27359,13 @@
       </p:cxnSp>
       <p:sp>
         <p:nvSpPr>
-          <p:cNvPr id="215" name="Oval 214"/>
-          <p:cNvSpPr/>
-          <p:nvPr/>
-        </p:nvSpPr>
-        <p:spPr>
-          <a:xfrm>
-            <a:off x="10730484" y="1851660"/>
+          <p:cNvPr id="225" name="Oval 224"/>
+          <p:cNvSpPr/>
+          <p:nvPr/>
+        </p:nvSpPr>
+        <p:spPr>
+          <a:xfrm>
+            <a:off x="10785347" y="2025396"/>
             <a:ext cx="155448" cy="155448"/>
           </a:xfrm>
           <a:prstGeom prst="ellipse">
@@ -27066,41 +27401,19 @@
       </p:sp>
       <p:cxnSp>
         <p:nvCxnSpPr>
-          <p:cNvPr id="216" name="Connector 215"/>
+          <p:cNvPr id="226" name="Connector 225"/>
           <p:cNvCxnSpPr/>
           <p:nvPr/>
         </p:nvCxnSpPr>
         <p:spPr>
           <a:xfrm flipH="1">
-            <a:off x="9646920" y="4315968"/>
-            <a:ext cx="1362456" cy="0"/>
+            <a:off x="10716767" y="3822191"/>
+            <a:ext cx="292609" cy="0"/>
           </a:xfrm>
           <a:prstGeom prst="line">
             <a:avLst/>
           </a:prstGeom>
-          <a:ln w="12700">
-            <a:solidFill>
-              <a:srgbClr val="404040"/>
-            </a:solidFill>
-            <a:prstDash val="dash"/>
-          </a:ln>
-        </p:spPr>
-      </p:cxnSp>
-      <p:cxnSp>
-        <p:nvCxnSpPr>
-          <p:cNvPr id="217" name="Connector 216"/>
-          <p:cNvCxnSpPr/>
-          <p:nvPr/>
-        </p:nvCxnSpPr>
-        <p:spPr>
-          <a:xfrm flipV="1">
-            <a:off x="9646920" y="4233672"/>
-            <a:ext cx="0" cy="82296"/>
-          </a:xfrm>
-          <a:prstGeom prst="line">
-            <a:avLst/>
-          </a:prstGeom>
-          <a:ln w="12700">
+          <a:ln w="15875">
             <a:solidFill>
               <a:srgbClr val="404040"/>
             </a:solidFill>
@@ -27111,13 +27424,13 @@
       </p:cxnSp>
       <p:sp>
         <p:nvSpPr>
-          <p:cNvPr id="218" name="Oval 217"/>
-          <p:cNvSpPr/>
-          <p:nvPr/>
-        </p:nvSpPr>
-        <p:spPr>
-          <a:xfrm>
-            <a:off x="10730484" y="4110228"/>
+          <p:cNvPr id="227" name="Oval 226"/>
+          <p:cNvSpPr/>
+          <p:nvPr/>
+        </p:nvSpPr>
+        <p:spPr>
+          <a:xfrm>
+            <a:off x="10785347" y="3598163"/>
             <a:ext cx="155448" cy="155448"/>
           </a:xfrm>
           <a:prstGeom prst="ellipse">
@@ -27153,7 +27466,7 @@
       </p:sp>
       <p:sp>
         <p:nvSpPr>
-          <p:cNvPr id="219" name="Rectangle 218"/>
+          <p:cNvPr id="228" name="Rectangle 227"/>
           <p:cNvSpPr/>
           <p:nvPr/>
         </p:nvSpPr>
@@ -27195,7 +27508,7 @@
       </p:sp>
       <p:sp>
         <p:nvSpPr>
-          <p:cNvPr id="220" name="Rectangle 219"/>
+          <p:cNvPr id="229" name="Rectangle 228"/>
           <p:cNvSpPr/>
           <p:nvPr/>
         </p:nvSpPr>
@@ -27237,7 +27550,7 @@
       </p:sp>
       <p:sp>
         <p:nvSpPr>
-          <p:cNvPr id="221" name="Rectangle 220"/>
+          <p:cNvPr id="230" name="Rectangle 229"/>
           <p:cNvSpPr/>
           <p:nvPr/>
         </p:nvSpPr>
@@ -27280,7 +27593,7 @@
       </p:sp>
       <p:sp>
         <p:nvSpPr>
-          <p:cNvPr id="222" name="Rectangle 221"/>
+          <p:cNvPr id="231" name="Rectangle 230"/>
           <p:cNvSpPr/>
           <p:nvPr/>
         </p:nvSpPr>
@@ -27322,7 +27635,7 @@
       </p:sp>
       <p:sp>
         <p:nvSpPr>
-          <p:cNvPr id="223" name="Rectangle 222"/>
+          <p:cNvPr id="232" name="Rectangle 231"/>
           <p:cNvSpPr/>
           <p:nvPr/>
         </p:nvSpPr>
@@ -27364,7 +27677,7 @@
       </p:sp>
       <p:sp>
         <p:nvSpPr>
-          <p:cNvPr id="224" name="Rectangle 223"/>
+          <p:cNvPr id="233" name="Rectangle 232"/>
           <p:cNvSpPr/>
           <p:nvPr/>
         </p:nvSpPr>
@@ -27399,14 +27712,14 @@
                 <a:latin typeface="맑은 고딕"/>
                 <a:ea typeface="맑은 고딕"/>
               </a:rPr>
-              <a:t>디자인 패턴: Strategy (uses ▸ interface ◂ △ implements)</a:t>
-            </a:r>
-          </a:p>
-        </p:txBody>
-      </p:sp>
-      <p:sp>
-        <p:nvSpPr>
-          <p:cNvPr id="225" name="Rectangle 224"/>
+              <a:t>디자인 패턴 (Chain·Strategy·Decorator·Observer·Adapter)</a:t>
+            </a:r>
+          </a:p>
+        </p:txBody>
+      </p:sp>
+      <p:sp>
+        <p:nvSpPr>
+          <p:cNvPr id="234" name="Rectangle 233"/>
           <p:cNvSpPr/>
           <p:nvPr/>
         </p:nvSpPr>
@@ -27448,7 +27761,7 @@
       </p:sp>
       <p:sp>
         <p:nvSpPr>
-          <p:cNvPr id="226" name="TextBox 225"/>
+          <p:cNvPr id="235" name="TextBox 234"/>
           <p:cNvSpPr txBox="1"/>
           <p:nvPr/>
         </p:nvSpPr>
@@ -27484,7 +27797,7 @@
       </p:sp>
       <p:sp>
         <p:nvSpPr>
-          <p:cNvPr id="227" name="Rectangle 226"/>
+          <p:cNvPr id="236" name="Rectangle 235"/>
           <p:cNvSpPr/>
           <p:nvPr/>
         </p:nvSpPr>
@@ -27526,7 +27839,7 @@
       </p:sp>
       <p:sp>
         <p:nvSpPr>
-          <p:cNvPr id="228" name="Rectangle 227"/>
+          <p:cNvPr id="237" name="Rectangle 236"/>
           <p:cNvSpPr/>
           <p:nvPr/>
         </p:nvSpPr>
@@ -27594,7 +27907,7 @@
       </p:sp>
       <p:sp>
         <p:nvSpPr>
-          <p:cNvPr id="229" name="Rectangle 228"/>
+          <p:cNvPr id="238" name="Rectangle 237"/>
           <p:cNvSpPr/>
           <p:nvPr/>
         </p:nvSpPr>
@@ -27642,7 +27955,7 @@
                 <a:latin typeface="맑은 고딕"/>
                 <a:ea typeface="맑은 고딕"/>
               </a:rPr>
-              <a:t>▪ Strategy 패턴: 점수·비용 함수·P/D 정책을 구현체 교체로 변경, 파이프라인은 불변</a:t>
+              <a:t>▪ Strategy·Decorator로 정책·지시를 갈아 끼움: 비용 함수·P/D 정책·노드 지시를 한 코드베이스에서 변경</a:t>
             </a:r>
           </a:p>
           <a:p>
@@ -27655,14 +27968,14 @@
                 <a:latin typeface="맑은 고딕"/>
                 <a:ea typeface="맑은 고딕"/>
               </a:rPr>
-              <a:t>▪ K8s·프록시 불필요, OSS 업스트림 의존 없음</a:t>
-            </a:r>
-          </a:p>
-        </p:txBody>
-      </p:sp>
-      <p:sp>
-        <p:nvSpPr>
-          <p:cNvPr id="230" name="Rectangle 229"/>
+              <a:t>▪ Adapter로 vLLM 계약 변경을 격리, K8s·프록시 불필요</a:t>
+            </a:r>
+          </a:p>
+        </p:txBody>
+      </p:sp>
+      <p:sp>
+        <p:nvSpPr>
+          <p:cNvPr id="239" name="Rectangle 238"/>
           <p:cNvSpPr/>
           <p:nvPr/>
         </p:nvSpPr>
@@ -27704,7 +28017,7 @@
       </p:sp>
       <p:sp>
         <p:nvSpPr>
-          <p:cNvPr id="231" name="Rectangle 230"/>
+          <p:cNvPr id="240" name="Rectangle 239"/>
           <p:cNvSpPr/>
           <p:nvPr/>
         </p:nvSpPr>
@@ -27772,7 +28085,7 @@
       </p:sp>
       <p:sp>
         <p:nvSpPr>
-          <p:cNvPr id="232" name="Rectangle 231"/>
+          <p:cNvPr id="241" name="Rectangle 240"/>
           <p:cNvSpPr/>
           <p:nvPr/>
         </p:nvSpPr>
@@ -27820,7 +28133,7 @@
                 <a:latin typeface="맑은 고딕"/>
                 <a:ea typeface="맑은 고딕"/>
               </a:rPr>
-              <a:t>▪ vLLM·NIXL 계약 추종·신기능 구현은 전부 우리 몫</a:t>
+              <a:t>▪ vLLM·NIXL 계약 추종·신기능은 우리 몫 (Adapter는 격리일 뿐 대신해 주지 않음)</a:t>
             </a:r>
           </a:p>
           <a:p>
@@ -27840,7 +28153,7 @@
       </p:sp>
       <p:sp>
         <p:nvSpPr>
-          <p:cNvPr id="233" name="TextBox 232"/>
+          <p:cNvPr id="242" name="TextBox 241"/>
           <p:cNvSpPr txBox="1"/>
           <p:nvPr/>
         </p:nvSpPr>
@@ -27876,7 +28189,7 @@
       </p:sp>
       <p:sp>
         <p:nvSpPr>
-          <p:cNvPr id="234" name="TextBox 233"/>
+          <p:cNvPr id="243" name="TextBox 242"/>
           <p:cNvSpPr txBox="1"/>
           <p:nvPr/>
         </p:nvSpPr>
@@ -27905,7 +28218,7 @@
                 <a:latin typeface="맑은 고딕"/>
                 <a:ea typeface="맑은 고딕"/>
               </a:rPr>
-              <a:t>※ ★P5 = 지시의 '송신'(오케스트레이션 범위). 수신·실행은 vLLM(엔진) 공통 선결(C5 접점 계약). P/D 보조 프로세스는 엔진이 아니라 오케스트레이션 소프트웨어다. 디자인 패턴: Strategy = Selector(Context)가 인터페이스를 참조(uses)하고 정책 구현체(P1~P3, P/D 판단 P4)가 이를 구현(implements, △)해 설정으로 교체. 박스는 프로세스가 아니라 한 프로세스 안의 모듈이고, 프로세스 경계는 굵은 바깥 박스.</a:t>
+              <a:t>※ ★P5 = 지시의 '송신'(오케스트레이션 범위). 수신·실행은 vLLM(엔진) 공통 선결(C5 접점 계약). P/D 보조 프로세스는 엔진이 아니라 오케스트레이션 소프트웨어다. 디자인 패턴: Chain of Responsibility(파이프라인), Strategy(정책 교체), Decorator(지시 조립), Observer(상태 갱신), Adapter(엔진 계약 격리). 박스는 프로세스가 아니라 한 프로세스 안의 모듈이고, 프로세스 경계는 굵은 바깥 박스.</a:t>
             </a:r>
           </a:p>
         </p:txBody>

</xml_diff>

<commit_message>
DP0: limit Own Router design patterns to 3 tied to Option-1 problems; update deck and doc
Co-Authored-By: Claude Sonnet 5.5 <noreply@anthropic.com>
Claude-Session: https://claude.ai/code/session_014XKnsGjraFTY3Q8v5o1PT9
</commit_message>
<xml_diff>
--- a/doc-mk/DP0/DP0-slides-v2.pptx
+++ b/doc-mk/DP0/DP0-slides-v2.pptx
@@ -790,7 +790,7 @@
           </a:p>
           <a:p>
             <a:r>
-              <a:t>2안(오른쪽)은 전부 우리가 소유하는 계층형 구조입니다. 한 프로세스 안에 Ingress, Pipeline(Admission → PolicyEngine → P/D 조율), State Plane(상태 저장소, 이벤트 구독, 메트릭 수집, 서버 등록)을 나눴고, 정책은 디자인 패턴으로 갈아 끼웁니다. 요청 경로는 Chain of Responsibility(파이프라인), 점수·P/D 정책은 Strategy(P1~P3 Scorer, P4 Planner), 노드 지시는 Decorator(P5), 상태 갱신은 Observer, vLLM 계약은 Adapter로 격리하고, 상태는 읽기 전용 StateView(Facade)로만 읽습니다. 이전 안은 단일 프로세스·정적 설정의 최소 구성이어서 확장성이 일방적으로 약했는데, 이번에는 상태를 공유하지 않는 레플리카 여러 개를 L4 로드밸런서 뒤에 두고 etcd로 서버를 등록하는 구성으로 같은 노력 수준에서 비교합니다. 구현은 되어 있지 않은 설계안입니다.</a:t>
+              <a:t>2안(오른쪽)은 전부 우리가 소유하는 계층형 구조입니다. 한 프로세스 안에 Ingress, Pipeline(Admission → PolicyEngine → P/D 조율), State Plane(상태 저장소, 이벤트 구독, 메트릭 수집, 서버 등록)을 나눴고, 정책은 세 가지 패턴으로 갈아 끼웁니다. 각각 1안의 문제와 연결됩니다. Strategy는 점수·P/D 정책을 구현체 교체로 바꾸게 해서 1안의 plugin 역할을 합니다. Decorator는 노드 지시(P5)를 한 겹씩 덧붙여서 1안에서 보조 프로세스가 지시를 덮어쓰던 문제를 없앱니다. Adapter는 vLLM 계약을 한곳에 가둬서 1안에서 우리 확장이 OSS 내부 동작에 기대던 문제를 줄입니다. 이전 안은 단일 프로세스·정적 설정의 최소 구성이어서 확장성이 일방적으로 약했는데, 이번에는 상태를 공유하지 않는 레플리카 여러 개를 L4 로드밸런서 뒤에 두고 etcd로 서버를 등록하는 구성으로 같은 노력 수준에서 비교합니다. 구현은 되어 있지 않은 설계안입니다.</a:t>
             </a:r>
           </a:p>
           <a:p>
@@ -25550,48 +25550,6 @@
         </p:nvSpPr>
         <p:spPr>
           <a:xfrm>
-            <a:off x="7955279" y="2084832"/>
-            <a:ext cx="1691640" cy="137160"/>
-          </a:xfrm>
-          <a:prstGeom prst="rect">
-            <a:avLst/>
-          </a:prstGeom>
-          <a:solidFill>
-            <a:srgbClr val="EDE7F6"/>
-          </a:solidFill>
-          <a:ln w="9525">
-            <a:solidFill>
-              <a:srgbClr val="5E35B1"/>
-            </a:solidFill>
-          </a:ln>
-          <a:effectLst/>
-        </p:spPr>
-        <p:txBody>
-          <a:bodyPr rtlCol="0" anchor="ctr" wrap="square" lIns="18288" tIns="0" rIns="18288" bIns="0"/>
-          <a:lstStyle/>
-          <a:p>
-            <a:pPr algn="ctr"/>
-            <a:r>
-              <a:rPr sz="600" b="1">
-                <a:solidFill>
-                  <a:srgbClr val="5E35B1"/>
-                </a:solidFill>
-                <a:latin typeface="맑은 고딕"/>
-                <a:ea typeface="맑은 고딕"/>
-              </a:rPr>
-              <a:t>«Chain of Responsibility» Pipeline</a:t>
-            </a:r>
-          </a:p>
-        </p:txBody>
-      </p:sp>
-      <p:sp>
-        <p:nvSpPr>
-          <p:cNvPr id="178" name="Rectangle 177"/>
-          <p:cNvSpPr/>
-          <p:nvPr/>
-        </p:nvSpPr>
-        <p:spPr>
-          <a:xfrm>
             <a:off x="7333488" y="2240280"/>
             <a:ext cx="868680" cy="237744"/>
           </a:xfrm>
@@ -25628,7 +25586,7 @@
       </p:sp>
       <p:sp>
         <p:nvSpPr>
-          <p:cNvPr id="179" name="Rectangle 178"/>
+          <p:cNvPr id="178" name="Rectangle 177"/>
           <p:cNvSpPr/>
           <p:nvPr/>
         </p:nvSpPr>
@@ -25670,7 +25628,7 @@
       </p:sp>
       <p:sp>
         <p:nvSpPr>
-          <p:cNvPr id="180" name="Rectangle 179"/>
+          <p:cNvPr id="179" name="Rectangle 178"/>
           <p:cNvSpPr/>
           <p:nvPr/>
         </p:nvSpPr>
@@ -25710,6 +25668,28 @@
           </a:p>
         </p:txBody>
       </p:sp>
+      <p:cxnSp>
+        <p:nvCxnSpPr>
+          <p:cNvPr id="180" name="Connector 179"/>
+          <p:cNvCxnSpPr/>
+          <p:nvPr/>
+        </p:nvCxnSpPr>
+        <p:spPr>
+          <a:xfrm>
+            <a:off x="8202168" y="2359152"/>
+            <a:ext cx="118872" cy="0"/>
+          </a:xfrm>
+          <a:prstGeom prst="line">
+            <a:avLst/>
+          </a:prstGeom>
+          <a:ln w="15875">
+            <a:solidFill>
+              <a:srgbClr val="C55A11"/>
+            </a:solidFill>
+            <a:tailEnd type="triangle"/>
+          </a:ln>
+        </p:spPr>
+      </p:cxnSp>
       <p:cxnSp>
         <p:nvCxnSpPr>
           <p:cNvPr id="181" name="Connector 180"/>
@@ -25718,7 +25698,7 @@
         </p:nvCxnSpPr>
         <p:spPr>
           <a:xfrm>
-            <a:off x="8202168" y="2359152"/>
+            <a:off x="9372600" y="2359152"/>
             <a:ext cx="118872" cy="0"/>
           </a:xfrm>
           <a:prstGeom prst="line">
@@ -25740,28 +25720,6 @@
         </p:nvCxnSpPr>
         <p:spPr>
           <a:xfrm>
-            <a:off x="9372600" y="2359152"/>
-            <a:ext cx="118872" cy="0"/>
-          </a:xfrm>
-          <a:prstGeom prst="line">
-            <a:avLst/>
-          </a:prstGeom>
-          <a:ln w="15875">
-            <a:solidFill>
-              <a:srgbClr val="C55A11"/>
-            </a:solidFill>
-            <a:tailEnd type="triangle"/>
-          </a:ln>
-        </p:spPr>
-      </p:cxnSp>
-      <p:cxnSp>
-        <p:nvCxnSpPr>
-          <p:cNvPr id="183" name="Connector 182"/>
-          <p:cNvCxnSpPr/>
-          <p:nvPr/>
-        </p:nvCxnSpPr>
-        <p:spPr>
-          <a:xfrm>
             <a:off x="7635240" y="2029968"/>
             <a:ext cx="0" cy="210312"/>
           </a:xfrm>
@@ -25778,7 +25736,7 @@
       </p:cxnSp>
       <p:sp>
         <p:nvSpPr>
-          <p:cNvPr id="184" name="Oval 183"/>
+          <p:cNvPr id="183" name="Oval 182"/>
           <p:cNvSpPr/>
           <p:nvPr/>
         </p:nvSpPr>
@@ -25820,49 +25778,49 @@
       </p:sp>
       <p:sp>
         <p:nvSpPr>
+          <p:cNvPr id="184" name="Rectangle 183"/>
+          <p:cNvSpPr/>
+          <p:nvPr/>
+        </p:nvSpPr>
+        <p:spPr>
+          <a:xfrm>
+            <a:off x="7333488" y="2523744"/>
+            <a:ext cx="1600200" cy="137160"/>
+          </a:xfrm>
+          <a:prstGeom prst="rect">
+            <a:avLst/>
+          </a:prstGeom>
+          <a:solidFill>
+            <a:srgbClr val="EDE7F6"/>
+          </a:solidFill>
+          <a:ln w="9525">
+            <a:solidFill>
+              <a:srgbClr val="5E35B1"/>
+            </a:solidFill>
+          </a:ln>
+          <a:effectLst/>
+        </p:spPr>
+        <p:txBody>
+          <a:bodyPr rtlCol="0" anchor="ctr" wrap="square" lIns="18288" tIns="0" rIns="18288" bIns="0"/>
+          <a:lstStyle/>
+          <a:p>
+            <a:pPr algn="ctr"/>
+            <a:r>
+              <a:rPr sz="600" b="1">
+                <a:solidFill>
+                  <a:srgbClr val="5E35B1"/>
+                </a:solidFill>
+                <a:latin typeface="맑은 고딕"/>
+                <a:ea typeface="맑은 고딕"/>
+              </a:rPr>
+              <a:t>«Strategy» 점수 정책 ↔ 1안 plugin 대응</a:t>
+            </a:r>
+          </a:p>
+        </p:txBody>
+      </p:sp>
+      <p:sp>
+        <p:nvSpPr>
           <p:cNvPr id="185" name="Rectangle 184"/>
-          <p:cNvSpPr/>
-          <p:nvPr/>
-        </p:nvSpPr>
-        <p:spPr>
-          <a:xfrm>
-            <a:off x="7333488" y="2523744"/>
-            <a:ext cx="914400" cy="137160"/>
-          </a:xfrm>
-          <a:prstGeom prst="rect">
-            <a:avLst/>
-          </a:prstGeom>
-          <a:solidFill>
-            <a:srgbClr val="EDE7F6"/>
-          </a:solidFill>
-          <a:ln w="9525">
-            <a:solidFill>
-              <a:srgbClr val="5E35B1"/>
-            </a:solidFill>
-          </a:ln>
-          <a:effectLst/>
-        </p:spPr>
-        <p:txBody>
-          <a:bodyPr rtlCol="0" anchor="ctr" wrap="square" lIns="18288" tIns="0" rIns="18288" bIns="0"/>
-          <a:lstStyle/>
-          <a:p>
-            <a:pPr algn="ctr"/>
-            <a:r>
-              <a:rPr sz="600" b="1">
-                <a:solidFill>
-                  <a:srgbClr val="5E35B1"/>
-                </a:solidFill>
-                <a:latin typeface="맑은 고딕"/>
-                <a:ea typeface="맑은 고딕"/>
-              </a:rPr>
-              <a:t>«Strategy» 점수 정책</a:t>
-            </a:r>
-          </a:p>
-        </p:txBody>
-      </p:sp>
-      <p:sp>
-        <p:nvSpPr>
-          <p:cNvPr id="186" name="Rectangle 185"/>
           <p:cNvSpPr/>
           <p:nvPr/>
         </p:nvSpPr>
@@ -25894,7 +25852,7 @@
       </p:sp>
       <p:sp>
         <p:nvSpPr>
-          <p:cNvPr id="187" name="TextBox 186"/>
+          <p:cNvPr id="186" name="TextBox 185"/>
           <p:cNvSpPr txBox="1"/>
           <p:nvPr/>
         </p:nvSpPr>
@@ -25930,7 +25888,7 @@
       </p:sp>
       <p:sp>
         <p:nvSpPr>
-          <p:cNvPr id="188" name="Rectangle 187"/>
+          <p:cNvPr id="187" name="Rectangle 186"/>
           <p:cNvSpPr/>
           <p:nvPr/>
         </p:nvSpPr>
@@ -25972,7 +25930,7 @@
       </p:sp>
       <p:sp>
         <p:nvSpPr>
-          <p:cNvPr id="189" name="Rectangle 188"/>
+          <p:cNvPr id="188" name="Rectangle 187"/>
           <p:cNvSpPr/>
           <p:nvPr/>
         </p:nvSpPr>
@@ -26014,7 +25972,7 @@
       </p:sp>
       <p:sp>
         <p:nvSpPr>
-          <p:cNvPr id="190" name="Rectangle 189"/>
+          <p:cNvPr id="189" name="Rectangle 188"/>
           <p:cNvSpPr/>
           <p:nvPr/>
         </p:nvSpPr>
@@ -26056,7 +26014,7 @@
       </p:sp>
       <p:cxnSp>
         <p:nvCxnSpPr>
-          <p:cNvPr id="191" name="Connector 190"/>
+          <p:cNvPr id="190" name="Connector 189"/>
           <p:cNvCxnSpPr/>
           <p:nvPr/>
         </p:nvCxnSpPr>
@@ -26078,49 +26036,49 @@
       </p:cxnSp>
       <p:sp>
         <p:nvSpPr>
+          <p:cNvPr id="191" name="Rectangle 190"/>
+          <p:cNvSpPr/>
+          <p:nvPr/>
+        </p:nvSpPr>
+        <p:spPr>
+          <a:xfrm>
+            <a:off x="9217152" y="2523744"/>
+            <a:ext cx="914400" cy="137160"/>
+          </a:xfrm>
+          <a:prstGeom prst="rect">
+            <a:avLst/>
+          </a:prstGeom>
+          <a:solidFill>
+            <a:srgbClr val="EDE7F6"/>
+          </a:solidFill>
+          <a:ln w="9525">
+            <a:solidFill>
+              <a:srgbClr val="5E35B1"/>
+            </a:solidFill>
+          </a:ln>
+          <a:effectLst/>
+        </p:spPr>
+        <p:txBody>
+          <a:bodyPr rtlCol="0" anchor="ctr" wrap="square" lIns="18288" tIns="0" rIns="18288" bIns="0"/>
+          <a:lstStyle/>
+          <a:p>
+            <a:pPr algn="ctr"/>
+            <a:r>
+              <a:rPr sz="600" b="1">
+                <a:solidFill>
+                  <a:srgbClr val="5E35B1"/>
+                </a:solidFill>
+                <a:latin typeface="맑은 고딕"/>
+                <a:ea typeface="맑은 고딕"/>
+              </a:rPr>
+              <a:t>«Strategy» P/D 정책</a:t>
+            </a:r>
+          </a:p>
+        </p:txBody>
+      </p:sp>
+      <p:sp>
+        <p:nvSpPr>
           <p:cNvPr id="192" name="Rectangle 191"/>
-          <p:cNvSpPr/>
-          <p:nvPr/>
-        </p:nvSpPr>
-        <p:spPr>
-          <a:xfrm>
-            <a:off x="9217152" y="2523744"/>
-            <a:ext cx="1188720" cy="137160"/>
-          </a:xfrm>
-          <a:prstGeom prst="rect">
-            <a:avLst/>
-          </a:prstGeom>
-          <a:solidFill>
-            <a:srgbClr val="EDE7F6"/>
-          </a:solidFill>
-          <a:ln w="9525">
-            <a:solidFill>
-              <a:srgbClr val="5E35B1"/>
-            </a:solidFill>
-          </a:ln>
-          <a:effectLst/>
-        </p:spPr>
-        <p:txBody>
-          <a:bodyPr rtlCol="0" anchor="ctr" wrap="square" lIns="18288" tIns="0" rIns="18288" bIns="0"/>
-          <a:lstStyle/>
-          <a:p>
-            <a:pPr algn="ctr"/>
-            <a:r>
-              <a:rPr sz="600" b="1">
-                <a:solidFill>
-                  <a:srgbClr val="5E35B1"/>
-                </a:solidFill>
-                <a:latin typeface="맑은 고딕"/>
-                <a:ea typeface="맑은 고딕"/>
-              </a:rPr>
-              <a:t>«Strategy» P/D 정책</a:t>
-            </a:r>
-          </a:p>
-        </p:txBody>
-      </p:sp>
-      <p:sp>
-        <p:nvSpPr>
-          <p:cNvPr id="193" name="Rectangle 192"/>
           <p:cNvSpPr/>
           <p:nvPr/>
         </p:nvSpPr>
@@ -26152,7 +26110,7 @@
       </p:sp>
       <p:sp>
         <p:nvSpPr>
-          <p:cNvPr id="194" name="TextBox 193"/>
+          <p:cNvPr id="193" name="TextBox 192"/>
           <p:cNvSpPr txBox="1"/>
           <p:nvPr/>
         </p:nvSpPr>
@@ -26188,7 +26146,7 @@
       </p:sp>
       <p:sp>
         <p:nvSpPr>
-          <p:cNvPr id="195" name="Rectangle 194"/>
+          <p:cNvPr id="194" name="Rectangle 193"/>
           <p:cNvSpPr/>
           <p:nvPr/>
         </p:nvSpPr>
@@ -26230,7 +26188,7 @@
       </p:sp>
       <p:cxnSp>
         <p:nvCxnSpPr>
-          <p:cNvPr id="196" name="Connector 195"/>
+          <p:cNvPr id="195" name="Connector 194"/>
           <p:cNvCxnSpPr/>
           <p:nvPr/>
         </p:nvCxnSpPr>
@@ -26252,49 +26210,49 @@
       </p:cxnSp>
       <p:sp>
         <p:nvSpPr>
+          <p:cNvPr id="196" name="Rectangle 195"/>
+          <p:cNvSpPr/>
+          <p:nvPr/>
+        </p:nvSpPr>
+        <p:spPr>
+          <a:xfrm>
+            <a:off x="9217152" y="3090672"/>
+            <a:ext cx="1536192" cy="137160"/>
+          </a:xfrm>
+          <a:prstGeom prst="rect">
+            <a:avLst/>
+          </a:prstGeom>
+          <a:solidFill>
+            <a:srgbClr val="EDE7F6"/>
+          </a:solidFill>
+          <a:ln w="9525">
+            <a:solidFill>
+              <a:srgbClr val="5E35B1"/>
+            </a:solidFill>
+          </a:ln>
+          <a:effectLst/>
+        </p:spPr>
+        <p:txBody>
+          <a:bodyPr rtlCol="0" anchor="ctr" wrap="square" lIns="18288" tIns="0" rIns="18288" bIns="0"/>
+          <a:lstStyle/>
+          <a:p>
+            <a:pPr algn="ctr"/>
+            <a:r>
+              <a:rPr sz="600" b="1">
+                <a:solidFill>
+                  <a:srgbClr val="5E35B1"/>
+                </a:solidFill>
+                <a:latin typeface="맑은 고딕"/>
+                <a:ea typeface="맑은 고딕"/>
+              </a:rPr>
+              <a:t>«Decorator» P5 ↔ 1안 덮어쓰기 해결</a:t>
+            </a:r>
+          </a:p>
+        </p:txBody>
+      </p:sp>
+      <p:sp>
+        <p:nvSpPr>
           <p:cNvPr id="197" name="Rectangle 196"/>
-          <p:cNvSpPr/>
-          <p:nvPr/>
-        </p:nvSpPr>
-        <p:spPr>
-          <a:xfrm>
-            <a:off x="9217152" y="3090672"/>
-            <a:ext cx="1371600" cy="137160"/>
-          </a:xfrm>
-          <a:prstGeom prst="rect">
-            <a:avLst/>
-          </a:prstGeom>
-          <a:solidFill>
-            <a:srgbClr val="EDE7F6"/>
-          </a:solidFill>
-          <a:ln w="9525">
-            <a:solidFill>
-              <a:srgbClr val="5E35B1"/>
-            </a:solidFill>
-          </a:ln>
-          <a:effectLst/>
-        </p:spPr>
-        <p:txBody>
-          <a:bodyPr rtlCol="0" anchor="ctr" wrap="square" lIns="18288" tIns="0" rIns="18288" bIns="0"/>
-          <a:lstStyle/>
-          <a:p>
-            <a:pPr algn="ctr"/>
-            <a:r>
-              <a:rPr sz="600" b="1">
-                <a:solidFill>
-                  <a:srgbClr val="5E35B1"/>
-                </a:solidFill>
-                <a:latin typeface="맑은 고딕"/>
-                <a:ea typeface="맑은 고딕"/>
-              </a:rPr>
-              <a:t>«Decorator» 지시 체인 (P5)</a:t>
-            </a:r>
-          </a:p>
-        </p:txBody>
-      </p:sp>
-      <p:sp>
-        <p:nvSpPr>
-          <p:cNvPr id="198" name="Rectangle 197"/>
           <p:cNvSpPr/>
           <p:nvPr/>
         </p:nvSpPr>
@@ -26336,49 +26294,7 @@
       </p:sp>
       <p:sp>
         <p:nvSpPr>
-          <p:cNvPr id="199" name="Rectangle 198"/>
-          <p:cNvSpPr/>
-          <p:nvPr/>
-        </p:nvSpPr>
-        <p:spPr>
-          <a:xfrm>
-            <a:off x="7333488" y="3493008"/>
-            <a:ext cx="914400" cy="137160"/>
-          </a:xfrm>
-          <a:prstGeom prst="rect">
-            <a:avLst/>
-          </a:prstGeom>
-          <a:solidFill>
-            <a:srgbClr val="EDE7F6"/>
-          </a:solidFill>
-          <a:ln w="9525">
-            <a:solidFill>
-              <a:srgbClr val="5E35B1"/>
-            </a:solidFill>
-          </a:ln>
-          <a:effectLst/>
-        </p:spPr>
-        <p:txBody>
-          <a:bodyPr rtlCol="0" anchor="ctr" wrap="square" lIns="18288" tIns="0" rIns="18288" bIns="0"/>
-          <a:lstStyle/>
-          <a:p>
-            <a:pPr algn="ctr"/>
-            <a:r>
-              <a:rPr sz="600" b="1">
-                <a:solidFill>
-                  <a:srgbClr val="5E35B1"/>
-                </a:solidFill>
-                <a:latin typeface="맑은 고딕"/>
-                <a:ea typeface="맑은 고딕"/>
-              </a:rPr>
-              <a:t>«Observer» 상태 갱신</a:t>
-            </a:r>
-          </a:p>
-        </p:txBody>
-      </p:sp>
-      <p:sp>
-        <p:nvSpPr>
-          <p:cNvPr id="200" name="Rectangle 199"/>
+          <p:cNvPr id="198" name="Rectangle 197"/>
           <p:cNvSpPr/>
           <p:nvPr/>
         </p:nvSpPr>
@@ -26429,24 +26345,11 @@
               <a:t>Subscriber</a:t>
             </a:r>
           </a:p>
-          <a:p>
-            <a:pPr algn="ctr"/>
-            <a:r>
-              <a:rPr sz="600" b="0">
-                <a:solidFill>
-                  <a:srgbClr val="404040"/>
-                </a:solidFill>
-                <a:latin typeface="맑은 고딕"/>
-                <a:ea typeface="맑은 고딕"/>
-              </a:rPr>
-              <a:t>(Subject)</a:t>
-            </a:r>
-          </a:p>
-        </p:txBody>
-      </p:sp>
-      <p:sp>
-        <p:nvSpPr>
-          <p:cNvPr id="201" name="Rectangle 200"/>
+        </p:txBody>
+      </p:sp>
+      <p:sp>
+        <p:nvSpPr>
+          <p:cNvPr id="199" name="Rectangle 198"/>
           <p:cNvSpPr/>
           <p:nvPr/>
         </p:nvSpPr>
@@ -26482,6 +26385,70 @@
                 <a:ea typeface="맑은 고딕"/>
               </a:rPr>
               <a:t>KV Index 갱신</a:t>
+            </a:r>
+          </a:p>
+        </p:txBody>
+      </p:sp>
+      <p:cxnSp>
+        <p:nvCxnSpPr>
+          <p:cNvPr id="200" name="Connector 199"/>
+          <p:cNvCxnSpPr/>
+          <p:nvPr/>
+        </p:nvCxnSpPr>
+        <p:spPr>
+          <a:xfrm flipV="1">
+            <a:off x="8110728" y="3758184"/>
+            <a:ext cx="118872" cy="64007"/>
+          </a:xfrm>
+          <a:prstGeom prst="line">
+            <a:avLst/>
+          </a:prstGeom>
+          <a:ln w="12700">
+            <a:solidFill>
+              <a:srgbClr val="C55A11"/>
+            </a:solidFill>
+            <a:tailEnd type="triangle"/>
+          </a:ln>
+        </p:spPr>
+      </p:cxnSp>
+      <p:sp>
+        <p:nvSpPr>
+          <p:cNvPr id="201" name="Rectangle 200"/>
+          <p:cNvSpPr/>
+          <p:nvPr/>
+        </p:nvSpPr>
+        <p:spPr>
+          <a:xfrm>
+            <a:off x="8229600" y="3904487"/>
+            <a:ext cx="868680" cy="210312"/>
+          </a:xfrm>
+          <a:prstGeom prst="rect">
+            <a:avLst/>
+          </a:prstGeom>
+          <a:solidFill>
+            <a:srgbClr val="FBE5D6"/>
+          </a:solidFill>
+          <a:ln w="12700">
+            <a:solidFill>
+              <a:srgbClr val="C55A11"/>
+            </a:solidFill>
+          </a:ln>
+          <a:effectLst/>
+        </p:spPr>
+        <p:txBody>
+          <a:bodyPr rtlCol="0" anchor="ctr" wrap="square" lIns="36576" tIns="18288" rIns="36576" bIns="18288"/>
+          <a:lstStyle/>
+          <a:p>
+            <a:pPr algn="ctr"/>
+            <a:r>
+              <a:rPr sz="650" b="1">
+                <a:solidFill>
+                  <a:srgbClr val="000000"/>
+                </a:solidFill>
+                <a:latin typeface="맑은 고딕"/>
+                <a:ea typeface="맑은 고딕"/>
+              </a:rPr>
+              <a:t>Metrics 스냅샷</a:t>
             </a:r>
           </a:p>
         </p:txBody>
@@ -26493,9 +26460,9 @@
           <p:nvPr/>
         </p:nvCxnSpPr>
         <p:spPr>
-          <a:xfrm flipV="1">
-            <a:off x="8110728" y="3758184"/>
-            <a:ext cx="118872" cy="64007"/>
+          <a:xfrm>
+            <a:off x="8110728" y="3959352"/>
+            <a:ext cx="118872" cy="45720"/>
           </a:xfrm>
           <a:prstGeom prst="line">
             <a:avLst/>
@@ -26516,8 +26483,8 @@
         </p:nvSpPr>
         <p:spPr>
           <a:xfrm>
-            <a:off x="8229600" y="3904487"/>
-            <a:ext cx="868680" cy="210312"/>
+            <a:off x="9217152" y="3657600"/>
+            <a:ext cx="731520" cy="457200"/>
           </a:xfrm>
           <a:prstGeom prst="rect">
             <a:avLst/>
@@ -26525,7 +26492,7 @@
           <a:solidFill>
             <a:srgbClr val="FBE5D6"/>
           </a:solidFill>
-          <a:ln w="12700">
+          <a:ln w="19050">
             <a:solidFill>
               <a:srgbClr val="C55A11"/>
             </a:solidFill>
@@ -26538,14 +26505,27 @@
           <a:p>
             <a:pPr algn="ctr"/>
             <a:r>
-              <a:rPr sz="650" b="1">
+              <a:rPr sz="700" b="1">
                 <a:solidFill>
                   <a:srgbClr val="000000"/>
                 </a:solidFill>
                 <a:latin typeface="맑은 고딕"/>
                 <a:ea typeface="맑은 고딕"/>
               </a:rPr>
-              <a:t>Metrics 스냅샷</a:t>
+              <a:t>StateView</a:t>
+            </a:r>
+          </a:p>
+          <a:p>
+            <a:pPr algn="ctr"/>
+            <a:r>
+              <a:rPr sz="600" b="0">
+                <a:solidFill>
+                  <a:srgbClr val="404040"/>
+                </a:solidFill>
+                <a:latin typeface="맑은 고딕"/>
+                <a:ea typeface="맑은 고딕"/>
+              </a:rPr>
+              <a:t>읽기 전용 조회</a:t>
             </a:r>
           </a:p>
         </p:txBody>
@@ -26558,8 +26538,8 @@
         </p:nvCxnSpPr>
         <p:spPr>
           <a:xfrm>
-            <a:off x="8110728" y="3959352"/>
-            <a:ext cx="118872" cy="45720"/>
+            <a:off x="9098280" y="3877056"/>
+            <a:ext cx="118872" cy="0"/>
           </a:xfrm>
           <a:prstGeom prst="line">
             <a:avLst/>
@@ -26572,76 +26552,21 @@
           </a:ln>
         </p:spPr>
       </p:cxnSp>
-      <p:sp>
-        <p:nvSpPr>
-          <p:cNvPr id="205" name="Rectangle 204"/>
-          <p:cNvSpPr/>
-          <p:nvPr/>
-        </p:nvSpPr>
-        <p:spPr>
-          <a:xfrm>
-            <a:off x="9217152" y="3657600"/>
-            <a:ext cx="731520" cy="457200"/>
-          </a:xfrm>
-          <a:prstGeom prst="rect">
-            <a:avLst/>
-          </a:prstGeom>
-          <a:solidFill>
-            <a:srgbClr val="FBE5D6"/>
-          </a:solidFill>
-          <a:ln w="19050">
-            <a:solidFill>
-              <a:srgbClr val="C55A11"/>
-            </a:solidFill>
-          </a:ln>
-          <a:effectLst/>
-        </p:spPr>
-        <p:txBody>
-          <a:bodyPr rtlCol="0" anchor="ctr" wrap="square" lIns="36576" tIns="18288" rIns="36576" bIns="18288"/>
-          <a:lstStyle/>
-          <a:p>
-            <a:pPr algn="ctr"/>
-            <a:r>
-              <a:rPr sz="700" b="1">
-                <a:solidFill>
-                  <a:srgbClr val="000000"/>
-                </a:solidFill>
-                <a:latin typeface="맑은 고딕"/>
-                <a:ea typeface="맑은 고딕"/>
-              </a:rPr>
-              <a:t>StateView</a:t>
-            </a:r>
-          </a:p>
-          <a:p>
-            <a:pPr algn="ctr"/>
-            <a:r>
-              <a:rPr sz="600" b="0">
-                <a:solidFill>
-                  <a:srgbClr val="404040"/>
-                </a:solidFill>
-                <a:latin typeface="맑은 고딕"/>
-                <a:ea typeface="맑은 고딕"/>
-              </a:rPr>
-              <a:t>읽기 전용 Facade</a:t>
-            </a:r>
-          </a:p>
-        </p:txBody>
-      </p:sp>
       <p:cxnSp>
         <p:nvCxnSpPr>
-          <p:cNvPr id="206" name="Connector 205"/>
+          <p:cNvPr id="205" name="Connector 204"/>
           <p:cNvCxnSpPr/>
           <p:nvPr/>
         </p:nvCxnSpPr>
         <p:spPr>
-          <a:xfrm>
-            <a:off x="9098280" y="3877056"/>
-            <a:ext cx="118872" cy="0"/>
+          <a:xfrm flipH="1" flipV="1">
+            <a:off x="8961120" y="3392424"/>
+            <a:ext cx="548640" cy="265176"/>
           </a:xfrm>
           <a:prstGeom prst="line">
             <a:avLst/>
           </a:prstGeom>
-          <a:ln w="12700">
+          <a:ln w="15875">
             <a:solidFill>
               <a:srgbClr val="C55A11"/>
             </a:solidFill>
@@ -26649,6 +26574,48 @@
           </a:ln>
         </p:spPr>
       </p:cxnSp>
+      <p:sp>
+        <p:nvSpPr>
+          <p:cNvPr id="206" name="Oval 205"/>
+          <p:cNvSpPr/>
+          <p:nvPr/>
+        </p:nvSpPr>
+        <p:spPr>
+          <a:xfrm>
+            <a:off x="9203436" y="3451860"/>
+            <a:ext cx="155448" cy="155448"/>
+          </a:xfrm>
+          <a:prstGeom prst="ellipse">
+            <a:avLst/>
+          </a:prstGeom>
+          <a:solidFill>
+            <a:srgbClr val="C55A11"/>
+          </a:solidFill>
+          <a:ln w="9525">
+            <a:solidFill>
+              <a:srgbClr val="FFFFFF"/>
+            </a:solidFill>
+          </a:ln>
+          <a:effectLst/>
+        </p:spPr>
+        <p:txBody>
+          <a:bodyPr rtlCol="0" anchor="ctr" wrap="square" lIns="0" tIns="0" rIns="0" bIns="0"/>
+          <a:lstStyle/>
+          <a:p>
+            <a:pPr algn="ctr"/>
+            <a:r>
+              <a:rPr sz="650" b="1">
+                <a:solidFill>
+                  <a:srgbClr val="FFFFFF"/>
+                </a:solidFill>
+                <a:latin typeface="맑은 고딕"/>
+                <a:ea typeface="맑은 고딕"/>
+              </a:rPr>
+              <a:t>6</a:t>
+            </a:r>
+          </a:p>
+        </p:txBody>
+      </p:sp>
       <p:cxnSp>
         <p:nvCxnSpPr>
           <p:cNvPr id="207" name="Connector 206"/>
@@ -26656,9 +26623,9 @@
           <p:nvPr/>
         </p:nvCxnSpPr>
         <p:spPr>
-          <a:xfrm flipH="1" flipV="1">
-            <a:off x="8961120" y="3392424"/>
-            <a:ext cx="548640" cy="265176"/>
+          <a:xfrm flipV="1">
+            <a:off x="9784080" y="3419856"/>
+            <a:ext cx="0" cy="237744"/>
           </a:xfrm>
           <a:prstGeom prst="line">
             <a:avLst/>
@@ -26673,42 +26640,55 @@
       </p:cxnSp>
       <p:sp>
         <p:nvSpPr>
-          <p:cNvPr id="208" name="Oval 207"/>
-          <p:cNvSpPr/>
-          <p:nvPr/>
-        </p:nvSpPr>
-        <p:spPr>
-          <a:xfrm>
-            <a:off x="9203436" y="3451860"/>
-            <a:ext cx="155448" cy="155448"/>
-          </a:xfrm>
-          <a:prstGeom prst="ellipse">
-            <a:avLst/>
-          </a:prstGeom>
-          <a:solidFill>
-            <a:srgbClr val="C55A11"/>
-          </a:solidFill>
-          <a:ln w="9525">
-            <a:solidFill>
-              <a:srgbClr val="FFFFFF"/>
-            </a:solidFill>
-          </a:ln>
-          <a:effectLst/>
-        </p:spPr>
-        <p:txBody>
-          <a:bodyPr rtlCol="0" anchor="ctr" wrap="square" lIns="0" tIns="0" rIns="0" bIns="0"/>
-          <a:lstStyle/>
-          <a:p>
-            <a:pPr algn="ctr"/>
-            <a:r>
-              <a:rPr sz="650" b="1">
-                <a:solidFill>
-                  <a:srgbClr val="FFFFFF"/>
-                </a:solidFill>
-                <a:latin typeface="맑은 고딕"/>
-                <a:ea typeface="맑은 고딕"/>
-              </a:rPr>
-              <a:t>6</a:t>
+          <p:cNvPr id="208" name="Rectangle 207"/>
+          <p:cNvSpPr/>
+          <p:nvPr/>
+        </p:nvSpPr>
+        <p:spPr>
+          <a:xfrm>
+            <a:off x="10021824" y="3657600"/>
+            <a:ext cx="694944" cy="457200"/>
+          </a:xfrm>
+          <a:prstGeom prst="rect">
+            <a:avLst/>
+          </a:prstGeom>
+          <a:solidFill>
+            <a:srgbClr val="FBE5D6"/>
+          </a:solidFill>
+          <a:ln w="19050">
+            <a:solidFill>
+              <a:srgbClr val="C55A11"/>
+            </a:solidFill>
+          </a:ln>
+          <a:effectLst/>
+        </p:spPr>
+        <p:txBody>
+          <a:bodyPr rtlCol="0" anchor="ctr" wrap="square" lIns="36576" tIns="18288" rIns="36576" bIns="18288"/>
+          <a:lstStyle/>
+          <a:p>
+            <a:pPr algn="ctr"/>
+            <a:r>
+              <a:rPr sz="700" b="1">
+                <a:solidFill>
+                  <a:srgbClr val="000000"/>
+                </a:solidFill>
+                <a:latin typeface="맑은 고딕"/>
+                <a:ea typeface="맑은 고딕"/>
+              </a:rPr>
+              <a:t>F Registry</a:t>
+            </a:r>
+          </a:p>
+          <a:p>
+            <a:pPr algn="ctr"/>
+            <a:r>
+              <a:rPr sz="600" b="0">
+                <a:solidFill>
+                  <a:srgbClr val="404040"/>
+                </a:solidFill>
+                <a:latin typeface="맑은 고딕"/>
+                <a:ea typeface="맑은 고딕"/>
+              </a:rPr>
+              <a:t>etcd watch</a:t>
             </a:r>
           </a:p>
         </p:txBody>
@@ -26720,83 +26700,6 @@
           <p:nvPr/>
         </p:nvCxnSpPr>
         <p:spPr>
-          <a:xfrm flipV="1">
-            <a:off x="9784080" y="3419856"/>
-            <a:ext cx="0" cy="237744"/>
-          </a:xfrm>
-          <a:prstGeom prst="line">
-            <a:avLst/>
-          </a:prstGeom>
-          <a:ln w="15875">
-            <a:solidFill>
-              <a:srgbClr val="C55A11"/>
-            </a:solidFill>
-            <a:tailEnd type="triangle"/>
-          </a:ln>
-        </p:spPr>
-      </p:cxnSp>
-      <p:sp>
-        <p:nvSpPr>
-          <p:cNvPr id="210" name="Rectangle 209"/>
-          <p:cNvSpPr/>
-          <p:nvPr/>
-        </p:nvSpPr>
-        <p:spPr>
-          <a:xfrm>
-            <a:off x="10021824" y="3657600"/>
-            <a:ext cx="694944" cy="457200"/>
-          </a:xfrm>
-          <a:prstGeom prst="rect">
-            <a:avLst/>
-          </a:prstGeom>
-          <a:solidFill>
-            <a:srgbClr val="FBE5D6"/>
-          </a:solidFill>
-          <a:ln w="19050">
-            <a:solidFill>
-              <a:srgbClr val="C55A11"/>
-            </a:solidFill>
-          </a:ln>
-          <a:effectLst/>
-        </p:spPr>
-        <p:txBody>
-          <a:bodyPr rtlCol="0" anchor="ctr" wrap="square" lIns="36576" tIns="18288" rIns="36576" bIns="18288"/>
-          <a:lstStyle/>
-          <a:p>
-            <a:pPr algn="ctr"/>
-            <a:r>
-              <a:rPr sz="700" b="1">
-                <a:solidFill>
-                  <a:srgbClr val="000000"/>
-                </a:solidFill>
-                <a:latin typeface="맑은 고딕"/>
-                <a:ea typeface="맑은 고딕"/>
-              </a:rPr>
-              <a:t>F Registry</a:t>
-            </a:r>
-          </a:p>
-          <a:p>
-            <a:pPr algn="ctr"/>
-            <a:r>
-              <a:rPr sz="600" b="0">
-                <a:solidFill>
-                  <a:srgbClr val="404040"/>
-                </a:solidFill>
-                <a:latin typeface="맑은 고딕"/>
-                <a:ea typeface="맑은 고딕"/>
-              </a:rPr>
-              <a:t>etcd watch</a:t>
-            </a:r>
-          </a:p>
-        </p:txBody>
-      </p:sp>
-      <p:cxnSp>
-        <p:nvCxnSpPr>
-          <p:cNvPr id="211" name="Connector 210"/>
-          <p:cNvCxnSpPr/>
-          <p:nvPr/>
-        </p:nvCxnSpPr>
-        <p:spPr>
           <a:xfrm>
             <a:off x="7150608" y="4165091"/>
             <a:ext cx="2999232" cy="0"/>
@@ -26814,7 +26717,7 @@
       </p:cxnSp>
       <p:cxnSp>
         <p:nvCxnSpPr>
-          <p:cNvPr id="212" name="Connector 211"/>
+          <p:cNvPr id="210" name="Connector 209"/>
           <p:cNvCxnSpPr/>
           <p:nvPr/>
         </p:nvCxnSpPr>
@@ -26836,7 +26739,7 @@
       </p:cxnSp>
       <p:sp>
         <p:nvSpPr>
-          <p:cNvPr id="213" name="Oval 212"/>
+          <p:cNvPr id="211" name="Oval 210"/>
           <p:cNvSpPr/>
           <p:nvPr/>
         </p:nvSpPr>
@@ -26878,91 +26781,91 @@
       </p:sp>
       <p:sp>
         <p:nvSpPr>
+          <p:cNvPr id="212" name="Rectangle 211"/>
+          <p:cNvSpPr/>
+          <p:nvPr/>
+        </p:nvSpPr>
+        <p:spPr>
+          <a:xfrm>
+            <a:off x="7333488" y="4215384"/>
+            <a:ext cx="1417320" cy="137160"/>
+          </a:xfrm>
+          <a:prstGeom prst="rect">
+            <a:avLst/>
+          </a:prstGeom>
+          <a:solidFill>
+            <a:srgbClr val="EDE7F6"/>
+          </a:solidFill>
+          <a:ln w="9525">
+            <a:solidFill>
+              <a:srgbClr val="5E35B1"/>
+            </a:solidFill>
+          </a:ln>
+          <a:effectLst/>
+        </p:spPr>
+        <p:txBody>
+          <a:bodyPr rtlCol="0" anchor="ctr" wrap="square" lIns="18288" tIns="0" rIns="18288" bIns="0"/>
+          <a:lstStyle/>
+          <a:p>
+            <a:pPr algn="ctr"/>
+            <a:r>
+              <a:rPr sz="600" b="1">
+                <a:solidFill>
+                  <a:srgbClr val="5E35B1"/>
+                </a:solidFill>
+                <a:latin typeface="맑은 고딕"/>
+                <a:ea typeface="맑은 고딕"/>
+              </a:rPr>
+              <a:t>«Adapter» ↔ 1안 OSS 의존 해결</a:t>
+            </a:r>
+          </a:p>
+        </p:txBody>
+      </p:sp>
+      <p:sp>
+        <p:nvSpPr>
+          <p:cNvPr id="213" name="Rectangle 212"/>
+          <p:cNvSpPr/>
+          <p:nvPr/>
+        </p:nvSpPr>
+        <p:spPr>
+          <a:xfrm>
+            <a:off x="8796528" y="4215384"/>
+            <a:ext cx="1920240" cy="137160"/>
+          </a:xfrm>
+          <a:prstGeom prst="rect">
+            <a:avLst/>
+          </a:prstGeom>
+          <a:solidFill>
+            <a:srgbClr val="FFFFFF"/>
+          </a:solidFill>
+          <a:ln w="9525">
+            <a:solidFill>
+              <a:srgbClr val="5E35B1"/>
+            </a:solidFill>
+          </a:ln>
+          <a:effectLst/>
+        </p:spPr>
+        <p:txBody>
+          <a:bodyPr rtlCol="0" anchor="ctr" wrap="square" lIns="18288" tIns="0" rIns="18288" bIns="0"/>
+          <a:lstStyle/>
+          <a:p>
+            <a:pPr algn="ctr"/>
+            <a:r>
+              <a:rPr sz="600" b="1">
+                <a:solidFill>
+                  <a:srgbClr val="5E35B1"/>
+                </a:solidFill>
+                <a:latin typeface="맑은 고딕"/>
+                <a:ea typeface="맑은 고딕"/>
+              </a:rPr>
+              <a:t>vLLM 계약: KV 이벤트 · /metrics · kv_params</a:t>
+            </a:r>
+          </a:p>
+        </p:txBody>
+      </p:sp>
+      <p:sp>
+        <p:nvSpPr>
           <p:cNvPr id="214" name="Rectangle 213"/>
-          <p:cNvSpPr/>
-          <p:nvPr/>
-        </p:nvSpPr>
-        <p:spPr>
-          <a:xfrm>
-            <a:off x="7333488" y="4215384"/>
-            <a:ext cx="822960" cy="137160"/>
-          </a:xfrm>
-          <a:prstGeom prst="rect">
-            <a:avLst/>
-          </a:prstGeom>
-          <a:solidFill>
-            <a:srgbClr val="EDE7F6"/>
-          </a:solidFill>
-          <a:ln w="9525">
-            <a:solidFill>
-              <a:srgbClr val="5E35B1"/>
-            </a:solidFill>
-          </a:ln>
-          <a:effectLst/>
-        </p:spPr>
-        <p:txBody>
-          <a:bodyPr rtlCol="0" anchor="ctr" wrap="square" lIns="18288" tIns="0" rIns="18288" bIns="0"/>
-          <a:lstStyle/>
-          <a:p>
-            <a:pPr algn="ctr"/>
-            <a:r>
-              <a:rPr sz="600" b="1">
-                <a:solidFill>
-                  <a:srgbClr val="5E35B1"/>
-                </a:solidFill>
-                <a:latin typeface="맑은 고딕"/>
-                <a:ea typeface="맑은 고딕"/>
-              </a:rPr>
-              <a:t>«Adapter»</a:t>
-            </a:r>
-          </a:p>
-        </p:txBody>
-      </p:sp>
-      <p:sp>
-        <p:nvSpPr>
-          <p:cNvPr id="215" name="Rectangle 214"/>
-          <p:cNvSpPr/>
-          <p:nvPr/>
-        </p:nvSpPr>
-        <p:spPr>
-          <a:xfrm>
-            <a:off x="8193024" y="4215384"/>
-            <a:ext cx="2523744" cy="137160"/>
-          </a:xfrm>
-          <a:prstGeom prst="rect">
-            <a:avLst/>
-          </a:prstGeom>
-          <a:solidFill>
-            <a:srgbClr val="FFFFFF"/>
-          </a:solidFill>
-          <a:ln w="9525">
-            <a:solidFill>
-              <a:srgbClr val="5E35B1"/>
-            </a:solidFill>
-          </a:ln>
-          <a:effectLst/>
-        </p:spPr>
-        <p:txBody>
-          <a:bodyPr rtlCol="0" anchor="ctr" wrap="square" lIns="18288" tIns="0" rIns="18288" bIns="0"/>
-          <a:lstStyle/>
-          <a:p>
-            <a:pPr algn="ctr"/>
-            <a:r>
-              <a:rPr sz="600" b="1">
-                <a:solidFill>
-                  <a:srgbClr val="5E35B1"/>
-                </a:solidFill>
-                <a:latin typeface="맑은 고딕"/>
-                <a:ea typeface="맑은 고딕"/>
-              </a:rPr>
-              <a:t>vLLM 계약 어댑터: KV 이벤트 · /metrics · kv_transfer_params</a:t>
-            </a:r>
-          </a:p>
-        </p:txBody>
-      </p:sp>
-      <p:sp>
-        <p:nvSpPr>
-          <p:cNvPr id="216" name="Rectangle 215"/>
           <p:cNvSpPr/>
           <p:nvPr/>
         </p:nvSpPr>
@@ -26994,7 +26897,7 @@
       </p:sp>
       <p:sp>
         <p:nvSpPr>
-          <p:cNvPr id="217" name="Rectangle 216"/>
+          <p:cNvPr id="215" name="Rectangle 214"/>
           <p:cNvSpPr/>
           <p:nvPr/>
         </p:nvSpPr>
@@ -27036,7 +26939,7 @@
       </p:sp>
       <p:sp>
         <p:nvSpPr>
-          <p:cNvPr id="218" name="Rectangle 217"/>
+          <p:cNvPr id="216" name="Rectangle 215"/>
           <p:cNvSpPr/>
           <p:nvPr/>
         </p:nvSpPr>
@@ -27117,7 +27020,7 @@
       </p:sp>
       <p:sp>
         <p:nvSpPr>
-          <p:cNvPr id="219" name="Rectangle 218"/>
+          <p:cNvPr id="217" name="Rectangle 216"/>
           <p:cNvSpPr/>
           <p:nvPr/>
         </p:nvSpPr>
@@ -27149,7 +27052,7 @@
       </p:sp>
       <p:sp>
         <p:nvSpPr>
-          <p:cNvPr id="220" name="Rectangle 219"/>
+          <p:cNvPr id="218" name="Rectangle 217"/>
           <p:cNvSpPr/>
           <p:nvPr/>
         </p:nvSpPr>
@@ -27191,7 +27094,7 @@
       </p:sp>
       <p:sp>
         <p:nvSpPr>
-          <p:cNvPr id="221" name="Rectangle 220"/>
+          <p:cNvPr id="219" name="Rectangle 218"/>
           <p:cNvSpPr/>
           <p:nvPr/>
         </p:nvSpPr>
@@ -27266,6 +27169,71 @@
                 <a:ea typeface="맑은 고딕"/>
               </a:rPr>
               <a:t>/metrics</a:t>
+            </a:r>
+          </a:p>
+        </p:txBody>
+      </p:sp>
+      <p:cxnSp>
+        <p:nvCxnSpPr>
+          <p:cNvPr id="220" name="Connector 219"/>
+          <p:cNvCxnSpPr/>
+          <p:nvPr/>
+        </p:nvCxnSpPr>
+        <p:spPr>
+          <a:xfrm>
+            <a:off x="11411712" y="2770632"/>
+            <a:ext cx="0" cy="457200"/>
+          </a:xfrm>
+          <a:prstGeom prst="line">
+            <a:avLst/>
+          </a:prstGeom>
+          <a:ln w="15875">
+            <a:solidFill>
+              <a:srgbClr val="404040"/>
+            </a:solidFill>
+            <a:headEnd type="triangle"/>
+            <a:tailEnd type="triangle"/>
+          </a:ln>
+        </p:spPr>
+      </p:cxnSp>
+      <p:sp>
+        <p:nvSpPr>
+          <p:cNvPr id="221" name="Oval 220"/>
+          <p:cNvSpPr/>
+          <p:nvPr/>
+        </p:nvSpPr>
+        <p:spPr>
+          <a:xfrm>
+            <a:off x="11553443" y="2793492"/>
+            <a:ext cx="155448" cy="155448"/>
+          </a:xfrm>
+          <a:prstGeom prst="ellipse">
+            <a:avLst/>
+          </a:prstGeom>
+          <a:solidFill>
+            <a:srgbClr val="C55A11"/>
+          </a:solidFill>
+          <a:ln w="9525">
+            <a:solidFill>
+              <a:srgbClr val="FFFFFF"/>
+            </a:solidFill>
+          </a:ln>
+          <a:effectLst/>
+        </p:spPr>
+        <p:txBody>
+          <a:bodyPr rtlCol="0" anchor="ctr" wrap="square" lIns="0" tIns="0" rIns="0" bIns="0"/>
+          <a:lstStyle/>
+          <a:p>
+            <a:pPr algn="ctr"/>
+            <a:r>
+              <a:rPr sz="650" b="1">
+                <a:solidFill>
+                  <a:srgbClr val="FFFFFF"/>
+                </a:solidFill>
+                <a:latin typeface="맑은 고딕"/>
+                <a:ea typeface="맑은 고딕"/>
+              </a:rPr>
+              <a:t>4</a:t>
             </a:r>
           </a:p>
         </p:txBody>
@@ -27277,9 +27245,9 @@
           <p:nvPr/>
         </p:nvCxnSpPr>
         <p:spPr>
-          <a:xfrm>
-            <a:off x="11411712" y="2770632"/>
-            <a:ext cx="0" cy="457200"/>
+          <a:xfrm flipV="1">
+            <a:off x="10716767" y="2194560"/>
+            <a:ext cx="292609" cy="164592"/>
           </a:xfrm>
           <a:prstGeom prst="line">
             <a:avLst/>
@@ -27288,7 +27256,6 @@
             <a:solidFill>
               <a:srgbClr val="404040"/>
             </a:solidFill>
-            <a:headEnd type="triangle"/>
             <a:tailEnd type="triangle"/>
           </a:ln>
         </p:spPr>
@@ -27301,7 +27268,7 @@
         </p:nvSpPr>
         <p:spPr>
           <a:xfrm>
-            <a:off x="11553443" y="2793492"/>
+            <a:off x="10785347" y="2025396"/>
             <a:ext cx="155448" cy="155448"/>
           </a:xfrm>
           <a:prstGeom prst="ellipse">
@@ -27330,7 +27297,7 @@
                 <a:latin typeface="맑은 고딕"/>
                 <a:ea typeface="맑은 고딕"/>
               </a:rPr>
-              <a:t>4</a:t>
+              <a:t>3</a:t>
             </a:r>
           </a:p>
         </p:txBody>
@@ -27342,70 +27309,6 @@
           <p:nvPr/>
         </p:nvCxnSpPr>
         <p:spPr>
-          <a:xfrm flipV="1">
-            <a:off x="10716767" y="2194560"/>
-            <a:ext cx="292609" cy="164592"/>
-          </a:xfrm>
-          <a:prstGeom prst="line">
-            <a:avLst/>
-          </a:prstGeom>
-          <a:ln w="15875">
-            <a:solidFill>
-              <a:srgbClr val="404040"/>
-            </a:solidFill>
-            <a:tailEnd type="triangle"/>
-          </a:ln>
-        </p:spPr>
-      </p:cxnSp>
-      <p:sp>
-        <p:nvSpPr>
-          <p:cNvPr id="225" name="Oval 224"/>
-          <p:cNvSpPr/>
-          <p:nvPr/>
-        </p:nvSpPr>
-        <p:spPr>
-          <a:xfrm>
-            <a:off x="10785347" y="2025396"/>
-            <a:ext cx="155448" cy="155448"/>
-          </a:xfrm>
-          <a:prstGeom prst="ellipse">
-            <a:avLst/>
-          </a:prstGeom>
-          <a:solidFill>
-            <a:srgbClr val="C55A11"/>
-          </a:solidFill>
-          <a:ln w="9525">
-            <a:solidFill>
-              <a:srgbClr val="FFFFFF"/>
-            </a:solidFill>
-          </a:ln>
-          <a:effectLst/>
-        </p:spPr>
-        <p:txBody>
-          <a:bodyPr rtlCol="0" anchor="ctr" wrap="square" lIns="0" tIns="0" rIns="0" bIns="0"/>
-          <a:lstStyle/>
-          <a:p>
-            <a:pPr algn="ctr"/>
-            <a:r>
-              <a:rPr sz="650" b="1">
-                <a:solidFill>
-                  <a:srgbClr val="FFFFFF"/>
-                </a:solidFill>
-                <a:latin typeface="맑은 고딕"/>
-                <a:ea typeface="맑은 고딕"/>
-              </a:rPr>
-              <a:t>3</a:t>
-            </a:r>
-          </a:p>
-        </p:txBody>
-      </p:sp>
-      <p:cxnSp>
-        <p:nvCxnSpPr>
-          <p:cNvPr id="226" name="Connector 225"/>
-          <p:cNvCxnSpPr/>
-          <p:nvPr/>
-        </p:nvCxnSpPr>
-        <p:spPr>
           <a:xfrm flipH="1">
             <a:off x="10716767" y="3822191"/>
             <a:ext cx="292609" cy="0"/>
@@ -27424,7 +27327,7 @@
       </p:cxnSp>
       <p:sp>
         <p:nvSpPr>
-          <p:cNvPr id="227" name="Oval 226"/>
+          <p:cNvPr id="225" name="Oval 224"/>
           <p:cNvSpPr/>
           <p:nvPr/>
         </p:nvSpPr>
@@ -27466,7 +27369,7 @@
       </p:sp>
       <p:sp>
         <p:nvSpPr>
-          <p:cNvPr id="228" name="Rectangle 227"/>
+          <p:cNvPr id="226" name="Rectangle 225"/>
           <p:cNvSpPr/>
           <p:nvPr/>
         </p:nvSpPr>
@@ -27508,7 +27411,7 @@
       </p:sp>
       <p:sp>
         <p:nvSpPr>
-          <p:cNvPr id="229" name="Rectangle 228"/>
+          <p:cNvPr id="227" name="Rectangle 226"/>
           <p:cNvSpPr/>
           <p:nvPr/>
         </p:nvSpPr>
@@ -27550,7 +27453,7 @@
       </p:sp>
       <p:sp>
         <p:nvSpPr>
-          <p:cNvPr id="230" name="Rectangle 229"/>
+          <p:cNvPr id="228" name="Rectangle 227"/>
           <p:cNvSpPr/>
           <p:nvPr/>
         </p:nvSpPr>
@@ -27593,7 +27496,7 @@
       </p:sp>
       <p:sp>
         <p:nvSpPr>
-          <p:cNvPr id="231" name="Rectangle 230"/>
+          <p:cNvPr id="229" name="Rectangle 228"/>
           <p:cNvSpPr/>
           <p:nvPr/>
         </p:nvSpPr>
@@ -27635,7 +27538,7 @@
       </p:sp>
       <p:sp>
         <p:nvSpPr>
-          <p:cNvPr id="232" name="Rectangle 231"/>
+          <p:cNvPr id="230" name="Rectangle 229"/>
           <p:cNvSpPr/>
           <p:nvPr/>
         </p:nvSpPr>
@@ -27677,7 +27580,7 @@
       </p:sp>
       <p:sp>
         <p:nvSpPr>
-          <p:cNvPr id="233" name="Rectangle 232"/>
+          <p:cNvPr id="231" name="Rectangle 230"/>
           <p:cNvSpPr/>
           <p:nvPr/>
         </p:nvSpPr>
@@ -27712,14 +27615,14 @@
                 <a:latin typeface="맑은 고딕"/>
                 <a:ea typeface="맑은 고딕"/>
               </a:rPr>
-              <a:t>디자인 패턴 (Chain·Strategy·Decorator·Observer·Adapter)</a:t>
-            </a:r>
-          </a:p>
-        </p:txBody>
-      </p:sp>
-      <p:sp>
-        <p:nvSpPr>
-          <p:cNvPr id="234" name="Rectangle 233"/>
+              <a:t>디자인 패턴 3개: 1안 문제에 대응 (Strategy·Decorator·Adapter)</a:t>
+            </a:r>
+          </a:p>
+        </p:txBody>
+      </p:sp>
+      <p:sp>
+        <p:nvSpPr>
+          <p:cNvPr id="232" name="Rectangle 231"/>
           <p:cNvSpPr/>
           <p:nvPr/>
         </p:nvSpPr>
@@ -27761,7 +27664,7 @@
       </p:sp>
       <p:sp>
         <p:nvSpPr>
-          <p:cNvPr id="235" name="TextBox 234"/>
+          <p:cNvPr id="233" name="TextBox 232"/>
           <p:cNvSpPr txBox="1"/>
           <p:nvPr/>
         </p:nvSpPr>
@@ -27797,7 +27700,7 @@
       </p:sp>
       <p:sp>
         <p:nvSpPr>
-          <p:cNvPr id="236" name="Rectangle 235"/>
+          <p:cNvPr id="234" name="Rectangle 233"/>
           <p:cNvSpPr/>
           <p:nvPr/>
         </p:nvSpPr>
@@ -27839,7 +27742,7 @@
       </p:sp>
       <p:sp>
         <p:nvSpPr>
-          <p:cNvPr id="237" name="Rectangle 236"/>
+          <p:cNvPr id="235" name="Rectangle 234"/>
           <p:cNvSpPr/>
           <p:nvPr/>
         </p:nvSpPr>
@@ -27907,7 +27810,7 @@
       </p:sp>
       <p:sp>
         <p:nvSpPr>
-          <p:cNvPr id="238" name="Rectangle 237"/>
+          <p:cNvPr id="236" name="Rectangle 235"/>
           <p:cNvSpPr/>
           <p:nvPr/>
         </p:nvSpPr>
@@ -27955,7 +27858,7 @@
                 <a:latin typeface="맑은 고딕"/>
                 <a:ea typeface="맑은 고딕"/>
               </a:rPr>
-              <a:t>▪ Strategy·Decorator로 정책·지시를 갈아 끼움: 비용 함수·P/D 정책·노드 지시를 한 코드베이스에서 변경</a:t>
+              <a:t>▪ Strategy·Decorator로 정책·지시를 갈아 끼움: 비용 함수·P/D 정책·노드 지시를 한 코드베이스에서 변경, P/D 경로 P5도 덮어쓰기 없이 전달</a:t>
             </a:r>
           </a:p>
           <a:p>
@@ -27968,14 +27871,14 @@
                 <a:latin typeface="맑은 고딕"/>
                 <a:ea typeface="맑은 고딕"/>
               </a:rPr>
-              <a:t>▪ Adapter로 vLLM 계약 변경을 격리, K8s·프록시 불필요</a:t>
-            </a:r>
-          </a:p>
-        </p:txBody>
-      </p:sp>
-      <p:sp>
-        <p:nvSpPr>
-          <p:cNvPr id="239" name="Rectangle 238"/>
+              <a:t>▪ Adapter로 vLLM 계약 변경을 격리, OSS 내부 동작 의존 없음, K8s·프록시 불필요</a:t>
+            </a:r>
+          </a:p>
+        </p:txBody>
+      </p:sp>
+      <p:sp>
+        <p:nvSpPr>
+          <p:cNvPr id="237" name="Rectangle 236"/>
           <p:cNvSpPr/>
           <p:nvPr/>
         </p:nvSpPr>
@@ -28017,7 +27920,7 @@
       </p:sp>
       <p:sp>
         <p:nvSpPr>
-          <p:cNvPr id="240" name="Rectangle 239"/>
+          <p:cNvPr id="238" name="Rectangle 237"/>
           <p:cNvSpPr/>
           <p:nvPr/>
         </p:nvSpPr>
@@ -28085,7 +27988,7 @@
       </p:sp>
       <p:sp>
         <p:nvSpPr>
-          <p:cNvPr id="241" name="Rectangle 240"/>
+          <p:cNvPr id="239" name="Rectangle 238"/>
           <p:cNvSpPr/>
           <p:nvPr/>
         </p:nvSpPr>
@@ -28153,7 +28056,7 @@
       </p:sp>
       <p:sp>
         <p:nvSpPr>
-          <p:cNvPr id="242" name="TextBox 241"/>
+          <p:cNvPr id="240" name="TextBox 239"/>
           <p:cNvSpPr txBox="1"/>
           <p:nvPr/>
         </p:nvSpPr>
@@ -28189,7 +28092,7 @@
       </p:sp>
       <p:sp>
         <p:nvSpPr>
-          <p:cNvPr id="243" name="TextBox 242"/>
+          <p:cNvPr id="241" name="TextBox 240"/>
           <p:cNvSpPr txBox="1"/>
           <p:nvPr/>
         </p:nvSpPr>
@@ -28218,7 +28121,7 @@
                 <a:latin typeface="맑은 고딕"/>
                 <a:ea typeface="맑은 고딕"/>
               </a:rPr>
-              <a:t>※ ★P5 = 지시의 '송신'(오케스트레이션 범위). 수신·실행은 vLLM(엔진) 공통 선결(C5 접점 계약). P/D 보조 프로세스는 엔진이 아니라 오케스트레이션 소프트웨어다. 디자인 패턴: Chain of Responsibility(파이프라인), Strategy(정책 교체), Decorator(지시 조립), Observer(상태 갱신), Adapter(엔진 계약 격리). 박스는 프로세스가 아니라 한 프로세스 안의 모듈이고, 프로세스 경계는 굵은 바깥 박스.</a:t>
+              <a:t>※ ★P5 = 지시의 '송신'(오케스트레이션 범위). 수신·실행은 vLLM(엔진) 공통 선결(C5 접점 계약). P/D 보조 프로세스는 엔진이 아니라 오케스트레이션 소프트웨어다. 디자인 패턴(1안 문제와 연결): Strategy = 정책 교체(1안 plugin에 대응), Decorator = P5 지시 조립(1안 P/D 경로 덮어쓰기 해결), Adapter = vLLM 계약 격리(1안 OSS 동작 의존 해결). 박스는 프로세스가 아니라 한 프로세스 안의 모듈이고, 프로세스 경계는 굵은 바깥 박스.</a:t>
             </a:r>
           </a:p>
         </p:txBody>

</xml_diff>

<commit_message>
DP0: owner-set stars (Q3 1안 2/2안 3, Q4 1안 3/2안 1), add QA result + per-QA criteria slides with projected values
Co-Authored-By: Claude Sonnet 5.5 <noreply@anthropic.com>
Claude-Session: https://claude.ai/code/session_014XKnsGjraFTY3Q8v5o1PT9
</commit_message>
<xml_diff>
--- a/doc-mk/DP0/DP0-slides-v2.pptx
+++ b/doc-mk/DP0/DP0-slides-v2.pptx
@@ -911,7 +911,7 @@
           </a:p>
           <a:p>
             <a:r>
-              <a:t>그래서 3 대 3으로 동등하고 별은 둘 다 ●●○입니다. 업스트림 추종(S5)과 신기능 확보(S6)는 변경·유지 용이성의 일부이므로 QA 안에 넣었고, 구현 부담과 증거 수준은 QA 밖 제약·리스크로 따로 둡니다.</a:t>
+              <a:t>그래서 시나리오 승수는 3 대 3입니다. 다만 이 연구에서 자주 바뀌는 것은 정책(S2~S4)이라 가중 2를 주면 평균 변경 module이 1안 3.2, 2안 1.9가 되어 별은 1안 ●●○, 2안 ●●●입니다. 가중을 같게 두면 둘 다 ●●○입니다(가정). 업스트림 추종(S5)과 신기능 확보(S6)는 변경·유지 용이성의 일부이므로 QA 안에 넣었고, 구현 부담과 증거 수준은 QA 밖 제약·리스크로 따로 둡니다.</a:t>
             </a:r>
           </a:p>
           <a:p>
@@ -31567,7 +31567,7 @@
                 <a:latin typeface="맑은 고딕"/>
                 <a:ea typeface="맑은 고딕"/>
               </a:rPr>
-              <a:t>3 대 3 → Q3 변경·유지 용이성 동등</a:t>
+              <a:t>3 대 3 + 정책 변경 가중 → 2안 우세(가정)</a:t>
             </a:r>
           </a:p>
           <a:p>
@@ -31580,7 +31580,7 @@
                 <a:latin typeface="맑은 고딕"/>
                 <a:ea typeface="맑은 고딕"/>
               </a:rPr>
-              <a:t>1안 ●●○  /  2안 ●●○  (성격만 다름)</a:t>
+              <a:t>1안 ●●○  /  2안 ●●●  (같은 가중이면 ●●○ 동등)</a:t>
             </a:r>
           </a:p>
         </p:txBody>
@@ -31717,7 +31717,7 @@
                 <a:latin typeface="맑은 고딕"/>
                 <a:ea typeface="맑은 고딕"/>
               </a:rPr>
-              <a:t>※ 가설 [C] (일부 [A]: P1~P4 plugin은 합성 백엔드로 끝단 실행). 시나리오 가중치는 정하지 않았다. 용어: plugin = 기존 코드를 안 고치고 끼우는 확장 모듈 · patch = 기존 모듈 수정</a:t>
+              <a:t>※ 가설 [C] (일부 [A]: P1~P4 plugin은 합성 백엔드로 끝단 실행). 시나리오 가중치: 정책 변경 S2~S4 = 2, 나머지 1 (가정). 용어: plugin = 기존 코드를 안 고치고 끼우는 확장 모듈 · patch = 기존 모듈 수정</a:t>
             </a:r>
           </a:p>
         </p:txBody>
@@ -34563,7 +34563,7 @@
             <a:avLst/>
           </a:prstGeom>
           <a:solidFill>
-            <a:srgbClr val="FFFFFF"/>
+            <a:srgbClr val="FBE5D6"/>
           </a:solidFill>
           <a:ln w="6350">
             <a:solidFill>
@@ -34585,7 +34585,7 @@
                 <a:latin typeface="맑은 고딕"/>
                 <a:ea typeface="맑은 고딕"/>
               </a:rPr>
-              <a:t>●●○</a:t>
+              <a:t>●●●</a:t>
             </a:r>
           </a:p>
         </p:txBody>
@@ -34627,7 +34627,7 @@
                 <a:latin typeface="맑은 고딕"/>
                 <a:ea typeface="맑은 고딕"/>
               </a:rPr>
-              <a:t>동등(3 대 3): S1·S5·S6은 1안(흡수), S2·S3·S4는 2안(통제). 앞 장 S1~S6</a:t>
+              <a:t>시나리오는 3 대 3이나 정책 변경(S2~S4)을 가중 2로 보면 2안 ≤2 module. 같은 가중이면 동등(●●○)</a:t>
             </a:r>
           </a:p>
         </p:txBody>
@@ -34753,7 +34753,7 @@
                 <a:latin typeface="맑은 고딕"/>
                 <a:ea typeface="맑은 고딕"/>
               </a:rPr>
-              <a:t>●●○</a:t>
+              <a:t>●○○</a:t>
             </a:r>
           </a:p>
         </p:txBody>
@@ -34795,7 +34795,7 @@
                 <a:latin typeface="맑은 고딕"/>
                 <a:ea typeface="맑은 고딕"/>
               </a:rPr>
-              <a:t>1안: K8s 복제·서버 풀·흐름 제어 검증됨. 2안: 레플리카·HA 직접 구축, 2노드 실측 불가</a:t>
+              <a:t>1안: K8s 복제·서버 풀 검증됨. 2안: 레플리카가 상태 비공유라 갱신 부하 ∝N, SE(16) 64% 예상. 외삽</a:t>
             </a:r>
           </a:p>
         </p:txBody>
@@ -36149,7 +36149,7 @@
                 <a:latin typeface="맑은 고딕"/>
                 <a:ea typeface="맑은 고딕"/>
               </a:rPr>
-              <a:t>QA 4개는 9 대 9 동점이고 제약·리스크는 1안이 우위다. 동점은 QA 우선순위가 정하므로 Q2 지연에서 갈려 2안(자체 구현)을 선택한다.</a:t>
+              <a:t>QA 4개는 9 대 9 동점이고(2안 변경 용이성 ●●●, 확장성 ●○○) 제약·리스크는 1안이 우위다. 동점은 QA 우선순위가 정하므로 Q2 지연에서 갈려 2안(자체 구현)을 선택한다.</a:t>
             </a:r>
           </a:p>
           <a:p>
@@ -36162,7 +36162,7 @@
                 <a:latin typeface="맑은 고딕"/>
                 <a:ea typeface="맑은 고딕"/>
               </a:rPr>
-              <a:t>· 직접 개발(2안)은 지연을, OSS 확장(1안)은 확장성을 얻고, 변경·유지 용이성은 흡수(1안) 대 통제(2안)로 동등하다.</a:t>
+              <a:t>· 직접 개발(2안)은 지연을, OSS 확장(1안)은 확장성을 얻고, 변경·유지 용이성은 흡수(1안) 대 통제(2안)이고 정책 변경 가중에서 2안이 앞선다.</a:t>
             </a:r>
           </a:p>
           <a:p>

</xml_diff>

<commit_message>
DP0: Q3 3-metric model (token cost > effort > modules), evaluation scenario/simulation/system-SLO slides, sourced star criteria, sharding supplement diagram
Co-Authored-By: Claude Sonnet 5.5 <noreply@anthropic.com>
Claude-Session: https://claude.ai/code/session_014XKnsGjraFTY3Q8v5o1PT9
</commit_message>
<xml_diff>
--- a/doc-mk/DP0/DP0-slides-v2.pptx
+++ b/doc-mk/DP0/DP0-slides-v2.pptx
@@ -12,6 +12,7 @@
     <p:sldId id="641" r:id="rId3"/>
     <p:sldId id="697" r:id="rId4"/>
     <p:sldId id="558" r:id="rId5"/>
+    <p:sldId id="700" r:id="rId13"/>
     <p:sldId id="699" r:id="rId12"/>
     <p:sldId id="698" r:id="rId11"/>
   </p:sldIdLst>
@@ -891,32 +892,27 @@
           <a:lstStyle/>
           <a:p>
             <a:r>
-              <a:t>[DP0 설계 - 변경 용이성(Q3) 시나리오 S1~S6]</a:t>
-            </a:r>
-          </a:p>
-          <a:p>
-            <a:r>
-              <a:t>변경 용이성은 요구가 바뀔 때 무엇을 얼마나 바꿔야 하는지로 잽니다. 변경 시나리오 6개를 두 안에 대어 봤습니다.</a:t>
-            </a:r>
-          </a:p>
-          <a:p>
-            <a:r>
-              <a:t>1안이 앞서는 것은 S1(새 메모리 종류 추가: 설정 표에 이름만 추가), S5(vLLM·NIXL 계약 변경: 오픈소스가 대신 따라감), S6(신규 기능: 오픈소스가 제공)입니다. 환경 변화와 신기능을 오픈소스가 흡수해 주는 쪽입니다.</a:t>
-            </a:r>
-          </a:p>
-          <a:p>
-            <a:r>
-              <a:t>2안이 앞서는 것은 S2(비용 함수 교체), S3(P/D 정책 교체), S4(노드 지시 추가)입니다. 우리 로직을 한 코드베이스에서 Strategy 구현체 교체로 바꾸기 때문에 오픈소스 구조의 제약(기존 모듈 동작 의존, 보조 프로세스 수정, 별도 이미지)을 받지 않습니다. 통제하는 쪽입니다.</a:t>
-            </a:r>
-          </a:p>
-          <a:p>
-            <a:r>
-              <a:t>그래서 시나리오 승수는 3 대 3입니다. 다만 이 연구에서 자주 바뀌는 것은 정책(S2~S4)이라 가중 2를 주면 평균 변경 module이 1안 3.2, 2안 1.9가 되어 별은 1안 ●●○, 2안 ●●●입니다. 가중을 같게 두면 둘 다 ●●○입니다(가정). 업스트림 추종(S5)과 신기능 확보(S6)는 변경·유지 용이성의 일부이므로 QA 안에 넣었고, 구현 부담과 증거 수준은 QA 밖 제약·리스크로 따로 둡니다.</a:t>
-            </a:r>
-          </a:p>
-          <a:p>
-            <a:r>
-              <a:t>S4는 오케스트레이션 측 변경만 비교합니다. 새 지시 키를 vLLM이 이해하게 하는 변경은 어느 안이든 똑같이 필요한 공통 선결입니다.</a:t>
+              <a:t>[DP0 설계 - 2안 확장성 보완(서버 샤딩)]</a:t>
+            </a:r>
+          </a:p>
+          <a:p>
+            <a:r>
+              <a:t>왼쪽은 지금 2안입니다. 레플리카가 상태를 공유하지 않아서 각 레플리카가 전체 서버의 KV 이벤트와 메트릭을 전부 처리합니다. 서버가 N배가 되면 레플리카마다 처리량이 N배가 되어 결정이 느려지고 상태가 낡아 서버 확장성 별이 낮습니다.</a:t>
+            </a:r>
+          </a:p>
+          <a:p>
+            <a:r>
+              <a:t>오른쪽은 보완안입니다. 서버를 샤드로 나눠 샤드마다 Shard Router가 담당 서버의 상태만 처리하고, 앞단의 무상태 Front Router는 샤드별 요약만 보고 샤드를 고릅니다. 샤드끼리는 부하와 prefix 요약만 교환합니다. 샤드 안의 구조와 디자인 패턴은 지금 2안 그대로 재사용합니다.</a:t>
+            </a:r>
+          </a:p>
+          <a:p>
+            <a:r>
+              <a:t>효과는 가설입니다. 확장성은 올라갈 가능성이 있지만 hop과 요약 지연이 생겨 지연 경계와 구현 부담은 커집니다. 그래서 별 합계가 오른다고 단정하지 않고, 서버 수별 Goodput(E4)과 Front Router hop(E1)으로 확인합니다.</a:t>
+            </a:r>
+          </a:p>
+          <a:p>
+            <a:r>
+              <a:t>이 방향은 DP0-1의 S2 두 단계 위임과 같습니다.</a:t>
             </a:r>
           </a:p>
         </p:txBody>
@@ -942,6 +938,101 @@
 </file>
 
 <file path=ppt/notesSlides/notesSlide6.xml><?xml version="1.0" encoding="utf-8"?>
+<p:notes xmlns:a="http://schemas.openxmlformats.org/drawingml/2006/main" xmlns:p="http://schemas.openxmlformats.org/presentationml/2006/main" xmlns:r="http://schemas.openxmlformats.org/officeDocument/2006/relationships">
+  <p:cSld>
+    <p:spTree>
+      <p:nvGrpSpPr>
+        <p:cNvPr id="1" name=""/>
+        <p:cNvGrpSpPr/>
+        <p:nvPr/>
+      </p:nvGrpSpPr>
+      <p:grpSpPr>
+        <a:xfrm>
+          <a:off x="0" y="0"/>
+          <a:ext cx="0" cy="0"/>
+          <a:chOff x="0" y="0"/>
+          <a:chExt cx="0" cy="0"/>
+        </a:xfrm>
+      </p:grpSpPr>
+      <p:sp>
+        <p:nvSpPr>
+          <p:cNvPr id="2" name="Slide Image Placeholder 1"/>
+          <p:cNvSpPr>
+            <a:spLocks noGrp="1"/>
+          </p:cNvSpPr>
+          <p:nvPr>
+            <p:ph type="sldImg" idx="2"/>
+          </p:nvPr>
+        </p:nvSpPr>
+        <p:spPr/>
+      </p:sp>
+      <p:sp>
+        <p:nvSpPr>
+          <p:cNvPr id="3" name="Notes Placeholder 2"/>
+          <p:cNvSpPr>
+            <a:spLocks noGrp="1"/>
+          </p:cNvSpPr>
+          <p:nvPr>
+            <p:ph type="body" idx="3" sz="quarter"/>
+          </p:nvPr>
+        </p:nvSpPr>
+        <p:spPr/>
+        <p:txBody>
+          <a:bodyPr/>
+          <a:lstStyle/>
+          <a:p>
+            <a:r>
+              <a:t>[DP0 설계 - 변경 용이성(Q3) 시나리오 S1~S6]</a:t>
+            </a:r>
+          </a:p>
+          <a:p>
+            <a:r>
+              <a:t>변경 용이성은 요구가 바뀔 때 무엇을 얼마나 바꿔야 하는지로 잽니다. 변경 시나리오 6개를 두 안에 대어 봤습니다.</a:t>
+            </a:r>
+          </a:p>
+          <a:p>
+            <a:r>
+              <a:t>1안이 앞서는 것은 S1(새 메모리 종류 추가: 설정 표에 이름만 추가), S5(vLLM·NIXL 계약 변경: 오픈소스가 대신 따라감), S6(신규 기능: 오픈소스가 제공)입니다. 환경 변화와 신기능을 오픈소스가 흡수해 주는 쪽입니다.</a:t>
+            </a:r>
+          </a:p>
+          <a:p>
+            <a:r>
+              <a:t>2안이 앞서는 것은 S2(비용 함수 교체), S3(P/D 정책 교체), S4(노드 지시 추가)입니다. 우리 로직을 한 코드베이스에서 Strategy 구현체 교체로 바꾸기 때문에 오픈소스 구조의 제약(기존 모듈 동작 의존, 보조 프로세스 수정, 별도 이미지)을 받지 않습니다. 통제하는 쪽입니다.</a:t>
+            </a:r>
+          </a:p>
+          <a:p>
+            <a:r>
+              <a:t>그래서 시나리오 승수는 3 대 3입니다. 다만 이 연구에서 자주 바뀌는 것은 정책(S2~S4)이라 가중 2를 주면 평균 변경 module이 1안 3.2, 2안 1.9가 되어 별은 1안 ●●○, 2안 ●●●입니다. 가중을 같게 두면 둘 다 ●●○입니다(가정). 업스트림 추종(S5)과 신기능 확보(S6)는 변경·유지 용이성의 일부이므로 QA 안에 넣었고, 구현 부담과 증거 수준은 QA 밖 제약·리스크로 따로 둡니다.</a:t>
+            </a:r>
+          </a:p>
+          <a:p>
+            <a:r>
+              <a:t>S4는 오케스트레이션 측 변경만 비교합니다. 새 지시 키를 vLLM이 이해하게 하는 변경은 어느 안이든 똑같이 필요한 공통 선결입니다.</a:t>
+            </a:r>
+          </a:p>
+        </p:txBody>
+      </p:sp>
+      <p:sp>
+        <p:nvSpPr>
+          <p:cNvPr id="4" name="Slide Number Placeholder 3"/>
+          <p:cNvSpPr>
+            <a:spLocks noGrp="1"/>
+          </p:cNvSpPr>
+          <p:nvPr>
+            <p:ph type="sldNum" idx="5" sz="quarter"/>
+          </p:nvPr>
+        </p:nvSpPr>
+        <p:spPr/>
+      </p:sp>
+    </p:spTree>
+  </p:cSld>
+  <p:clrMapOvr>
+    <a:masterClrMapping/>
+  </p:clrMapOvr>
+</p:notes>
+</file>
+
+<file path=ppt/notesSlides/notesSlide7.xml><?xml version="1.0" encoding="utf-8"?>
 <p:notes xmlns:a="http://schemas.openxmlformats.org/drawingml/2006/main" xmlns:p="http://schemas.openxmlformats.org/presentationml/2006/main" xmlns:r="http://schemas.openxmlformats.org/officeDocument/2006/relationships">
   <p:cSld>
     <p:spTree>
@@ -36242,6 +36333,4751 @@
 </p:sld>
 </file>
 
+<file path=ppt/slides/slide7.xml><?xml version="1.0" encoding="utf-8"?>
+<p:sld xmlns:a="http://schemas.openxmlformats.org/drawingml/2006/main" xmlns:p="http://schemas.openxmlformats.org/presentationml/2006/main" xmlns:r="http://schemas.openxmlformats.org/officeDocument/2006/relationships">
+  <p:cSld>
+    <p:spTree>
+      <p:nvGrpSpPr>
+        <p:cNvPr id="1" name=""/>
+        <p:cNvGrpSpPr/>
+        <p:nvPr/>
+      </p:nvGrpSpPr>
+      <p:grpSpPr/>
+      <p:sp>
+        <p:nvSpPr>
+          <p:cNvPr id="3" name="제목 2"/>
+          <p:cNvSpPr>
+            <a:spLocks noGrp="1"/>
+          </p:cNvSpPr>
+          <p:nvPr>
+            <p:ph type="title"/>
+          </p:nvPr>
+        </p:nvSpPr>
+        <p:spPr>
+          <a:xfrm>
+            <a:off x="234949" y="137379"/>
+            <a:ext cx="7631530" cy="365125"/>
+          </a:xfrm>
+        </p:spPr>
+        <p:txBody>
+          <a:bodyPr/>
+          <a:lstStyle/>
+          <a:p>
+            <a:r>
+              <a:rPr lang="en-US" altLang="ko-KR" dirty="0"/>
+              <a:t>DP0. 2안 확장성 보완 설계 - 서버 샤딩</a:t>
+            </a:r>
+          </a:p>
+        </p:txBody>
+      </p:sp>
+      <p:sp>
+        <p:nvSpPr>
+          <p:cNvPr id="5" name="직사각형 4"/>
+          <p:cNvSpPr/>
+          <p:nvPr/>
+        </p:nvSpPr>
+        <p:spPr>
+          <a:xfrm>
+            <a:off x="234949" y="596176"/>
+            <a:ext cx="11747501" cy="396603"/>
+          </a:xfrm>
+          <a:prstGeom prst="rect">
+            <a:avLst/>
+          </a:prstGeom>
+          <a:solidFill>
+            <a:schemeClr val="bg1">
+              <a:lumMod val="50000"/>
+            </a:schemeClr>
+          </a:solidFill>
+          <a:ln>
+            <a:noFill/>
+          </a:ln>
+        </p:spPr>
+        <p:style>
+          <a:lnRef idx="2">
+            <a:schemeClr val="accent1">
+              <a:shade val="50000"/>
+            </a:schemeClr>
+          </a:lnRef>
+          <a:fillRef idx="1">
+            <a:schemeClr val="accent1"/>
+          </a:fillRef>
+          <a:effectRef idx="0">
+            <a:schemeClr val="accent1"/>
+          </a:effectRef>
+          <a:fontRef idx="minor">
+            <a:schemeClr val="lt1"/>
+          </a:fontRef>
+        </p:style>
+        <p:txBody>
+          <a:bodyPr rtlCol="0" anchor="ctr"/>
+          <a:lstStyle/>
+          <a:p>
+            <a:pPr algn="ctr"/>
+            <a:endParaRPr lang="ko-KR" altLang="en-US"/>
+          </a:p>
+        </p:txBody>
+      </p:sp>
+      <p:sp>
+        <p:nvSpPr>
+          <p:cNvPr id="8" name="TextBox 7"/>
+          <p:cNvSpPr txBox="1"/>
+          <p:nvPr/>
+        </p:nvSpPr>
+        <p:spPr>
+          <a:xfrm>
+            <a:off x="469760" y="627926"/>
+            <a:ext cx="7592951" cy="307777"/>
+          </a:xfrm>
+          <a:prstGeom prst="rect">
+            <a:avLst/>
+          </a:prstGeom>
+          <a:noFill/>
+        </p:spPr>
+        <p:txBody>
+          <a:bodyPr wrap="square" rtlCol="0">
+            <a:spAutoFit/>
+          </a:bodyPr>
+          <a:lstStyle/>
+          <a:p>
+            <a:pPr lvl="0">
+              <a:defRPr/>
+            </a:pPr>
+            <a:r>
+              <a:rPr lang="ko-KR" altLang="en-US" sz="1400" b="1" dirty="0" err="1">
+                <a:solidFill>
+                  <a:schemeClr val="bg1"/>
+                </a:solidFill>
+              </a:rPr>
+              <a:t>서버 담당 분할(샤딩)로 레플리카당 상태 처리량을 줄인다 (보완안, 별점 미반영)</a:t>
+            </a:r>
+            <a:endParaRPr lang="ko-KR" altLang="en-US" sz="1400" b="1" dirty="0">
+              <a:solidFill>
+                <a:schemeClr val="bg1"/>
+              </a:solidFill>
+            </a:endParaRPr>
+          </a:p>
+        </p:txBody>
+      </p:sp>
+      <p:sp>
+        <p:nvSpPr>
+          <p:cNvPr id="39" name="직사각형 38"/>
+          <p:cNvSpPr/>
+          <p:nvPr/>
+        </p:nvSpPr>
+        <p:spPr>
+          <a:xfrm>
+            <a:off x="403086" y="678726"/>
+            <a:ext cx="66675" cy="216270"/>
+          </a:xfrm>
+          <a:prstGeom prst="rect">
+            <a:avLst/>
+          </a:prstGeom>
+          <a:solidFill>
+            <a:schemeClr val="bg1"/>
+          </a:solidFill>
+          <a:ln w="19050">
+            <a:noFill/>
+          </a:ln>
+        </p:spPr>
+        <p:style>
+          <a:lnRef idx="2">
+            <a:schemeClr val="accent1">
+              <a:shade val="50000"/>
+            </a:schemeClr>
+          </a:lnRef>
+          <a:fillRef idx="1">
+            <a:schemeClr val="accent1"/>
+          </a:fillRef>
+          <a:effectRef idx="0">
+            <a:schemeClr val="accent1"/>
+          </a:effectRef>
+          <a:fontRef idx="minor">
+            <a:schemeClr val="lt1"/>
+          </a:fontRef>
+        </p:style>
+        <p:txBody>
+          <a:bodyPr rtlCol="0" anchor="ctr"/>
+          <a:lstStyle/>
+          <a:p>
+            <a:pPr algn="ctr"/>
+            <a:endParaRPr lang="ko-KR" altLang="en-US" sz="1600"/>
+          </a:p>
+        </p:txBody>
+      </p:sp>
+      <p:sp>
+        <p:nvSpPr>
+          <p:cNvPr id="48" name="모서리가 둥근 직사각형 47"/>
+          <p:cNvSpPr/>
+          <p:nvPr/>
+        </p:nvSpPr>
+        <p:spPr>
+          <a:xfrm>
+            <a:off x="10177272" y="629703"/>
+            <a:ext cx="868680" cy="321123"/>
+          </a:xfrm>
+          <a:prstGeom prst="roundRect">
+            <a:avLst/>
+          </a:prstGeom>
+          <a:solidFill>
+            <a:schemeClr val="accent2">
+              <a:lumMod val="50000"/>
+            </a:schemeClr>
+          </a:solidFill>
+        </p:spPr>
+        <p:style>
+          <a:lnRef idx="0">
+            <a:schemeClr val="accent2"/>
+          </a:lnRef>
+          <a:fillRef idx="3">
+            <a:schemeClr val="accent2"/>
+          </a:fillRef>
+          <a:effectRef idx="3">
+            <a:schemeClr val="accent2"/>
+          </a:effectRef>
+          <a:fontRef idx="minor">
+            <a:schemeClr val="lt1"/>
+          </a:fontRef>
+        </p:style>
+        <p:txBody>
+          <a:bodyPr rIns="0" rtlCol="0" anchor="ctr"/>
+          <a:lstStyle/>
+          <a:p>
+            <a:r>
+              <a:rPr lang="en-US" altLang="ko-KR" sz="900" b="1" dirty="0">
+                <a:latin typeface="맑은 고딕" panose="020B0503020000020004" pitchFamily="50" charset="-127"/>
+              </a:rPr>
+              <a:t>Q1~Q4</a:t>
+            </a:r>
+            <a:endParaRPr lang="ko-KR" altLang="en-US" sz="900" b="1" dirty="0">
+              <a:latin typeface="맑은 고딕" panose="020B0503020000020004" pitchFamily="50" charset="-127"/>
+              <a:ea typeface="맑은 고딕" panose="020B0503020000020004" pitchFamily="50" charset="-127"/>
+            </a:endParaRPr>
+          </a:p>
+        </p:txBody>
+      </p:sp>
+      <p:sp>
+        <p:nvSpPr>
+          <p:cNvPr id="38" name="모서리가 둥근 직사각형 37"/>
+          <p:cNvSpPr/>
+          <p:nvPr/>
+        </p:nvSpPr>
+        <p:spPr>
+          <a:xfrm>
+            <a:off x="9235440" y="627572"/>
+            <a:ext cx="868680" cy="323254"/>
+          </a:xfrm>
+          <a:prstGeom prst="roundRect">
+            <a:avLst/>
+          </a:prstGeom>
+          <a:solidFill>
+            <a:schemeClr val="accent5">
+              <a:lumMod val="50000"/>
+            </a:schemeClr>
+          </a:solidFill>
+        </p:spPr>
+        <p:style>
+          <a:lnRef idx="0">
+            <a:schemeClr val="accent1"/>
+          </a:lnRef>
+          <a:fillRef idx="3">
+            <a:schemeClr val="accent1"/>
+          </a:fillRef>
+          <a:effectRef idx="3">
+            <a:schemeClr val="accent1"/>
+          </a:effectRef>
+          <a:fontRef idx="minor">
+            <a:schemeClr val="lt1"/>
+          </a:fontRef>
+        </p:style>
+        <p:txBody>
+          <a:bodyPr rtlCol="0" anchor="ctr"/>
+          <a:lstStyle/>
+          <a:p>
+            <a:r>
+              <a:rPr lang="en-US" altLang="ko-KR" sz="900" b="1" dirty="0">
+                <a:latin typeface="맑은 고딕" panose="020B0503020000020004" pitchFamily="50" charset="-127"/>
+                <a:ea typeface="맑은 고딕" panose="020B0503020000020004" pitchFamily="50" charset="-127"/>
+              </a:rPr>
+              <a:t>F1~F4</a:t>
+            </a:r>
+            <a:endParaRPr lang="ko-KR" altLang="en-US" sz="900" b="1" dirty="0">
+              <a:latin typeface="맑은 고딕" panose="020B0503020000020004" pitchFamily="50" charset="-127"/>
+              <a:ea typeface="맑은 고딕" panose="020B0503020000020004" pitchFamily="50" charset="-127"/>
+            </a:endParaRPr>
+          </a:p>
+        </p:txBody>
+      </p:sp>
+      <p:sp>
+        <p:nvSpPr>
+          <p:cNvPr id="70" name="모서리가 둥근 직사각형 69"/>
+          <p:cNvSpPr/>
+          <p:nvPr/>
+        </p:nvSpPr>
+        <p:spPr>
+          <a:xfrm>
+            <a:off x="11119104" y="627572"/>
+            <a:ext cx="868680" cy="323254"/>
+          </a:xfrm>
+          <a:prstGeom prst="roundRect">
+            <a:avLst/>
+          </a:prstGeom>
+          <a:solidFill>
+            <a:schemeClr val="accent6">
+              <a:lumMod val="50000"/>
+            </a:schemeClr>
+          </a:solidFill>
+        </p:spPr>
+        <p:style>
+          <a:lnRef idx="0">
+            <a:schemeClr val="accent1"/>
+          </a:lnRef>
+          <a:fillRef idx="3">
+            <a:schemeClr val="accent1"/>
+          </a:fillRef>
+          <a:effectRef idx="3">
+            <a:schemeClr val="accent1"/>
+          </a:effectRef>
+          <a:fontRef idx="minor">
+            <a:schemeClr val="lt1"/>
+          </a:fontRef>
+        </p:style>
+        <p:txBody>
+          <a:bodyPr rtlCol="0" anchor="ctr"/>
+          <a:lstStyle/>
+          <a:p>
+            <a:r>
+              <a:rPr lang="en-US" altLang="ko-KR" sz="900" b="1" dirty="0">
+                <a:latin typeface="맑은 고딕" panose="020B0503020000020004" pitchFamily="50" charset="-127"/>
+                <a:ea typeface="맑은 고딕" panose="020B0503020000020004" pitchFamily="50" charset="-127"/>
+              </a:rPr>
+              <a:t>C1~C6</a:t>
+            </a:r>
+            <a:endParaRPr lang="ko-KR" altLang="en-US" sz="900" b="1" dirty="0">
+              <a:latin typeface="맑은 고딕" panose="020B0503020000020004" pitchFamily="50" charset="-127"/>
+              <a:ea typeface="맑은 고딕" panose="020B0503020000020004" pitchFamily="50" charset="-127"/>
+            </a:endParaRPr>
+          </a:p>
+        </p:txBody>
+      </p:sp>
+      <p:sp>
+        <p:nvSpPr>
+          <p:cNvPr id="57" name="슬라이드 번호 개체 틀 1"/>
+          <p:cNvSpPr>
+            <a:spLocks noGrp="1"/>
+          </p:cNvSpPr>
+          <p:nvPr>
+            <p:ph type="sldNum" sz="quarter" idx="4"/>
+          </p:nvPr>
+        </p:nvSpPr>
+        <p:spPr>
+          <a:xfrm>
+            <a:off x="5620080" y="6597650"/>
+            <a:ext cx="456466" cy="209550"/>
+          </a:xfrm>
+        </p:spPr>
+        <p:txBody>
+          <a:bodyPr/>
+          <a:lstStyle/>
+          <a:p>
+            <a:fld id="{7F889C64-266A-4D07-AD8F-5B592E61CCE1}" type="slidenum">
+              <a:rPr lang="ko-KR" altLang="en-US" smtClean="0"/>
+              <a:pPr/>
+              <a:t>4</a:t>
+            </a:fld>
+            <a:endParaRPr lang="ko-KR" altLang="en-US" dirty="0"/>
+          </a:p>
+        </p:txBody>
+      </p:sp>
+      <p:cxnSp>
+        <p:nvCxnSpPr>
+          <p:cNvPr id="59" name="직선 연결선 58"/>
+          <p:cNvCxnSpPr/>
+          <p:nvPr/>
+        </p:nvCxnSpPr>
+        <p:spPr>
+          <a:xfrm>
+            <a:off x="8383231" y="457197"/>
+            <a:ext cx="58597" cy="0"/>
+          </a:xfrm>
+          <a:prstGeom prst="line">
+            <a:avLst/>
+          </a:prstGeom>
+          <a:ln w="28575">
+            <a:solidFill>
+              <a:schemeClr val="bg1">
+                <a:lumMod val="65000"/>
+              </a:schemeClr>
+            </a:solidFill>
+          </a:ln>
+        </p:spPr>
+        <p:style>
+          <a:lnRef idx="1">
+            <a:schemeClr val="accent1"/>
+          </a:lnRef>
+          <a:fillRef idx="0">
+            <a:schemeClr val="accent1"/>
+          </a:fillRef>
+          <a:effectRef idx="0">
+            <a:schemeClr val="accent1"/>
+          </a:effectRef>
+          <a:fontRef idx="minor">
+            <a:schemeClr val="tx1"/>
+          </a:fontRef>
+        </p:style>
+      </p:cxnSp>
+      <p:cxnSp>
+        <p:nvCxnSpPr>
+          <p:cNvPr id="60" name="직선 연결선 59"/>
+          <p:cNvCxnSpPr/>
+          <p:nvPr/>
+        </p:nvCxnSpPr>
+        <p:spPr>
+          <a:xfrm>
+            <a:off x="8461250" y="457197"/>
+            <a:ext cx="58597" cy="0"/>
+          </a:xfrm>
+          <a:prstGeom prst="line">
+            <a:avLst/>
+          </a:prstGeom>
+          <a:ln w="28575">
+            <a:solidFill>
+              <a:schemeClr val="bg1">
+                <a:lumMod val="65000"/>
+              </a:schemeClr>
+            </a:solidFill>
+          </a:ln>
+        </p:spPr>
+        <p:style>
+          <a:lnRef idx="1">
+            <a:schemeClr val="accent1"/>
+          </a:lnRef>
+          <a:fillRef idx="0">
+            <a:schemeClr val="accent1"/>
+          </a:fillRef>
+          <a:effectRef idx="0">
+            <a:schemeClr val="accent1"/>
+          </a:effectRef>
+          <a:fontRef idx="minor">
+            <a:schemeClr val="tx1"/>
+          </a:fontRef>
+        </p:style>
+      </p:cxnSp>
+      <p:cxnSp>
+        <p:nvCxnSpPr>
+          <p:cNvPr id="61" name="직선 연결선 60"/>
+          <p:cNvCxnSpPr/>
+          <p:nvPr/>
+        </p:nvCxnSpPr>
+        <p:spPr>
+          <a:xfrm>
+            <a:off x="8539269" y="457197"/>
+            <a:ext cx="58597" cy="0"/>
+          </a:xfrm>
+          <a:prstGeom prst="line">
+            <a:avLst/>
+          </a:prstGeom>
+          <a:ln w="28575">
+            <a:solidFill>
+              <a:schemeClr val="bg1"/>
+            </a:solidFill>
+          </a:ln>
+        </p:spPr>
+        <p:style>
+          <a:lnRef idx="1">
+            <a:schemeClr val="accent1"/>
+          </a:lnRef>
+          <a:fillRef idx="0">
+            <a:schemeClr val="accent1"/>
+          </a:fillRef>
+          <a:effectRef idx="0">
+            <a:schemeClr val="accent1"/>
+          </a:effectRef>
+          <a:fontRef idx="minor">
+            <a:schemeClr val="tx1"/>
+          </a:fontRef>
+        </p:style>
+      </p:cxnSp>
+      <p:cxnSp>
+        <p:nvCxnSpPr>
+          <p:cNvPr id="62" name="직선 연결선 61"/>
+          <p:cNvCxnSpPr/>
+          <p:nvPr/>
+        </p:nvCxnSpPr>
+        <p:spPr>
+          <a:xfrm>
+            <a:off x="8617288" y="457197"/>
+            <a:ext cx="58597" cy="0"/>
+          </a:xfrm>
+          <a:prstGeom prst="line">
+            <a:avLst/>
+          </a:prstGeom>
+          <a:ln w="28575">
+            <a:solidFill>
+              <a:schemeClr val="bg1">
+                <a:lumMod val="65000"/>
+              </a:schemeClr>
+            </a:solidFill>
+          </a:ln>
+        </p:spPr>
+        <p:style>
+          <a:lnRef idx="1">
+            <a:schemeClr val="accent1"/>
+          </a:lnRef>
+          <a:fillRef idx="0">
+            <a:schemeClr val="accent1"/>
+          </a:fillRef>
+          <a:effectRef idx="0">
+            <a:schemeClr val="accent1"/>
+          </a:effectRef>
+          <a:fontRef idx="minor">
+            <a:schemeClr val="tx1"/>
+          </a:fontRef>
+        </p:style>
+      </p:cxnSp>
+      <p:cxnSp>
+        <p:nvCxnSpPr>
+          <p:cNvPr id="63" name="직선 연결선 62"/>
+          <p:cNvCxnSpPr/>
+          <p:nvPr/>
+        </p:nvCxnSpPr>
+        <p:spPr>
+          <a:xfrm>
+            <a:off x="8695307" y="457197"/>
+            <a:ext cx="58597" cy="0"/>
+          </a:xfrm>
+          <a:prstGeom prst="line">
+            <a:avLst/>
+          </a:prstGeom>
+          <a:ln w="28575">
+            <a:solidFill>
+              <a:schemeClr val="bg1">
+                <a:lumMod val="65000"/>
+              </a:schemeClr>
+            </a:solidFill>
+          </a:ln>
+        </p:spPr>
+        <p:style>
+          <a:lnRef idx="1">
+            <a:schemeClr val="accent1"/>
+          </a:lnRef>
+          <a:fillRef idx="0">
+            <a:schemeClr val="accent1"/>
+          </a:fillRef>
+          <a:effectRef idx="0">
+            <a:schemeClr val="accent1"/>
+          </a:effectRef>
+          <a:fontRef idx="minor">
+            <a:schemeClr val="tx1"/>
+          </a:fontRef>
+        </p:style>
+      </p:cxnSp>
+      <p:cxnSp>
+        <p:nvCxnSpPr>
+          <p:cNvPr id="64" name="직선 연결선 63"/>
+          <p:cNvCxnSpPr/>
+          <p:nvPr/>
+        </p:nvCxnSpPr>
+        <p:spPr>
+          <a:xfrm>
+            <a:off x="8773326" y="457197"/>
+            <a:ext cx="58597" cy="0"/>
+          </a:xfrm>
+          <a:prstGeom prst="line">
+            <a:avLst/>
+          </a:prstGeom>
+          <a:ln w="28575">
+            <a:solidFill>
+              <a:schemeClr val="bg1">
+                <a:lumMod val="65000"/>
+              </a:schemeClr>
+            </a:solidFill>
+          </a:ln>
+        </p:spPr>
+        <p:style>
+          <a:lnRef idx="1">
+            <a:schemeClr val="accent1"/>
+          </a:lnRef>
+          <a:fillRef idx="0">
+            <a:schemeClr val="accent1"/>
+          </a:fillRef>
+          <a:effectRef idx="0">
+            <a:schemeClr val="accent1"/>
+          </a:effectRef>
+          <a:fontRef idx="minor">
+            <a:schemeClr val="tx1"/>
+          </a:fontRef>
+        </p:style>
+      </p:cxnSp>
+      <p:cxnSp>
+        <p:nvCxnSpPr>
+          <p:cNvPr id="67" name="직선 연결선 66"/>
+          <p:cNvCxnSpPr/>
+          <p:nvPr/>
+        </p:nvCxnSpPr>
+        <p:spPr>
+          <a:xfrm>
+            <a:off x="8851345" y="457197"/>
+            <a:ext cx="58597" cy="0"/>
+          </a:xfrm>
+          <a:prstGeom prst="line">
+            <a:avLst/>
+          </a:prstGeom>
+          <a:ln w="28575">
+            <a:solidFill>
+              <a:schemeClr val="bg1">
+                <a:lumMod val="65000"/>
+              </a:schemeClr>
+            </a:solidFill>
+          </a:ln>
+        </p:spPr>
+        <p:style>
+          <a:lnRef idx="1">
+            <a:schemeClr val="accent1"/>
+          </a:lnRef>
+          <a:fillRef idx="0">
+            <a:schemeClr val="accent1"/>
+          </a:fillRef>
+          <a:effectRef idx="0">
+            <a:schemeClr val="accent1"/>
+          </a:effectRef>
+          <a:fontRef idx="minor">
+            <a:schemeClr val="tx1"/>
+          </a:fontRef>
+        </p:style>
+      </p:cxnSp>
+      <p:cxnSp>
+        <p:nvCxnSpPr>
+          <p:cNvPr id="97" name="직선 연결선 96"/>
+          <p:cNvCxnSpPr/>
+          <p:nvPr/>
+        </p:nvCxnSpPr>
+        <p:spPr>
+          <a:xfrm>
+            <a:off x="8929364" y="457197"/>
+            <a:ext cx="58597" cy="0"/>
+          </a:xfrm>
+          <a:prstGeom prst="line">
+            <a:avLst/>
+          </a:prstGeom>
+          <a:ln w="28575">
+            <a:solidFill>
+              <a:schemeClr val="bg1">
+                <a:lumMod val="65000"/>
+              </a:schemeClr>
+            </a:solidFill>
+          </a:ln>
+        </p:spPr>
+        <p:style>
+          <a:lnRef idx="1">
+            <a:schemeClr val="accent1"/>
+          </a:lnRef>
+          <a:fillRef idx="0">
+            <a:schemeClr val="accent1"/>
+          </a:fillRef>
+          <a:effectRef idx="0">
+            <a:schemeClr val="accent1"/>
+          </a:effectRef>
+          <a:fontRef idx="minor">
+            <a:schemeClr val="tx1"/>
+          </a:fontRef>
+        </p:style>
+      </p:cxnSp>
+      <p:cxnSp>
+        <p:nvCxnSpPr>
+          <p:cNvPr id="98" name="직선 연결선 97"/>
+          <p:cNvCxnSpPr/>
+          <p:nvPr/>
+        </p:nvCxnSpPr>
+        <p:spPr>
+          <a:xfrm>
+            <a:off x="9007383" y="457197"/>
+            <a:ext cx="58597" cy="0"/>
+          </a:xfrm>
+          <a:prstGeom prst="line">
+            <a:avLst/>
+          </a:prstGeom>
+          <a:ln w="28575">
+            <a:solidFill>
+              <a:schemeClr val="bg1">
+                <a:lumMod val="65000"/>
+              </a:schemeClr>
+            </a:solidFill>
+          </a:ln>
+        </p:spPr>
+        <p:style>
+          <a:lnRef idx="1">
+            <a:schemeClr val="accent1"/>
+          </a:lnRef>
+          <a:fillRef idx="0">
+            <a:schemeClr val="accent1"/>
+          </a:fillRef>
+          <a:effectRef idx="0">
+            <a:schemeClr val="accent1"/>
+          </a:effectRef>
+          <a:fontRef idx="minor">
+            <a:schemeClr val="tx1"/>
+          </a:fontRef>
+        </p:style>
+      </p:cxnSp>
+      <p:cxnSp>
+        <p:nvCxnSpPr>
+          <p:cNvPr id="101" name="직선 연결선 100"/>
+          <p:cNvCxnSpPr/>
+          <p:nvPr/>
+        </p:nvCxnSpPr>
+        <p:spPr>
+          <a:xfrm>
+            <a:off x="9085403" y="457197"/>
+            <a:ext cx="58597" cy="0"/>
+          </a:xfrm>
+          <a:prstGeom prst="line">
+            <a:avLst/>
+          </a:prstGeom>
+          <a:ln w="28575">
+            <a:solidFill>
+              <a:schemeClr val="bg1">
+                <a:lumMod val="65000"/>
+              </a:schemeClr>
+            </a:solidFill>
+          </a:ln>
+        </p:spPr>
+        <p:style>
+          <a:lnRef idx="1">
+            <a:schemeClr val="accent1"/>
+          </a:lnRef>
+          <a:fillRef idx="0">
+            <a:schemeClr val="accent1"/>
+          </a:fillRef>
+          <a:effectRef idx="0">
+            <a:schemeClr val="accent1"/>
+          </a:effectRef>
+          <a:fontRef idx="minor">
+            <a:schemeClr val="tx1"/>
+          </a:fontRef>
+        </p:style>
+      </p:cxnSp>
+      <p:sp>
+        <p:nvSpPr>
+          <p:cNvPr id="4" name="직사각형 3"/>
+          <p:cNvSpPr/>
+          <p:nvPr/>
+        </p:nvSpPr>
+        <p:spPr>
+          <a:xfrm>
+            <a:off x="6291415" y="180689"/>
+            <a:ext cx="1541832" cy="276999"/>
+          </a:xfrm>
+          <a:prstGeom prst="rect">
+            <a:avLst/>
+          </a:prstGeom>
+        </p:spPr>
+        <p:txBody>
+          <a:bodyPr wrap="none">
+            <a:spAutoFit/>
+          </a:bodyPr>
+          <a:lstStyle/>
+          <a:p>
+            <a:r>
+              <a:rPr lang="en-US" altLang="ko-KR" sz="1200" b="1" dirty="0"/>
+              <a:t>(Where to locate?)</a:t>
+            </a:r>
+            <a:endParaRPr lang="ko-KR" altLang="en-US" sz="1200" dirty="0"/>
+          </a:p>
+        </p:txBody>
+      </p:sp>
+      <p:sp>
+        <p:nvSpPr>
+          <p:cNvPr id="102" name="Rectangle 101"/>
+          <p:cNvSpPr/>
+          <p:nvPr/>
+        </p:nvSpPr>
+        <p:spPr>
+          <a:xfrm>
+            <a:off x="246888" y="1042415"/>
+            <a:ext cx="4480560" cy="274320"/>
+          </a:xfrm>
+          <a:prstGeom prst="rect">
+            <a:avLst/>
+          </a:prstGeom>
+          <a:solidFill>
+            <a:srgbClr val="404040"/>
+          </a:solidFill>
+          <a:ln w="6350">
+            <a:solidFill>
+              <a:srgbClr val="404040"/>
+            </a:solidFill>
+          </a:ln>
+          <a:effectLst/>
+        </p:spPr>
+        <p:txBody>
+          <a:bodyPr rtlCol="0" anchor="ctr" wrap="square" lIns="64008" tIns="27432" rIns="45720" bIns="27432"/>
+          <a:lstStyle/>
+          <a:p>
+            <a:pPr algn="l"/>
+            <a:r>
+              <a:rPr sz="950" b="1">
+                <a:solidFill>
+                  <a:srgbClr val="FFFFFF"/>
+                </a:solidFill>
+                <a:latin typeface="맑은 고딕"/>
+                <a:ea typeface="맑은 고딕"/>
+              </a:rPr>
+              <a:t>현재 2안 (보완 전): 레플리카 상태 비공유</a:t>
+            </a:r>
+          </a:p>
+        </p:txBody>
+      </p:sp>
+      <p:sp>
+        <p:nvSpPr>
+          <p:cNvPr id="103" name="Rectangle 102"/>
+          <p:cNvSpPr/>
+          <p:nvPr/>
+        </p:nvSpPr>
+        <p:spPr>
+          <a:xfrm>
+            <a:off x="246888" y="1316736"/>
+            <a:ext cx="4480560" cy="2743200"/>
+          </a:xfrm>
+          <a:prstGeom prst="rect">
+            <a:avLst/>
+          </a:prstGeom>
+          <a:solidFill>
+            <a:srgbClr val="FFFFFF"/>
+          </a:solidFill>
+          <a:ln w="6350">
+            <a:solidFill>
+              <a:srgbClr val="BFBFBF"/>
+            </a:solidFill>
+          </a:ln>
+          <a:effectLst/>
+        </p:spPr>
+        <p:txBody>
+          <a:bodyPr rtlCol="0" anchor="ctr"/>
+          <a:lstStyle/>
+          <a:p>
+            <a:pPr algn="ctr"/>
+          </a:p>
+        </p:txBody>
+      </p:sp>
+      <p:sp>
+        <p:nvSpPr>
+          <p:cNvPr id="104" name="Rectangle 103"/>
+          <p:cNvSpPr/>
+          <p:nvPr/>
+        </p:nvSpPr>
+        <p:spPr>
+          <a:xfrm>
+            <a:off x="384048" y="2103120"/>
+            <a:ext cx="822960" cy="384048"/>
+          </a:xfrm>
+          <a:prstGeom prst="rect">
+            <a:avLst/>
+          </a:prstGeom>
+          <a:solidFill>
+            <a:srgbClr val="FFFFFF"/>
+          </a:solidFill>
+          <a:ln w="12700">
+            <a:solidFill>
+              <a:srgbClr val="7F7F7F"/>
+            </a:solidFill>
+          </a:ln>
+          <a:effectLst/>
+        </p:spPr>
+        <p:txBody>
+          <a:bodyPr rtlCol="0" anchor="ctr" wrap="square" lIns="36576" tIns="18288" rIns="36576" bIns="18288"/>
+          <a:lstStyle/>
+          <a:p>
+            <a:pPr algn="ctr"/>
+            <a:r>
+              <a:rPr sz="800" b="1">
+                <a:solidFill>
+                  <a:srgbClr val="000000"/>
+                </a:solidFill>
+                <a:latin typeface="맑은 고딕"/>
+                <a:ea typeface="맑은 고딕"/>
+              </a:rPr>
+              <a:t>L4 LB</a:t>
+            </a:r>
+          </a:p>
+        </p:txBody>
+      </p:sp>
+      <p:sp>
+        <p:nvSpPr>
+          <p:cNvPr id="105" name="Rectangle 104"/>
+          <p:cNvSpPr/>
+          <p:nvPr/>
+        </p:nvSpPr>
+        <p:spPr>
+          <a:xfrm>
+            <a:off x="1572768" y="1572768"/>
+            <a:ext cx="1325880" cy="566928"/>
+          </a:xfrm>
+          <a:prstGeom prst="rect">
+            <a:avLst/>
+          </a:prstGeom>
+          <a:solidFill>
+            <a:srgbClr val="FBE5D6"/>
+          </a:solidFill>
+          <a:ln w="15875">
+            <a:solidFill>
+              <a:srgbClr val="C55A11"/>
+            </a:solidFill>
+          </a:ln>
+          <a:effectLst/>
+        </p:spPr>
+        <p:txBody>
+          <a:bodyPr rtlCol="0" anchor="ctr" wrap="square" lIns="36576" tIns="18288" rIns="36576" bIns="18288"/>
+          <a:lstStyle/>
+          <a:p>
+            <a:pPr algn="ctr"/>
+            <a:r>
+              <a:rPr sz="800" b="1">
+                <a:solidFill>
+                  <a:srgbClr val="000000"/>
+                </a:solidFill>
+                <a:latin typeface="맑은 고딕"/>
+                <a:ea typeface="맑은 고딕"/>
+              </a:rPr>
+              <a:t>Router 레플리카 1</a:t>
+            </a:r>
+          </a:p>
+          <a:p>
+            <a:pPr algn="ctr"/>
+            <a:r>
+              <a:rPr sz="700" b="0">
+                <a:solidFill>
+                  <a:srgbClr val="404040"/>
+                </a:solidFill>
+                <a:latin typeface="맑은 고딕"/>
+                <a:ea typeface="맑은 고딕"/>
+              </a:rPr>
+              <a:t>전체 서버 N대의</a:t>
+            </a:r>
+          </a:p>
+          <a:p>
+            <a:pPr algn="ctr"/>
+            <a:r>
+              <a:rPr sz="700" b="0">
+                <a:solidFill>
+                  <a:srgbClr val="C00000"/>
+                </a:solidFill>
+                <a:latin typeface="맑은 고딕"/>
+                <a:ea typeface="맑은 고딕"/>
+              </a:rPr>
+              <a:t>이벤트·메트릭 전부 처리</a:t>
+            </a:r>
+          </a:p>
+        </p:txBody>
+      </p:sp>
+      <p:cxnSp>
+        <p:nvCxnSpPr>
+          <p:cNvPr id="106" name="Connector 105"/>
+          <p:cNvCxnSpPr/>
+          <p:nvPr/>
+        </p:nvCxnSpPr>
+        <p:spPr>
+          <a:xfrm flipV="1">
+            <a:off x="1207008" y="1856231"/>
+            <a:ext cx="365760" cy="438913"/>
+          </a:xfrm>
+          <a:prstGeom prst="line">
+            <a:avLst/>
+          </a:prstGeom>
+          <a:ln w="12700">
+            <a:solidFill>
+              <a:srgbClr val="404040"/>
+            </a:solidFill>
+            <a:tailEnd type="triangle"/>
+          </a:ln>
+        </p:spPr>
+      </p:cxnSp>
+      <p:sp>
+        <p:nvSpPr>
+          <p:cNvPr id="107" name="Rectangle 106"/>
+          <p:cNvSpPr/>
+          <p:nvPr/>
+        </p:nvSpPr>
+        <p:spPr>
+          <a:xfrm>
+            <a:off x="1572768" y="2578608"/>
+            <a:ext cx="1325880" cy="566928"/>
+          </a:xfrm>
+          <a:prstGeom prst="rect">
+            <a:avLst/>
+          </a:prstGeom>
+          <a:solidFill>
+            <a:srgbClr val="FBE5D6"/>
+          </a:solidFill>
+          <a:ln w="15875">
+            <a:solidFill>
+              <a:srgbClr val="C55A11"/>
+            </a:solidFill>
+          </a:ln>
+          <a:effectLst/>
+        </p:spPr>
+        <p:txBody>
+          <a:bodyPr rtlCol="0" anchor="ctr" wrap="square" lIns="36576" tIns="18288" rIns="36576" bIns="18288"/>
+          <a:lstStyle/>
+          <a:p>
+            <a:pPr algn="ctr"/>
+            <a:r>
+              <a:rPr sz="800" b="1">
+                <a:solidFill>
+                  <a:srgbClr val="000000"/>
+                </a:solidFill>
+                <a:latin typeface="맑은 고딕"/>
+                <a:ea typeface="맑은 고딕"/>
+              </a:rPr>
+              <a:t>Router 레플리카 2</a:t>
+            </a:r>
+          </a:p>
+          <a:p>
+            <a:pPr algn="ctr"/>
+            <a:r>
+              <a:rPr sz="700" b="0">
+                <a:solidFill>
+                  <a:srgbClr val="404040"/>
+                </a:solidFill>
+                <a:latin typeface="맑은 고딕"/>
+                <a:ea typeface="맑은 고딕"/>
+              </a:rPr>
+              <a:t>전체 서버 N대의</a:t>
+            </a:r>
+          </a:p>
+          <a:p>
+            <a:pPr algn="ctr"/>
+            <a:r>
+              <a:rPr sz="700" b="0">
+                <a:solidFill>
+                  <a:srgbClr val="C00000"/>
+                </a:solidFill>
+                <a:latin typeface="맑은 고딕"/>
+                <a:ea typeface="맑은 고딕"/>
+              </a:rPr>
+              <a:t>이벤트·메트릭 전부 처리</a:t>
+            </a:r>
+          </a:p>
+        </p:txBody>
+      </p:sp>
+      <p:cxnSp>
+        <p:nvCxnSpPr>
+          <p:cNvPr id="108" name="Connector 107"/>
+          <p:cNvCxnSpPr/>
+          <p:nvPr/>
+        </p:nvCxnSpPr>
+        <p:spPr>
+          <a:xfrm>
+            <a:off x="1207008" y="2295144"/>
+            <a:ext cx="365760" cy="566928"/>
+          </a:xfrm>
+          <a:prstGeom prst="line">
+            <a:avLst/>
+          </a:prstGeom>
+          <a:ln w="12700">
+            <a:solidFill>
+              <a:srgbClr val="404040"/>
+            </a:solidFill>
+            <a:tailEnd type="triangle"/>
+          </a:ln>
+        </p:spPr>
+      </p:cxnSp>
+      <p:sp>
+        <p:nvSpPr>
+          <p:cNvPr id="109" name="Rectangle 108"/>
+          <p:cNvSpPr/>
+          <p:nvPr/>
+        </p:nvSpPr>
+        <p:spPr>
+          <a:xfrm>
+            <a:off x="3630168" y="1481328"/>
+            <a:ext cx="868680" cy="310896"/>
+          </a:xfrm>
+          <a:prstGeom prst="rect">
+            <a:avLst/>
+          </a:prstGeom>
+          <a:solidFill>
+            <a:srgbClr val="D9D9D9"/>
+          </a:solidFill>
+          <a:ln w="12700">
+            <a:solidFill>
+              <a:srgbClr val="7F7F7F"/>
+            </a:solidFill>
+          </a:ln>
+          <a:effectLst/>
+        </p:spPr>
+        <p:txBody>
+          <a:bodyPr rtlCol="0" anchor="ctr" wrap="square" lIns="36576" tIns="18288" rIns="36576" bIns="18288"/>
+          <a:lstStyle/>
+          <a:p>
+            <a:pPr algn="ctr"/>
+            <a:r>
+              <a:rPr sz="750" b="1">
+                <a:solidFill>
+                  <a:srgbClr val="000000"/>
+                </a:solidFill>
+                <a:latin typeface="맑은 고딕"/>
+                <a:ea typeface="맑은 고딕"/>
+              </a:rPr>
+              <a:t>vLLM 1</a:t>
+            </a:r>
+          </a:p>
+        </p:txBody>
+      </p:sp>
+      <p:sp>
+        <p:nvSpPr>
+          <p:cNvPr id="110" name="Rectangle 109"/>
+          <p:cNvSpPr/>
+          <p:nvPr/>
+        </p:nvSpPr>
+        <p:spPr>
+          <a:xfrm>
+            <a:off x="3630168" y="1920240"/>
+            <a:ext cx="868680" cy="310896"/>
+          </a:xfrm>
+          <a:prstGeom prst="rect">
+            <a:avLst/>
+          </a:prstGeom>
+          <a:solidFill>
+            <a:srgbClr val="D9D9D9"/>
+          </a:solidFill>
+          <a:ln w="12700">
+            <a:solidFill>
+              <a:srgbClr val="7F7F7F"/>
+            </a:solidFill>
+          </a:ln>
+          <a:effectLst/>
+        </p:spPr>
+        <p:txBody>
+          <a:bodyPr rtlCol="0" anchor="ctr" wrap="square" lIns="36576" tIns="18288" rIns="36576" bIns="18288"/>
+          <a:lstStyle/>
+          <a:p>
+            <a:pPr algn="ctr"/>
+            <a:r>
+              <a:rPr sz="750" b="1">
+                <a:solidFill>
+                  <a:srgbClr val="000000"/>
+                </a:solidFill>
+                <a:latin typeface="맑은 고딕"/>
+                <a:ea typeface="맑은 고딕"/>
+              </a:rPr>
+              <a:t>vLLM 2</a:t>
+            </a:r>
+          </a:p>
+        </p:txBody>
+      </p:sp>
+      <p:sp>
+        <p:nvSpPr>
+          <p:cNvPr id="111" name="Rectangle 110"/>
+          <p:cNvSpPr/>
+          <p:nvPr/>
+        </p:nvSpPr>
+        <p:spPr>
+          <a:xfrm>
+            <a:off x="3630168" y="2359152"/>
+            <a:ext cx="868680" cy="310896"/>
+          </a:xfrm>
+          <a:prstGeom prst="rect">
+            <a:avLst/>
+          </a:prstGeom>
+          <a:solidFill>
+            <a:srgbClr val="D9D9D9"/>
+          </a:solidFill>
+          <a:ln w="12700">
+            <a:solidFill>
+              <a:srgbClr val="7F7F7F"/>
+            </a:solidFill>
+          </a:ln>
+          <a:effectLst/>
+        </p:spPr>
+        <p:txBody>
+          <a:bodyPr rtlCol="0" anchor="ctr" wrap="square" lIns="36576" tIns="18288" rIns="36576" bIns="18288"/>
+          <a:lstStyle/>
+          <a:p>
+            <a:pPr algn="ctr"/>
+            <a:r>
+              <a:rPr sz="750" b="1">
+                <a:solidFill>
+                  <a:srgbClr val="000000"/>
+                </a:solidFill>
+                <a:latin typeface="맑은 고딕"/>
+                <a:ea typeface="맑은 고딕"/>
+              </a:rPr>
+              <a:t>…</a:t>
+            </a:r>
+          </a:p>
+        </p:txBody>
+      </p:sp>
+      <p:sp>
+        <p:nvSpPr>
+          <p:cNvPr id="112" name="Rectangle 111"/>
+          <p:cNvSpPr/>
+          <p:nvPr/>
+        </p:nvSpPr>
+        <p:spPr>
+          <a:xfrm>
+            <a:off x="3630168" y="2798064"/>
+            <a:ext cx="868680" cy="310896"/>
+          </a:xfrm>
+          <a:prstGeom prst="rect">
+            <a:avLst/>
+          </a:prstGeom>
+          <a:solidFill>
+            <a:srgbClr val="D9D9D9"/>
+          </a:solidFill>
+          <a:ln w="12700">
+            <a:solidFill>
+              <a:srgbClr val="7F7F7F"/>
+            </a:solidFill>
+          </a:ln>
+          <a:effectLst/>
+        </p:spPr>
+        <p:txBody>
+          <a:bodyPr rtlCol="0" anchor="ctr" wrap="square" lIns="36576" tIns="18288" rIns="36576" bIns="18288"/>
+          <a:lstStyle/>
+          <a:p>
+            <a:pPr algn="ctr"/>
+            <a:r>
+              <a:rPr sz="750" b="1">
+                <a:solidFill>
+                  <a:srgbClr val="000000"/>
+                </a:solidFill>
+                <a:latin typeface="맑은 고딕"/>
+                <a:ea typeface="맑은 고딕"/>
+              </a:rPr>
+              <a:t>vLLM N-1</a:t>
+            </a:r>
+          </a:p>
+        </p:txBody>
+      </p:sp>
+      <p:sp>
+        <p:nvSpPr>
+          <p:cNvPr id="113" name="Rectangle 112"/>
+          <p:cNvSpPr/>
+          <p:nvPr/>
+        </p:nvSpPr>
+        <p:spPr>
+          <a:xfrm>
+            <a:off x="3630168" y="3236976"/>
+            <a:ext cx="868680" cy="310896"/>
+          </a:xfrm>
+          <a:prstGeom prst="rect">
+            <a:avLst/>
+          </a:prstGeom>
+          <a:solidFill>
+            <a:srgbClr val="D9D9D9"/>
+          </a:solidFill>
+          <a:ln w="12700">
+            <a:solidFill>
+              <a:srgbClr val="7F7F7F"/>
+            </a:solidFill>
+          </a:ln>
+          <a:effectLst/>
+        </p:spPr>
+        <p:txBody>
+          <a:bodyPr rtlCol="0" anchor="ctr" wrap="square" lIns="36576" tIns="18288" rIns="36576" bIns="18288"/>
+          <a:lstStyle/>
+          <a:p>
+            <a:pPr algn="ctr"/>
+            <a:r>
+              <a:rPr sz="750" b="1">
+                <a:solidFill>
+                  <a:srgbClr val="000000"/>
+                </a:solidFill>
+                <a:latin typeface="맑은 고딕"/>
+                <a:ea typeface="맑은 고딕"/>
+              </a:rPr>
+              <a:t>vLLM N</a:t>
+            </a:r>
+          </a:p>
+        </p:txBody>
+      </p:sp>
+      <p:cxnSp>
+        <p:nvCxnSpPr>
+          <p:cNvPr id="114" name="Connector 113"/>
+          <p:cNvCxnSpPr/>
+          <p:nvPr/>
+        </p:nvCxnSpPr>
+        <p:spPr>
+          <a:xfrm flipV="1">
+            <a:off x="2898648" y="1636776"/>
+            <a:ext cx="731520" cy="219455"/>
+          </a:xfrm>
+          <a:prstGeom prst="line">
+            <a:avLst/>
+          </a:prstGeom>
+          <a:ln w="7620">
+            <a:solidFill>
+              <a:srgbClr val="C9A58A"/>
+            </a:solidFill>
+            <a:tailEnd type="triangle"/>
+          </a:ln>
+        </p:spPr>
+      </p:cxnSp>
+      <p:cxnSp>
+        <p:nvCxnSpPr>
+          <p:cNvPr id="115" name="Connector 114"/>
+          <p:cNvCxnSpPr/>
+          <p:nvPr/>
+        </p:nvCxnSpPr>
+        <p:spPr>
+          <a:xfrm>
+            <a:off x="2898648" y="1856231"/>
+            <a:ext cx="731520" cy="219457"/>
+          </a:xfrm>
+          <a:prstGeom prst="line">
+            <a:avLst/>
+          </a:prstGeom>
+          <a:ln w="7620">
+            <a:solidFill>
+              <a:srgbClr val="C9A58A"/>
+            </a:solidFill>
+            <a:tailEnd type="triangle"/>
+          </a:ln>
+        </p:spPr>
+      </p:cxnSp>
+      <p:cxnSp>
+        <p:nvCxnSpPr>
+          <p:cNvPr id="116" name="Connector 115"/>
+          <p:cNvCxnSpPr/>
+          <p:nvPr/>
+        </p:nvCxnSpPr>
+        <p:spPr>
+          <a:xfrm>
+            <a:off x="2898648" y="1856231"/>
+            <a:ext cx="731520" cy="658369"/>
+          </a:xfrm>
+          <a:prstGeom prst="line">
+            <a:avLst/>
+          </a:prstGeom>
+          <a:ln w="7620">
+            <a:solidFill>
+              <a:srgbClr val="C9A58A"/>
+            </a:solidFill>
+            <a:tailEnd type="triangle"/>
+          </a:ln>
+        </p:spPr>
+      </p:cxnSp>
+      <p:cxnSp>
+        <p:nvCxnSpPr>
+          <p:cNvPr id="117" name="Connector 116"/>
+          <p:cNvCxnSpPr/>
+          <p:nvPr/>
+        </p:nvCxnSpPr>
+        <p:spPr>
+          <a:xfrm>
+            <a:off x="2898648" y="1856231"/>
+            <a:ext cx="731520" cy="1097281"/>
+          </a:xfrm>
+          <a:prstGeom prst="line">
+            <a:avLst/>
+          </a:prstGeom>
+          <a:ln w="7620">
+            <a:solidFill>
+              <a:srgbClr val="C9A58A"/>
+            </a:solidFill>
+            <a:tailEnd type="triangle"/>
+          </a:ln>
+        </p:spPr>
+      </p:cxnSp>
+      <p:cxnSp>
+        <p:nvCxnSpPr>
+          <p:cNvPr id="118" name="Connector 117"/>
+          <p:cNvCxnSpPr/>
+          <p:nvPr/>
+        </p:nvCxnSpPr>
+        <p:spPr>
+          <a:xfrm>
+            <a:off x="2898648" y="1856231"/>
+            <a:ext cx="731520" cy="1536193"/>
+          </a:xfrm>
+          <a:prstGeom prst="line">
+            <a:avLst/>
+          </a:prstGeom>
+          <a:ln w="7620">
+            <a:solidFill>
+              <a:srgbClr val="C9A58A"/>
+            </a:solidFill>
+            <a:tailEnd type="triangle"/>
+          </a:ln>
+        </p:spPr>
+      </p:cxnSp>
+      <p:cxnSp>
+        <p:nvCxnSpPr>
+          <p:cNvPr id="119" name="Connector 118"/>
+          <p:cNvCxnSpPr/>
+          <p:nvPr/>
+        </p:nvCxnSpPr>
+        <p:spPr>
+          <a:xfrm flipV="1">
+            <a:off x="2898648" y="1636776"/>
+            <a:ext cx="731520" cy="1225296"/>
+          </a:xfrm>
+          <a:prstGeom prst="line">
+            <a:avLst/>
+          </a:prstGeom>
+          <a:ln w="7620">
+            <a:solidFill>
+              <a:srgbClr val="C9A58A"/>
+            </a:solidFill>
+            <a:tailEnd type="triangle"/>
+          </a:ln>
+        </p:spPr>
+      </p:cxnSp>
+      <p:cxnSp>
+        <p:nvCxnSpPr>
+          <p:cNvPr id="120" name="Connector 119"/>
+          <p:cNvCxnSpPr/>
+          <p:nvPr/>
+        </p:nvCxnSpPr>
+        <p:spPr>
+          <a:xfrm flipV="1">
+            <a:off x="2898648" y="2075688"/>
+            <a:ext cx="731520" cy="786384"/>
+          </a:xfrm>
+          <a:prstGeom prst="line">
+            <a:avLst/>
+          </a:prstGeom>
+          <a:ln w="7620">
+            <a:solidFill>
+              <a:srgbClr val="C9A58A"/>
+            </a:solidFill>
+            <a:tailEnd type="triangle"/>
+          </a:ln>
+        </p:spPr>
+      </p:cxnSp>
+      <p:cxnSp>
+        <p:nvCxnSpPr>
+          <p:cNvPr id="121" name="Connector 120"/>
+          <p:cNvCxnSpPr/>
+          <p:nvPr/>
+        </p:nvCxnSpPr>
+        <p:spPr>
+          <a:xfrm flipV="1">
+            <a:off x="2898648" y="2514600"/>
+            <a:ext cx="731520" cy="347472"/>
+          </a:xfrm>
+          <a:prstGeom prst="line">
+            <a:avLst/>
+          </a:prstGeom>
+          <a:ln w="7620">
+            <a:solidFill>
+              <a:srgbClr val="C9A58A"/>
+            </a:solidFill>
+            <a:tailEnd type="triangle"/>
+          </a:ln>
+        </p:spPr>
+      </p:cxnSp>
+      <p:cxnSp>
+        <p:nvCxnSpPr>
+          <p:cNvPr id="122" name="Connector 121"/>
+          <p:cNvCxnSpPr/>
+          <p:nvPr/>
+        </p:nvCxnSpPr>
+        <p:spPr>
+          <a:xfrm>
+            <a:off x="2898648" y="2862072"/>
+            <a:ext cx="731520" cy="91440"/>
+          </a:xfrm>
+          <a:prstGeom prst="line">
+            <a:avLst/>
+          </a:prstGeom>
+          <a:ln w="7620">
+            <a:solidFill>
+              <a:srgbClr val="C9A58A"/>
+            </a:solidFill>
+            <a:tailEnd type="triangle"/>
+          </a:ln>
+        </p:spPr>
+      </p:cxnSp>
+      <p:cxnSp>
+        <p:nvCxnSpPr>
+          <p:cNvPr id="123" name="Connector 122"/>
+          <p:cNvCxnSpPr/>
+          <p:nvPr/>
+        </p:nvCxnSpPr>
+        <p:spPr>
+          <a:xfrm>
+            <a:off x="2898648" y="2862072"/>
+            <a:ext cx="731520" cy="530352"/>
+          </a:xfrm>
+          <a:prstGeom prst="line">
+            <a:avLst/>
+          </a:prstGeom>
+          <a:ln w="7620">
+            <a:solidFill>
+              <a:srgbClr val="C9A58A"/>
+            </a:solidFill>
+            <a:tailEnd type="triangle"/>
+          </a:ln>
+        </p:spPr>
+      </p:cxnSp>
+      <p:sp>
+        <p:nvSpPr>
+          <p:cNvPr id="124" name="TextBox 123"/>
+          <p:cNvSpPr txBox="1"/>
+          <p:nvPr/>
+        </p:nvSpPr>
+        <p:spPr>
+          <a:xfrm>
+            <a:off x="338328" y="3474720"/>
+            <a:ext cx="4297680" cy="548640"/>
+          </a:xfrm>
+          <a:prstGeom prst="rect">
+            <a:avLst/>
+          </a:prstGeom>
+          <a:noFill/>
+        </p:spPr>
+        <p:txBody>
+          <a:bodyPr wrap="square" anchor="t" lIns="0" tIns="0" rIns="0" bIns="0">
+            <a:spAutoFit/>
+          </a:bodyPr>
+          <a:lstStyle/>
+          <a:p>
+            <a:pPr algn="l"/>
+            <a:r>
+              <a:rPr sz="850" b="1">
+                <a:solidFill>
+                  <a:srgbClr val="C00000"/>
+                </a:solidFill>
+                <a:latin typeface="맑은 고딕"/>
+                <a:ea typeface="맑은 고딕"/>
+              </a:rPr>
+              <a:t>레플리카당 갱신 부하 ∝ N</a:t>
+            </a:r>
+          </a:p>
+          <a:p>
+            <a:pPr algn="l"/>
+            <a:r>
+              <a:rPr sz="750" b="0">
+                <a:solidFill>
+                  <a:srgbClr val="000000"/>
+                </a:solidFill>
+                <a:latin typeface="맑은 고딕"/>
+                <a:ea typeface="맑은 고딕"/>
+              </a:rPr>
+              <a:t>서버가 N배가 되면 레플리카마다 이벤트·메트릭을 N배 처리 → 결정 지연·상태 낡음 → goodput 포화 (SE(16) ≈ 64%, ★)</a:t>
+            </a:r>
+          </a:p>
+        </p:txBody>
+      </p:sp>
+      <p:sp>
+        <p:nvSpPr>
+          <p:cNvPr id="125" name="Rectangle 124"/>
+          <p:cNvSpPr/>
+          <p:nvPr/>
+        </p:nvSpPr>
+        <p:spPr>
+          <a:xfrm>
+            <a:off x="4892040" y="1042415"/>
+            <a:ext cx="7104888" cy="274320"/>
+          </a:xfrm>
+          <a:prstGeom prst="rect">
+            <a:avLst/>
+          </a:prstGeom>
+          <a:solidFill>
+            <a:srgbClr val="C55A11"/>
+          </a:solidFill>
+          <a:ln w="6350">
+            <a:solidFill>
+              <a:srgbClr val="C55A11"/>
+            </a:solidFill>
+          </a:ln>
+          <a:effectLst/>
+        </p:spPr>
+        <p:txBody>
+          <a:bodyPr rtlCol="0" anchor="ctr" wrap="square" lIns="64008" tIns="27432" rIns="45720" bIns="27432"/>
+          <a:lstStyle/>
+          <a:p>
+            <a:pPr algn="l"/>
+            <a:r>
+              <a:rPr sz="950" b="1">
+                <a:solidFill>
+                  <a:srgbClr val="FFFFFF"/>
+                </a:solidFill>
+                <a:latin typeface="맑은 고딕"/>
+                <a:ea typeface="맑은 고딕"/>
+              </a:rPr>
+              <a:t>보완 설계: 서버 샤딩 (Front Router + Shard Router)</a:t>
+            </a:r>
+          </a:p>
+        </p:txBody>
+      </p:sp>
+      <p:sp>
+        <p:nvSpPr>
+          <p:cNvPr id="126" name="Rectangle 125"/>
+          <p:cNvSpPr/>
+          <p:nvPr/>
+        </p:nvSpPr>
+        <p:spPr>
+          <a:xfrm>
+            <a:off x="4892040" y="1316736"/>
+            <a:ext cx="7104888" cy="2743200"/>
+          </a:xfrm>
+          <a:prstGeom prst="rect">
+            <a:avLst/>
+          </a:prstGeom>
+          <a:solidFill>
+            <a:srgbClr val="FFFFFF"/>
+          </a:solidFill>
+          <a:ln w="6350">
+            <a:solidFill>
+              <a:srgbClr val="BFBFBF"/>
+            </a:solidFill>
+          </a:ln>
+          <a:effectLst/>
+        </p:spPr>
+        <p:txBody>
+          <a:bodyPr rtlCol="0" anchor="ctr"/>
+          <a:lstStyle/>
+          <a:p>
+            <a:pPr algn="ctr"/>
+          </a:p>
+        </p:txBody>
+      </p:sp>
+      <p:sp>
+        <p:nvSpPr>
+          <p:cNvPr id="127" name="Rectangle 126"/>
+          <p:cNvSpPr/>
+          <p:nvPr/>
+        </p:nvSpPr>
+        <p:spPr>
+          <a:xfrm>
+            <a:off x="4983479" y="2103120"/>
+            <a:ext cx="566928" cy="310896"/>
+          </a:xfrm>
+          <a:prstGeom prst="rect">
+            <a:avLst/>
+          </a:prstGeom>
+          <a:solidFill>
+            <a:srgbClr val="FFFFFF"/>
+          </a:solidFill>
+          <a:ln w="12700">
+            <a:solidFill>
+              <a:srgbClr val="7F7F7F"/>
+            </a:solidFill>
+          </a:ln>
+          <a:effectLst/>
+        </p:spPr>
+        <p:txBody>
+          <a:bodyPr rtlCol="0" anchor="ctr" wrap="square" lIns="36576" tIns="18288" rIns="36576" bIns="18288"/>
+          <a:lstStyle/>
+          <a:p>
+            <a:pPr algn="ctr"/>
+            <a:r>
+              <a:rPr sz="750" b="1">
+                <a:solidFill>
+                  <a:srgbClr val="000000"/>
+                </a:solidFill>
+                <a:latin typeface="맑은 고딕"/>
+                <a:ea typeface="맑은 고딕"/>
+              </a:rPr>
+              <a:t>Client</a:t>
+            </a:r>
+          </a:p>
+        </p:txBody>
+      </p:sp>
+      <p:sp>
+        <p:nvSpPr>
+          <p:cNvPr id="128" name="Rectangle 127"/>
+          <p:cNvSpPr/>
+          <p:nvPr/>
+        </p:nvSpPr>
+        <p:spPr>
+          <a:xfrm>
+            <a:off x="5715000" y="2103120"/>
+            <a:ext cx="566928" cy="310896"/>
+          </a:xfrm>
+          <a:prstGeom prst="rect">
+            <a:avLst/>
+          </a:prstGeom>
+          <a:solidFill>
+            <a:srgbClr val="FFFFFF"/>
+          </a:solidFill>
+          <a:ln w="12700">
+            <a:solidFill>
+              <a:srgbClr val="7F7F7F"/>
+            </a:solidFill>
+          </a:ln>
+          <a:effectLst/>
+        </p:spPr>
+        <p:txBody>
+          <a:bodyPr rtlCol="0" anchor="ctr" wrap="square" lIns="36576" tIns="18288" rIns="36576" bIns="18288"/>
+          <a:lstStyle/>
+          <a:p>
+            <a:pPr algn="ctr"/>
+            <a:r>
+              <a:rPr sz="750" b="1">
+                <a:solidFill>
+                  <a:srgbClr val="000000"/>
+                </a:solidFill>
+                <a:latin typeface="맑은 고딕"/>
+                <a:ea typeface="맑은 고딕"/>
+              </a:rPr>
+              <a:t>L4 LB</a:t>
+            </a:r>
+          </a:p>
+        </p:txBody>
+      </p:sp>
+      <p:cxnSp>
+        <p:nvCxnSpPr>
+          <p:cNvPr id="129" name="Connector 128"/>
+          <p:cNvCxnSpPr/>
+          <p:nvPr/>
+        </p:nvCxnSpPr>
+        <p:spPr>
+          <a:xfrm>
+            <a:off x="5550407" y="2258568"/>
+            <a:ext cx="164593" cy="0"/>
+          </a:xfrm>
+          <a:prstGeom prst="line">
+            <a:avLst/>
+          </a:prstGeom>
+          <a:ln w="15875">
+            <a:solidFill>
+              <a:srgbClr val="404040"/>
+            </a:solidFill>
+            <a:tailEnd type="triangle"/>
+          </a:ln>
+        </p:spPr>
+      </p:cxnSp>
+      <p:sp>
+        <p:nvSpPr>
+          <p:cNvPr id="130" name="Rectangle 129"/>
+          <p:cNvSpPr/>
+          <p:nvPr/>
+        </p:nvSpPr>
+        <p:spPr>
+          <a:xfrm>
+            <a:off x="6492240" y="1463040"/>
+            <a:ext cx="1783080" cy="1600200"/>
+          </a:xfrm>
+          <a:prstGeom prst="rect">
+            <a:avLst/>
+          </a:prstGeom>
+          <a:solidFill>
+            <a:srgbClr val="FFFFFF"/>
+          </a:solidFill>
+          <a:ln w="15875">
+            <a:solidFill>
+              <a:srgbClr val="C55A11"/>
+            </a:solidFill>
+          </a:ln>
+          <a:effectLst/>
+        </p:spPr>
+        <p:txBody>
+          <a:bodyPr rtlCol="0" anchor="ctr"/>
+          <a:lstStyle/>
+          <a:p>
+            <a:pPr algn="ctr"/>
+          </a:p>
+        </p:txBody>
+      </p:sp>
+      <p:sp>
+        <p:nvSpPr>
+          <p:cNvPr id="131" name="Rectangle 130"/>
+          <p:cNvSpPr/>
+          <p:nvPr/>
+        </p:nvSpPr>
+        <p:spPr>
+          <a:xfrm>
+            <a:off x="6492240" y="1463040"/>
+            <a:ext cx="1783080" cy="173736"/>
+          </a:xfrm>
+          <a:prstGeom prst="rect">
+            <a:avLst/>
+          </a:prstGeom>
+          <a:solidFill>
+            <a:srgbClr val="C55A11"/>
+          </a:solidFill>
+          <a:ln w="12700">
+            <a:solidFill>
+              <a:srgbClr val="C55A11"/>
+            </a:solidFill>
+          </a:ln>
+          <a:effectLst/>
+        </p:spPr>
+        <p:txBody>
+          <a:bodyPr rtlCol="0" anchor="ctr" wrap="square" lIns="45720" tIns="0" rIns="18288" bIns="0"/>
+          <a:lstStyle/>
+          <a:p>
+            <a:pPr algn="l"/>
+            <a:r>
+              <a:rPr sz="800" b="1">
+                <a:solidFill>
+                  <a:srgbClr val="FFFFFF"/>
+                </a:solidFill>
+                <a:latin typeface="맑은 고딕"/>
+                <a:ea typeface="맑은 고딕"/>
+              </a:rPr>
+              <a:t>«process» Front Router ×K</a:t>
+            </a:r>
+          </a:p>
+        </p:txBody>
+      </p:sp>
+      <p:sp>
+        <p:nvSpPr>
+          <p:cNvPr id="132" name="Rectangle 131"/>
+          <p:cNvSpPr/>
+          <p:nvPr/>
+        </p:nvSpPr>
+        <p:spPr>
+          <a:xfrm>
+            <a:off x="6629400" y="1783080"/>
+            <a:ext cx="1508760" cy="457200"/>
+          </a:xfrm>
+          <a:prstGeom prst="rect">
+            <a:avLst/>
+          </a:prstGeom>
+          <a:solidFill>
+            <a:srgbClr val="FBE5D6"/>
+          </a:solidFill>
+          <a:ln w="12700">
+            <a:solidFill>
+              <a:srgbClr val="C55A11"/>
+            </a:solidFill>
+          </a:ln>
+          <a:effectLst/>
+        </p:spPr>
+        <p:txBody>
+          <a:bodyPr rtlCol="0" anchor="ctr" wrap="square" lIns="36576" tIns="18288" rIns="36576" bIns="18288"/>
+          <a:lstStyle/>
+          <a:p>
+            <a:pPr algn="ctr"/>
+            <a:r>
+              <a:rPr sz="750" b="1">
+                <a:solidFill>
+                  <a:srgbClr val="000000"/>
+                </a:solidFill>
+                <a:latin typeface="맑은 고딕"/>
+                <a:ea typeface="맑은 고딕"/>
+              </a:rPr>
+              <a:t>Shard Selector</a:t>
+            </a:r>
+          </a:p>
+          <a:p>
+            <a:pPr algn="ctr"/>
+            <a:r>
+              <a:rPr sz="650" b="0">
+                <a:solidFill>
+                  <a:srgbClr val="000000"/>
+                </a:solidFill>
+                <a:latin typeface="맑은 고딕"/>
+                <a:ea typeface="맑은 고딕"/>
+              </a:rPr>
+              <a:t>요약 테이블만 보고 샤드 선택</a:t>
+            </a:r>
+          </a:p>
+        </p:txBody>
+      </p:sp>
+      <p:sp>
+        <p:nvSpPr>
+          <p:cNvPr id="133" name="Rectangle 132"/>
+          <p:cNvSpPr/>
+          <p:nvPr/>
+        </p:nvSpPr>
+        <p:spPr>
+          <a:xfrm>
+            <a:off x="6583680" y="1874519"/>
+            <a:ext cx="91440" cy="54864"/>
+          </a:xfrm>
+          <a:prstGeom prst="rect">
+            <a:avLst/>
+          </a:prstGeom>
+          <a:solidFill>
+            <a:srgbClr val="FBE5D6"/>
+          </a:solidFill>
+          <a:ln w="9525">
+            <a:solidFill>
+              <a:srgbClr val="C55A11"/>
+            </a:solidFill>
+          </a:ln>
+          <a:effectLst/>
+        </p:spPr>
+        <p:txBody>
+          <a:bodyPr rtlCol="0" anchor="ctr"/>
+          <a:lstStyle/>
+          <a:p>
+            <a:pPr algn="ctr"/>
+          </a:p>
+        </p:txBody>
+      </p:sp>
+      <p:sp>
+        <p:nvSpPr>
+          <p:cNvPr id="134" name="Rectangle 133"/>
+          <p:cNvSpPr/>
+          <p:nvPr/>
+        </p:nvSpPr>
+        <p:spPr>
+          <a:xfrm>
+            <a:off x="6583680" y="2011680"/>
+            <a:ext cx="91440" cy="54864"/>
+          </a:xfrm>
+          <a:prstGeom prst="rect">
+            <a:avLst/>
+          </a:prstGeom>
+          <a:solidFill>
+            <a:srgbClr val="FBE5D6"/>
+          </a:solidFill>
+          <a:ln w="9525">
+            <a:solidFill>
+              <a:srgbClr val="C55A11"/>
+            </a:solidFill>
+          </a:ln>
+          <a:effectLst/>
+        </p:spPr>
+        <p:txBody>
+          <a:bodyPr rtlCol="0" anchor="ctr"/>
+          <a:lstStyle/>
+          <a:p>
+            <a:pPr algn="ctr"/>
+          </a:p>
+        </p:txBody>
+      </p:sp>
+      <p:sp>
+        <p:nvSpPr>
+          <p:cNvPr id="135" name="Rectangle 134"/>
+          <p:cNvSpPr/>
+          <p:nvPr/>
+        </p:nvSpPr>
+        <p:spPr>
+          <a:xfrm>
+            <a:off x="6629400" y="2377440"/>
+            <a:ext cx="1508760" cy="548640"/>
+          </a:xfrm>
+          <a:prstGeom prst="rect">
+            <a:avLst/>
+          </a:prstGeom>
+          <a:solidFill>
+            <a:srgbClr val="FBE5D6"/>
+          </a:solidFill>
+          <a:ln w="12700">
+            <a:solidFill>
+              <a:srgbClr val="C55A11"/>
+            </a:solidFill>
+          </a:ln>
+          <a:effectLst/>
+        </p:spPr>
+        <p:txBody>
+          <a:bodyPr rtlCol="0" anchor="ctr" wrap="square" lIns="36576" tIns="18288" rIns="36576" bIns="18288"/>
+          <a:lstStyle/>
+          <a:p>
+            <a:pPr algn="ctr"/>
+            <a:r>
+              <a:rPr sz="750" b="1">
+                <a:solidFill>
+                  <a:srgbClr val="000000"/>
+                </a:solidFill>
+                <a:latin typeface="맑은 고딕"/>
+                <a:ea typeface="맑은 고딕"/>
+              </a:rPr>
+              <a:t>요약 테이블</a:t>
+            </a:r>
+          </a:p>
+          <a:p>
+            <a:pPr algn="ctr"/>
+            <a:r>
+              <a:rPr sz="650" b="0">
+                <a:solidFill>
+                  <a:srgbClr val="000000"/>
+                </a:solidFill>
+                <a:latin typeface="맑은 고딕"/>
+                <a:ea typeface="맑은 고딕"/>
+              </a:rPr>
+              <a:t>샤드별 부하 · prefix sketch</a:t>
+            </a:r>
+          </a:p>
+          <a:p>
+            <a:pPr algn="ctr"/>
+            <a:r>
+              <a:rPr sz="650" b="0">
+                <a:solidFill>
+                  <a:srgbClr val="000000"/>
+                </a:solidFill>
+                <a:latin typeface="맑은 고딕"/>
+                <a:ea typeface="맑은 고딕"/>
+              </a:rPr>
+              <a:t>(~1 s 주기로 갱신)</a:t>
+            </a:r>
+          </a:p>
+        </p:txBody>
+      </p:sp>
+      <p:sp>
+        <p:nvSpPr>
+          <p:cNvPr id="136" name="Rectangle 135"/>
+          <p:cNvSpPr/>
+          <p:nvPr/>
+        </p:nvSpPr>
+        <p:spPr>
+          <a:xfrm>
+            <a:off x="6583680" y="2487168"/>
+            <a:ext cx="91440" cy="54864"/>
+          </a:xfrm>
+          <a:prstGeom prst="rect">
+            <a:avLst/>
+          </a:prstGeom>
+          <a:solidFill>
+            <a:srgbClr val="FBE5D6"/>
+          </a:solidFill>
+          <a:ln w="9525">
+            <a:solidFill>
+              <a:srgbClr val="C55A11"/>
+            </a:solidFill>
+          </a:ln>
+          <a:effectLst/>
+        </p:spPr>
+        <p:txBody>
+          <a:bodyPr rtlCol="0" anchor="ctr"/>
+          <a:lstStyle/>
+          <a:p>
+            <a:pPr algn="ctr"/>
+          </a:p>
+        </p:txBody>
+      </p:sp>
+      <p:sp>
+        <p:nvSpPr>
+          <p:cNvPr id="137" name="Rectangle 136"/>
+          <p:cNvSpPr/>
+          <p:nvPr/>
+        </p:nvSpPr>
+        <p:spPr>
+          <a:xfrm>
+            <a:off x="6583680" y="2651760"/>
+            <a:ext cx="91440" cy="54864"/>
+          </a:xfrm>
+          <a:prstGeom prst="rect">
+            <a:avLst/>
+          </a:prstGeom>
+          <a:solidFill>
+            <a:srgbClr val="FBE5D6"/>
+          </a:solidFill>
+          <a:ln w="9525">
+            <a:solidFill>
+              <a:srgbClr val="C55A11"/>
+            </a:solidFill>
+          </a:ln>
+          <a:effectLst/>
+        </p:spPr>
+        <p:txBody>
+          <a:bodyPr rtlCol="0" anchor="ctr"/>
+          <a:lstStyle/>
+          <a:p>
+            <a:pPr algn="ctr"/>
+          </a:p>
+        </p:txBody>
+      </p:sp>
+      <p:cxnSp>
+        <p:nvCxnSpPr>
+          <p:cNvPr id="138" name="Connector 137"/>
+          <p:cNvCxnSpPr/>
+          <p:nvPr/>
+        </p:nvCxnSpPr>
+        <p:spPr>
+          <a:xfrm>
+            <a:off x="6281927" y="2258568"/>
+            <a:ext cx="210313" cy="0"/>
+          </a:xfrm>
+          <a:prstGeom prst="line">
+            <a:avLst/>
+          </a:prstGeom>
+          <a:ln w="15875">
+            <a:solidFill>
+              <a:srgbClr val="404040"/>
+            </a:solidFill>
+            <a:tailEnd type="triangle"/>
+          </a:ln>
+        </p:spPr>
+      </p:cxnSp>
+      <p:sp>
+        <p:nvSpPr>
+          <p:cNvPr id="139" name="Rectangle 138"/>
+          <p:cNvSpPr/>
+          <p:nvPr/>
+        </p:nvSpPr>
+        <p:spPr>
+          <a:xfrm>
+            <a:off x="8641080" y="1417320"/>
+            <a:ext cx="2011680" cy="1188720"/>
+          </a:xfrm>
+          <a:prstGeom prst="rect">
+            <a:avLst/>
+          </a:prstGeom>
+          <a:solidFill>
+            <a:srgbClr val="FFFFFF"/>
+          </a:solidFill>
+          <a:ln w="15875">
+            <a:solidFill>
+              <a:srgbClr val="C55A11"/>
+            </a:solidFill>
+          </a:ln>
+          <a:effectLst/>
+        </p:spPr>
+        <p:txBody>
+          <a:bodyPr rtlCol="0" anchor="ctr"/>
+          <a:lstStyle/>
+          <a:p>
+            <a:pPr algn="ctr"/>
+          </a:p>
+        </p:txBody>
+      </p:sp>
+      <p:sp>
+        <p:nvSpPr>
+          <p:cNvPr id="140" name="Rectangle 139"/>
+          <p:cNvSpPr/>
+          <p:nvPr/>
+        </p:nvSpPr>
+        <p:spPr>
+          <a:xfrm>
+            <a:off x="8641080" y="1417320"/>
+            <a:ext cx="2011680" cy="173736"/>
+          </a:xfrm>
+          <a:prstGeom prst="rect">
+            <a:avLst/>
+          </a:prstGeom>
+          <a:solidFill>
+            <a:srgbClr val="C55A11"/>
+          </a:solidFill>
+          <a:ln w="12700">
+            <a:solidFill>
+              <a:srgbClr val="C55A11"/>
+            </a:solidFill>
+          </a:ln>
+          <a:effectLst/>
+        </p:spPr>
+        <p:txBody>
+          <a:bodyPr rtlCol="0" anchor="ctr" wrap="square" lIns="45720" tIns="0" rIns="18288" bIns="0"/>
+          <a:lstStyle/>
+          <a:p>
+            <a:pPr algn="l"/>
+            <a:r>
+              <a:rPr sz="800" b="1">
+                <a:solidFill>
+                  <a:srgbClr val="FFFFFF"/>
+                </a:solidFill>
+                <a:latin typeface="맑은 고딕"/>
+                <a:ea typeface="맑은 고딕"/>
+              </a:rPr>
+              <a:t>«process» Shard Router A</a:t>
+            </a:r>
+          </a:p>
+        </p:txBody>
+      </p:sp>
+      <p:sp>
+        <p:nvSpPr>
+          <p:cNvPr id="141" name="Rectangle 140"/>
+          <p:cNvSpPr/>
+          <p:nvPr/>
+        </p:nvSpPr>
+        <p:spPr>
+          <a:xfrm>
+            <a:off x="8750808" y="1691640"/>
+            <a:ext cx="914400" cy="384048"/>
+          </a:xfrm>
+          <a:prstGeom prst="rect">
+            <a:avLst/>
+          </a:prstGeom>
+          <a:solidFill>
+            <a:srgbClr val="FBE5D6"/>
+          </a:solidFill>
+          <a:ln w="12700">
+            <a:solidFill>
+              <a:srgbClr val="C55A11"/>
+            </a:solidFill>
+          </a:ln>
+          <a:effectLst/>
+        </p:spPr>
+        <p:txBody>
+          <a:bodyPr rtlCol="0" anchor="ctr" wrap="square" lIns="36576" tIns="18288" rIns="36576" bIns="18288"/>
+          <a:lstStyle/>
+          <a:p>
+            <a:pPr algn="ctr"/>
+            <a:r>
+              <a:rPr sz="750" b="1">
+                <a:solidFill>
+                  <a:srgbClr val="000000"/>
+                </a:solidFill>
+                <a:latin typeface="맑은 고딕"/>
+                <a:ea typeface="맑은 고딕"/>
+              </a:rPr>
+              <a:t>Pipeline</a:t>
+            </a:r>
+          </a:p>
+          <a:p>
+            <a:pPr algn="ctr"/>
+            <a:r>
+              <a:rPr sz="650" b="0">
+                <a:solidFill>
+                  <a:srgbClr val="000000"/>
+                </a:solidFill>
+                <a:latin typeface="맑은 고딕"/>
+                <a:ea typeface="맑은 고딕"/>
+              </a:rPr>
+              <a:t>Admission · Selector</a:t>
+            </a:r>
+          </a:p>
+          <a:p>
+            <a:pPr algn="ctr"/>
+            <a:r>
+              <a:rPr sz="650" b="0">
+                <a:solidFill>
+                  <a:srgbClr val="000000"/>
+                </a:solidFill>
+                <a:latin typeface="맑은 고딕"/>
+                <a:ea typeface="맑은 고딕"/>
+              </a:rPr>
+              <a:t>Dispatcher</a:t>
+            </a:r>
+          </a:p>
+        </p:txBody>
+      </p:sp>
+      <p:sp>
+        <p:nvSpPr>
+          <p:cNvPr id="142" name="Rectangle 141"/>
+          <p:cNvSpPr/>
+          <p:nvPr/>
+        </p:nvSpPr>
+        <p:spPr>
+          <a:xfrm>
+            <a:off x="8705088" y="1768449"/>
+            <a:ext cx="91440" cy="54864"/>
+          </a:xfrm>
+          <a:prstGeom prst="rect">
+            <a:avLst/>
+          </a:prstGeom>
+          <a:solidFill>
+            <a:srgbClr val="FBE5D6"/>
+          </a:solidFill>
+          <a:ln w="9525">
+            <a:solidFill>
+              <a:srgbClr val="C55A11"/>
+            </a:solidFill>
+          </a:ln>
+          <a:effectLst/>
+        </p:spPr>
+        <p:txBody>
+          <a:bodyPr rtlCol="0" anchor="ctr"/>
+          <a:lstStyle/>
+          <a:p>
+            <a:pPr algn="ctr"/>
+          </a:p>
+        </p:txBody>
+      </p:sp>
+      <p:sp>
+        <p:nvSpPr>
+          <p:cNvPr id="143" name="Rectangle 142"/>
+          <p:cNvSpPr/>
+          <p:nvPr/>
+        </p:nvSpPr>
+        <p:spPr>
+          <a:xfrm>
+            <a:off x="8705088" y="1883664"/>
+            <a:ext cx="91440" cy="54864"/>
+          </a:xfrm>
+          <a:prstGeom prst="rect">
+            <a:avLst/>
+          </a:prstGeom>
+          <a:solidFill>
+            <a:srgbClr val="FBE5D6"/>
+          </a:solidFill>
+          <a:ln w="9525">
+            <a:solidFill>
+              <a:srgbClr val="C55A11"/>
+            </a:solidFill>
+          </a:ln>
+          <a:effectLst/>
+        </p:spPr>
+        <p:txBody>
+          <a:bodyPr rtlCol="0" anchor="ctr"/>
+          <a:lstStyle/>
+          <a:p>
+            <a:pPr algn="ctr"/>
+          </a:p>
+        </p:txBody>
+      </p:sp>
+      <p:sp>
+        <p:nvSpPr>
+          <p:cNvPr id="144" name="Rectangle 143"/>
+          <p:cNvSpPr/>
+          <p:nvPr/>
+        </p:nvSpPr>
+        <p:spPr>
+          <a:xfrm>
+            <a:off x="9720072" y="1691640"/>
+            <a:ext cx="841248" cy="384048"/>
+          </a:xfrm>
+          <a:prstGeom prst="rect">
+            <a:avLst/>
+          </a:prstGeom>
+          <a:solidFill>
+            <a:srgbClr val="FBE5D6"/>
+          </a:solidFill>
+          <a:ln w="12700">
+            <a:solidFill>
+              <a:srgbClr val="C55A11"/>
+            </a:solidFill>
+          </a:ln>
+          <a:effectLst/>
+        </p:spPr>
+        <p:txBody>
+          <a:bodyPr rtlCol="0" anchor="ctr" wrap="square" lIns="36576" tIns="18288" rIns="36576" bIns="18288"/>
+          <a:lstStyle/>
+          <a:p>
+            <a:pPr algn="ctr"/>
+            <a:r>
+              <a:rPr sz="750" b="1">
+                <a:solidFill>
+                  <a:srgbClr val="000000"/>
+                </a:solidFill>
+                <a:latin typeface="맑은 고딕"/>
+                <a:ea typeface="맑은 고딕"/>
+              </a:rPr>
+              <a:t>State Plane</a:t>
+            </a:r>
+          </a:p>
+          <a:p>
+            <a:pPr algn="ctr"/>
+            <a:r>
+              <a:rPr sz="650" b="0">
+                <a:solidFill>
+                  <a:srgbClr val="000000"/>
+                </a:solidFill>
+                <a:latin typeface="맑은 고딕"/>
+                <a:ea typeface="맑은 고딕"/>
+              </a:rPr>
+              <a:t>담당 서버만</a:t>
+            </a:r>
+          </a:p>
+        </p:txBody>
+      </p:sp>
+      <p:sp>
+        <p:nvSpPr>
+          <p:cNvPr id="145" name="Rectangle 144"/>
+          <p:cNvSpPr/>
+          <p:nvPr/>
+        </p:nvSpPr>
+        <p:spPr>
+          <a:xfrm>
+            <a:off x="9674351" y="1768449"/>
+            <a:ext cx="91440" cy="54864"/>
+          </a:xfrm>
+          <a:prstGeom prst="rect">
+            <a:avLst/>
+          </a:prstGeom>
+          <a:solidFill>
+            <a:srgbClr val="FBE5D6"/>
+          </a:solidFill>
+          <a:ln w="9525">
+            <a:solidFill>
+              <a:srgbClr val="C55A11"/>
+            </a:solidFill>
+          </a:ln>
+          <a:effectLst/>
+        </p:spPr>
+        <p:txBody>
+          <a:bodyPr rtlCol="0" anchor="ctr"/>
+          <a:lstStyle/>
+          <a:p>
+            <a:pPr algn="ctr"/>
+          </a:p>
+        </p:txBody>
+      </p:sp>
+      <p:sp>
+        <p:nvSpPr>
+          <p:cNvPr id="146" name="Rectangle 145"/>
+          <p:cNvSpPr/>
+          <p:nvPr/>
+        </p:nvSpPr>
+        <p:spPr>
+          <a:xfrm>
+            <a:off x="9674351" y="1883664"/>
+            <a:ext cx="91440" cy="54864"/>
+          </a:xfrm>
+          <a:prstGeom prst="rect">
+            <a:avLst/>
+          </a:prstGeom>
+          <a:solidFill>
+            <a:srgbClr val="FBE5D6"/>
+          </a:solidFill>
+          <a:ln w="9525">
+            <a:solidFill>
+              <a:srgbClr val="C55A11"/>
+            </a:solidFill>
+          </a:ln>
+          <a:effectLst/>
+        </p:spPr>
+        <p:txBody>
+          <a:bodyPr rtlCol="0" anchor="ctr"/>
+          <a:lstStyle/>
+          <a:p>
+            <a:pPr algn="ctr"/>
+          </a:p>
+        </p:txBody>
+      </p:sp>
+      <p:sp>
+        <p:nvSpPr>
+          <p:cNvPr id="147" name="TextBox 146"/>
+          <p:cNvSpPr txBox="1"/>
+          <p:nvPr/>
+        </p:nvSpPr>
+        <p:spPr>
+          <a:xfrm>
+            <a:off x="8732520" y="2130552"/>
+            <a:ext cx="1828800" cy="457200"/>
+          </a:xfrm>
+          <a:prstGeom prst="rect">
+            <a:avLst/>
+          </a:prstGeom>
+          <a:noFill/>
+        </p:spPr>
+        <p:txBody>
+          <a:bodyPr wrap="square" anchor="t" lIns="0" tIns="0" rIns="0" bIns="0">
+            <a:spAutoFit/>
+          </a:bodyPr>
+          <a:lstStyle/>
+          <a:p>
+            <a:pPr algn="l"/>
+            <a:r>
+              <a:rPr sz="650" b="1">
+                <a:solidFill>
+                  <a:srgbClr val="000000"/>
+                </a:solidFill>
+                <a:latin typeface="맑은 고딕"/>
+                <a:ea typeface="맑은 고딕"/>
+              </a:rPr>
+              <a:t>담당 서버 1 ~ N/2</a:t>
+            </a:r>
+          </a:p>
+          <a:p>
+            <a:pPr algn="l"/>
+            <a:r>
+              <a:rPr sz="650" b="0">
+                <a:solidFill>
+                  <a:srgbClr val="5E35B1"/>
+                </a:solidFill>
+                <a:latin typeface="맑은 고딕"/>
+                <a:ea typeface="맑은 고딕"/>
+              </a:rPr>
+              <a:t>패턴(Strategy·Decorator·Adapter)은 샤드 안에서 그대로 재사용</a:t>
+            </a:r>
+          </a:p>
+        </p:txBody>
+      </p:sp>
+      <p:sp>
+        <p:nvSpPr>
+          <p:cNvPr id="148" name="Rectangle 147"/>
+          <p:cNvSpPr/>
+          <p:nvPr/>
+        </p:nvSpPr>
+        <p:spPr>
+          <a:xfrm>
+            <a:off x="10972800" y="1508760"/>
+            <a:ext cx="713232" cy="1005840"/>
+          </a:xfrm>
+          <a:prstGeom prst="rect">
+            <a:avLst/>
+          </a:prstGeom>
+          <a:solidFill>
+            <a:srgbClr val="D9D9D9"/>
+          </a:solidFill>
+          <a:ln w="12700">
+            <a:solidFill>
+              <a:srgbClr val="7F7F7F"/>
+            </a:solidFill>
+          </a:ln>
+          <a:effectLst/>
+        </p:spPr>
+        <p:txBody>
+          <a:bodyPr rtlCol="0" anchor="ctr" wrap="square" lIns="36576" tIns="18288" rIns="36576" bIns="18288"/>
+          <a:lstStyle/>
+          <a:p>
+            <a:pPr algn="ctr"/>
+            <a:r>
+              <a:rPr sz="750" b="1">
+                <a:solidFill>
+                  <a:srgbClr val="000000"/>
+                </a:solidFill>
+                <a:latin typeface="맑은 고딕"/>
+                <a:ea typeface="맑은 고딕"/>
+              </a:rPr>
+              <a:t>vLLM</a:t>
+            </a:r>
+          </a:p>
+          <a:p>
+            <a:pPr algn="ctr"/>
+            <a:r>
+              <a:rPr sz="700" b="0">
+                <a:solidFill>
+                  <a:srgbClr val="404040"/>
+                </a:solidFill>
+                <a:latin typeface="맑은 고딕"/>
+                <a:ea typeface="맑은 고딕"/>
+              </a:rPr>
+              <a:t>담당 서버</a:t>
+            </a:r>
+          </a:p>
+          <a:p>
+            <a:pPr algn="ctr"/>
+            <a:r>
+              <a:rPr sz="650" b="0">
+                <a:solidFill>
+                  <a:srgbClr val="404040"/>
+                </a:solidFill>
+                <a:latin typeface="맑은 고딕"/>
+                <a:ea typeface="맑은 고딕"/>
+              </a:rPr>
+              <a:t>KV 이벤트·</a:t>
+            </a:r>
+          </a:p>
+          <a:p>
+            <a:pPr algn="ctr"/>
+            <a:r>
+              <a:rPr sz="650" b="0">
+                <a:solidFill>
+                  <a:srgbClr val="404040"/>
+                </a:solidFill>
+                <a:latin typeface="맑은 고딕"/>
+                <a:ea typeface="맑은 고딕"/>
+              </a:rPr>
+              <a:t>/metrics는</a:t>
+            </a:r>
+          </a:p>
+          <a:p>
+            <a:pPr algn="ctr"/>
+            <a:r>
+              <a:rPr sz="650" b="0">
+                <a:solidFill>
+                  <a:srgbClr val="C00000"/>
+                </a:solidFill>
+                <a:latin typeface="맑은 고딕"/>
+                <a:ea typeface="맑은 고딕"/>
+              </a:rPr>
+              <a:t>이 샤드로만</a:t>
+            </a:r>
+          </a:p>
+        </p:txBody>
+      </p:sp>
+      <p:cxnSp>
+        <p:nvCxnSpPr>
+          <p:cNvPr id="149" name="Connector 148"/>
+          <p:cNvCxnSpPr/>
+          <p:nvPr/>
+        </p:nvCxnSpPr>
+        <p:spPr>
+          <a:xfrm>
+            <a:off x="10652759" y="2011680"/>
+            <a:ext cx="320041" cy="0"/>
+          </a:xfrm>
+          <a:prstGeom prst="line">
+            <a:avLst/>
+          </a:prstGeom>
+          <a:ln w="15875">
+            <a:solidFill>
+              <a:srgbClr val="404040"/>
+            </a:solidFill>
+            <a:headEnd type="triangle"/>
+            <a:tailEnd type="triangle"/>
+          </a:ln>
+        </p:spPr>
+      </p:cxnSp>
+      <p:sp>
+        <p:nvSpPr>
+          <p:cNvPr id="150" name="Rectangle 149"/>
+          <p:cNvSpPr/>
+          <p:nvPr/>
+        </p:nvSpPr>
+        <p:spPr>
+          <a:xfrm>
+            <a:off x="8641080" y="2788920"/>
+            <a:ext cx="2011680" cy="1188720"/>
+          </a:xfrm>
+          <a:prstGeom prst="rect">
+            <a:avLst/>
+          </a:prstGeom>
+          <a:solidFill>
+            <a:srgbClr val="FFFFFF"/>
+          </a:solidFill>
+          <a:ln w="15875">
+            <a:solidFill>
+              <a:srgbClr val="C55A11"/>
+            </a:solidFill>
+          </a:ln>
+          <a:effectLst/>
+        </p:spPr>
+        <p:txBody>
+          <a:bodyPr rtlCol="0" anchor="ctr"/>
+          <a:lstStyle/>
+          <a:p>
+            <a:pPr algn="ctr"/>
+          </a:p>
+        </p:txBody>
+      </p:sp>
+      <p:sp>
+        <p:nvSpPr>
+          <p:cNvPr id="151" name="Rectangle 150"/>
+          <p:cNvSpPr/>
+          <p:nvPr/>
+        </p:nvSpPr>
+        <p:spPr>
+          <a:xfrm>
+            <a:off x="8641080" y="2788920"/>
+            <a:ext cx="2011680" cy="173736"/>
+          </a:xfrm>
+          <a:prstGeom prst="rect">
+            <a:avLst/>
+          </a:prstGeom>
+          <a:solidFill>
+            <a:srgbClr val="C55A11"/>
+          </a:solidFill>
+          <a:ln w="12700">
+            <a:solidFill>
+              <a:srgbClr val="C55A11"/>
+            </a:solidFill>
+          </a:ln>
+          <a:effectLst/>
+        </p:spPr>
+        <p:txBody>
+          <a:bodyPr rtlCol="0" anchor="ctr" wrap="square" lIns="45720" tIns="0" rIns="18288" bIns="0"/>
+          <a:lstStyle/>
+          <a:p>
+            <a:pPr algn="l"/>
+            <a:r>
+              <a:rPr sz="800" b="1">
+                <a:solidFill>
+                  <a:srgbClr val="FFFFFF"/>
+                </a:solidFill>
+                <a:latin typeface="맑은 고딕"/>
+                <a:ea typeface="맑은 고딕"/>
+              </a:rPr>
+              <a:t>«process» Shard Router B</a:t>
+            </a:r>
+          </a:p>
+        </p:txBody>
+      </p:sp>
+      <p:sp>
+        <p:nvSpPr>
+          <p:cNvPr id="152" name="Rectangle 151"/>
+          <p:cNvSpPr/>
+          <p:nvPr/>
+        </p:nvSpPr>
+        <p:spPr>
+          <a:xfrm>
+            <a:off x="8750808" y="3063239"/>
+            <a:ext cx="914400" cy="384048"/>
+          </a:xfrm>
+          <a:prstGeom prst="rect">
+            <a:avLst/>
+          </a:prstGeom>
+          <a:solidFill>
+            <a:srgbClr val="FBE5D6"/>
+          </a:solidFill>
+          <a:ln w="12700">
+            <a:solidFill>
+              <a:srgbClr val="C55A11"/>
+            </a:solidFill>
+          </a:ln>
+          <a:effectLst/>
+        </p:spPr>
+        <p:txBody>
+          <a:bodyPr rtlCol="0" anchor="ctr" wrap="square" lIns="36576" tIns="18288" rIns="36576" bIns="18288"/>
+          <a:lstStyle/>
+          <a:p>
+            <a:pPr algn="ctr"/>
+            <a:r>
+              <a:rPr sz="750" b="1">
+                <a:solidFill>
+                  <a:srgbClr val="000000"/>
+                </a:solidFill>
+                <a:latin typeface="맑은 고딕"/>
+                <a:ea typeface="맑은 고딕"/>
+              </a:rPr>
+              <a:t>Pipeline</a:t>
+            </a:r>
+          </a:p>
+          <a:p>
+            <a:pPr algn="ctr"/>
+            <a:r>
+              <a:rPr sz="650" b="0">
+                <a:solidFill>
+                  <a:srgbClr val="000000"/>
+                </a:solidFill>
+                <a:latin typeface="맑은 고딕"/>
+                <a:ea typeface="맑은 고딕"/>
+              </a:rPr>
+              <a:t>Admission · Selector</a:t>
+            </a:r>
+          </a:p>
+          <a:p>
+            <a:pPr algn="ctr"/>
+            <a:r>
+              <a:rPr sz="650" b="0">
+                <a:solidFill>
+                  <a:srgbClr val="000000"/>
+                </a:solidFill>
+                <a:latin typeface="맑은 고딕"/>
+                <a:ea typeface="맑은 고딕"/>
+              </a:rPr>
+              <a:t>Dispatcher</a:t>
+            </a:r>
+          </a:p>
+        </p:txBody>
+      </p:sp>
+      <p:sp>
+        <p:nvSpPr>
+          <p:cNvPr id="153" name="Rectangle 152"/>
+          <p:cNvSpPr/>
+          <p:nvPr/>
+        </p:nvSpPr>
+        <p:spPr>
+          <a:xfrm>
+            <a:off x="8705088" y="3140049"/>
+            <a:ext cx="91440" cy="54864"/>
+          </a:xfrm>
+          <a:prstGeom prst="rect">
+            <a:avLst/>
+          </a:prstGeom>
+          <a:solidFill>
+            <a:srgbClr val="FBE5D6"/>
+          </a:solidFill>
+          <a:ln w="9525">
+            <a:solidFill>
+              <a:srgbClr val="C55A11"/>
+            </a:solidFill>
+          </a:ln>
+          <a:effectLst/>
+        </p:spPr>
+        <p:txBody>
+          <a:bodyPr rtlCol="0" anchor="ctr"/>
+          <a:lstStyle/>
+          <a:p>
+            <a:pPr algn="ctr"/>
+          </a:p>
+        </p:txBody>
+      </p:sp>
+      <p:sp>
+        <p:nvSpPr>
+          <p:cNvPr id="154" name="Rectangle 153"/>
+          <p:cNvSpPr/>
+          <p:nvPr/>
+        </p:nvSpPr>
+        <p:spPr>
+          <a:xfrm>
+            <a:off x="8705088" y="3255263"/>
+            <a:ext cx="91440" cy="54864"/>
+          </a:xfrm>
+          <a:prstGeom prst="rect">
+            <a:avLst/>
+          </a:prstGeom>
+          <a:solidFill>
+            <a:srgbClr val="FBE5D6"/>
+          </a:solidFill>
+          <a:ln w="9525">
+            <a:solidFill>
+              <a:srgbClr val="C55A11"/>
+            </a:solidFill>
+          </a:ln>
+          <a:effectLst/>
+        </p:spPr>
+        <p:txBody>
+          <a:bodyPr rtlCol="0" anchor="ctr"/>
+          <a:lstStyle/>
+          <a:p>
+            <a:pPr algn="ctr"/>
+          </a:p>
+        </p:txBody>
+      </p:sp>
+      <p:sp>
+        <p:nvSpPr>
+          <p:cNvPr id="155" name="Rectangle 154"/>
+          <p:cNvSpPr/>
+          <p:nvPr/>
+        </p:nvSpPr>
+        <p:spPr>
+          <a:xfrm>
+            <a:off x="9720072" y="3063239"/>
+            <a:ext cx="841248" cy="384048"/>
+          </a:xfrm>
+          <a:prstGeom prst="rect">
+            <a:avLst/>
+          </a:prstGeom>
+          <a:solidFill>
+            <a:srgbClr val="FBE5D6"/>
+          </a:solidFill>
+          <a:ln w="12700">
+            <a:solidFill>
+              <a:srgbClr val="C55A11"/>
+            </a:solidFill>
+          </a:ln>
+          <a:effectLst/>
+        </p:spPr>
+        <p:txBody>
+          <a:bodyPr rtlCol="0" anchor="ctr" wrap="square" lIns="36576" tIns="18288" rIns="36576" bIns="18288"/>
+          <a:lstStyle/>
+          <a:p>
+            <a:pPr algn="ctr"/>
+            <a:r>
+              <a:rPr sz="750" b="1">
+                <a:solidFill>
+                  <a:srgbClr val="000000"/>
+                </a:solidFill>
+                <a:latin typeface="맑은 고딕"/>
+                <a:ea typeface="맑은 고딕"/>
+              </a:rPr>
+              <a:t>State Plane</a:t>
+            </a:r>
+          </a:p>
+          <a:p>
+            <a:pPr algn="ctr"/>
+            <a:r>
+              <a:rPr sz="650" b="0">
+                <a:solidFill>
+                  <a:srgbClr val="000000"/>
+                </a:solidFill>
+                <a:latin typeface="맑은 고딕"/>
+                <a:ea typeface="맑은 고딕"/>
+              </a:rPr>
+              <a:t>담당 서버만</a:t>
+            </a:r>
+          </a:p>
+        </p:txBody>
+      </p:sp>
+      <p:sp>
+        <p:nvSpPr>
+          <p:cNvPr id="156" name="Rectangle 155"/>
+          <p:cNvSpPr/>
+          <p:nvPr/>
+        </p:nvSpPr>
+        <p:spPr>
+          <a:xfrm>
+            <a:off x="9674351" y="3140049"/>
+            <a:ext cx="91440" cy="54864"/>
+          </a:xfrm>
+          <a:prstGeom prst="rect">
+            <a:avLst/>
+          </a:prstGeom>
+          <a:solidFill>
+            <a:srgbClr val="FBE5D6"/>
+          </a:solidFill>
+          <a:ln w="9525">
+            <a:solidFill>
+              <a:srgbClr val="C55A11"/>
+            </a:solidFill>
+          </a:ln>
+          <a:effectLst/>
+        </p:spPr>
+        <p:txBody>
+          <a:bodyPr rtlCol="0" anchor="ctr"/>
+          <a:lstStyle/>
+          <a:p>
+            <a:pPr algn="ctr"/>
+          </a:p>
+        </p:txBody>
+      </p:sp>
+      <p:sp>
+        <p:nvSpPr>
+          <p:cNvPr id="157" name="Rectangle 156"/>
+          <p:cNvSpPr/>
+          <p:nvPr/>
+        </p:nvSpPr>
+        <p:spPr>
+          <a:xfrm>
+            <a:off x="9674351" y="3255263"/>
+            <a:ext cx="91440" cy="54864"/>
+          </a:xfrm>
+          <a:prstGeom prst="rect">
+            <a:avLst/>
+          </a:prstGeom>
+          <a:solidFill>
+            <a:srgbClr val="FBE5D6"/>
+          </a:solidFill>
+          <a:ln w="9525">
+            <a:solidFill>
+              <a:srgbClr val="C55A11"/>
+            </a:solidFill>
+          </a:ln>
+          <a:effectLst/>
+        </p:spPr>
+        <p:txBody>
+          <a:bodyPr rtlCol="0" anchor="ctr"/>
+          <a:lstStyle/>
+          <a:p>
+            <a:pPr algn="ctr"/>
+          </a:p>
+        </p:txBody>
+      </p:sp>
+      <p:sp>
+        <p:nvSpPr>
+          <p:cNvPr id="158" name="TextBox 157"/>
+          <p:cNvSpPr txBox="1"/>
+          <p:nvPr/>
+        </p:nvSpPr>
+        <p:spPr>
+          <a:xfrm>
+            <a:off x="8732520" y="3502152"/>
+            <a:ext cx="1828800" cy="457200"/>
+          </a:xfrm>
+          <a:prstGeom prst="rect">
+            <a:avLst/>
+          </a:prstGeom>
+          <a:noFill/>
+        </p:spPr>
+        <p:txBody>
+          <a:bodyPr wrap="square" anchor="t" lIns="0" tIns="0" rIns="0" bIns="0">
+            <a:spAutoFit/>
+          </a:bodyPr>
+          <a:lstStyle/>
+          <a:p>
+            <a:pPr algn="l"/>
+            <a:r>
+              <a:rPr sz="650" b="1">
+                <a:solidFill>
+                  <a:srgbClr val="000000"/>
+                </a:solidFill>
+                <a:latin typeface="맑은 고딕"/>
+                <a:ea typeface="맑은 고딕"/>
+              </a:rPr>
+              <a:t>담당 서버 N/2+1 ~ N</a:t>
+            </a:r>
+          </a:p>
+          <a:p>
+            <a:pPr algn="l"/>
+            <a:r>
+              <a:rPr sz="650" b="0">
+                <a:solidFill>
+                  <a:srgbClr val="5E35B1"/>
+                </a:solidFill>
+                <a:latin typeface="맑은 고딕"/>
+                <a:ea typeface="맑은 고딕"/>
+              </a:rPr>
+              <a:t>패턴(Strategy·Decorator·Adapter)은 샤드 안에서 그대로 재사용</a:t>
+            </a:r>
+          </a:p>
+        </p:txBody>
+      </p:sp>
+      <p:sp>
+        <p:nvSpPr>
+          <p:cNvPr id="159" name="Rectangle 158"/>
+          <p:cNvSpPr/>
+          <p:nvPr/>
+        </p:nvSpPr>
+        <p:spPr>
+          <a:xfrm>
+            <a:off x="10972800" y="2880360"/>
+            <a:ext cx="713232" cy="1005840"/>
+          </a:xfrm>
+          <a:prstGeom prst="rect">
+            <a:avLst/>
+          </a:prstGeom>
+          <a:solidFill>
+            <a:srgbClr val="D9D9D9"/>
+          </a:solidFill>
+          <a:ln w="12700">
+            <a:solidFill>
+              <a:srgbClr val="7F7F7F"/>
+            </a:solidFill>
+          </a:ln>
+          <a:effectLst/>
+        </p:spPr>
+        <p:txBody>
+          <a:bodyPr rtlCol="0" anchor="ctr" wrap="square" lIns="36576" tIns="18288" rIns="36576" bIns="18288"/>
+          <a:lstStyle/>
+          <a:p>
+            <a:pPr algn="ctr"/>
+            <a:r>
+              <a:rPr sz="750" b="1">
+                <a:solidFill>
+                  <a:srgbClr val="000000"/>
+                </a:solidFill>
+                <a:latin typeface="맑은 고딕"/>
+                <a:ea typeface="맑은 고딕"/>
+              </a:rPr>
+              <a:t>vLLM</a:t>
+            </a:r>
+          </a:p>
+          <a:p>
+            <a:pPr algn="ctr"/>
+            <a:r>
+              <a:rPr sz="700" b="0">
+                <a:solidFill>
+                  <a:srgbClr val="404040"/>
+                </a:solidFill>
+                <a:latin typeface="맑은 고딕"/>
+                <a:ea typeface="맑은 고딕"/>
+              </a:rPr>
+              <a:t>담당 서버</a:t>
+            </a:r>
+          </a:p>
+          <a:p>
+            <a:pPr algn="ctr"/>
+            <a:r>
+              <a:rPr sz="650" b="0">
+                <a:solidFill>
+                  <a:srgbClr val="404040"/>
+                </a:solidFill>
+                <a:latin typeface="맑은 고딕"/>
+                <a:ea typeface="맑은 고딕"/>
+              </a:rPr>
+              <a:t>KV 이벤트·</a:t>
+            </a:r>
+          </a:p>
+          <a:p>
+            <a:pPr algn="ctr"/>
+            <a:r>
+              <a:rPr sz="650" b="0">
+                <a:solidFill>
+                  <a:srgbClr val="404040"/>
+                </a:solidFill>
+                <a:latin typeface="맑은 고딕"/>
+                <a:ea typeface="맑은 고딕"/>
+              </a:rPr>
+              <a:t>/metrics는</a:t>
+            </a:r>
+          </a:p>
+          <a:p>
+            <a:pPr algn="ctr"/>
+            <a:r>
+              <a:rPr sz="650" b="0">
+                <a:solidFill>
+                  <a:srgbClr val="C00000"/>
+                </a:solidFill>
+                <a:latin typeface="맑은 고딕"/>
+                <a:ea typeface="맑은 고딕"/>
+              </a:rPr>
+              <a:t>이 샤드로만</a:t>
+            </a:r>
+          </a:p>
+        </p:txBody>
+      </p:sp>
+      <p:cxnSp>
+        <p:nvCxnSpPr>
+          <p:cNvPr id="160" name="Connector 159"/>
+          <p:cNvCxnSpPr/>
+          <p:nvPr/>
+        </p:nvCxnSpPr>
+        <p:spPr>
+          <a:xfrm>
+            <a:off x="10652759" y="3383279"/>
+            <a:ext cx="320041" cy="0"/>
+          </a:xfrm>
+          <a:prstGeom prst="line">
+            <a:avLst/>
+          </a:prstGeom>
+          <a:ln w="15875">
+            <a:solidFill>
+              <a:srgbClr val="404040"/>
+            </a:solidFill>
+            <a:headEnd type="triangle"/>
+            <a:tailEnd type="triangle"/>
+          </a:ln>
+        </p:spPr>
+      </p:cxnSp>
+      <p:cxnSp>
+        <p:nvCxnSpPr>
+          <p:cNvPr id="161" name="Connector 160"/>
+          <p:cNvCxnSpPr/>
+          <p:nvPr/>
+        </p:nvCxnSpPr>
+        <p:spPr>
+          <a:xfrm flipV="1">
+            <a:off x="8275320" y="1828800"/>
+            <a:ext cx="365760" cy="182880"/>
+          </a:xfrm>
+          <a:prstGeom prst="line">
+            <a:avLst/>
+          </a:prstGeom>
+          <a:ln w="15875">
+            <a:solidFill>
+              <a:srgbClr val="404040"/>
+            </a:solidFill>
+            <a:tailEnd type="triangle"/>
+          </a:ln>
+        </p:spPr>
+      </p:cxnSp>
+      <p:cxnSp>
+        <p:nvCxnSpPr>
+          <p:cNvPr id="162" name="Connector 161"/>
+          <p:cNvCxnSpPr/>
+          <p:nvPr/>
+        </p:nvCxnSpPr>
+        <p:spPr>
+          <a:xfrm>
+            <a:off x="8275320" y="2514600"/>
+            <a:ext cx="365760" cy="868680"/>
+          </a:xfrm>
+          <a:prstGeom prst="line">
+            <a:avLst/>
+          </a:prstGeom>
+          <a:ln w="15875">
+            <a:solidFill>
+              <a:srgbClr val="404040"/>
+            </a:solidFill>
+            <a:tailEnd type="triangle"/>
+          </a:ln>
+        </p:spPr>
+      </p:cxnSp>
+      <p:cxnSp>
+        <p:nvCxnSpPr>
+          <p:cNvPr id="163" name="Connector 162"/>
+          <p:cNvCxnSpPr/>
+          <p:nvPr/>
+        </p:nvCxnSpPr>
+        <p:spPr>
+          <a:xfrm>
+            <a:off x="9646920" y="2606040"/>
+            <a:ext cx="0" cy="182880"/>
+          </a:xfrm>
+          <a:prstGeom prst="line">
+            <a:avLst/>
+          </a:prstGeom>
+          <a:ln w="19050">
+            <a:solidFill>
+              <a:srgbClr val="C00000"/>
+            </a:solidFill>
+            <a:headEnd type="triangle"/>
+            <a:tailEnd type="triangle"/>
+          </a:ln>
+        </p:spPr>
+      </p:cxnSp>
+      <p:sp>
+        <p:nvSpPr>
+          <p:cNvPr id="164" name="TextBox 163"/>
+          <p:cNvSpPr txBox="1"/>
+          <p:nvPr/>
+        </p:nvSpPr>
+        <p:spPr>
+          <a:xfrm>
+            <a:off x="8366759" y="2624328"/>
+            <a:ext cx="1188720" cy="128016"/>
+          </a:xfrm>
+          <a:prstGeom prst="rect">
+            <a:avLst/>
+          </a:prstGeom>
+          <a:noFill/>
+        </p:spPr>
+        <p:txBody>
+          <a:bodyPr wrap="square" anchor="t" lIns="0" tIns="0" rIns="0" bIns="0">
+            <a:spAutoFit/>
+          </a:bodyPr>
+          <a:lstStyle/>
+          <a:p>
+            <a:pPr algn="r"/>
+            <a:r>
+              <a:rPr sz="700" b="1">
+                <a:solidFill>
+                  <a:srgbClr val="C00000"/>
+                </a:solidFill>
+                <a:latin typeface="맑은 고딕"/>
+                <a:ea typeface="맑은 고딕"/>
+              </a:rPr>
+              <a:t>샤드 요약 교환</a:t>
+            </a:r>
+          </a:p>
+        </p:txBody>
+      </p:sp>
+      <p:sp>
+        <p:nvSpPr>
+          <p:cNvPr id="165" name="Rectangle 164"/>
+          <p:cNvSpPr/>
+          <p:nvPr/>
+        </p:nvSpPr>
+        <p:spPr>
+          <a:xfrm>
+            <a:off x="6492240" y="3200400"/>
+            <a:ext cx="1783080" cy="731520"/>
+          </a:xfrm>
+          <a:prstGeom prst="rect">
+            <a:avLst/>
+          </a:prstGeom>
+          <a:solidFill>
+            <a:srgbClr val="F2F2F2"/>
+          </a:solidFill>
+          <a:ln w="12700">
+            <a:solidFill>
+              <a:srgbClr val="7F7F7F"/>
+            </a:solidFill>
+          </a:ln>
+          <a:effectLst/>
+        </p:spPr>
+        <p:txBody>
+          <a:bodyPr rtlCol="0" anchor="ctr" wrap="square" lIns="36576" tIns="18288" rIns="36576" bIns="18288"/>
+          <a:lstStyle/>
+          <a:p>
+            <a:pPr algn="ctr"/>
+            <a:r>
+              <a:rPr sz="800" b="1">
+                <a:solidFill>
+                  <a:srgbClr val="000000"/>
+                </a:solidFill>
+                <a:latin typeface="맑은 고딕"/>
+                <a:ea typeface="맑은 고딕"/>
+              </a:rPr>
+              <a:t>etcd</a:t>
+            </a:r>
+          </a:p>
+          <a:p>
+            <a:pPr algn="ctr"/>
+            <a:r>
+              <a:rPr sz="700" b="0">
+                <a:solidFill>
+                  <a:srgbClr val="404040"/>
+                </a:solidFill>
+                <a:latin typeface="맑은 고딕"/>
+                <a:ea typeface="맑은 고딕"/>
+              </a:rPr>
+              <a:t>서버 → 샤드 배정(lease)</a:t>
+            </a:r>
+          </a:p>
+          <a:p>
+            <a:pPr algn="ctr"/>
+            <a:r>
+              <a:rPr sz="650" b="0">
+                <a:solidFill>
+                  <a:srgbClr val="404040"/>
+                </a:solidFill>
+                <a:latin typeface="맑은 고딕"/>
+                <a:ea typeface="맑은 고딕"/>
+              </a:rPr>
+              <a:t>샤드 장애 시 lease 만료 후</a:t>
+            </a:r>
+          </a:p>
+          <a:p>
+            <a:pPr algn="ctr"/>
+            <a:r>
+              <a:rPr sz="650" b="0">
+                <a:solidFill>
+                  <a:srgbClr val="404040"/>
+                </a:solidFill>
+                <a:latin typeface="맑은 고딕"/>
+                <a:ea typeface="맑은 고딕"/>
+              </a:rPr>
+              <a:t>이웃 샤드가 인수</a:t>
+            </a:r>
+          </a:p>
+        </p:txBody>
+      </p:sp>
+      <p:cxnSp>
+        <p:nvCxnSpPr>
+          <p:cNvPr id="166" name="Connector 165"/>
+          <p:cNvCxnSpPr/>
+          <p:nvPr/>
+        </p:nvCxnSpPr>
+        <p:spPr>
+          <a:xfrm>
+            <a:off x="8275320" y="3611880"/>
+            <a:ext cx="365760" cy="45720"/>
+          </a:xfrm>
+          <a:prstGeom prst="line">
+            <a:avLst/>
+          </a:prstGeom>
+          <a:ln w="12700">
+            <a:solidFill>
+              <a:srgbClr val="404040"/>
+            </a:solidFill>
+            <a:prstDash val="dash"/>
+            <a:tailEnd type="triangle"/>
+          </a:ln>
+        </p:spPr>
+      </p:cxnSp>
+      <p:cxnSp>
+        <p:nvCxnSpPr>
+          <p:cNvPr id="167" name="Connector 166"/>
+          <p:cNvCxnSpPr/>
+          <p:nvPr/>
+        </p:nvCxnSpPr>
+        <p:spPr>
+          <a:xfrm flipV="1">
+            <a:off x="8275320" y="2514600"/>
+            <a:ext cx="365760" cy="777240"/>
+          </a:xfrm>
+          <a:prstGeom prst="line">
+            <a:avLst/>
+          </a:prstGeom>
+          <a:ln w="12700">
+            <a:solidFill>
+              <a:srgbClr val="404040"/>
+            </a:solidFill>
+            <a:prstDash val="dash"/>
+            <a:tailEnd type="triangle"/>
+          </a:ln>
+        </p:spPr>
+      </p:cxnSp>
+      <p:sp>
+        <p:nvSpPr>
+          <p:cNvPr id="168" name="Oval 167"/>
+          <p:cNvSpPr/>
+          <p:nvPr/>
+        </p:nvSpPr>
+        <p:spPr>
+          <a:xfrm>
+            <a:off x="8060435" y="1705356"/>
+            <a:ext cx="155448" cy="155448"/>
+          </a:xfrm>
+          <a:prstGeom prst="ellipse">
+            <a:avLst/>
+          </a:prstGeom>
+          <a:solidFill>
+            <a:srgbClr val="404040"/>
+          </a:solidFill>
+          <a:ln w="9525">
+            <a:solidFill>
+              <a:srgbClr val="FFFFFF"/>
+            </a:solidFill>
+          </a:ln>
+          <a:effectLst/>
+        </p:spPr>
+        <p:txBody>
+          <a:bodyPr rtlCol="0" anchor="ctr" wrap="square" lIns="0" tIns="0" rIns="0" bIns="0"/>
+          <a:lstStyle/>
+          <a:p>
+            <a:pPr algn="ctr"/>
+            <a:r>
+              <a:rPr sz="650" b="1">
+                <a:solidFill>
+                  <a:srgbClr val="FFFFFF"/>
+                </a:solidFill>
+                <a:latin typeface="맑은 고딕"/>
+                <a:ea typeface="맑은 고딕"/>
+              </a:rPr>
+              <a:t>1</a:t>
+            </a:r>
+          </a:p>
+        </p:txBody>
+      </p:sp>
+      <p:sp>
+        <p:nvSpPr>
+          <p:cNvPr id="169" name="Oval 168"/>
+          <p:cNvSpPr/>
+          <p:nvPr/>
+        </p:nvSpPr>
+        <p:spPr>
+          <a:xfrm>
+            <a:off x="8581643" y="1888236"/>
+            <a:ext cx="155448" cy="155448"/>
+          </a:xfrm>
+          <a:prstGeom prst="ellipse">
+            <a:avLst/>
+          </a:prstGeom>
+          <a:solidFill>
+            <a:srgbClr val="404040"/>
+          </a:solidFill>
+          <a:ln w="9525">
+            <a:solidFill>
+              <a:srgbClr val="FFFFFF"/>
+            </a:solidFill>
+          </a:ln>
+          <a:effectLst/>
+        </p:spPr>
+        <p:txBody>
+          <a:bodyPr rtlCol="0" anchor="ctr" wrap="square" lIns="0" tIns="0" rIns="0" bIns="0"/>
+          <a:lstStyle/>
+          <a:p>
+            <a:pPr algn="ctr"/>
+            <a:r>
+              <a:rPr sz="650" b="1">
+                <a:solidFill>
+                  <a:srgbClr val="FFFFFF"/>
+                </a:solidFill>
+                <a:latin typeface="맑은 고딕"/>
+                <a:ea typeface="맑은 고딕"/>
+              </a:rPr>
+              <a:t>2</a:t>
+            </a:r>
+          </a:p>
+        </p:txBody>
+      </p:sp>
+      <p:sp>
+        <p:nvSpPr>
+          <p:cNvPr id="170" name="Oval 169"/>
+          <p:cNvSpPr/>
+          <p:nvPr/>
+        </p:nvSpPr>
+        <p:spPr>
+          <a:xfrm>
+            <a:off x="11580876" y="1431036"/>
+            <a:ext cx="155448" cy="155448"/>
+          </a:xfrm>
+          <a:prstGeom prst="ellipse">
+            <a:avLst/>
+          </a:prstGeom>
+          <a:solidFill>
+            <a:srgbClr val="404040"/>
+          </a:solidFill>
+          <a:ln w="9525">
+            <a:solidFill>
+              <a:srgbClr val="FFFFFF"/>
+            </a:solidFill>
+          </a:ln>
+          <a:effectLst/>
+        </p:spPr>
+        <p:txBody>
+          <a:bodyPr rtlCol="0" anchor="ctr" wrap="square" lIns="0" tIns="0" rIns="0" bIns="0"/>
+          <a:lstStyle/>
+          <a:p>
+            <a:pPr algn="ctr"/>
+            <a:r>
+              <a:rPr sz="650" b="1">
+                <a:solidFill>
+                  <a:srgbClr val="FFFFFF"/>
+                </a:solidFill>
+                <a:latin typeface="맑은 고딕"/>
+                <a:ea typeface="맑은 고딕"/>
+              </a:rPr>
+              <a:t>3</a:t>
+            </a:r>
+          </a:p>
+        </p:txBody>
+      </p:sp>
+      <p:sp>
+        <p:nvSpPr>
+          <p:cNvPr id="171" name="Oval 170"/>
+          <p:cNvSpPr/>
+          <p:nvPr/>
+        </p:nvSpPr>
+        <p:spPr>
+          <a:xfrm>
+            <a:off x="9569196" y="2619756"/>
+            <a:ext cx="155448" cy="155448"/>
+          </a:xfrm>
+          <a:prstGeom prst="ellipse">
+            <a:avLst/>
+          </a:prstGeom>
+          <a:solidFill>
+            <a:srgbClr val="404040"/>
+          </a:solidFill>
+          <a:ln w="9525">
+            <a:solidFill>
+              <a:srgbClr val="FFFFFF"/>
+            </a:solidFill>
+          </a:ln>
+          <a:effectLst/>
+        </p:spPr>
+        <p:txBody>
+          <a:bodyPr rtlCol="0" anchor="ctr" wrap="square" lIns="0" tIns="0" rIns="0" bIns="0"/>
+          <a:lstStyle/>
+          <a:p>
+            <a:pPr algn="ctr"/>
+            <a:r>
+              <a:rPr sz="650" b="1">
+                <a:solidFill>
+                  <a:srgbClr val="FFFFFF"/>
+                </a:solidFill>
+                <a:latin typeface="맑은 고딕"/>
+                <a:ea typeface="맑은 고딕"/>
+              </a:rPr>
+              <a:t>4</a:t>
+            </a:r>
+          </a:p>
+        </p:txBody>
+      </p:sp>
+      <p:sp>
+        <p:nvSpPr>
+          <p:cNvPr id="172" name="TextBox 171"/>
+          <p:cNvSpPr txBox="1"/>
+          <p:nvPr/>
+        </p:nvSpPr>
+        <p:spPr>
+          <a:xfrm>
+            <a:off x="246888" y="4160520"/>
+            <a:ext cx="11750040" cy="182880"/>
+          </a:xfrm>
+          <a:prstGeom prst="rect">
+            <a:avLst/>
+          </a:prstGeom>
+          <a:noFill/>
+        </p:spPr>
+        <p:txBody>
+          <a:bodyPr wrap="square" anchor="t" lIns="0" tIns="0" rIns="0" bIns="0">
+            <a:spAutoFit/>
+          </a:bodyPr>
+          <a:lstStyle/>
+          <a:p>
+            <a:pPr algn="l"/>
+            <a:r>
+              <a:rPr sz="1000" b="1">
+                <a:solidFill>
+                  <a:srgbClr val="000000"/>
+                </a:solidFill>
+                <a:latin typeface="맑은 고딕"/>
+                <a:ea typeface="맑은 고딕"/>
+              </a:rPr>
+              <a:t>동작 규칙</a:t>
+            </a:r>
+          </a:p>
+        </p:txBody>
+      </p:sp>
+      <p:sp>
+        <p:nvSpPr>
+          <p:cNvPr id="173" name="Rectangle 172"/>
+          <p:cNvSpPr/>
+          <p:nvPr/>
+        </p:nvSpPr>
+        <p:spPr>
+          <a:xfrm>
+            <a:off x="246888" y="4361688"/>
+            <a:ext cx="274320" cy="246888"/>
+          </a:xfrm>
+          <a:prstGeom prst="rect">
+            <a:avLst/>
+          </a:prstGeom>
+          <a:solidFill>
+            <a:srgbClr val="C55A11"/>
+          </a:solidFill>
+          <a:ln w="12700">
+            <a:solidFill>
+              <a:srgbClr val="C55A11"/>
+            </a:solidFill>
+          </a:ln>
+          <a:effectLst/>
+        </p:spPr>
+        <p:txBody>
+          <a:bodyPr rtlCol="0" anchor="ctr" wrap="square" lIns="36576" tIns="18288" rIns="36576" bIns="18288"/>
+          <a:lstStyle/>
+          <a:p>
+            <a:pPr algn="ctr"/>
+            <a:r>
+              <a:rPr sz="900" b="1">
+                <a:solidFill>
+                  <a:srgbClr val="FFFFFF"/>
+                </a:solidFill>
+                <a:latin typeface="맑은 고딕"/>
+                <a:ea typeface="맑은 고딕"/>
+              </a:rPr>
+              <a:t>①</a:t>
+            </a:r>
+          </a:p>
+        </p:txBody>
+      </p:sp>
+      <p:sp>
+        <p:nvSpPr>
+          <p:cNvPr id="174" name="TextBox 173"/>
+          <p:cNvSpPr txBox="1"/>
+          <p:nvPr/>
+        </p:nvSpPr>
+        <p:spPr>
+          <a:xfrm>
+            <a:off x="594360" y="4370831"/>
+            <a:ext cx="5577840" cy="246888"/>
+          </a:xfrm>
+          <a:prstGeom prst="rect">
+            <a:avLst/>
+          </a:prstGeom>
+          <a:noFill/>
+        </p:spPr>
+        <p:txBody>
+          <a:bodyPr wrap="square" anchor="ctr" lIns="0" tIns="0" rIns="0" bIns="0">
+            <a:spAutoFit/>
+          </a:bodyPr>
+          <a:lstStyle/>
+          <a:p>
+            <a:pPr algn="l"/>
+            <a:r>
+              <a:rPr sz="720" b="0">
+                <a:solidFill>
+                  <a:srgbClr val="000000"/>
+                </a:solidFill>
+                <a:latin typeface="맑은 고딕"/>
+                <a:ea typeface="맑은 고딕"/>
+              </a:rPr>
+              <a:t>요청은 Front Router의 Shard Selector가 요약 테이블만 보고 샤드를 고른다. Front Router는 상태를 갖지 않아 몇 개든 늘릴 수 있다</a:t>
+            </a:r>
+          </a:p>
+        </p:txBody>
+      </p:sp>
+      <p:sp>
+        <p:nvSpPr>
+          <p:cNvPr id="175" name="Rectangle 174"/>
+          <p:cNvSpPr/>
+          <p:nvPr/>
+        </p:nvSpPr>
+        <p:spPr>
+          <a:xfrm>
+            <a:off x="246888" y="4690872"/>
+            <a:ext cx="274320" cy="246888"/>
+          </a:xfrm>
+          <a:prstGeom prst="rect">
+            <a:avLst/>
+          </a:prstGeom>
+          <a:solidFill>
+            <a:srgbClr val="C55A11"/>
+          </a:solidFill>
+          <a:ln w="12700">
+            <a:solidFill>
+              <a:srgbClr val="C55A11"/>
+            </a:solidFill>
+          </a:ln>
+          <a:effectLst/>
+        </p:spPr>
+        <p:txBody>
+          <a:bodyPr rtlCol="0" anchor="ctr" wrap="square" lIns="36576" tIns="18288" rIns="36576" bIns="18288"/>
+          <a:lstStyle/>
+          <a:p>
+            <a:pPr algn="ctr"/>
+            <a:r>
+              <a:rPr sz="900" b="1">
+                <a:solidFill>
+                  <a:srgbClr val="FFFFFF"/>
+                </a:solidFill>
+                <a:latin typeface="맑은 고딕"/>
+                <a:ea typeface="맑은 고딕"/>
+              </a:rPr>
+              <a:t>②</a:t>
+            </a:r>
+          </a:p>
+        </p:txBody>
+      </p:sp>
+      <p:sp>
+        <p:nvSpPr>
+          <p:cNvPr id="176" name="TextBox 175"/>
+          <p:cNvSpPr txBox="1"/>
+          <p:nvPr/>
+        </p:nvSpPr>
+        <p:spPr>
+          <a:xfrm>
+            <a:off x="594360" y="4700016"/>
+            <a:ext cx="5577840" cy="246888"/>
+          </a:xfrm>
+          <a:prstGeom prst="rect">
+            <a:avLst/>
+          </a:prstGeom>
+          <a:noFill/>
+        </p:spPr>
+        <p:txBody>
+          <a:bodyPr wrap="square" anchor="ctr" lIns="0" tIns="0" rIns="0" bIns="0">
+            <a:spAutoFit/>
+          </a:bodyPr>
+          <a:lstStyle/>
+          <a:p>
+            <a:pPr algn="l"/>
+            <a:r>
+              <a:rPr sz="720" b="0">
+                <a:solidFill>
+                  <a:srgbClr val="000000"/>
+                </a:solidFill>
+                <a:latin typeface="맑은 고딕"/>
+                <a:ea typeface="맑은 고딕"/>
+              </a:rPr>
+              <a:t>선택된 Shard Router가 담당 서버의 상세 상태로 서버를 고르고 P/D 조율·지시(P5)를 한다. 샤드 안 구조는 현재 2안과 같아 코드를 재사용한다</a:t>
+            </a:r>
+          </a:p>
+        </p:txBody>
+      </p:sp>
+      <p:sp>
+        <p:nvSpPr>
+          <p:cNvPr id="177" name="Rectangle 176"/>
+          <p:cNvSpPr/>
+          <p:nvPr/>
+        </p:nvSpPr>
+        <p:spPr>
+          <a:xfrm>
+            <a:off x="246888" y="5020056"/>
+            <a:ext cx="274320" cy="246888"/>
+          </a:xfrm>
+          <a:prstGeom prst="rect">
+            <a:avLst/>
+          </a:prstGeom>
+          <a:solidFill>
+            <a:srgbClr val="C55A11"/>
+          </a:solidFill>
+          <a:ln w="12700">
+            <a:solidFill>
+              <a:srgbClr val="C55A11"/>
+            </a:solidFill>
+          </a:ln>
+          <a:effectLst/>
+        </p:spPr>
+        <p:txBody>
+          <a:bodyPr rtlCol="0" anchor="ctr" wrap="square" lIns="36576" tIns="18288" rIns="36576" bIns="18288"/>
+          <a:lstStyle/>
+          <a:p>
+            <a:pPr algn="ctr"/>
+            <a:r>
+              <a:rPr sz="900" b="1">
+                <a:solidFill>
+                  <a:srgbClr val="FFFFFF"/>
+                </a:solidFill>
+                <a:latin typeface="맑은 고딕"/>
+                <a:ea typeface="맑은 고딕"/>
+              </a:rPr>
+              <a:t>③</a:t>
+            </a:r>
+          </a:p>
+        </p:txBody>
+      </p:sp>
+      <p:sp>
+        <p:nvSpPr>
+          <p:cNvPr id="178" name="TextBox 177"/>
+          <p:cNvSpPr txBox="1"/>
+          <p:nvPr/>
+        </p:nvSpPr>
+        <p:spPr>
+          <a:xfrm>
+            <a:off x="594360" y="5029200"/>
+            <a:ext cx="5577840" cy="246888"/>
+          </a:xfrm>
+          <a:prstGeom prst="rect">
+            <a:avLst/>
+          </a:prstGeom>
+          <a:noFill/>
+        </p:spPr>
+        <p:txBody>
+          <a:bodyPr wrap="square" anchor="ctr" lIns="0" tIns="0" rIns="0" bIns="0">
+            <a:spAutoFit/>
+          </a:bodyPr>
+          <a:lstStyle/>
+          <a:p>
+            <a:pPr algn="l"/>
+            <a:r>
+              <a:rPr sz="720" b="0">
+                <a:solidFill>
+                  <a:srgbClr val="000000"/>
+                </a:solidFill>
+                <a:latin typeface="맑은 고딕"/>
+                <a:ea typeface="맑은 고딕"/>
+              </a:rPr>
+              <a:t>서버는 한 샤드에만 속해 이벤트·메트릭 처리량이 N ÷ 샤드 수로 줄고, 샤드 수를 서버에 비례해 늘리면 레플리카당 부하가 일정하다 (SE 개선의 근거)</a:t>
+            </a:r>
+          </a:p>
+        </p:txBody>
+      </p:sp>
+      <p:sp>
+        <p:nvSpPr>
+          <p:cNvPr id="179" name="Rectangle 178"/>
+          <p:cNvSpPr/>
+          <p:nvPr/>
+        </p:nvSpPr>
+        <p:spPr>
+          <a:xfrm>
+            <a:off x="246888" y="5349240"/>
+            <a:ext cx="274320" cy="246888"/>
+          </a:xfrm>
+          <a:prstGeom prst="rect">
+            <a:avLst/>
+          </a:prstGeom>
+          <a:solidFill>
+            <a:srgbClr val="C55A11"/>
+          </a:solidFill>
+          <a:ln w="12700">
+            <a:solidFill>
+              <a:srgbClr val="C55A11"/>
+            </a:solidFill>
+          </a:ln>
+          <a:effectLst/>
+        </p:spPr>
+        <p:txBody>
+          <a:bodyPr rtlCol="0" anchor="ctr" wrap="square" lIns="36576" tIns="18288" rIns="36576" bIns="18288"/>
+          <a:lstStyle/>
+          <a:p>
+            <a:pPr algn="ctr"/>
+            <a:r>
+              <a:rPr sz="900" b="1">
+                <a:solidFill>
+                  <a:srgbClr val="FFFFFF"/>
+                </a:solidFill>
+                <a:latin typeface="맑은 고딕"/>
+                <a:ea typeface="맑은 고딕"/>
+              </a:rPr>
+              <a:t>④</a:t>
+            </a:r>
+          </a:p>
+        </p:txBody>
+      </p:sp>
+      <p:sp>
+        <p:nvSpPr>
+          <p:cNvPr id="180" name="TextBox 179"/>
+          <p:cNvSpPr txBox="1"/>
+          <p:nvPr/>
+        </p:nvSpPr>
+        <p:spPr>
+          <a:xfrm>
+            <a:off x="594360" y="5358384"/>
+            <a:ext cx="5577840" cy="246888"/>
+          </a:xfrm>
+          <a:prstGeom prst="rect">
+            <a:avLst/>
+          </a:prstGeom>
+          <a:noFill/>
+        </p:spPr>
+        <p:txBody>
+          <a:bodyPr wrap="square" anchor="ctr" lIns="0" tIns="0" rIns="0" bIns="0">
+            <a:spAutoFit/>
+          </a:bodyPr>
+          <a:lstStyle/>
+          <a:p>
+            <a:pPr algn="l"/>
+            <a:r>
+              <a:rPr sz="720" b="0">
+                <a:solidFill>
+                  <a:srgbClr val="000000"/>
+                </a:solidFill>
+                <a:latin typeface="맑은 고딕"/>
+                <a:ea typeface="맑은 고딕"/>
+              </a:rPr>
+              <a:t>샤드끼리는 부하·prefix sketch 요약만 교환한다. 요약은 최대 ~1 s 낡을 수 있어 캐시 인지 라우팅 정확도가 일부 떨어진다 (DP0-1의 S2 '2단 위임'과 같은 방향)</a:t>
+            </a:r>
+          </a:p>
+        </p:txBody>
+      </p:sp>
+      <p:sp>
+        <p:nvSpPr>
+          <p:cNvPr id="181" name="Rectangle 180"/>
+          <p:cNvSpPr/>
+          <p:nvPr/>
+        </p:nvSpPr>
+        <p:spPr>
+          <a:xfrm>
+            <a:off x="6400800" y="4160520"/>
+            <a:ext cx="777240" cy="219456"/>
+          </a:xfrm>
+          <a:prstGeom prst="rect">
+            <a:avLst/>
+          </a:prstGeom>
+          <a:solidFill>
+            <a:srgbClr val="404040"/>
+          </a:solidFill>
+          <a:ln w="12700">
+            <a:solidFill>
+              <a:srgbClr val="404040"/>
+            </a:solidFill>
+          </a:ln>
+          <a:effectLst/>
+        </p:spPr>
+        <p:txBody>
+          <a:bodyPr rtlCol="0" anchor="ctr" wrap="square" lIns="36576" tIns="18288" rIns="36576" bIns="18288"/>
+          <a:lstStyle/>
+          <a:p>
+            <a:pPr algn="ctr"/>
+            <a:r>
+              <a:rPr sz="800" b="1">
+                <a:solidFill>
+                  <a:srgbClr val="FFFFFF"/>
+                </a:solidFill>
+                <a:latin typeface="맑은 고딕"/>
+                <a:ea typeface="맑은 고딕"/>
+              </a:rPr>
+              <a:t>QA</a:t>
+            </a:r>
+          </a:p>
+        </p:txBody>
+      </p:sp>
+      <p:sp>
+        <p:nvSpPr>
+          <p:cNvPr id="182" name="Rectangle 181"/>
+          <p:cNvSpPr/>
+          <p:nvPr/>
+        </p:nvSpPr>
+        <p:spPr>
+          <a:xfrm>
+            <a:off x="7178040" y="4160520"/>
+            <a:ext cx="1097280" cy="219456"/>
+          </a:xfrm>
+          <a:prstGeom prst="rect">
+            <a:avLst/>
+          </a:prstGeom>
+          <a:solidFill>
+            <a:srgbClr val="404040"/>
+          </a:solidFill>
+          <a:ln w="12700">
+            <a:solidFill>
+              <a:srgbClr val="404040"/>
+            </a:solidFill>
+          </a:ln>
+          <a:effectLst/>
+        </p:spPr>
+        <p:txBody>
+          <a:bodyPr rtlCol="0" anchor="ctr" wrap="square" lIns="36576" tIns="18288" rIns="36576" bIns="18288"/>
+          <a:lstStyle/>
+          <a:p>
+            <a:pPr algn="ctr"/>
+            <a:r>
+              <a:rPr sz="800" b="1">
+                <a:solidFill>
+                  <a:srgbClr val="FFFFFF"/>
+                </a:solidFill>
+                <a:latin typeface="맑은 고딕"/>
+                <a:ea typeface="맑은 고딕"/>
+              </a:rPr>
+              <a:t>현재 2안</a:t>
+            </a:r>
+          </a:p>
+        </p:txBody>
+      </p:sp>
+      <p:sp>
+        <p:nvSpPr>
+          <p:cNvPr id="183" name="Rectangle 182"/>
+          <p:cNvSpPr/>
+          <p:nvPr/>
+        </p:nvSpPr>
+        <p:spPr>
+          <a:xfrm>
+            <a:off x="8275319" y="4160520"/>
+            <a:ext cx="1371600" cy="219456"/>
+          </a:xfrm>
+          <a:prstGeom prst="rect">
+            <a:avLst/>
+          </a:prstGeom>
+          <a:solidFill>
+            <a:srgbClr val="404040"/>
+          </a:solidFill>
+          <a:ln w="12700">
+            <a:solidFill>
+              <a:srgbClr val="404040"/>
+            </a:solidFill>
+          </a:ln>
+          <a:effectLst/>
+        </p:spPr>
+        <p:txBody>
+          <a:bodyPr rtlCol="0" anchor="ctr" wrap="square" lIns="36576" tIns="18288" rIns="36576" bIns="18288"/>
+          <a:lstStyle/>
+          <a:p>
+            <a:pPr algn="ctr"/>
+            <a:r>
+              <a:rPr sz="800" b="1">
+                <a:solidFill>
+                  <a:srgbClr val="FFFFFF"/>
+                </a:solidFill>
+                <a:latin typeface="맑은 고딕"/>
+                <a:ea typeface="맑은 고딕"/>
+              </a:rPr>
+              <a:t>보완 후 (예상)</a:t>
+            </a:r>
+          </a:p>
+        </p:txBody>
+      </p:sp>
+      <p:sp>
+        <p:nvSpPr>
+          <p:cNvPr id="184" name="Rectangle 183"/>
+          <p:cNvSpPr/>
+          <p:nvPr/>
+        </p:nvSpPr>
+        <p:spPr>
+          <a:xfrm>
+            <a:off x="9646919" y="4160520"/>
+            <a:ext cx="2350008" cy="219456"/>
+          </a:xfrm>
+          <a:prstGeom prst="rect">
+            <a:avLst/>
+          </a:prstGeom>
+          <a:solidFill>
+            <a:srgbClr val="404040"/>
+          </a:solidFill>
+          <a:ln w="12700">
+            <a:solidFill>
+              <a:srgbClr val="404040"/>
+            </a:solidFill>
+          </a:ln>
+          <a:effectLst/>
+        </p:spPr>
+        <p:txBody>
+          <a:bodyPr rtlCol="0" anchor="ctr" wrap="square" lIns="36576" tIns="18288" rIns="36576" bIns="18288"/>
+          <a:lstStyle/>
+          <a:p>
+            <a:pPr algn="ctr"/>
+            <a:r>
+              <a:rPr sz="800" b="1">
+                <a:solidFill>
+                  <a:srgbClr val="FFFFFF"/>
+                </a:solidFill>
+                <a:latin typeface="맑은 고딕"/>
+                <a:ea typeface="맑은 고딕"/>
+              </a:rPr>
+              <a:t>이유 · 비용</a:t>
+            </a:r>
+          </a:p>
+        </p:txBody>
+      </p:sp>
+      <p:sp>
+        <p:nvSpPr>
+          <p:cNvPr id="185" name="Rectangle 184"/>
+          <p:cNvSpPr/>
+          <p:nvPr/>
+        </p:nvSpPr>
+        <p:spPr>
+          <a:xfrm>
+            <a:off x="6400800" y="4379976"/>
+            <a:ext cx="777240" cy="329184"/>
+          </a:xfrm>
+          <a:prstGeom prst="rect">
+            <a:avLst/>
+          </a:prstGeom>
+          <a:solidFill>
+            <a:srgbClr val="F2F2F2"/>
+          </a:solidFill>
+          <a:ln w="6350">
+            <a:solidFill>
+              <a:srgbClr val="BFBFBF"/>
+            </a:solidFill>
+          </a:ln>
+          <a:effectLst/>
+        </p:spPr>
+        <p:txBody>
+          <a:bodyPr rtlCol="0" anchor="ctr" wrap="square" lIns="64008" tIns="27432" rIns="45720" bIns="27432"/>
+          <a:lstStyle/>
+          <a:p>
+            <a:pPr algn="l"/>
+            <a:r>
+              <a:rPr sz="700" b="1">
+                <a:solidFill>
+                  <a:srgbClr val="000000"/>
+                </a:solidFill>
+                <a:latin typeface="맑은 고딕"/>
+                <a:ea typeface="맑은 고딕"/>
+              </a:rPr>
+              <a:t>Q4 확장성</a:t>
+            </a:r>
+          </a:p>
+        </p:txBody>
+      </p:sp>
+      <p:sp>
+        <p:nvSpPr>
+          <p:cNvPr id="186" name="Rectangle 185"/>
+          <p:cNvSpPr/>
+          <p:nvPr/>
+        </p:nvSpPr>
+        <p:spPr>
+          <a:xfrm>
+            <a:off x="7178040" y="4379976"/>
+            <a:ext cx="1097280" cy="329184"/>
+          </a:xfrm>
+          <a:prstGeom prst="rect">
+            <a:avLst/>
+          </a:prstGeom>
+          <a:solidFill>
+            <a:srgbClr val="FFFFFF"/>
+          </a:solidFill>
+          <a:ln w="6350">
+            <a:solidFill>
+              <a:srgbClr val="BFBFBF"/>
+            </a:solidFill>
+          </a:ln>
+          <a:effectLst/>
+        </p:spPr>
+        <p:txBody>
+          <a:bodyPr rtlCol="0" anchor="ctr" wrap="square" lIns="64008" tIns="27432" rIns="45720" bIns="27432"/>
+          <a:lstStyle/>
+          <a:p>
+            <a:pPr algn="l"/>
+            <a:r>
+              <a:rPr sz="700" b="0">
+                <a:solidFill>
+                  <a:srgbClr val="000000"/>
+                </a:solidFill>
+                <a:latin typeface="맑은 고딕"/>
+                <a:ea typeface="맑은 고딕"/>
+              </a:rPr>
+              <a:t>SE(16) 64% ★</a:t>
+            </a:r>
+          </a:p>
+        </p:txBody>
+      </p:sp>
+      <p:sp>
+        <p:nvSpPr>
+          <p:cNvPr id="187" name="Rectangle 186"/>
+          <p:cNvSpPr/>
+          <p:nvPr/>
+        </p:nvSpPr>
+        <p:spPr>
+          <a:xfrm>
+            <a:off x="8275319" y="4379976"/>
+            <a:ext cx="1371600" cy="329184"/>
+          </a:xfrm>
+          <a:prstGeom prst="rect">
+            <a:avLst/>
+          </a:prstGeom>
+          <a:solidFill>
+            <a:srgbClr val="FFFFFF"/>
+          </a:solidFill>
+          <a:ln w="6350">
+            <a:solidFill>
+              <a:srgbClr val="BFBFBF"/>
+            </a:solidFill>
+          </a:ln>
+          <a:effectLst/>
+        </p:spPr>
+        <p:txBody>
+          <a:bodyPr rtlCol="0" anchor="ctr" wrap="square" lIns="64008" tIns="27432" rIns="45720" bIns="27432"/>
+          <a:lstStyle/>
+          <a:p>
+            <a:pPr algn="l"/>
+            <a:r>
+              <a:rPr sz="700" b="0">
+                <a:solidFill>
+                  <a:srgbClr val="000000"/>
+                </a:solidFill>
+                <a:latin typeface="맑은 고딕"/>
+                <a:ea typeface="맑은 고딕"/>
+              </a:rPr>
+              <a:t>≈ 80% ★★ (가설)</a:t>
+            </a:r>
+          </a:p>
+        </p:txBody>
+      </p:sp>
+      <p:sp>
+        <p:nvSpPr>
+          <p:cNvPr id="188" name="Rectangle 187"/>
+          <p:cNvSpPr/>
+          <p:nvPr/>
+        </p:nvSpPr>
+        <p:spPr>
+          <a:xfrm>
+            <a:off x="9646919" y="4379976"/>
+            <a:ext cx="2350008" cy="329184"/>
+          </a:xfrm>
+          <a:prstGeom prst="rect">
+            <a:avLst/>
+          </a:prstGeom>
+          <a:solidFill>
+            <a:srgbClr val="FFFFFF"/>
+          </a:solidFill>
+          <a:ln w="6350">
+            <a:solidFill>
+              <a:srgbClr val="BFBFBF"/>
+            </a:solidFill>
+          </a:ln>
+          <a:effectLst/>
+        </p:spPr>
+        <p:txBody>
+          <a:bodyPr rtlCol="0" anchor="ctr" wrap="square" lIns="64008" tIns="27432" rIns="45720" bIns="27432"/>
+          <a:lstStyle/>
+          <a:p>
+            <a:pPr algn="l"/>
+            <a:r>
+              <a:rPr sz="700" b="0">
+                <a:solidFill>
+                  <a:srgbClr val="000000"/>
+                </a:solidFill>
+                <a:latin typeface="맑은 고딕"/>
+                <a:ea typeface="맑은 고딕"/>
+              </a:rPr>
+              <a:t>상태 갱신 부하 ∝ N → 일정. 70% 경계 통과 여부는 E4/시뮬로 확인</a:t>
+            </a:r>
+          </a:p>
+        </p:txBody>
+      </p:sp>
+      <p:sp>
+        <p:nvSpPr>
+          <p:cNvPr id="189" name="Rectangle 188"/>
+          <p:cNvSpPr/>
+          <p:nvPr/>
+        </p:nvSpPr>
+        <p:spPr>
+          <a:xfrm>
+            <a:off x="6400800" y="4709160"/>
+            <a:ext cx="777240" cy="329184"/>
+          </a:xfrm>
+          <a:prstGeom prst="rect">
+            <a:avLst/>
+          </a:prstGeom>
+          <a:solidFill>
+            <a:srgbClr val="F2F2F2"/>
+          </a:solidFill>
+          <a:ln w="6350">
+            <a:solidFill>
+              <a:srgbClr val="BFBFBF"/>
+            </a:solidFill>
+          </a:ln>
+          <a:effectLst/>
+        </p:spPr>
+        <p:txBody>
+          <a:bodyPr rtlCol="0" anchor="ctr" wrap="square" lIns="64008" tIns="27432" rIns="45720" bIns="27432"/>
+          <a:lstStyle/>
+          <a:p>
+            <a:pPr algn="l"/>
+            <a:r>
+              <a:rPr sz="700" b="1">
+                <a:solidFill>
+                  <a:srgbClr val="000000"/>
+                </a:solidFill>
+                <a:latin typeface="맑은 고딕"/>
+                <a:ea typeface="맑은 고딕"/>
+              </a:rPr>
+              <a:t>Q2 지연</a:t>
+            </a:r>
+          </a:p>
+        </p:txBody>
+      </p:sp>
+      <p:sp>
+        <p:nvSpPr>
+          <p:cNvPr id="190" name="Rectangle 189"/>
+          <p:cNvSpPr/>
+          <p:nvPr/>
+        </p:nvSpPr>
+        <p:spPr>
+          <a:xfrm>
+            <a:off x="7178040" y="4709160"/>
+            <a:ext cx="1097280" cy="329184"/>
+          </a:xfrm>
+          <a:prstGeom prst="rect">
+            <a:avLst/>
+          </a:prstGeom>
+          <a:solidFill>
+            <a:srgbClr val="FFFFFF"/>
+          </a:solidFill>
+          <a:ln w="6350">
+            <a:solidFill>
+              <a:srgbClr val="BFBFBF"/>
+            </a:solidFill>
+          </a:ln>
+          <a:effectLst/>
+        </p:spPr>
+        <p:txBody>
+          <a:bodyPr rtlCol="0" anchor="ctr" wrap="square" lIns="64008" tIns="27432" rIns="45720" bIns="27432"/>
+          <a:lstStyle/>
+          <a:p>
+            <a:pPr algn="l"/>
+            <a:r>
+              <a:rPr sz="700" b="0">
+                <a:solidFill>
+                  <a:srgbClr val="000000"/>
+                </a:solidFill>
+                <a:latin typeface="맑은 고딕"/>
+                <a:ea typeface="맑은 고딕"/>
+              </a:rPr>
+              <a:t>TTFT 1,940 ms ★★★</a:t>
+            </a:r>
+          </a:p>
+        </p:txBody>
+      </p:sp>
+      <p:sp>
+        <p:nvSpPr>
+          <p:cNvPr id="191" name="Rectangle 190"/>
+          <p:cNvSpPr/>
+          <p:nvPr/>
+        </p:nvSpPr>
+        <p:spPr>
+          <a:xfrm>
+            <a:off x="8275319" y="4709160"/>
+            <a:ext cx="1371600" cy="329184"/>
+          </a:xfrm>
+          <a:prstGeom prst="rect">
+            <a:avLst/>
+          </a:prstGeom>
+          <a:solidFill>
+            <a:srgbClr val="FFFFFF"/>
+          </a:solidFill>
+          <a:ln w="6350">
+            <a:solidFill>
+              <a:srgbClr val="BFBFBF"/>
+            </a:solidFill>
+          </a:ln>
+          <a:effectLst/>
+        </p:spPr>
+        <p:txBody>
+          <a:bodyPr rtlCol="0" anchor="ctr" wrap="square" lIns="64008" tIns="27432" rIns="45720" bIns="27432"/>
+          <a:lstStyle/>
+          <a:p>
+            <a:pPr algn="l"/>
+            <a:r>
+              <a:rPr sz="700" b="0">
+                <a:solidFill>
+                  <a:srgbClr val="000000"/>
+                </a:solidFill>
+                <a:latin typeface="맑은 고딕"/>
+                <a:ea typeface="맑은 고딕"/>
+              </a:rPr>
+              <a:t>+30~60 ms, 2 s 경계</a:t>
+            </a:r>
+          </a:p>
+        </p:txBody>
+      </p:sp>
+      <p:sp>
+        <p:nvSpPr>
+          <p:cNvPr id="192" name="Rectangle 191"/>
+          <p:cNvSpPr/>
+          <p:nvPr/>
+        </p:nvSpPr>
+        <p:spPr>
+          <a:xfrm>
+            <a:off x="9646919" y="4709160"/>
+            <a:ext cx="2350008" cy="329184"/>
+          </a:xfrm>
+          <a:prstGeom prst="rect">
+            <a:avLst/>
+          </a:prstGeom>
+          <a:solidFill>
+            <a:srgbClr val="FFFFFF"/>
+          </a:solidFill>
+          <a:ln w="6350">
+            <a:solidFill>
+              <a:srgbClr val="BFBFBF"/>
+            </a:solidFill>
+          </a:ln>
+          <a:effectLst/>
+        </p:spPr>
+        <p:txBody>
+          <a:bodyPr rtlCol="0" anchor="ctr" wrap="square" lIns="64008" tIns="27432" rIns="45720" bIns="27432"/>
+          <a:lstStyle/>
+          <a:p>
+            <a:pPr algn="l"/>
+            <a:r>
+              <a:rPr sz="700" b="0">
+                <a:solidFill>
+                  <a:srgbClr val="000000"/>
+                </a:solidFill>
+                <a:latin typeface="맑은 고딕"/>
+                <a:ea typeface="맑은 고딕"/>
+              </a:rPr>
+              <a:t>Front Router hop 약 10 ms + 요약 낡음으로 캐시 적중 손실. ★★★ 유지 불확실</a:t>
+            </a:r>
+          </a:p>
+        </p:txBody>
+      </p:sp>
+      <p:sp>
+        <p:nvSpPr>
+          <p:cNvPr id="193" name="Rectangle 192"/>
+          <p:cNvSpPr/>
+          <p:nvPr/>
+        </p:nvSpPr>
+        <p:spPr>
+          <a:xfrm>
+            <a:off x="6400800" y="5038344"/>
+            <a:ext cx="777240" cy="329184"/>
+          </a:xfrm>
+          <a:prstGeom prst="rect">
+            <a:avLst/>
+          </a:prstGeom>
+          <a:solidFill>
+            <a:srgbClr val="F2F2F2"/>
+          </a:solidFill>
+          <a:ln w="6350">
+            <a:solidFill>
+              <a:srgbClr val="BFBFBF"/>
+            </a:solidFill>
+          </a:ln>
+          <a:effectLst/>
+        </p:spPr>
+        <p:txBody>
+          <a:bodyPr rtlCol="0" anchor="ctr" wrap="square" lIns="64008" tIns="27432" rIns="45720" bIns="27432"/>
+          <a:lstStyle/>
+          <a:p>
+            <a:pPr algn="l"/>
+            <a:r>
+              <a:rPr sz="700" b="1">
+                <a:solidFill>
+                  <a:srgbClr val="000000"/>
+                </a:solidFill>
+                <a:latin typeface="맑은 고딕"/>
+                <a:ea typeface="맑은 고딕"/>
+              </a:rPr>
+              <a:t>Q3 변경</a:t>
+            </a:r>
+          </a:p>
+        </p:txBody>
+      </p:sp>
+      <p:sp>
+        <p:nvSpPr>
+          <p:cNvPr id="194" name="Rectangle 193"/>
+          <p:cNvSpPr/>
+          <p:nvPr/>
+        </p:nvSpPr>
+        <p:spPr>
+          <a:xfrm>
+            <a:off x="7178040" y="5038344"/>
+            <a:ext cx="1097280" cy="329184"/>
+          </a:xfrm>
+          <a:prstGeom prst="rect">
+            <a:avLst/>
+          </a:prstGeom>
+          <a:solidFill>
+            <a:srgbClr val="FFFFFF"/>
+          </a:solidFill>
+          <a:ln w="6350">
+            <a:solidFill>
+              <a:srgbClr val="BFBFBF"/>
+            </a:solidFill>
+          </a:ln>
+          <a:effectLst/>
+        </p:spPr>
+        <p:txBody>
+          <a:bodyPr rtlCol="0" anchor="ctr" wrap="square" lIns="64008" tIns="27432" rIns="45720" bIns="27432"/>
+          <a:lstStyle/>
+          <a:p>
+            <a:pPr algn="l"/>
+            <a:r>
+              <a:rPr sz="700" b="0">
+                <a:solidFill>
+                  <a:srgbClr val="000000"/>
+                </a:solidFill>
+                <a:latin typeface="맑은 고딕"/>
+                <a:ea typeface="맑은 고딕"/>
+              </a:rPr>
+              <a:t>module 1.9 ★★★</a:t>
+            </a:r>
+          </a:p>
+        </p:txBody>
+      </p:sp>
+      <p:sp>
+        <p:nvSpPr>
+          <p:cNvPr id="195" name="Rectangle 194"/>
+          <p:cNvSpPr/>
+          <p:nvPr/>
+        </p:nvSpPr>
+        <p:spPr>
+          <a:xfrm>
+            <a:off x="8275319" y="5038344"/>
+            <a:ext cx="1371600" cy="329184"/>
+          </a:xfrm>
+          <a:prstGeom prst="rect">
+            <a:avLst/>
+          </a:prstGeom>
+          <a:solidFill>
+            <a:srgbClr val="FFFFFF"/>
+          </a:solidFill>
+          <a:ln w="6350">
+            <a:solidFill>
+              <a:srgbClr val="BFBFBF"/>
+            </a:solidFill>
+          </a:ln>
+          <a:effectLst/>
+        </p:spPr>
+        <p:txBody>
+          <a:bodyPr rtlCol="0" anchor="ctr" wrap="square" lIns="64008" tIns="27432" rIns="45720" bIns="27432"/>
+          <a:lstStyle/>
+          <a:p>
+            <a:pPr algn="l"/>
+            <a:r>
+              <a:rPr sz="700" b="0">
+                <a:solidFill>
+                  <a:srgbClr val="000000"/>
+                </a:solidFill>
+                <a:latin typeface="맑은 고딕"/>
+                <a:ea typeface="맑은 고딕"/>
+              </a:rPr>
+              <a:t>+1~2 module</a:t>
+            </a:r>
+          </a:p>
+        </p:txBody>
+      </p:sp>
+      <p:sp>
+        <p:nvSpPr>
+          <p:cNvPr id="196" name="Rectangle 195"/>
+          <p:cNvSpPr/>
+          <p:nvPr/>
+        </p:nvSpPr>
+        <p:spPr>
+          <a:xfrm>
+            <a:off x="9646919" y="5038344"/>
+            <a:ext cx="2350008" cy="329184"/>
+          </a:xfrm>
+          <a:prstGeom prst="rect">
+            <a:avLst/>
+          </a:prstGeom>
+          <a:solidFill>
+            <a:srgbClr val="FFFFFF"/>
+          </a:solidFill>
+          <a:ln w="6350">
+            <a:solidFill>
+              <a:srgbClr val="BFBFBF"/>
+            </a:solidFill>
+          </a:ln>
+          <a:effectLst/>
+        </p:spPr>
+        <p:txBody>
+          <a:bodyPr rtlCol="0" anchor="ctr" wrap="square" lIns="64008" tIns="27432" rIns="45720" bIns="27432"/>
+          <a:lstStyle/>
+          <a:p>
+            <a:pPr algn="l"/>
+            <a:r>
+              <a:rPr sz="700" b="0">
+                <a:solidFill>
+                  <a:srgbClr val="000000"/>
+                </a:solidFill>
+                <a:latin typeface="맑은 고딕"/>
+                <a:ea typeface="맑은 고딕"/>
+              </a:rPr>
+              <a:t>Front Router · 샤드 배정(etcd) 추가. 정책 교체(S2~S4)는 샤드 안이라 영향 작음</a:t>
+            </a:r>
+          </a:p>
+        </p:txBody>
+      </p:sp>
+      <p:sp>
+        <p:nvSpPr>
+          <p:cNvPr id="197" name="Rectangle 196"/>
+          <p:cNvSpPr/>
+          <p:nvPr/>
+        </p:nvSpPr>
+        <p:spPr>
+          <a:xfrm>
+            <a:off x="6400800" y="5367528"/>
+            <a:ext cx="777240" cy="329184"/>
+          </a:xfrm>
+          <a:prstGeom prst="rect">
+            <a:avLst/>
+          </a:prstGeom>
+          <a:solidFill>
+            <a:srgbClr val="F2F2F2"/>
+          </a:solidFill>
+          <a:ln w="6350">
+            <a:solidFill>
+              <a:srgbClr val="BFBFBF"/>
+            </a:solidFill>
+          </a:ln>
+          <a:effectLst/>
+        </p:spPr>
+        <p:txBody>
+          <a:bodyPr rtlCol="0" anchor="ctr" wrap="square" lIns="64008" tIns="27432" rIns="45720" bIns="27432"/>
+          <a:lstStyle/>
+          <a:p>
+            <a:pPr algn="l"/>
+            <a:r>
+              <a:rPr sz="700" b="1">
+                <a:solidFill>
+                  <a:srgbClr val="000000"/>
+                </a:solidFill>
+                <a:latin typeface="맑은 고딕"/>
+                <a:ea typeface="맑은 고딕"/>
+              </a:rPr>
+              <a:t>구현 부담</a:t>
+            </a:r>
+          </a:p>
+        </p:txBody>
+      </p:sp>
+      <p:sp>
+        <p:nvSpPr>
+          <p:cNvPr id="198" name="Rectangle 197"/>
+          <p:cNvSpPr/>
+          <p:nvPr/>
+        </p:nvSpPr>
+        <p:spPr>
+          <a:xfrm>
+            <a:off x="7178040" y="5367528"/>
+            <a:ext cx="1097280" cy="329184"/>
+          </a:xfrm>
+          <a:prstGeom prst="rect">
+            <a:avLst/>
+          </a:prstGeom>
+          <a:solidFill>
+            <a:srgbClr val="FFFFFF"/>
+          </a:solidFill>
+          <a:ln w="6350">
+            <a:solidFill>
+              <a:srgbClr val="BFBFBF"/>
+            </a:solidFill>
+          </a:ln>
+          <a:effectLst/>
+        </p:spPr>
+        <p:txBody>
+          <a:bodyPr rtlCol="0" anchor="ctr" wrap="square" lIns="64008" tIns="27432" rIns="45720" bIns="27432"/>
+          <a:lstStyle/>
+          <a:p>
+            <a:pPr algn="l"/>
+            <a:r>
+              <a:rPr sz="700" b="0">
+                <a:solidFill>
+                  <a:srgbClr val="000000"/>
+                </a:solidFill>
+                <a:latin typeface="맑은 고딕"/>
+                <a:ea typeface="맑은 고딕"/>
+              </a:rPr>
+              <a:t>6/6 직접 구현</a:t>
+            </a:r>
+          </a:p>
+        </p:txBody>
+      </p:sp>
+      <p:sp>
+        <p:nvSpPr>
+          <p:cNvPr id="199" name="Rectangle 198"/>
+          <p:cNvSpPr/>
+          <p:nvPr/>
+        </p:nvSpPr>
+        <p:spPr>
+          <a:xfrm>
+            <a:off x="8275319" y="5367528"/>
+            <a:ext cx="1371600" cy="329184"/>
+          </a:xfrm>
+          <a:prstGeom prst="rect">
+            <a:avLst/>
+          </a:prstGeom>
+          <a:solidFill>
+            <a:srgbClr val="FFFFFF"/>
+          </a:solidFill>
+          <a:ln w="6350">
+            <a:solidFill>
+              <a:srgbClr val="BFBFBF"/>
+            </a:solidFill>
+          </a:ln>
+          <a:effectLst/>
+        </p:spPr>
+        <p:txBody>
+          <a:bodyPr rtlCol="0" anchor="ctr" wrap="square" lIns="64008" tIns="27432" rIns="45720" bIns="27432"/>
+          <a:lstStyle/>
+          <a:p>
+            <a:pPr algn="l"/>
+            <a:r>
+              <a:rPr sz="700" b="0">
+                <a:solidFill>
+                  <a:srgbClr val="000000"/>
+                </a:solidFill>
+                <a:latin typeface="맑은 고딕"/>
+                <a:ea typeface="맑은 고딕"/>
+              </a:rPr>
+              <a:t>더 증가</a:t>
+            </a:r>
+          </a:p>
+        </p:txBody>
+      </p:sp>
+      <p:sp>
+        <p:nvSpPr>
+          <p:cNvPr id="200" name="Rectangle 199"/>
+          <p:cNvSpPr/>
+          <p:nvPr/>
+        </p:nvSpPr>
+        <p:spPr>
+          <a:xfrm>
+            <a:off x="9646919" y="5367528"/>
+            <a:ext cx="2350008" cy="329184"/>
+          </a:xfrm>
+          <a:prstGeom prst="rect">
+            <a:avLst/>
+          </a:prstGeom>
+          <a:solidFill>
+            <a:srgbClr val="FFFFFF"/>
+          </a:solidFill>
+          <a:ln w="6350">
+            <a:solidFill>
+              <a:srgbClr val="BFBFBF"/>
+            </a:solidFill>
+          </a:ln>
+          <a:effectLst/>
+        </p:spPr>
+        <p:txBody>
+          <a:bodyPr rtlCol="0" anchor="ctr" wrap="square" lIns="64008" tIns="27432" rIns="45720" bIns="27432"/>
+          <a:lstStyle/>
+          <a:p>
+            <a:pPr algn="l"/>
+            <a:r>
+              <a:rPr sz="700" b="0">
+                <a:solidFill>
+                  <a:srgbClr val="000000"/>
+                </a:solidFill>
+                <a:latin typeface="맑은 고딕"/>
+                <a:ea typeface="맑은 고딕"/>
+              </a:rPr>
+              <a:t>Front Router, 요약 교환, 샤드 인수 로직. QA 밖 비용으로 병기</a:t>
+            </a:r>
+          </a:p>
+        </p:txBody>
+      </p:sp>
+      <p:sp>
+        <p:nvSpPr>
+          <p:cNvPr id="201" name="Rectangle 200"/>
+          <p:cNvSpPr/>
+          <p:nvPr/>
+        </p:nvSpPr>
+        <p:spPr>
+          <a:xfrm>
+            <a:off x="246888" y="5760720"/>
+            <a:ext cx="11750040" cy="475488"/>
+          </a:xfrm>
+          <a:prstGeom prst="rect">
+            <a:avLst/>
+          </a:prstGeom>
+          <a:solidFill>
+            <a:srgbClr val="FFFBEA"/>
+          </a:solidFill>
+          <a:ln w="12700">
+            <a:solidFill>
+              <a:srgbClr val="BF9000"/>
+            </a:solidFill>
+          </a:ln>
+          <a:effectLst/>
+        </p:spPr>
+        <p:txBody>
+          <a:bodyPr rtlCol="0" anchor="ctr"/>
+          <a:lstStyle/>
+          <a:p>
+            <a:pPr algn="ctr"/>
+          </a:p>
+        </p:txBody>
+      </p:sp>
+      <p:sp>
+        <p:nvSpPr>
+          <p:cNvPr id="202" name="TextBox 201"/>
+          <p:cNvSpPr txBox="1"/>
+          <p:nvPr/>
+        </p:nvSpPr>
+        <p:spPr>
+          <a:xfrm>
+            <a:off x="338328" y="5788152"/>
+            <a:ext cx="11567160" cy="438912"/>
+          </a:xfrm>
+          <a:prstGeom prst="rect">
+            <a:avLst/>
+          </a:prstGeom>
+          <a:noFill/>
+        </p:spPr>
+        <p:txBody>
+          <a:bodyPr wrap="square" anchor="t" lIns="0" tIns="0" rIns="0" bIns="0">
+            <a:spAutoFit/>
+          </a:bodyPr>
+          <a:lstStyle/>
+          <a:p>
+            <a:pPr algn="l"/>
+            <a:r>
+              <a:rPr sz="900" b="1">
+                <a:solidFill>
+                  <a:srgbClr val="C00000"/>
+                </a:solidFill>
+                <a:latin typeface="맑은 고딕"/>
+                <a:ea typeface="맑은 고딕"/>
+              </a:rPr>
+              <a:t>정리  </a:t>
+            </a:r>
+            <a:r>
+              <a:rPr sz="850" b="0">
+                <a:solidFill>
+                  <a:srgbClr val="000000"/>
+                </a:solidFill>
+                <a:latin typeface="맑은 고딕"/>
+                <a:ea typeface="맑은 고딕"/>
+              </a:rPr>
+              <a:t>샤딩은 Q4를 ★에서 ★★로 올릴 가능성이 있지만 Q2(경계)와 구현 부담을 키운다. 별 합계로는 +1(Q4) 대신 Q2 ★★★ 유지가 불확실해 합계가 오른다고 단정할 수 없다. 이 장은 가설이며 확정은 E4(서버 수별 Goodput)와 E1(Front Router hop)로 한다.</a:t>
+            </a:r>
+          </a:p>
+        </p:txBody>
+      </p:sp>
+      <p:sp>
+        <p:nvSpPr>
+          <p:cNvPr id="203" name="TextBox 202"/>
+          <p:cNvSpPr txBox="1"/>
+          <p:nvPr/>
+        </p:nvSpPr>
+        <p:spPr>
+          <a:xfrm>
+            <a:off x="246888" y="6309360"/>
+            <a:ext cx="11750040" cy="128016"/>
+          </a:xfrm>
+          <a:prstGeom prst="rect">
+            <a:avLst/>
+          </a:prstGeom>
+          <a:noFill/>
+        </p:spPr>
+        <p:txBody>
+          <a:bodyPr wrap="square" anchor="t" lIns="0" tIns="0" rIns="0" bIns="0">
+            <a:spAutoFit/>
+          </a:bodyPr>
+          <a:lstStyle/>
+          <a:p>
+            <a:pPr algn="l"/>
+            <a:r>
+              <a:rPr sz="700" b="0">
+                <a:solidFill>
+                  <a:srgbClr val="404040"/>
+                </a:solidFill>
+                <a:latin typeface="맑은 고딕"/>
+                <a:ea typeface="맑은 고딕"/>
+              </a:rPr>
+              <a:t>※ 보완 설계안(미구현). 효과 수치는 모두 가설 [C]. 소유자 확정 별점(Q4 ★)은 보완 전 현재 설계 기준이며 이 장으로 바꾸지 않았다.</a:t>
+            </a:r>
+          </a:p>
+        </p:txBody>
+      </p:sp>
+    </p:spTree>
+  </p:cSld>
+  <p:clrMapOvr>
+    <a:masterClrMapping/>
+  </p:clrMapOvr>
+</p:sld>
+</file>
+
 <file path=ppt/theme/theme1.xml><?xml version="1.0" encoding="utf-8"?>
 <a:theme xmlns:a="http://schemas.openxmlformats.org/drawingml/2006/main" name="Office 테마">
   <a:themeElements>

</xml_diff>